<commit_message>
docs(website): prepare usehormuz root-site migration
</commit_message>
<xml_diff>
--- a/website/public/downloads/hormuz-buyer-briefing.pptx
+++ b/website/public/downloads/hormuz-buyer-briefing.pptx
@@ -2,19 +2,19 @@
 <file path=ppt/presentation.xml><?xml version="1.0" encoding="utf-8"?>
 <p:presentation xmlns:p="http://schemas.openxmlformats.org/presentationml/2006/main">
   <p:sldMasterIdLst>
-    <p:sldMasterId xmlns:r="http://schemas.openxmlformats.org/officeDocument/2006/relationships" id="2147483648" r:id="R4f41969821fc4574"/>
+    <p:sldMasterId xmlns:r="http://schemas.openxmlformats.org/officeDocument/2006/relationships" id="2147483648" r:id="R864f688023be417b"/>
   </p:sldMasterIdLst>
   <p:notesMasterIdLst>
-    <p:notesMasterId xmlns:r="http://schemas.openxmlformats.org/officeDocument/2006/relationships" r:id="R0307dc74f7a24c58"/>
+    <p:notesMasterId xmlns:r="http://schemas.openxmlformats.org/officeDocument/2006/relationships" r:id="Ra16e95166cbd4900"/>
   </p:notesMasterIdLst>
   <p:sldIdLst>
-    <p:sldId xmlns:r="http://schemas.openxmlformats.org/officeDocument/2006/relationships" id="256" r:id="Re71d4f6438c34956"/>
-    <p:sldId xmlns:r="http://schemas.openxmlformats.org/officeDocument/2006/relationships" id="257" r:id="R111556643ce04146"/>
-    <p:sldId xmlns:r="http://schemas.openxmlformats.org/officeDocument/2006/relationships" id="258" r:id="R457f112c9291484f"/>
-    <p:sldId xmlns:r="http://schemas.openxmlformats.org/officeDocument/2006/relationships" id="259" r:id="R3da72f236e4246b4"/>
-    <p:sldId xmlns:r="http://schemas.openxmlformats.org/officeDocument/2006/relationships" id="260" r:id="R010ba966cb5c48df"/>
-    <p:sldId xmlns:r="http://schemas.openxmlformats.org/officeDocument/2006/relationships" id="261" r:id="Rcfe58305d09c4218"/>
-    <p:sldId xmlns:r="http://schemas.openxmlformats.org/officeDocument/2006/relationships" id="262" r:id="R68e280f7fc444870"/>
+    <p:sldId xmlns:r="http://schemas.openxmlformats.org/officeDocument/2006/relationships" id="256" r:id="Rfbd4cc0a9591479d"/>
+    <p:sldId xmlns:r="http://schemas.openxmlformats.org/officeDocument/2006/relationships" id="257" r:id="Rc413cb69a1354a18"/>
+    <p:sldId xmlns:r="http://schemas.openxmlformats.org/officeDocument/2006/relationships" id="258" r:id="Rcb314aa38d2f4487"/>
+    <p:sldId xmlns:r="http://schemas.openxmlformats.org/officeDocument/2006/relationships" id="259" r:id="Ref6c1433c1414a08"/>
+    <p:sldId xmlns:r="http://schemas.openxmlformats.org/officeDocument/2006/relationships" id="260" r:id="Rc4d8c75b472b4152"/>
+    <p:sldId xmlns:r="http://schemas.openxmlformats.org/officeDocument/2006/relationships" id="261" r:id="R7ae6b24e897d4eda"/>
+    <p:sldId xmlns:r="http://schemas.openxmlformats.org/officeDocument/2006/relationships" id="262" r:id="R96df3d5743a347e2"/>
   </p:sldIdLst>
   <p:sldSz cx="12192000" cy="6858000"/>
   <p:notesSz cx="6858000" cy="9144000"/>
@@ -643,7 +643,7 @@
           </a:p>
           <a:p xmlns:a="http://schemas.openxmlformats.org/drawingml/2006/main">
             <a:r>
-              <a:t>https://xpounder-com.github.io/hormuz/demo/</a:t>
+              <a:t>https://usehormuz.github.io/demo/</a:t>
             </a:r>
           </a:p>
           <a:p xmlns:a="http://schemas.openxmlformats.org/drawingml/2006/main">
@@ -1028,7 +1028,7 @@
           </a:p>
           <a:p xmlns:a="http://schemas.openxmlformats.org/drawingml/2006/main">
             <a:r>
-              <a:t>https://xpounder-com.github.io/hormuz/</a:t>
+              <a:t>https://usehormuz.github.io/</a:t>
             </a:r>
           </a:p>
           <a:p xmlns:a="http://schemas.openxmlformats.org/drawingml/2006/main">
@@ -1116,7 +1116,7 @@
   </p:cSld>
   <p:clrMap bg1="lt1" tx1="dk1" bg2="lt2" tx2="dk2" accent1="accent1" accent2="accent2" accent3="accent3" accent4="accent4" accent5="accent5" accent6="accent6" hlink="hlink" folHlink="folHlink"/>
   <p:sldLayoutIdLst>
-    <p:sldLayoutId xmlns:r="http://schemas.openxmlformats.org/officeDocument/2006/relationships" id="2147483649" r:id="R44869c663f834a7e"/>
+    <p:sldLayoutId xmlns:r="http://schemas.openxmlformats.org/officeDocument/2006/relationships" id="2147483649" r:id="R0a4284ef4ceb4b5c"/>
   </p:sldLayoutIdLst>
   <p:txStyles>
     <p:titleStyle>
@@ -1697,6 +1697,7 @@
           <a:lstStyle xmlns:a="http://schemas.openxmlformats.org/drawingml/2006/main"/>
           <a:p xmlns:a="http://schemas.openxmlformats.org/drawingml/2006/main">
             <a:pPr>
+              <a:buNone/>
               <a:defRPr sz="1425" b="1">
                 <a:solidFill>
                   <a:srgbClr val="68E6DD"/>
@@ -1755,6 +1756,7 @@
           <a:lstStyle xmlns:a="http://schemas.openxmlformats.org/drawingml/2006/main"/>
           <a:p xmlns:a="http://schemas.openxmlformats.org/drawingml/2006/main">
             <a:pPr>
+              <a:buNone/>
               <a:defRPr sz="1275" b="0">
                 <a:solidFill>
                   <a:srgbClr val="B9CCC7"/>
@@ -1773,7 +1775,29 @@
                 <a:ea typeface="Arial"/>
                 <a:cs typeface="Arial"/>
               </a:rPr>
-              <a:t>HORMUZ  /  Mehrdad Zaker  /  30 Aug 2026                                      01 / 07</a:t>
+              <a:t>HORMUZ  /  Mehrdad Zaker  /  </a:t>
+            </a:r>
+            <a:r>
+              <a:rPr sz="1275" b="0">
+                <a:solidFill>
+                  <a:srgbClr val="B9CCC7"/>
+                </a:solidFill>
+                <a:latin typeface="Arial"/>
+                <a:ea typeface="Arial"/>
+                <a:cs typeface="Arial"/>
+              </a:rPr>
+              <a:t>31 Aug 2026</a:t>
+            </a:r>
+            <a:r>
+              <a:rPr sz="1275" b="0">
+                <a:solidFill>
+                  <a:srgbClr val="B9CCC7"/>
+                </a:solidFill>
+                <a:latin typeface="Arial"/>
+                <a:ea typeface="Arial"/>
+                <a:cs typeface="Arial"/>
+              </a:rPr>
+              <a:t>                                      01 / 07</a:t>
             </a:r>
           </a:p>
         </p:txBody>
@@ -1813,6 +1837,7 @@
           <a:lstStyle xmlns:a="http://schemas.openxmlformats.org/drawingml/2006/main"/>
           <a:p xmlns:a="http://schemas.openxmlformats.org/drawingml/2006/main">
             <a:pPr>
+              <a:buNone/>
               <a:defRPr sz="5100" b="1">
                 <a:solidFill>
                   <a:srgbClr val="FBFCF8"/>
@@ -1836,6 +1861,7 @@
           </a:p>
           <a:p xmlns:a="http://schemas.openxmlformats.org/drawingml/2006/main">
             <a:pPr>
+              <a:buNone/>
               <a:defRPr sz="5100" b="1">
                 <a:solidFill>
                   <a:srgbClr val="FBFCF8"/>
@@ -1894,6 +1920,7 @@
           <a:lstStyle xmlns:a="http://schemas.openxmlformats.org/drawingml/2006/main"/>
           <a:p xmlns:a="http://schemas.openxmlformats.org/drawingml/2006/main">
             <a:pPr>
+              <a:buNone/>
               <a:defRPr sz="2325" b="0">
                 <a:solidFill>
                   <a:srgbClr val="D9E1DF"/>
@@ -1917,6 +1944,7 @@
           </a:p>
           <a:p xmlns:a="http://schemas.openxmlformats.org/drawingml/2006/main">
             <a:pPr>
+              <a:buNone/>
               <a:defRPr sz="2325" b="0">
                 <a:solidFill>
                   <a:srgbClr val="D9E1DF"/>
@@ -1975,6 +2003,7 @@
           <a:lstStyle xmlns:a="http://schemas.openxmlformats.org/drawingml/2006/main"/>
           <a:p xmlns:a="http://schemas.openxmlformats.org/drawingml/2006/main">
             <a:pPr>
+              <a:buNone/>
               <a:defRPr sz="1875" b="1">
                 <a:solidFill>
                   <a:srgbClr val="68E6DD"/>
@@ -2062,6 +2091,7 @@
           <a:lstStyle xmlns:a="http://schemas.openxmlformats.org/drawingml/2006/main"/>
           <a:p xmlns:a="http://schemas.openxmlformats.org/drawingml/2006/main">
             <a:pPr>
+              <a:buNone/>
               <a:defRPr sz="1425" b="1">
                 <a:solidFill>
                   <a:srgbClr val="087F78"/>
@@ -2120,6 +2150,7 @@
           <a:lstStyle xmlns:a="http://schemas.openxmlformats.org/drawingml/2006/main"/>
           <a:p xmlns:a="http://schemas.openxmlformats.org/drawingml/2006/main">
             <a:pPr>
+              <a:buNone/>
               <a:defRPr sz="3600" b="1">
                 <a:solidFill>
                   <a:srgbClr val="101B20"/>
@@ -2178,6 +2209,7 @@
           <a:lstStyle xmlns:a="http://schemas.openxmlformats.org/drawingml/2006/main"/>
           <a:p xmlns:a="http://schemas.openxmlformats.org/drawingml/2006/main">
             <a:pPr>
+              <a:buNone/>
               <a:defRPr sz="1275" b="0">
                 <a:solidFill>
                   <a:srgbClr val="607077"/>
@@ -2196,7 +2228,29 @@
                 <a:ea typeface="Arial"/>
                 <a:cs typeface="Arial"/>
               </a:rPr>
-              <a:t>HORMUZ  /  Mehrdad Zaker  /  30 Aug 2026                                      02 / 07</a:t>
+              <a:t>HORMUZ  /  Mehrdad Zaker  /  </a:t>
+            </a:r>
+            <a:r>
+              <a:rPr sz="1275" b="0">
+                <a:solidFill>
+                  <a:srgbClr val="607077"/>
+                </a:solidFill>
+                <a:latin typeface="Arial"/>
+                <a:ea typeface="Arial"/>
+                <a:cs typeface="Arial"/>
+              </a:rPr>
+              <a:t>31 Aug 2026</a:t>
+            </a:r>
+            <a:r>
+              <a:rPr sz="1275" b="0">
+                <a:solidFill>
+                  <a:srgbClr val="607077"/>
+                </a:solidFill>
+                <a:latin typeface="Arial"/>
+                <a:ea typeface="Arial"/>
+                <a:cs typeface="Arial"/>
+              </a:rPr>
+              <a:t>                                      02 / 07</a:t>
             </a:r>
           </a:p>
         </p:txBody>
@@ -2236,6 +2290,7 @@
           <a:lstStyle xmlns:a="http://schemas.openxmlformats.org/drawingml/2006/main"/>
           <a:p xmlns:a="http://schemas.openxmlformats.org/drawingml/2006/main">
             <a:pPr>
+              <a:buNone/>
               <a:defRPr sz="3450" b="0">
                 <a:solidFill>
                   <a:srgbClr val="087F78"/>
@@ -2294,6 +2349,7 @@
           <a:lstStyle xmlns:a="http://schemas.openxmlformats.org/drawingml/2006/main"/>
           <a:p xmlns:a="http://schemas.openxmlformats.org/drawingml/2006/main">
             <a:pPr>
+              <a:buNone/>
               <a:defRPr sz="3450" b="0">
                 <a:solidFill>
                   <a:srgbClr val="087F78"/>
@@ -2385,6 +2441,7 @@
           <a:lstStyle xmlns:a="http://schemas.openxmlformats.org/drawingml/2006/main"/>
           <a:p xmlns:a="http://schemas.openxmlformats.org/drawingml/2006/main">
             <a:pPr>
+              <a:buNone/>
               <a:defRPr sz="1650" b="1">
                 <a:solidFill>
                   <a:srgbClr val="087F78"/>
@@ -2443,6 +2500,7 @@
           <a:lstStyle xmlns:a="http://schemas.openxmlformats.org/drawingml/2006/main"/>
           <a:p xmlns:a="http://schemas.openxmlformats.org/drawingml/2006/main">
             <a:pPr>
+              <a:buNone/>
               <a:defRPr sz="1800" b="0">
                 <a:solidFill>
                   <a:srgbClr val="101B20"/>
@@ -2466,6 +2524,7 @@
           </a:p>
           <a:p xmlns:a="http://schemas.openxmlformats.org/drawingml/2006/main">
             <a:pPr>
+              <a:buNone/>
               <a:defRPr sz="1800" b="0">
                 <a:solidFill>
                   <a:srgbClr val="101B20"/>
@@ -2557,6 +2616,7 @@
           <a:lstStyle xmlns:a="http://schemas.openxmlformats.org/drawingml/2006/main"/>
           <a:p xmlns:a="http://schemas.openxmlformats.org/drawingml/2006/main">
             <a:pPr>
+              <a:buNone/>
               <a:defRPr sz="1650" b="1">
                 <a:solidFill>
                   <a:srgbClr val="087F78"/>
@@ -2615,6 +2675,7 @@
           <a:lstStyle xmlns:a="http://schemas.openxmlformats.org/drawingml/2006/main"/>
           <a:p xmlns:a="http://schemas.openxmlformats.org/drawingml/2006/main">
             <a:pPr>
+              <a:buNone/>
               <a:defRPr sz="1800" b="0">
                 <a:solidFill>
                   <a:srgbClr val="101B20"/>
@@ -2638,6 +2699,7 @@
           </a:p>
           <a:p xmlns:a="http://schemas.openxmlformats.org/drawingml/2006/main">
             <a:pPr>
+              <a:buNone/>
               <a:defRPr sz="1800" b="0">
                 <a:solidFill>
                   <a:srgbClr val="101B20"/>
@@ -2729,6 +2791,7 @@
           <a:lstStyle xmlns:a="http://schemas.openxmlformats.org/drawingml/2006/main"/>
           <a:p xmlns:a="http://schemas.openxmlformats.org/drawingml/2006/main">
             <a:pPr>
+              <a:buNone/>
               <a:defRPr sz="1650" b="1">
                 <a:solidFill>
                   <a:srgbClr val="087F78"/>
@@ -2787,6 +2850,7 @@
           <a:lstStyle xmlns:a="http://schemas.openxmlformats.org/drawingml/2006/main"/>
           <a:p xmlns:a="http://schemas.openxmlformats.org/drawingml/2006/main">
             <a:pPr>
+              <a:buNone/>
               <a:defRPr sz="1800" b="0">
                 <a:solidFill>
                   <a:srgbClr val="101B20"/>
@@ -2810,6 +2874,7 @@
           </a:p>
           <a:p xmlns:a="http://schemas.openxmlformats.org/drawingml/2006/main">
             <a:pPr>
+              <a:buNone/>
               <a:defRPr sz="1800" b="0">
                 <a:solidFill>
                   <a:srgbClr val="101B20"/>
@@ -2868,6 +2933,7 @@
           <a:lstStyle xmlns:a="http://schemas.openxmlformats.org/drawingml/2006/main"/>
           <a:p xmlns:a="http://schemas.openxmlformats.org/drawingml/2006/main">
             <a:pPr>
+              <a:buNone/>
               <a:defRPr sz="2400" b="1">
                 <a:solidFill>
                   <a:srgbClr val="101B20"/>
@@ -2926,6 +2992,7 @@
           <a:lstStyle xmlns:a="http://schemas.openxmlformats.org/drawingml/2006/main"/>
           <a:p xmlns:a="http://schemas.openxmlformats.org/drawingml/2006/main">
             <a:pPr>
+              <a:buNone/>
               <a:defRPr sz="1875" b="0">
                 <a:solidFill>
                   <a:srgbClr val="607077"/>
@@ -3013,6 +3080,7 @@
           <a:lstStyle xmlns:a="http://schemas.openxmlformats.org/drawingml/2006/main"/>
           <a:p xmlns:a="http://schemas.openxmlformats.org/drawingml/2006/main">
             <a:pPr>
+              <a:buNone/>
               <a:defRPr sz="1425" b="1">
                 <a:solidFill>
                   <a:srgbClr val="68E6DD"/>
@@ -3071,6 +3139,7 @@
           <a:lstStyle xmlns:a="http://schemas.openxmlformats.org/drawingml/2006/main"/>
           <a:p xmlns:a="http://schemas.openxmlformats.org/drawingml/2006/main">
             <a:pPr>
+              <a:buNone/>
               <a:defRPr sz="3600" b="1">
                 <a:solidFill>
                   <a:srgbClr val="FBFCF8"/>
@@ -3129,6 +3198,7 @@
           <a:lstStyle xmlns:a="http://schemas.openxmlformats.org/drawingml/2006/main"/>
           <a:p xmlns:a="http://schemas.openxmlformats.org/drawingml/2006/main">
             <a:pPr>
+              <a:buNone/>
               <a:defRPr sz="1275" b="0">
                 <a:solidFill>
                   <a:srgbClr val="B9CCC7"/>
@@ -3147,7 +3217,29 @@
                 <a:ea typeface="Arial"/>
                 <a:cs typeface="Arial"/>
               </a:rPr>
-              <a:t>HORMUZ  /  Mehrdad Zaker  /  30 Aug 2026                                      03 / 07</a:t>
+              <a:t>HORMUZ  /  Mehrdad Zaker  /  </a:t>
+            </a:r>
+            <a:r>
+              <a:rPr sz="1275" b="0">
+                <a:solidFill>
+                  <a:srgbClr val="B9CCC7"/>
+                </a:solidFill>
+                <a:latin typeface="Arial"/>
+                <a:ea typeface="Arial"/>
+                <a:cs typeface="Arial"/>
+              </a:rPr>
+              <a:t>31 Aug 2026</a:t>
+            </a:r>
+            <a:r>
+              <a:rPr sz="1275" b="0">
+                <a:solidFill>
+                  <a:srgbClr val="B9CCC7"/>
+                </a:solidFill>
+                <a:latin typeface="Arial"/>
+                <a:ea typeface="Arial"/>
+                <a:cs typeface="Arial"/>
+              </a:rPr>
+              <a:t>                                      03 / 07</a:t>
             </a:r>
           </a:p>
         </p:txBody>
@@ -3187,6 +3279,7 @@
           <a:lstStyle xmlns:a="http://schemas.openxmlformats.org/drawingml/2006/main"/>
           <a:p xmlns:a="http://schemas.openxmlformats.org/drawingml/2006/main">
             <a:pPr>
+              <a:buNone/>
               <a:defRPr sz="10500" b="1">
                 <a:solidFill>
                   <a:srgbClr val="68E6DD"/>
@@ -3245,6 +3338,7 @@
           <a:lstStyle xmlns:a="http://schemas.openxmlformats.org/drawingml/2006/main"/>
           <a:p xmlns:a="http://schemas.openxmlformats.org/drawingml/2006/main">
             <a:pPr>
+              <a:buNone/>
               <a:defRPr sz="2250" b="1">
                 <a:solidFill>
                   <a:srgbClr val="FBFCF8"/>
@@ -3303,6 +3397,7 @@
           <a:lstStyle xmlns:a="http://schemas.openxmlformats.org/drawingml/2006/main"/>
           <a:p xmlns:a="http://schemas.openxmlformats.org/drawingml/2006/main">
             <a:pPr>
+              <a:buNone/>
               <a:defRPr sz="2325" b="0">
                 <a:solidFill>
                   <a:srgbClr val="FBFCF8"/>
@@ -3326,6 +3421,7 @@
           </a:p>
           <a:p xmlns:a="http://schemas.openxmlformats.org/drawingml/2006/main">
             <a:pPr>
+              <a:buNone/>
               <a:defRPr sz="2325" b="0">
                 <a:solidFill>
                   <a:srgbClr val="FBFCF8"/>
@@ -3349,6 +3445,7 @@
           </a:p>
           <a:p xmlns:a="http://schemas.openxmlformats.org/drawingml/2006/main">
             <a:pPr>
+              <a:buNone/>
               <a:defRPr sz="2325" b="0">
                 <a:solidFill>
                   <a:srgbClr val="FBFCF8"/>
@@ -3372,6 +3469,7 @@
           </a:p>
           <a:p xmlns:a="http://schemas.openxmlformats.org/drawingml/2006/main">
             <a:pPr>
+              <a:buNone/>
               <a:defRPr sz="2325" b="0">
                 <a:solidFill>
                   <a:srgbClr val="FBFCF8"/>
@@ -3430,6 +3528,7 @@
           <a:lstStyle xmlns:a="http://schemas.openxmlformats.org/drawingml/2006/main"/>
           <a:p xmlns:a="http://schemas.openxmlformats.org/drawingml/2006/main">
             <a:pPr>
+              <a:buNone/>
               <a:defRPr sz="1875" b="0">
                 <a:solidFill>
                   <a:srgbClr val="D9E1DF"/>
@@ -3517,6 +3616,7 @@
           <a:lstStyle xmlns:a="http://schemas.openxmlformats.org/drawingml/2006/main"/>
           <a:p xmlns:a="http://schemas.openxmlformats.org/drawingml/2006/main">
             <a:pPr>
+              <a:buNone/>
               <a:defRPr sz="1425" b="1">
                 <a:solidFill>
                   <a:srgbClr val="087F78"/>
@@ -3575,6 +3675,7 @@
           <a:lstStyle xmlns:a="http://schemas.openxmlformats.org/drawingml/2006/main"/>
           <a:p xmlns:a="http://schemas.openxmlformats.org/drawingml/2006/main">
             <a:pPr>
+              <a:buNone/>
               <a:defRPr sz="3600" b="1">
                 <a:solidFill>
                   <a:srgbClr val="101B20"/>
@@ -3633,6 +3734,7 @@
           <a:lstStyle xmlns:a="http://schemas.openxmlformats.org/drawingml/2006/main"/>
           <a:p xmlns:a="http://schemas.openxmlformats.org/drawingml/2006/main">
             <a:pPr>
+              <a:buNone/>
               <a:defRPr sz="1275" b="0">
                 <a:solidFill>
                   <a:srgbClr val="607077"/>
@@ -3651,7 +3753,29 @@
                 <a:ea typeface="Arial"/>
                 <a:cs typeface="Arial"/>
               </a:rPr>
-              <a:t>HORMUZ  /  Mehrdad Zaker  /  30 Aug 2026                                      04 / 07</a:t>
+              <a:t>HORMUZ  /  Mehrdad Zaker  /  </a:t>
+            </a:r>
+            <a:r>
+              <a:rPr sz="1275" b="0">
+                <a:solidFill>
+                  <a:srgbClr val="607077"/>
+                </a:solidFill>
+                <a:latin typeface="Arial"/>
+                <a:ea typeface="Arial"/>
+                <a:cs typeface="Arial"/>
+              </a:rPr>
+              <a:t>31 Aug 2026</a:t>
+            </a:r>
+            <a:r>
+              <a:rPr sz="1275" b="0">
+                <a:solidFill>
+                  <a:srgbClr val="607077"/>
+                </a:solidFill>
+                <a:latin typeface="Arial"/>
+                <a:ea typeface="Arial"/>
+                <a:cs typeface="Arial"/>
+              </a:rPr>
+              <a:t>                                      04 / 07</a:t>
             </a:r>
           </a:p>
         </p:txBody>
@@ -3691,6 +3815,7 @@
           <a:lstStyle xmlns:a="http://schemas.openxmlformats.org/drawingml/2006/main"/>
           <a:p xmlns:a="http://schemas.openxmlformats.org/drawingml/2006/main">
             <a:pPr>
+              <a:buNone/>
               <a:defRPr sz="2550" b="1">
                 <a:solidFill>
                   <a:srgbClr val="087F78"/>
@@ -3749,6 +3874,7 @@
           <a:lstStyle xmlns:a="http://schemas.openxmlformats.org/drawingml/2006/main"/>
           <a:p xmlns:a="http://schemas.openxmlformats.org/drawingml/2006/main">
             <a:pPr>
+              <a:buNone/>
               <a:defRPr sz="2100" b="0">
                 <a:solidFill>
                   <a:srgbClr val="101B20"/>
@@ -3772,6 +3898,7 @@
           </a:p>
           <a:p xmlns:a="http://schemas.openxmlformats.org/drawingml/2006/main">
             <a:pPr>
+              <a:buNone/>
               <a:defRPr sz="2100" b="0">
                 <a:solidFill>
                   <a:srgbClr val="101B20"/>
@@ -3795,6 +3922,7 @@
           </a:p>
           <a:p xmlns:a="http://schemas.openxmlformats.org/drawingml/2006/main">
             <a:pPr>
+              <a:buNone/>
               <a:defRPr sz="2100" b="0">
                 <a:solidFill>
                   <a:srgbClr val="101B20"/>
@@ -3818,6 +3946,7 @@
           </a:p>
           <a:p xmlns:a="http://schemas.openxmlformats.org/drawingml/2006/main">
             <a:pPr>
+              <a:buNone/>
               <a:defRPr sz="2100" b="0">
                 <a:solidFill>
                   <a:srgbClr val="101B20"/>
@@ -3841,6 +3970,7 @@
           </a:p>
           <a:p xmlns:a="http://schemas.openxmlformats.org/drawingml/2006/main">
             <a:pPr>
+              <a:buNone/>
               <a:defRPr sz="2100" b="0">
                 <a:solidFill>
                   <a:srgbClr val="101B20"/>
@@ -3899,6 +4029,7 @@
           <a:lstStyle xmlns:a="http://schemas.openxmlformats.org/drawingml/2006/main"/>
           <a:p xmlns:a="http://schemas.openxmlformats.org/drawingml/2006/main">
             <a:pPr>
+              <a:buNone/>
               <a:defRPr sz="2550" b="1">
                 <a:solidFill>
                   <a:srgbClr val="087F78"/>
@@ -3957,6 +4088,7 @@
           <a:lstStyle xmlns:a="http://schemas.openxmlformats.org/drawingml/2006/main"/>
           <a:p xmlns:a="http://schemas.openxmlformats.org/drawingml/2006/main">
             <a:pPr>
+              <a:buNone/>
               <a:defRPr sz="2100" b="0">
                 <a:solidFill>
                   <a:srgbClr val="101B20"/>
@@ -3980,6 +4112,7 @@
           </a:p>
           <a:p xmlns:a="http://schemas.openxmlformats.org/drawingml/2006/main">
             <a:pPr>
+              <a:buNone/>
               <a:defRPr sz="2100" b="0">
                 <a:solidFill>
                   <a:srgbClr val="101B20"/>
@@ -4003,6 +4136,7 @@
           </a:p>
           <a:p xmlns:a="http://schemas.openxmlformats.org/drawingml/2006/main">
             <a:pPr>
+              <a:buNone/>
               <a:defRPr sz="2100" b="0">
                 <a:solidFill>
                   <a:srgbClr val="101B20"/>
@@ -4026,6 +4160,7 @@
           </a:p>
           <a:p xmlns:a="http://schemas.openxmlformats.org/drawingml/2006/main">
             <a:pPr>
+              <a:buNone/>
               <a:defRPr sz="2100" b="0">
                 <a:solidFill>
                   <a:srgbClr val="101B20"/>
@@ -4049,6 +4184,7 @@
           </a:p>
           <a:p xmlns:a="http://schemas.openxmlformats.org/drawingml/2006/main">
             <a:pPr>
+              <a:buNone/>
               <a:defRPr sz="2100" b="0">
                 <a:solidFill>
                   <a:srgbClr val="101B20"/>
@@ -4107,6 +4243,7 @@
           <a:lstStyle xmlns:a="http://schemas.openxmlformats.org/drawingml/2006/main"/>
           <a:p xmlns:a="http://schemas.openxmlformats.org/drawingml/2006/main">
             <a:pPr>
+              <a:buNone/>
               <a:defRPr sz="1800" b="0">
                 <a:solidFill>
                   <a:srgbClr val="607077"/>
@@ -4194,6 +4331,7 @@
           <a:lstStyle xmlns:a="http://schemas.openxmlformats.org/drawingml/2006/main"/>
           <a:p xmlns:a="http://schemas.openxmlformats.org/drawingml/2006/main">
             <a:pPr>
+              <a:buNone/>
               <a:defRPr sz="1425" b="1">
                 <a:solidFill>
                   <a:srgbClr val="087F78"/>
@@ -4252,6 +4390,7 @@
           <a:lstStyle xmlns:a="http://schemas.openxmlformats.org/drawingml/2006/main"/>
           <a:p xmlns:a="http://schemas.openxmlformats.org/drawingml/2006/main">
             <a:pPr>
+              <a:buNone/>
               <a:defRPr sz="3600" b="1">
                 <a:solidFill>
                   <a:srgbClr val="101B20"/>
@@ -4310,6 +4449,7 @@
           <a:lstStyle xmlns:a="http://schemas.openxmlformats.org/drawingml/2006/main"/>
           <a:p xmlns:a="http://schemas.openxmlformats.org/drawingml/2006/main">
             <a:pPr>
+              <a:buNone/>
               <a:defRPr sz="1275" b="0">
                 <a:solidFill>
                   <a:srgbClr val="607077"/>
@@ -4328,7 +4468,29 @@
                 <a:ea typeface="Arial"/>
                 <a:cs typeface="Arial"/>
               </a:rPr>
-              <a:t>HORMUZ  /  Mehrdad Zaker  /  30 Aug 2026                                      05 / 07</a:t>
+              <a:t>HORMUZ  /  Mehrdad Zaker  /  </a:t>
+            </a:r>
+            <a:r>
+              <a:rPr sz="1275" b="0">
+                <a:solidFill>
+                  <a:srgbClr val="607077"/>
+                </a:solidFill>
+                <a:latin typeface="Arial"/>
+                <a:ea typeface="Arial"/>
+                <a:cs typeface="Arial"/>
+              </a:rPr>
+              <a:t>31 Aug 2026</a:t>
+            </a:r>
+            <a:r>
+              <a:rPr sz="1275" b="0">
+                <a:solidFill>
+                  <a:srgbClr val="607077"/>
+                </a:solidFill>
+                <a:latin typeface="Arial"/>
+                <a:ea typeface="Arial"/>
+                <a:cs typeface="Arial"/>
+              </a:rPr>
+              <a:t>                                      05 / 07</a:t>
             </a:r>
           </a:p>
         </p:txBody>
@@ -4368,6 +4530,7 @@
           <a:lstStyle xmlns:a="http://schemas.openxmlformats.org/drawingml/2006/main"/>
           <a:p xmlns:a="http://schemas.openxmlformats.org/drawingml/2006/main">
             <a:pPr>
+              <a:buNone/>
               <a:defRPr sz="3150" b="1">
                 <a:solidFill>
                   <a:srgbClr val="087F78"/>
@@ -4426,6 +4589,7 @@
           <a:lstStyle xmlns:a="http://schemas.openxmlformats.org/drawingml/2006/main"/>
           <a:p xmlns:a="http://schemas.openxmlformats.org/drawingml/2006/main">
             <a:pPr>
+              <a:buNone/>
               <a:defRPr sz="2100" b="0">
                 <a:solidFill>
                   <a:srgbClr val="101B20"/>
@@ -4484,6 +4648,7 @@
           <a:lstStyle xmlns:a="http://schemas.openxmlformats.org/drawingml/2006/main"/>
           <a:p xmlns:a="http://schemas.openxmlformats.org/drawingml/2006/main">
             <a:pPr>
+              <a:buNone/>
               <a:defRPr sz="2325" b="1">
                 <a:solidFill>
                   <a:srgbClr val="101B20"/>
@@ -4542,6 +4707,7 @@
           <a:lstStyle xmlns:a="http://schemas.openxmlformats.org/drawingml/2006/main"/>
           <a:p xmlns:a="http://schemas.openxmlformats.org/drawingml/2006/main">
             <a:pPr>
+              <a:buNone/>
               <a:defRPr sz="1875" b="0">
                 <a:solidFill>
                   <a:srgbClr val="607077"/>
@@ -4629,6 +4795,7 @@
           <a:lstStyle xmlns:a="http://schemas.openxmlformats.org/drawingml/2006/main"/>
           <a:p xmlns:a="http://schemas.openxmlformats.org/drawingml/2006/main">
             <a:pPr>
+              <a:buNone/>
               <a:defRPr sz="1425" b="1">
                 <a:solidFill>
                   <a:srgbClr val="087F78"/>
@@ -4687,6 +4854,7 @@
           <a:lstStyle xmlns:a="http://schemas.openxmlformats.org/drawingml/2006/main"/>
           <a:p xmlns:a="http://schemas.openxmlformats.org/drawingml/2006/main">
             <a:pPr>
+              <a:buNone/>
               <a:defRPr sz="3600" b="1">
                 <a:solidFill>
                   <a:srgbClr val="101B20"/>
@@ -4745,6 +4913,7 @@
           <a:lstStyle xmlns:a="http://schemas.openxmlformats.org/drawingml/2006/main"/>
           <a:p xmlns:a="http://schemas.openxmlformats.org/drawingml/2006/main">
             <a:pPr>
+              <a:buNone/>
               <a:defRPr sz="1275" b="0">
                 <a:solidFill>
                   <a:srgbClr val="607077"/>
@@ -4763,7 +4932,29 @@
                 <a:ea typeface="Arial"/>
                 <a:cs typeface="Arial"/>
               </a:rPr>
-              <a:t>HORMUZ  /  Mehrdad Zaker  /  30 Aug 2026                                      06 / 07</a:t>
+              <a:t>HORMUZ  /  Mehrdad Zaker  /  </a:t>
+            </a:r>
+            <a:r>
+              <a:rPr sz="1275" b="0">
+                <a:solidFill>
+                  <a:srgbClr val="607077"/>
+                </a:solidFill>
+                <a:latin typeface="Arial"/>
+                <a:ea typeface="Arial"/>
+                <a:cs typeface="Arial"/>
+              </a:rPr>
+              <a:t>31 Aug 2026</a:t>
+            </a:r>
+            <a:r>
+              <a:rPr sz="1275" b="0">
+                <a:solidFill>
+                  <a:srgbClr val="607077"/>
+                </a:solidFill>
+                <a:latin typeface="Arial"/>
+                <a:ea typeface="Arial"/>
+                <a:cs typeface="Arial"/>
+              </a:rPr>
+              <a:t>                                      06 / 07</a:t>
             </a:r>
           </a:p>
         </p:txBody>
@@ -4803,6 +4994,7 @@
           <a:lstStyle xmlns:a="http://schemas.openxmlformats.org/drawingml/2006/main"/>
           <a:p xmlns:a="http://schemas.openxmlformats.org/drawingml/2006/main">
             <a:pPr>
+              <a:buNone/>
               <a:defRPr sz="4050" b="1">
                 <a:solidFill>
                   <a:srgbClr val="087F78"/>
@@ -4861,6 +5053,7 @@
           <a:lstStyle xmlns:a="http://schemas.openxmlformats.org/drawingml/2006/main"/>
           <a:p xmlns:a="http://schemas.openxmlformats.org/drawingml/2006/main">
             <a:pPr>
+              <a:buNone/>
               <a:defRPr sz="2325" b="1">
                 <a:solidFill>
                   <a:srgbClr val="101B20"/>
@@ -4919,6 +5112,7 @@
           <a:lstStyle xmlns:a="http://schemas.openxmlformats.org/drawingml/2006/main"/>
           <a:p xmlns:a="http://schemas.openxmlformats.org/drawingml/2006/main">
             <a:pPr>
+              <a:buNone/>
               <a:defRPr sz="1950" b="0">
                 <a:solidFill>
                   <a:srgbClr val="101B20"/>
@@ -4977,6 +5171,7 @@
           <a:lstStyle xmlns:a="http://schemas.openxmlformats.org/drawingml/2006/main"/>
           <a:p xmlns:a="http://schemas.openxmlformats.org/drawingml/2006/main">
             <a:pPr>
+              <a:buNone/>
               <a:defRPr sz="4050" b="1">
                 <a:solidFill>
                   <a:srgbClr val="087F78"/>
@@ -5035,6 +5230,7 @@
           <a:lstStyle xmlns:a="http://schemas.openxmlformats.org/drawingml/2006/main"/>
           <a:p xmlns:a="http://schemas.openxmlformats.org/drawingml/2006/main">
             <a:pPr>
+              <a:buNone/>
               <a:defRPr sz="2325" b="1">
                 <a:solidFill>
                   <a:srgbClr val="101B20"/>
@@ -5093,6 +5289,7 @@
           <a:lstStyle xmlns:a="http://schemas.openxmlformats.org/drawingml/2006/main"/>
           <a:p xmlns:a="http://schemas.openxmlformats.org/drawingml/2006/main">
             <a:pPr>
+              <a:buNone/>
               <a:defRPr sz="1950" b="0">
                 <a:solidFill>
                   <a:srgbClr val="101B20"/>
@@ -5151,6 +5348,7 @@
           <a:lstStyle xmlns:a="http://schemas.openxmlformats.org/drawingml/2006/main"/>
           <a:p xmlns:a="http://schemas.openxmlformats.org/drawingml/2006/main">
             <a:pPr>
+              <a:buNone/>
               <a:defRPr sz="4050" b="1">
                 <a:solidFill>
                   <a:srgbClr val="087F78"/>
@@ -5209,6 +5407,7 @@
           <a:lstStyle xmlns:a="http://schemas.openxmlformats.org/drawingml/2006/main"/>
           <a:p xmlns:a="http://schemas.openxmlformats.org/drawingml/2006/main">
             <a:pPr>
+              <a:buNone/>
               <a:defRPr sz="2325" b="1">
                 <a:solidFill>
                   <a:srgbClr val="101B20"/>
@@ -5267,6 +5466,7 @@
           <a:lstStyle xmlns:a="http://schemas.openxmlformats.org/drawingml/2006/main"/>
           <a:p xmlns:a="http://schemas.openxmlformats.org/drawingml/2006/main">
             <a:pPr>
+              <a:buNone/>
               <a:defRPr sz="1950" b="0">
                 <a:solidFill>
                   <a:srgbClr val="101B20"/>
@@ -5325,6 +5525,7 @@
           <a:lstStyle xmlns:a="http://schemas.openxmlformats.org/drawingml/2006/main"/>
           <a:p xmlns:a="http://schemas.openxmlformats.org/drawingml/2006/main">
             <a:pPr>
+              <a:buNone/>
               <a:defRPr sz="1650" b="0">
                 <a:solidFill>
                   <a:srgbClr val="607077"/>
@@ -5412,6 +5613,7 @@
           <a:lstStyle xmlns:a="http://schemas.openxmlformats.org/drawingml/2006/main"/>
           <a:p xmlns:a="http://schemas.openxmlformats.org/drawingml/2006/main">
             <a:pPr>
+              <a:buNone/>
               <a:defRPr sz="1425" b="1">
                 <a:solidFill>
                   <a:srgbClr val="68E6DD"/>
@@ -5470,6 +5672,7 @@
           <a:lstStyle xmlns:a="http://schemas.openxmlformats.org/drawingml/2006/main"/>
           <a:p xmlns:a="http://schemas.openxmlformats.org/drawingml/2006/main">
             <a:pPr>
+              <a:buNone/>
               <a:defRPr sz="3600" b="1">
                 <a:solidFill>
                   <a:srgbClr val="FBFCF8"/>
@@ -5528,6 +5731,7 @@
           <a:lstStyle xmlns:a="http://schemas.openxmlformats.org/drawingml/2006/main"/>
           <a:p xmlns:a="http://schemas.openxmlformats.org/drawingml/2006/main">
             <a:pPr>
+              <a:buNone/>
               <a:defRPr sz="1275" b="0">
                 <a:solidFill>
                   <a:srgbClr val="B9CCC7"/>
@@ -5546,7 +5750,29 @@
                 <a:ea typeface="Arial"/>
                 <a:cs typeface="Arial"/>
               </a:rPr>
-              <a:t>HORMUZ  /  Mehrdad Zaker  /  30 Aug 2026                                      07 / 07</a:t>
+              <a:t>HORMUZ  /  Mehrdad Zaker  /  </a:t>
+            </a:r>
+            <a:r>
+              <a:rPr sz="1275" b="0">
+                <a:solidFill>
+                  <a:srgbClr val="B9CCC7"/>
+                </a:solidFill>
+                <a:latin typeface="Arial"/>
+                <a:ea typeface="Arial"/>
+                <a:cs typeface="Arial"/>
+              </a:rPr>
+              <a:t>31 Aug 2026</a:t>
+            </a:r>
+            <a:r>
+              <a:rPr sz="1275" b="0">
+                <a:solidFill>
+                  <a:srgbClr val="B9CCC7"/>
+                </a:solidFill>
+                <a:latin typeface="Arial"/>
+                <a:ea typeface="Arial"/>
+                <a:cs typeface="Arial"/>
+              </a:rPr>
+              <a:t>                                      07 / 07</a:t>
             </a:r>
           </a:p>
         </p:txBody>
@@ -5586,6 +5812,7 @@
           <a:lstStyle xmlns:a="http://schemas.openxmlformats.org/drawingml/2006/main"/>
           <a:p xmlns:a="http://schemas.openxmlformats.org/drawingml/2006/main">
             <a:pPr>
+              <a:buNone/>
               <a:defRPr sz="3300" b="0">
                 <a:solidFill>
                   <a:srgbClr val="FBFCF8"/>
@@ -5609,6 +5836,7 @@
           </a:p>
           <a:p xmlns:a="http://schemas.openxmlformats.org/drawingml/2006/main">
             <a:pPr>
+              <a:buNone/>
               <a:defRPr sz="3300" b="0">
                 <a:solidFill>
                   <a:srgbClr val="FBFCF8"/>
@@ -5632,6 +5860,7 @@
           </a:p>
           <a:p xmlns:a="http://schemas.openxmlformats.org/drawingml/2006/main">
             <a:pPr>
+              <a:buNone/>
               <a:defRPr sz="3300" b="0">
                 <a:solidFill>
                   <a:srgbClr val="FBFCF8"/>
@@ -5690,6 +5919,7 @@
           <a:lstStyle xmlns:a="http://schemas.openxmlformats.org/drawingml/2006/main"/>
           <a:p xmlns:a="http://schemas.openxmlformats.org/drawingml/2006/main">
             <a:pPr>
+              <a:buNone/>
               <a:defRPr sz="2325" b="1">
                 <a:solidFill>
                   <a:srgbClr val="68E6DD"/>
@@ -5713,6 +5943,7 @@
           </a:p>
           <a:p xmlns:a="http://schemas.openxmlformats.org/drawingml/2006/main">
             <a:pPr>
+              <a:buNone/>
               <a:defRPr sz="2325" b="1">
                 <a:solidFill>
                   <a:srgbClr val="68E6DD"/>
@@ -5771,6 +6002,7 @@
           <a:lstStyle xmlns:a="http://schemas.openxmlformats.org/drawingml/2006/main"/>
           <a:p xmlns:a="http://schemas.openxmlformats.org/drawingml/2006/main">
             <a:pPr>
+              <a:buNone/>
               <a:defRPr sz="1875" b="0">
                 <a:solidFill>
                   <a:srgbClr val="D9E1DF"/>
@@ -5789,7 +6021,7 @@
                 <a:ea typeface="Arial"/>
                 <a:cs typeface="Arial"/>
               </a:rPr>
-              <a:t>xpounder-com.github.io/hormuz</a:t>
+              <a:t>usehormuz.github.io</a:t>
             </a:r>
           </a:p>
         </p:txBody>

</xml_diff>

<commit_message>
Build the Hormuz controlled-passage brand across the website and materials
</commit_message>
<xml_diff>
--- a/website/public/downloads/hormuz-buyer-briefing.pptx
+++ b/website/public/downloads/hormuz-buyer-briefing.pptx
@@ -2,19 +2,19 @@
 <file path=ppt/presentation.xml><?xml version="1.0" encoding="utf-8"?>
 <p:presentation xmlns:p="http://schemas.openxmlformats.org/presentationml/2006/main">
   <p:sldMasterIdLst>
-    <p:sldMasterId xmlns:r="http://schemas.openxmlformats.org/officeDocument/2006/relationships" id="2147483648" r:id="R864f688023be417b"/>
+    <p:sldMasterId xmlns:r="http://schemas.openxmlformats.org/officeDocument/2006/relationships" id="2147483648" r:id="Ra58a792eb9f748a1"/>
   </p:sldMasterIdLst>
   <p:notesMasterIdLst>
-    <p:notesMasterId xmlns:r="http://schemas.openxmlformats.org/officeDocument/2006/relationships" r:id="Ra16e95166cbd4900"/>
+    <p:notesMasterId xmlns:r="http://schemas.openxmlformats.org/officeDocument/2006/relationships" r:id="Rff52f76960504176"/>
   </p:notesMasterIdLst>
   <p:sldIdLst>
-    <p:sldId xmlns:r="http://schemas.openxmlformats.org/officeDocument/2006/relationships" id="256" r:id="Rfbd4cc0a9591479d"/>
-    <p:sldId xmlns:r="http://schemas.openxmlformats.org/officeDocument/2006/relationships" id="257" r:id="Rc413cb69a1354a18"/>
-    <p:sldId xmlns:r="http://schemas.openxmlformats.org/officeDocument/2006/relationships" id="258" r:id="Rcb314aa38d2f4487"/>
-    <p:sldId xmlns:r="http://schemas.openxmlformats.org/officeDocument/2006/relationships" id="259" r:id="Ref6c1433c1414a08"/>
-    <p:sldId xmlns:r="http://schemas.openxmlformats.org/officeDocument/2006/relationships" id="260" r:id="Rc4d8c75b472b4152"/>
-    <p:sldId xmlns:r="http://schemas.openxmlformats.org/officeDocument/2006/relationships" id="261" r:id="R7ae6b24e897d4eda"/>
-    <p:sldId xmlns:r="http://schemas.openxmlformats.org/officeDocument/2006/relationships" id="262" r:id="R96df3d5743a347e2"/>
+    <p:sldId xmlns:r="http://schemas.openxmlformats.org/officeDocument/2006/relationships" id="256" r:id="R7ccfffa425794952"/>
+    <p:sldId xmlns:r="http://schemas.openxmlformats.org/officeDocument/2006/relationships" id="257" r:id="Ra1cef080f5cd484b"/>
+    <p:sldId xmlns:r="http://schemas.openxmlformats.org/officeDocument/2006/relationships" id="258" r:id="Ra7bcd4de67484574"/>
+    <p:sldId xmlns:r="http://schemas.openxmlformats.org/officeDocument/2006/relationships" id="259" r:id="R1cd4d01bb4c348fc"/>
+    <p:sldId xmlns:r="http://schemas.openxmlformats.org/officeDocument/2006/relationships" id="260" r:id="R2e05c9081aa4453d"/>
+    <p:sldId xmlns:r="http://schemas.openxmlformats.org/officeDocument/2006/relationships" id="261" r:id="R42e74a7881c34e99"/>
+    <p:sldId xmlns:r="http://schemas.openxmlformats.org/officeDocument/2006/relationships" id="262" r:id="R8c2582dc1d95408c"/>
   </p:sldIdLst>
   <p:sldSz cx="12192000" cy="6858000"/>
   <p:notesSz cx="6858000" cy="9144000"/>
@@ -1116,7 +1116,7 @@
   </p:cSld>
   <p:clrMap bg1="lt1" tx1="dk1" bg2="lt2" tx2="dk2" accent1="accent1" accent2="accent2" accent3="accent3" accent4="accent4" accent5="accent5" accent6="accent6" hlink="hlink" folHlink="folHlink"/>
   <p:sldLayoutIdLst>
-    <p:sldLayoutId xmlns:r="http://schemas.openxmlformats.org/officeDocument/2006/relationships" id="2147483649" r:id="R0a4284ef4ceb4b5c"/>
+    <p:sldLayoutId xmlns:r="http://schemas.openxmlformats.org/officeDocument/2006/relationships" id="2147483649" r:id="R3660d6fd5adc45c1"/>
   </p:sldLayoutIdLst>
   <p:txStyles>
     <p:titleStyle>
@@ -1649,7 +1649,7 @@
     <p:bg>
       <p:bgPr>
         <a:solidFill xmlns:a="http://schemas.openxmlformats.org/drawingml/2006/main">
-          <a:srgbClr val="07171A"/>
+          <a:srgbClr val="24392D"/>
         </a:solidFill>
       </p:bgPr>
     </p:bg>
@@ -1664,10 +1664,137 @@
       </p:grpSpPr>
       <p:sp>
         <p:nvSpPr>
-          <p:cNvPr id="6" name="section">
-            <a:extLst xmlns:a="http://schemas.openxmlformats.org/drawingml/2006/main">
-              <a:ext uri="{FF2B5EF4-FFF2-40B4-BE49-F238E27FC236}">
-                <a16:creationId xmlns:a16="http://schemas.microsoft.com/office/drawing/2014/main" id="{B6313DAF-C2D8-4A54-B78A-5B13336FD4C1}"/>
+          <p:cNvPr id="10" name="Hormuz mark boundary">
+            <a:extLst xmlns:a="http://schemas.openxmlformats.org/drawingml/2006/main">
+              <a:ext uri="{FF2B5EF4-FFF2-40B4-BE49-F238E27FC236}">
+                <a16:creationId xmlns:a16="http://schemas.microsoft.com/office/drawing/2014/main" id="{C6B9E46E-061A-4D5C-82B8-8682FFAAAB4C}"/>
+              </a:ext>
+            </a:extLst>
+          </p:cNvPr>
+          <p:cNvSpPr>
+            <a:spLocks xmlns:a="http://schemas.openxmlformats.org/drawingml/2006/main" noGrp="1"/>
+          </p:cNvSpPr>
+          <p:nvPr/>
+        </p:nvSpPr>
+        <p:spPr>
+          <a:xfrm xmlns:a="http://schemas.openxmlformats.org/drawingml/2006/main">
+            <a:off x="11201400" y="333375"/>
+            <a:ext cx="381000" cy="381000"/>
+          </a:xfrm>
+          <a:prstGeom xmlns:a="http://schemas.openxmlformats.org/drawingml/2006/main" prst="ellipse">
+            <a:avLst/>
+          </a:prstGeom>
+          <a:noFill xmlns:a="http://schemas.openxmlformats.org/drawingml/2006/main"/>
+          <a:ln xmlns:a="http://schemas.openxmlformats.org/drawingml/2006/main" w="9525">
+            <a:solidFill>
+              <a:srgbClr val="DCEDA6"/>
+            </a:solidFill>
+            <a:prstDash val="solid"/>
+          </a:ln>
+        </p:spPr>
+      </p:sp>
+      <p:sp>
+        <p:nvSpPr>
+          <p:cNvPr id="2" name="Hormuz mark bar 1">
+            <a:extLst xmlns:a="http://schemas.openxmlformats.org/drawingml/2006/main">
+              <a:ext uri="{FF2B5EF4-FFF2-40B4-BE49-F238E27FC236}">
+                <a16:creationId xmlns:a16="http://schemas.microsoft.com/office/drawing/2014/main" id="{C537582A-8AC9-4C27-91E2-439F78ED5DC1}"/>
+              </a:ext>
+            </a:extLst>
+          </p:cNvPr>
+          <p:cNvSpPr>
+            <a:spLocks xmlns:a="http://schemas.openxmlformats.org/drawingml/2006/main" noGrp="1"/>
+          </p:cNvSpPr>
+          <p:nvPr/>
+        </p:nvSpPr>
+        <p:spPr>
+          <a:xfrm xmlns:a="http://schemas.openxmlformats.org/drawingml/2006/main">
+            <a:off x="11287125" y="476250"/>
+            <a:ext cx="47625" cy="95250"/>
+          </a:xfrm>
+          <a:prstGeom xmlns:a="http://schemas.openxmlformats.org/drawingml/2006/main" prst="roundRect">
+            <a:avLst>
+              <a:gd name="adj" fmla="val 50000"/>
+            </a:avLst>
+          </a:prstGeom>
+          <a:solidFill xmlns:a="http://schemas.openxmlformats.org/drawingml/2006/main">
+            <a:srgbClr val="DCEDA6"/>
+          </a:solidFill>
+          <a:ln xmlns:a="http://schemas.openxmlformats.org/drawingml/2006/main" w="0">
+            <a:noFill/>
+          </a:ln>
+        </p:spPr>
+      </p:sp>
+      <p:sp>
+        <p:nvSpPr>
+          <p:cNvPr id="3" name="Hormuz mark bar 2">
+            <a:extLst xmlns:a="http://schemas.openxmlformats.org/drawingml/2006/main">
+              <a:ext uri="{FF2B5EF4-FFF2-40B4-BE49-F238E27FC236}">
+                <a16:creationId xmlns:a16="http://schemas.microsoft.com/office/drawing/2014/main" id="{7D2D332A-6CA9-4953-9BFF-A5F722B5A01C}"/>
+              </a:ext>
+            </a:extLst>
+          </p:cNvPr>
+          <p:cNvSpPr>
+            <a:spLocks xmlns:a="http://schemas.openxmlformats.org/drawingml/2006/main" noGrp="1"/>
+          </p:cNvSpPr>
+          <p:nvPr/>
+        </p:nvSpPr>
+        <p:spPr>
+          <a:xfrm xmlns:a="http://schemas.openxmlformats.org/drawingml/2006/main">
+            <a:off x="11363325" y="428625"/>
+            <a:ext cx="47625" cy="190500"/>
+          </a:xfrm>
+          <a:prstGeom xmlns:a="http://schemas.openxmlformats.org/drawingml/2006/main" prst="roundRect">
+            <a:avLst>
+              <a:gd name="adj" fmla="val 50000"/>
+            </a:avLst>
+          </a:prstGeom>
+          <a:solidFill xmlns:a="http://schemas.openxmlformats.org/drawingml/2006/main">
+            <a:srgbClr val="DCEDA6"/>
+          </a:solidFill>
+          <a:ln xmlns:a="http://schemas.openxmlformats.org/drawingml/2006/main" w="0">
+            <a:noFill/>
+          </a:ln>
+        </p:spPr>
+      </p:sp>
+      <p:sp>
+        <p:nvSpPr>
+          <p:cNvPr id="4" name="Hormuz mark bar 3">
+            <a:extLst xmlns:a="http://schemas.openxmlformats.org/drawingml/2006/main">
+              <a:ext uri="{FF2B5EF4-FFF2-40B4-BE49-F238E27FC236}">
+                <a16:creationId xmlns:a16="http://schemas.microsoft.com/office/drawing/2014/main" id="{5BC66629-64FE-44A2-BD8B-52BC59971833}"/>
+              </a:ext>
+            </a:extLst>
+          </p:cNvPr>
+          <p:cNvSpPr>
+            <a:spLocks xmlns:a="http://schemas.openxmlformats.org/drawingml/2006/main" noGrp="1"/>
+          </p:cNvSpPr>
+          <p:nvPr/>
+        </p:nvSpPr>
+        <p:spPr>
+          <a:xfrm xmlns:a="http://schemas.openxmlformats.org/drawingml/2006/main">
+            <a:off x="11439525" y="457200"/>
+            <a:ext cx="47625" cy="133350"/>
+          </a:xfrm>
+          <a:prstGeom xmlns:a="http://schemas.openxmlformats.org/drawingml/2006/main" prst="roundRect">
+            <a:avLst>
+              <a:gd name="adj" fmla="val 50000"/>
+            </a:avLst>
+          </a:prstGeom>
+          <a:solidFill xmlns:a="http://schemas.openxmlformats.org/drawingml/2006/main">
+            <a:srgbClr val="DCEDA6"/>
+          </a:solidFill>
+          <a:ln xmlns:a="http://schemas.openxmlformats.org/drawingml/2006/main" w="0">
+            <a:noFill/>
+          </a:ln>
+        </p:spPr>
+      </p:sp>
+      <p:sp>
+        <p:nvSpPr>
+          <p:cNvPr id="5" name="section">
+            <a:extLst xmlns:a="http://schemas.openxmlformats.org/drawingml/2006/main">
+              <a:ext uri="{FF2B5EF4-FFF2-40B4-BE49-F238E27FC236}">
+                <a16:creationId xmlns:a16="http://schemas.microsoft.com/office/drawing/2014/main" id="{D2671048-3259-40FE-9154-6A2D7246F4E5}"/>
               </a:ext>
             </a:extLst>
           </p:cNvPr>
@@ -1697,10 +1824,9 @@
           <a:lstStyle xmlns:a="http://schemas.openxmlformats.org/drawingml/2006/main"/>
           <a:p xmlns:a="http://schemas.openxmlformats.org/drawingml/2006/main">
             <a:pPr>
-              <a:buNone/>
               <a:defRPr sz="1425" b="1">
                 <a:solidFill>
-                  <a:srgbClr val="68E6DD"/>
+                  <a:srgbClr val="DCEDA6"/>
                 </a:solidFill>
                 <a:latin typeface="Arial"/>
                 <a:ea typeface="Arial"/>
@@ -1710,7 +1836,7 @@
             <a:r>
               <a:rPr sz="1425" b="1">
                 <a:solidFill>
-                  <a:srgbClr val="68E6DD"/>
+                  <a:srgbClr val="DCEDA6"/>
                 </a:solidFill>
                 <a:latin typeface="Arial"/>
                 <a:ea typeface="Arial"/>
@@ -1723,10 +1849,10 @@
       </p:sp>
       <p:sp>
         <p:nvSpPr>
-          <p:cNvPr id="2" name="footer">
-            <a:extLst xmlns:a="http://schemas.openxmlformats.org/drawingml/2006/main">
-              <a:ext uri="{FF2B5EF4-FFF2-40B4-BE49-F238E27FC236}">
-                <a16:creationId xmlns:a16="http://schemas.microsoft.com/office/drawing/2014/main" id="{77F8F306-41B6-4F48-BC9F-13E4A0FDF6BE}"/>
+          <p:cNvPr id="6" name="footer">
+            <a:extLst xmlns:a="http://schemas.openxmlformats.org/drawingml/2006/main">
+              <a:ext uri="{FF2B5EF4-FFF2-40B4-BE49-F238E27FC236}">
+                <a16:creationId xmlns:a16="http://schemas.microsoft.com/office/drawing/2014/main" id="{B28698F4-B9C0-4E60-8363-FE63B8E104D2}"/>
               </a:ext>
             </a:extLst>
           </p:cNvPr>
@@ -1756,10 +1882,9 @@
           <a:lstStyle xmlns:a="http://schemas.openxmlformats.org/drawingml/2006/main"/>
           <a:p xmlns:a="http://schemas.openxmlformats.org/drawingml/2006/main">
             <a:pPr>
-              <a:buNone/>
               <a:defRPr sz="1275" b="0">
                 <a:solidFill>
-                  <a:srgbClr val="B9CCC7"/>
+                  <a:srgbClr val="DCE6D5"/>
                 </a:solidFill>
                 <a:latin typeface="Arial"/>
                 <a:ea typeface="Arial"/>
@@ -1769,45 +1894,23 @@
             <a:r>
               <a:rPr sz="1275" b="0">
                 <a:solidFill>
-                  <a:srgbClr val="B9CCC7"/>
-                </a:solidFill>
-                <a:latin typeface="Arial"/>
-                <a:ea typeface="Arial"/>
-                <a:cs typeface="Arial"/>
-              </a:rPr>
-              <a:t>HORMUZ  /  Mehrdad Zaker  /  </a:t>
-            </a:r>
-            <a:r>
-              <a:rPr sz="1275" b="0">
-                <a:solidFill>
-                  <a:srgbClr val="B9CCC7"/>
-                </a:solidFill>
-                <a:latin typeface="Arial"/>
-                <a:ea typeface="Arial"/>
-                <a:cs typeface="Arial"/>
-              </a:rPr>
-              <a:t>31 Aug 2026</a:t>
-            </a:r>
-            <a:r>
-              <a:rPr sz="1275" b="0">
-                <a:solidFill>
-                  <a:srgbClr val="B9CCC7"/>
-                </a:solidFill>
-                <a:latin typeface="Arial"/>
-                <a:ea typeface="Arial"/>
-                <a:cs typeface="Arial"/>
-              </a:rPr>
-              <a:t>                                      01 / 07</a:t>
-            </a:r>
-          </a:p>
-        </p:txBody>
-      </p:sp>
-      <p:sp>
-        <p:nvSpPr>
-          <p:cNvPr id="3" name="cover-title">
-            <a:extLst xmlns:a="http://schemas.openxmlformats.org/drawingml/2006/main">
-              <a:ext uri="{FF2B5EF4-FFF2-40B4-BE49-F238E27FC236}">
-                <a16:creationId xmlns:a16="http://schemas.microsoft.com/office/drawing/2014/main" id="{8CBF09BF-1C91-4C3C-A15E-E9C78B2B70AA}"/>
+                  <a:srgbClr val="DCE6D5"/>
+                </a:solidFill>
+                <a:latin typeface="Arial"/>
+                <a:ea typeface="Arial"/>
+                <a:cs typeface="Arial"/>
+              </a:rPr>
+              <a:t>HORMUZ  /  Mehrdad Zaker  /  September 2026                                      01 / 07</a:t>
+            </a:r>
+          </a:p>
+        </p:txBody>
+      </p:sp>
+      <p:sp>
+        <p:nvSpPr>
+          <p:cNvPr id="7" name="cover-title">
+            <a:extLst xmlns:a="http://schemas.openxmlformats.org/drawingml/2006/main">
+              <a:ext uri="{FF2B5EF4-FFF2-40B4-BE49-F238E27FC236}">
+                <a16:creationId xmlns:a16="http://schemas.microsoft.com/office/drawing/2014/main" id="{AA1A8ABC-C81E-409A-AD7D-7DB1A24B0FB5}"/>
               </a:ext>
             </a:extLst>
           </p:cNvPr>
@@ -1837,60 +1940,58 @@
           <a:lstStyle xmlns:a="http://schemas.openxmlformats.org/drawingml/2006/main"/>
           <a:p xmlns:a="http://schemas.openxmlformats.org/drawingml/2006/main">
             <a:pPr>
-              <a:buNone/>
-              <a:defRPr sz="5100" b="1">
-                <a:solidFill>
-                  <a:srgbClr val="FBFCF8"/>
-                </a:solidFill>
-                <a:latin typeface="Arial"/>
-                <a:ea typeface="Arial"/>
-                <a:cs typeface="Arial"/>
-              </a:defRPr>
-            </a:pPr>
-            <a:r>
-              <a:rPr sz="5100" b="1">
-                <a:solidFill>
-                  <a:srgbClr val="FBFCF8"/>
-                </a:solidFill>
-                <a:latin typeface="Arial"/>
-                <a:ea typeface="Arial"/>
-                <a:cs typeface="Arial"/>
-              </a:rPr>
-              <a:t>Keep the coding clients.</a:t>
-            </a:r>
-          </a:p>
-          <a:p xmlns:a="http://schemas.openxmlformats.org/drawingml/2006/main">
-            <a:pPr>
-              <a:buNone/>
-              <a:defRPr sz="5100" b="1">
-                <a:solidFill>
-                  <a:srgbClr val="FBFCF8"/>
-                </a:solidFill>
-                <a:latin typeface="Arial"/>
-                <a:ea typeface="Arial"/>
-                <a:cs typeface="Arial"/>
-              </a:defRPr>
-            </a:pPr>
-            <a:r>
-              <a:rPr sz="5100" b="1">
-                <a:solidFill>
-                  <a:srgbClr val="FBFCF8"/>
-                </a:solidFill>
-                <a:latin typeface="Arial"/>
-                <a:ea typeface="Arial"/>
-                <a:cs typeface="Arial"/>
-              </a:rPr>
-              <a:t>Govern their model requests.</a:t>
-            </a:r>
-          </a:p>
-        </p:txBody>
-      </p:sp>
-      <p:sp>
-        <p:nvSpPr>
-          <p:cNvPr id="4" name="cover-summary">
-            <a:extLst xmlns:a="http://schemas.openxmlformats.org/drawingml/2006/main">
-              <a:ext uri="{FF2B5EF4-FFF2-40B4-BE49-F238E27FC236}">
-                <a16:creationId xmlns:a16="http://schemas.microsoft.com/office/drawing/2014/main" id="{1AAE38A0-44B5-410D-B933-4749374D6190}"/>
+              <a:defRPr sz="5700" b="1">
+                <a:solidFill>
+                  <a:srgbClr val="FAFBF6"/>
+                </a:solidFill>
+                <a:latin typeface="Arial"/>
+                <a:ea typeface="Arial"/>
+                <a:cs typeface="Arial"/>
+              </a:defRPr>
+            </a:pPr>
+            <a:r>
+              <a:rPr sz="5700" b="1">
+                <a:solidFill>
+                  <a:srgbClr val="FAFBF6"/>
+                </a:solidFill>
+                <a:latin typeface="Arial"/>
+                <a:ea typeface="Arial"/>
+                <a:cs typeface="Arial"/>
+              </a:rPr>
+              <a:t>Give your team AI.</a:t>
+            </a:r>
+          </a:p>
+          <a:p xmlns:a="http://schemas.openxmlformats.org/drawingml/2006/main">
+            <a:pPr>
+              <a:defRPr sz="5700" b="1">
+                <a:solidFill>
+                  <a:srgbClr val="FAFBF6"/>
+                </a:solidFill>
+                <a:latin typeface="Arial"/>
+                <a:ea typeface="Arial"/>
+                <a:cs typeface="Arial"/>
+              </a:defRPr>
+            </a:pPr>
+            <a:r>
+              <a:rPr sz="5700" b="1">
+                <a:solidFill>
+                  <a:srgbClr val="FAFBF6"/>
+                </a:solidFill>
+                <a:latin typeface="Arial"/>
+                <a:ea typeface="Arial"/>
+                <a:cs typeface="Arial"/>
+              </a:rPr>
+              <a:t>Keep control.</a:t>
+            </a:r>
+          </a:p>
+        </p:txBody>
+      </p:sp>
+      <p:sp>
+        <p:nvSpPr>
+          <p:cNvPr id="8" name="cover-summary">
+            <a:extLst xmlns:a="http://schemas.openxmlformats.org/drawingml/2006/main">
+              <a:ext uri="{FF2B5EF4-FFF2-40B4-BE49-F238E27FC236}">
+                <a16:creationId xmlns:a16="http://schemas.microsoft.com/office/drawing/2014/main" id="{13D1DF7D-FFFD-4A29-B8EE-0FFAF8E39172}"/>
               </a:ext>
             </a:extLst>
           </p:cNvPr>
@@ -1920,7 +2021,6 @@
           <a:lstStyle xmlns:a="http://schemas.openxmlformats.org/drawingml/2006/main"/>
           <a:p xmlns:a="http://schemas.openxmlformats.org/drawingml/2006/main">
             <a:pPr>
-              <a:buNone/>
               <a:defRPr sz="2325" b="0">
                 <a:solidFill>
                   <a:srgbClr val="D9E1DF"/>
@@ -1944,7 +2044,6 @@
           </a:p>
           <a:p xmlns:a="http://schemas.openxmlformats.org/drawingml/2006/main">
             <a:pPr>
-              <a:buNone/>
               <a:defRPr sz="2325" b="0">
                 <a:solidFill>
                   <a:srgbClr val="D9E1DF"/>
@@ -1970,10 +2069,10 @@
       </p:sp>
       <p:sp>
         <p:nvSpPr>
-          <p:cNvPr id="5" name="cover-boundary">
-            <a:extLst xmlns:a="http://schemas.openxmlformats.org/drawingml/2006/main">
-              <a:ext uri="{FF2B5EF4-FFF2-40B4-BE49-F238E27FC236}">
-                <a16:creationId xmlns:a16="http://schemas.microsoft.com/office/drawing/2014/main" id="{501A57EB-1A2D-4F81-9F95-5E3A8F9708B7}"/>
+          <p:cNvPr id="9" name="cover-boundary">
+            <a:extLst xmlns:a="http://schemas.openxmlformats.org/drawingml/2006/main">
+              <a:ext uri="{FF2B5EF4-FFF2-40B4-BE49-F238E27FC236}">
+                <a16:creationId xmlns:a16="http://schemas.microsoft.com/office/drawing/2014/main" id="{827AD065-2713-4FFF-8235-79A85510AF8E}"/>
               </a:ext>
             </a:extLst>
           </p:cNvPr>
@@ -2003,10 +2102,9 @@
           <a:lstStyle xmlns:a="http://schemas.openxmlformats.org/drawingml/2006/main"/>
           <a:p xmlns:a="http://schemas.openxmlformats.org/drawingml/2006/main">
             <a:pPr>
-              <a:buNone/>
               <a:defRPr sz="1875" b="1">
                 <a:solidFill>
-                  <a:srgbClr val="68E6DD"/>
+                  <a:srgbClr val="DCEDA6"/>
                 </a:solidFill>
                 <a:latin typeface="Arial"/>
                 <a:ea typeface="Arial"/>
@@ -2016,7 +2114,7 @@
             <a:r>
               <a:rPr sz="1875" b="1">
                 <a:solidFill>
-                  <a:srgbClr val="68E6DD"/>
+                  <a:srgbClr val="DCEDA6"/>
                 </a:solidFill>
                 <a:latin typeface="Arial"/>
                 <a:ea typeface="Arial"/>
@@ -2030,7 +2128,7 @@
     </p:spTree>
     <p:extLst>
       <p:ext uri="{BB962C8B-B14F-4D97-AF65-F5344CB8AC3E}">
-        <p14:creationId xmlns:p14="http://schemas.microsoft.com/office/powerpoint/2010/main" val="2008647847"/>
+        <p14:creationId xmlns:p14="http://schemas.microsoft.com/office/powerpoint/2010/main" val="274228205"/>
       </p:ext>
     </p:extLst>
   </p:cSld>
@@ -2043,7 +2141,7 @@
     <p:bg>
       <p:bgPr>
         <a:solidFill xmlns:a="http://schemas.openxmlformats.org/drawingml/2006/main">
-          <a:srgbClr val="F4F4EF"/>
+          <a:srgbClr val="F4F3EE"/>
         </a:solidFill>
       </p:bgPr>
     </p:bg>
@@ -2058,10 +2156,137 @@
       </p:grpSpPr>
       <p:sp>
         <p:nvSpPr>
-          <p:cNvPr id="17" name="section">
-            <a:extLst xmlns:a="http://schemas.openxmlformats.org/drawingml/2006/main">
-              <a:ext uri="{FF2B5EF4-FFF2-40B4-BE49-F238E27FC236}">
-                <a16:creationId xmlns:a16="http://schemas.microsoft.com/office/drawing/2014/main" id="{015FA848-9B1D-4D2D-8B00-0F11D297FA7C}"/>
+          <p:cNvPr id="21" name="Hormuz mark boundary">
+            <a:extLst xmlns:a="http://schemas.openxmlformats.org/drawingml/2006/main">
+              <a:ext uri="{FF2B5EF4-FFF2-40B4-BE49-F238E27FC236}">
+                <a16:creationId xmlns:a16="http://schemas.microsoft.com/office/drawing/2014/main" id="{9DC2F23B-2BDC-4C2E-A316-1B3211C52606}"/>
+              </a:ext>
+            </a:extLst>
+          </p:cNvPr>
+          <p:cNvSpPr>
+            <a:spLocks xmlns:a="http://schemas.openxmlformats.org/drawingml/2006/main" noGrp="1"/>
+          </p:cNvSpPr>
+          <p:nvPr/>
+        </p:nvSpPr>
+        <p:spPr>
+          <a:xfrm xmlns:a="http://schemas.openxmlformats.org/drawingml/2006/main">
+            <a:off x="11201400" y="333375"/>
+            <a:ext cx="381000" cy="381000"/>
+          </a:xfrm>
+          <a:prstGeom xmlns:a="http://schemas.openxmlformats.org/drawingml/2006/main" prst="ellipse">
+            <a:avLst/>
+          </a:prstGeom>
+          <a:noFill xmlns:a="http://schemas.openxmlformats.org/drawingml/2006/main"/>
+          <a:ln xmlns:a="http://schemas.openxmlformats.org/drawingml/2006/main" w="9525">
+            <a:solidFill>
+              <a:srgbClr val="31684B"/>
+            </a:solidFill>
+            <a:prstDash val="solid"/>
+          </a:ln>
+        </p:spPr>
+      </p:sp>
+      <p:sp>
+        <p:nvSpPr>
+          <p:cNvPr id="2" name="Hormuz mark bar 1">
+            <a:extLst xmlns:a="http://schemas.openxmlformats.org/drawingml/2006/main">
+              <a:ext uri="{FF2B5EF4-FFF2-40B4-BE49-F238E27FC236}">
+                <a16:creationId xmlns:a16="http://schemas.microsoft.com/office/drawing/2014/main" id="{3974FD04-8C31-4FF8-B519-C23EA3ECD2A1}"/>
+              </a:ext>
+            </a:extLst>
+          </p:cNvPr>
+          <p:cNvSpPr>
+            <a:spLocks xmlns:a="http://schemas.openxmlformats.org/drawingml/2006/main" noGrp="1"/>
+          </p:cNvSpPr>
+          <p:nvPr/>
+        </p:nvSpPr>
+        <p:spPr>
+          <a:xfrm xmlns:a="http://schemas.openxmlformats.org/drawingml/2006/main">
+            <a:off x="11287125" y="476250"/>
+            <a:ext cx="47625" cy="95250"/>
+          </a:xfrm>
+          <a:prstGeom xmlns:a="http://schemas.openxmlformats.org/drawingml/2006/main" prst="roundRect">
+            <a:avLst>
+              <a:gd name="adj" fmla="val 50000"/>
+            </a:avLst>
+          </a:prstGeom>
+          <a:solidFill xmlns:a="http://schemas.openxmlformats.org/drawingml/2006/main">
+            <a:srgbClr val="31684B"/>
+          </a:solidFill>
+          <a:ln xmlns:a="http://schemas.openxmlformats.org/drawingml/2006/main" w="0">
+            <a:noFill/>
+          </a:ln>
+        </p:spPr>
+      </p:sp>
+      <p:sp>
+        <p:nvSpPr>
+          <p:cNvPr id="3" name="Hormuz mark bar 2">
+            <a:extLst xmlns:a="http://schemas.openxmlformats.org/drawingml/2006/main">
+              <a:ext uri="{FF2B5EF4-FFF2-40B4-BE49-F238E27FC236}">
+                <a16:creationId xmlns:a16="http://schemas.microsoft.com/office/drawing/2014/main" id="{A500391C-75EE-4941-8568-84F15E22BBE4}"/>
+              </a:ext>
+            </a:extLst>
+          </p:cNvPr>
+          <p:cNvSpPr>
+            <a:spLocks xmlns:a="http://schemas.openxmlformats.org/drawingml/2006/main" noGrp="1"/>
+          </p:cNvSpPr>
+          <p:nvPr/>
+        </p:nvSpPr>
+        <p:spPr>
+          <a:xfrm xmlns:a="http://schemas.openxmlformats.org/drawingml/2006/main">
+            <a:off x="11363325" y="428625"/>
+            <a:ext cx="47625" cy="190500"/>
+          </a:xfrm>
+          <a:prstGeom xmlns:a="http://schemas.openxmlformats.org/drawingml/2006/main" prst="roundRect">
+            <a:avLst>
+              <a:gd name="adj" fmla="val 50000"/>
+            </a:avLst>
+          </a:prstGeom>
+          <a:solidFill xmlns:a="http://schemas.openxmlformats.org/drawingml/2006/main">
+            <a:srgbClr val="31684B"/>
+          </a:solidFill>
+          <a:ln xmlns:a="http://schemas.openxmlformats.org/drawingml/2006/main" w="0">
+            <a:noFill/>
+          </a:ln>
+        </p:spPr>
+      </p:sp>
+      <p:sp>
+        <p:nvSpPr>
+          <p:cNvPr id="4" name="Hormuz mark bar 3">
+            <a:extLst xmlns:a="http://schemas.openxmlformats.org/drawingml/2006/main">
+              <a:ext uri="{FF2B5EF4-FFF2-40B4-BE49-F238E27FC236}">
+                <a16:creationId xmlns:a16="http://schemas.microsoft.com/office/drawing/2014/main" id="{E51702F0-D634-457B-9BB6-22341D3E4534}"/>
+              </a:ext>
+            </a:extLst>
+          </p:cNvPr>
+          <p:cNvSpPr>
+            <a:spLocks xmlns:a="http://schemas.openxmlformats.org/drawingml/2006/main" noGrp="1"/>
+          </p:cNvSpPr>
+          <p:nvPr/>
+        </p:nvSpPr>
+        <p:spPr>
+          <a:xfrm xmlns:a="http://schemas.openxmlformats.org/drawingml/2006/main">
+            <a:off x="11439525" y="457200"/>
+            <a:ext cx="47625" cy="133350"/>
+          </a:xfrm>
+          <a:prstGeom xmlns:a="http://schemas.openxmlformats.org/drawingml/2006/main" prst="roundRect">
+            <a:avLst>
+              <a:gd name="adj" fmla="val 50000"/>
+            </a:avLst>
+          </a:prstGeom>
+          <a:solidFill xmlns:a="http://schemas.openxmlformats.org/drawingml/2006/main">
+            <a:srgbClr val="31684B"/>
+          </a:solidFill>
+          <a:ln xmlns:a="http://schemas.openxmlformats.org/drawingml/2006/main" w="0">
+            <a:noFill/>
+          </a:ln>
+        </p:spPr>
+      </p:sp>
+      <p:sp>
+        <p:nvSpPr>
+          <p:cNvPr id="5" name="section">
+            <a:extLst xmlns:a="http://schemas.openxmlformats.org/drawingml/2006/main">
+              <a:ext uri="{FF2B5EF4-FFF2-40B4-BE49-F238E27FC236}">
+                <a16:creationId xmlns:a16="http://schemas.microsoft.com/office/drawing/2014/main" id="{FD27D398-BC93-4B1D-B5F1-CE1B797F0D46}"/>
               </a:ext>
             </a:extLst>
           </p:cNvPr>
@@ -2091,10 +2316,9 @@
           <a:lstStyle xmlns:a="http://schemas.openxmlformats.org/drawingml/2006/main"/>
           <a:p xmlns:a="http://schemas.openxmlformats.org/drawingml/2006/main">
             <a:pPr>
-              <a:buNone/>
               <a:defRPr sz="1425" b="1">
                 <a:solidFill>
-                  <a:srgbClr val="087F78"/>
+                  <a:srgbClr val="31684B"/>
                 </a:solidFill>
                 <a:latin typeface="Arial"/>
                 <a:ea typeface="Arial"/>
@@ -2104,7 +2328,7 @@
             <a:r>
               <a:rPr sz="1425" b="1">
                 <a:solidFill>
-                  <a:srgbClr val="087F78"/>
+                  <a:srgbClr val="31684B"/>
                 </a:solidFill>
                 <a:latin typeface="Arial"/>
                 <a:ea typeface="Arial"/>
@@ -2117,10 +2341,10 @@
       </p:sp>
       <p:sp>
         <p:nvSpPr>
-          <p:cNvPr id="2" name="takeaway">
-            <a:extLst xmlns:a="http://schemas.openxmlformats.org/drawingml/2006/main">
-              <a:ext uri="{FF2B5EF4-FFF2-40B4-BE49-F238E27FC236}">
-                <a16:creationId xmlns:a16="http://schemas.microsoft.com/office/drawing/2014/main" id="{B9B6AA33-07B0-4A7A-BA8B-8BE4F4CB7BA9}"/>
+          <p:cNvPr id="6" name="takeaway">
+            <a:extLst xmlns:a="http://schemas.openxmlformats.org/drawingml/2006/main">
+              <a:ext uri="{FF2B5EF4-FFF2-40B4-BE49-F238E27FC236}">
+                <a16:creationId xmlns:a16="http://schemas.microsoft.com/office/drawing/2014/main" id="{78015F71-9063-4000-8F20-9E51CB1FEFC7}"/>
               </a:ext>
             </a:extLst>
           </p:cNvPr>
@@ -2150,10 +2374,9 @@
           <a:lstStyle xmlns:a="http://schemas.openxmlformats.org/drawingml/2006/main"/>
           <a:p xmlns:a="http://schemas.openxmlformats.org/drawingml/2006/main">
             <a:pPr>
-              <a:buNone/>
               <a:defRPr sz="3600" b="1">
                 <a:solidFill>
-                  <a:srgbClr val="101B20"/>
+                  <a:srgbClr val="202723"/>
                 </a:solidFill>
                 <a:latin typeface="Arial"/>
                 <a:ea typeface="Arial"/>
@@ -2163,7 +2386,7 @@
             <a:r>
               <a:rPr sz="3600" b="1">
                 <a:solidFill>
-                  <a:srgbClr val="101B20"/>
+                  <a:srgbClr val="202723"/>
                 </a:solidFill>
                 <a:latin typeface="Arial"/>
                 <a:ea typeface="Arial"/>
@@ -2176,10 +2399,10 @@
       </p:sp>
       <p:sp>
         <p:nvSpPr>
-          <p:cNvPr id="3" name="footer">
-            <a:extLst xmlns:a="http://schemas.openxmlformats.org/drawingml/2006/main">
-              <a:ext uri="{FF2B5EF4-FFF2-40B4-BE49-F238E27FC236}">
-                <a16:creationId xmlns:a16="http://schemas.microsoft.com/office/drawing/2014/main" id="{D3D70E60-B6AC-47F2-B3BD-B1A734FA8E35}"/>
+          <p:cNvPr id="7" name="footer">
+            <a:extLst xmlns:a="http://schemas.openxmlformats.org/drawingml/2006/main">
+              <a:ext uri="{FF2B5EF4-FFF2-40B4-BE49-F238E27FC236}">
+                <a16:creationId xmlns:a16="http://schemas.microsoft.com/office/drawing/2014/main" id="{68610D9D-BDBF-4D9B-A018-7DAB67B245F9}"/>
               </a:ext>
             </a:extLst>
           </p:cNvPr>
@@ -2209,10 +2432,9 @@
           <a:lstStyle xmlns:a="http://schemas.openxmlformats.org/drawingml/2006/main"/>
           <a:p xmlns:a="http://schemas.openxmlformats.org/drawingml/2006/main">
             <a:pPr>
-              <a:buNone/>
               <a:defRPr sz="1275" b="0">
                 <a:solidFill>
-                  <a:srgbClr val="607077"/>
+                  <a:srgbClr val="5C6758"/>
                 </a:solidFill>
                 <a:latin typeface="Arial"/>
                 <a:ea typeface="Arial"/>
@@ -2222,45 +2444,23 @@
             <a:r>
               <a:rPr sz="1275" b="0">
                 <a:solidFill>
-                  <a:srgbClr val="607077"/>
-                </a:solidFill>
-                <a:latin typeface="Arial"/>
-                <a:ea typeface="Arial"/>
-                <a:cs typeface="Arial"/>
-              </a:rPr>
-              <a:t>HORMUZ  /  Mehrdad Zaker  /  </a:t>
-            </a:r>
-            <a:r>
-              <a:rPr sz="1275" b="0">
-                <a:solidFill>
-                  <a:srgbClr val="607077"/>
-                </a:solidFill>
-                <a:latin typeface="Arial"/>
-                <a:ea typeface="Arial"/>
-                <a:cs typeface="Arial"/>
-              </a:rPr>
-              <a:t>31 Aug 2026</a:t>
-            </a:r>
-            <a:r>
-              <a:rPr sz="1275" b="0">
-                <a:solidFill>
-                  <a:srgbClr val="607077"/>
-                </a:solidFill>
-                <a:latin typeface="Arial"/>
-                <a:ea typeface="Arial"/>
-                <a:cs typeface="Arial"/>
-              </a:rPr>
-              <a:t>                                      02 / 07</a:t>
-            </a:r>
-          </a:p>
-        </p:txBody>
-      </p:sp>
-      <p:sp>
-        <p:nvSpPr>
-          <p:cNvPr id="4" name="arrow-one">
-            <a:extLst xmlns:a="http://schemas.openxmlformats.org/drawingml/2006/main">
-              <a:ext uri="{FF2B5EF4-FFF2-40B4-BE49-F238E27FC236}">
-                <a16:creationId xmlns:a16="http://schemas.microsoft.com/office/drawing/2014/main" id="{1694C47F-15CD-4D78-8F26-8899CF174972}"/>
+                  <a:srgbClr val="5C6758"/>
+                </a:solidFill>
+                <a:latin typeface="Arial"/>
+                <a:ea typeface="Arial"/>
+                <a:cs typeface="Arial"/>
+              </a:rPr>
+              <a:t>HORMUZ  /  Mehrdad Zaker  /  September 2026                                      02 / 07</a:t>
+            </a:r>
+          </a:p>
+        </p:txBody>
+      </p:sp>
+      <p:sp>
+        <p:nvSpPr>
+          <p:cNvPr id="8" name="arrow-one">
+            <a:extLst xmlns:a="http://schemas.openxmlformats.org/drawingml/2006/main">
+              <a:ext uri="{FF2B5EF4-FFF2-40B4-BE49-F238E27FC236}">
+                <a16:creationId xmlns:a16="http://schemas.microsoft.com/office/drawing/2014/main" id="{8627FC9A-7685-4943-B076-979A3E4E185C}"/>
               </a:ext>
             </a:extLst>
           </p:cNvPr>
@@ -2290,10 +2490,9 @@
           <a:lstStyle xmlns:a="http://schemas.openxmlformats.org/drawingml/2006/main"/>
           <a:p xmlns:a="http://schemas.openxmlformats.org/drawingml/2006/main">
             <a:pPr>
-              <a:buNone/>
               <a:defRPr sz="3450" b="0">
                 <a:solidFill>
-                  <a:srgbClr val="087F78"/>
+                  <a:srgbClr val="31684B"/>
                 </a:solidFill>
                 <a:latin typeface="Arial"/>
                 <a:ea typeface="Arial"/>
@@ -2303,7 +2502,7 @@
             <a:r>
               <a:rPr sz="3450" b="0">
                 <a:solidFill>
-                  <a:srgbClr val="087F78"/>
+                  <a:srgbClr val="31684B"/>
                 </a:solidFill>
                 <a:latin typeface="Arial"/>
                 <a:ea typeface="Arial"/>
@@ -2316,10 +2515,10 @@
       </p:sp>
       <p:sp>
         <p:nvSpPr>
-          <p:cNvPr id="5" name="arrow-two">
-            <a:extLst xmlns:a="http://schemas.openxmlformats.org/drawingml/2006/main">
-              <a:ext uri="{FF2B5EF4-FFF2-40B4-BE49-F238E27FC236}">
-                <a16:creationId xmlns:a16="http://schemas.microsoft.com/office/drawing/2014/main" id="{89D08514-555D-404F-822A-FD2DAA9C995C}"/>
+          <p:cNvPr id="9" name="arrow-two">
+            <a:extLst xmlns:a="http://schemas.openxmlformats.org/drawingml/2006/main">
+              <a:ext uri="{FF2B5EF4-FFF2-40B4-BE49-F238E27FC236}">
+                <a16:creationId xmlns:a16="http://schemas.microsoft.com/office/drawing/2014/main" id="{4D8BECAC-EA68-488C-818C-460CFF8882F5}"/>
               </a:ext>
             </a:extLst>
           </p:cNvPr>
@@ -2349,10 +2548,9 @@
           <a:lstStyle xmlns:a="http://schemas.openxmlformats.org/drawingml/2006/main"/>
           <a:p xmlns:a="http://schemas.openxmlformats.org/drawingml/2006/main">
             <a:pPr>
-              <a:buNone/>
               <a:defRPr sz="3450" b="0">
                 <a:solidFill>
-                  <a:srgbClr val="087F78"/>
+                  <a:srgbClr val="31684B"/>
                 </a:solidFill>
                 <a:latin typeface="Arial"/>
                 <a:ea typeface="Arial"/>
@@ -2362,7 +2560,7 @@
             <a:r>
               <a:rPr sz="3450" b="0">
                 <a:solidFill>
-                  <a:srgbClr val="087F78"/>
+                  <a:srgbClr val="31684B"/>
                 </a:solidFill>
                 <a:latin typeface="Arial"/>
                 <a:ea typeface="Arial"/>
@@ -2375,10 +2573,10 @@
       </p:sp>
       <p:sp>
         <p:nvSpPr>
-          <p:cNvPr id="6" name="EMPLOYEE CLIENT">
-            <a:extLst xmlns:a="http://schemas.openxmlformats.org/drawingml/2006/main">
-              <a:ext uri="{FF2B5EF4-FFF2-40B4-BE49-F238E27FC236}">
-                <a16:creationId xmlns:a16="http://schemas.microsoft.com/office/drawing/2014/main" id="{83D6C773-F1AB-4B39-99AA-0CA5B2A7AB57}"/>
+          <p:cNvPr id="10" name="EMPLOYEE CLIENT">
+            <a:extLst xmlns:a="http://schemas.openxmlformats.org/drawingml/2006/main">
+              <a:ext uri="{FF2B5EF4-FFF2-40B4-BE49-F238E27FC236}">
+                <a16:creationId xmlns:a16="http://schemas.microsoft.com/office/drawing/2014/main" id="{3C747C19-9256-430F-A723-53A6B34CF6F7}"/>
               </a:ext>
             </a:extLst>
           </p:cNvPr>
@@ -2396,11 +2594,11 @@
             <a:avLst/>
           </a:prstGeom>
           <a:solidFill xmlns:a="http://schemas.openxmlformats.org/drawingml/2006/main">
-            <a:srgbClr val="FBFCF8"/>
+            <a:srgbClr val="FAFBF6"/>
           </a:solidFill>
           <a:ln xmlns:a="http://schemas.openxmlformats.org/drawingml/2006/main" w="9525">
             <a:solidFill>
-              <a:srgbClr val="D9E1DF"/>
+              <a:srgbClr val="D4DBCC"/>
             </a:solidFill>
             <a:prstDash val="solid"/>
           </a:ln>
@@ -2408,10 +2606,10 @@
       </p:sp>
       <p:sp>
         <p:nvSpPr>
-          <p:cNvPr id="7" name="EMPLOYEE CLIENT-title">
-            <a:extLst xmlns:a="http://schemas.openxmlformats.org/drawingml/2006/main">
-              <a:ext uri="{FF2B5EF4-FFF2-40B4-BE49-F238E27FC236}">
-                <a16:creationId xmlns:a16="http://schemas.microsoft.com/office/drawing/2014/main" id="{51D00504-71FC-45A2-8DF0-245B294B9D76}"/>
+          <p:cNvPr id="11" name="EMPLOYEE CLIENT-title">
+            <a:extLst xmlns:a="http://schemas.openxmlformats.org/drawingml/2006/main">
+              <a:ext uri="{FF2B5EF4-FFF2-40B4-BE49-F238E27FC236}">
+                <a16:creationId xmlns:a16="http://schemas.microsoft.com/office/drawing/2014/main" id="{A7424B47-425A-4D2D-BCE7-F29BC10282C4}"/>
               </a:ext>
             </a:extLst>
           </p:cNvPr>
@@ -2441,10 +2639,9 @@
           <a:lstStyle xmlns:a="http://schemas.openxmlformats.org/drawingml/2006/main"/>
           <a:p xmlns:a="http://schemas.openxmlformats.org/drawingml/2006/main">
             <a:pPr>
-              <a:buNone/>
               <a:defRPr sz="1650" b="1">
                 <a:solidFill>
-                  <a:srgbClr val="087F78"/>
+                  <a:srgbClr val="31684B"/>
                 </a:solidFill>
                 <a:latin typeface="Arial"/>
                 <a:ea typeface="Arial"/>
@@ -2454,7 +2651,7 @@
             <a:r>
               <a:rPr sz="1650" b="1">
                 <a:solidFill>
-                  <a:srgbClr val="087F78"/>
+                  <a:srgbClr val="31684B"/>
                 </a:solidFill>
                 <a:latin typeface="Arial"/>
                 <a:ea typeface="Arial"/>
@@ -2467,10 +2664,10 @@
       </p:sp>
       <p:sp>
         <p:nvSpPr>
-          <p:cNvPr id="8" name="EMPLOYEE CLIENT-body">
-            <a:extLst xmlns:a="http://schemas.openxmlformats.org/drawingml/2006/main">
-              <a:ext uri="{FF2B5EF4-FFF2-40B4-BE49-F238E27FC236}">
-                <a16:creationId xmlns:a16="http://schemas.microsoft.com/office/drawing/2014/main" id="{0F33EEE6-9C0C-4E01-9A0A-BE5CA6AABC51}"/>
+          <p:cNvPr id="12" name="EMPLOYEE CLIENT-body">
+            <a:extLst xmlns:a="http://schemas.openxmlformats.org/drawingml/2006/main">
+              <a:ext uri="{FF2B5EF4-FFF2-40B4-BE49-F238E27FC236}">
+                <a16:creationId xmlns:a16="http://schemas.microsoft.com/office/drawing/2014/main" id="{59AC9921-B93D-4365-8846-B501545BD5EB}"/>
               </a:ext>
             </a:extLst>
           </p:cNvPr>
@@ -2500,10 +2697,9 @@
           <a:lstStyle xmlns:a="http://schemas.openxmlformats.org/drawingml/2006/main"/>
           <a:p xmlns:a="http://schemas.openxmlformats.org/drawingml/2006/main">
             <a:pPr>
-              <a:buNone/>
               <a:defRPr sz="1800" b="0">
                 <a:solidFill>
-                  <a:srgbClr val="101B20"/>
+                  <a:srgbClr val="202723"/>
                 </a:solidFill>
                 <a:latin typeface="Arial"/>
                 <a:ea typeface="Arial"/>
@@ -2513,7 +2709,7 @@
             <a:r>
               <a:rPr sz="1800" b="0">
                 <a:solidFill>
-                  <a:srgbClr val="101B20"/>
+                  <a:srgbClr val="202723"/>
                 </a:solidFill>
                 <a:latin typeface="Arial"/>
                 <a:ea typeface="Arial"/>
@@ -2524,10 +2720,9 @@
           </a:p>
           <a:p xmlns:a="http://schemas.openxmlformats.org/drawingml/2006/main">
             <a:pPr>
-              <a:buNone/>
               <a:defRPr sz="1800" b="0">
                 <a:solidFill>
-                  <a:srgbClr val="101B20"/>
+                  <a:srgbClr val="202723"/>
                 </a:solidFill>
                 <a:latin typeface="Arial"/>
                 <a:ea typeface="Arial"/>
@@ -2537,7 +2732,7 @@
             <a:r>
               <a:rPr sz="1800" b="0">
                 <a:solidFill>
-                  <a:srgbClr val="101B20"/>
+                  <a:srgbClr val="202723"/>
                 </a:solidFill>
                 <a:latin typeface="Arial"/>
                 <a:ea typeface="Arial"/>
@@ -2550,10 +2745,10 @@
       </p:sp>
       <p:sp>
         <p:nvSpPr>
-          <p:cNvPr id="9" name="HORMUZ">
-            <a:extLst xmlns:a="http://schemas.openxmlformats.org/drawingml/2006/main">
-              <a:ext uri="{FF2B5EF4-FFF2-40B4-BE49-F238E27FC236}">
-                <a16:creationId xmlns:a16="http://schemas.microsoft.com/office/drawing/2014/main" id="{5858114E-6776-466D-94BA-6A3DB785513B}"/>
+          <p:cNvPr id="13" name="HORMUZ">
+            <a:extLst xmlns:a="http://schemas.openxmlformats.org/drawingml/2006/main">
+              <a:ext uri="{FF2B5EF4-FFF2-40B4-BE49-F238E27FC236}">
+                <a16:creationId xmlns:a16="http://schemas.microsoft.com/office/drawing/2014/main" id="{4538982A-C968-4F17-A8ED-29674AC2F0A4}"/>
               </a:ext>
             </a:extLst>
           </p:cNvPr>
@@ -2571,11 +2766,11 @@
             <a:avLst/>
           </a:prstGeom>
           <a:solidFill xmlns:a="http://schemas.openxmlformats.org/drawingml/2006/main">
-            <a:srgbClr val="FBFCF8"/>
+            <a:srgbClr val="FAFBF6"/>
           </a:solidFill>
           <a:ln xmlns:a="http://schemas.openxmlformats.org/drawingml/2006/main" w="9525">
             <a:solidFill>
-              <a:srgbClr val="D9E1DF"/>
+              <a:srgbClr val="D4DBCC"/>
             </a:solidFill>
             <a:prstDash val="solid"/>
           </a:ln>
@@ -2583,10 +2778,10 @@
       </p:sp>
       <p:sp>
         <p:nvSpPr>
-          <p:cNvPr id="10" name="HORMUZ-title">
-            <a:extLst xmlns:a="http://schemas.openxmlformats.org/drawingml/2006/main">
-              <a:ext uri="{FF2B5EF4-FFF2-40B4-BE49-F238E27FC236}">
-                <a16:creationId xmlns:a16="http://schemas.microsoft.com/office/drawing/2014/main" id="{C358235F-E85F-4E44-88CD-B525225D178B}"/>
+          <p:cNvPr id="14" name="HORMUZ-title">
+            <a:extLst xmlns:a="http://schemas.openxmlformats.org/drawingml/2006/main">
+              <a:ext uri="{FF2B5EF4-FFF2-40B4-BE49-F238E27FC236}">
+                <a16:creationId xmlns:a16="http://schemas.microsoft.com/office/drawing/2014/main" id="{55E814F5-2C95-4AE9-85F9-23C16A3164A4}"/>
               </a:ext>
             </a:extLst>
           </p:cNvPr>
@@ -2616,10 +2811,9 @@
           <a:lstStyle xmlns:a="http://schemas.openxmlformats.org/drawingml/2006/main"/>
           <a:p xmlns:a="http://schemas.openxmlformats.org/drawingml/2006/main">
             <a:pPr>
-              <a:buNone/>
               <a:defRPr sz="1650" b="1">
                 <a:solidFill>
-                  <a:srgbClr val="087F78"/>
+                  <a:srgbClr val="31684B"/>
                 </a:solidFill>
                 <a:latin typeface="Arial"/>
                 <a:ea typeface="Arial"/>
@@ -2629,7 +2823,7 @@
             <a:r>
               <a:rPr sz="1650" b="1">
                 <a:solidFill>
-                  <a:srgbClr val="087F78"/>
+                  <a:srgbClr val="31684B"/>
                 </a:solidFill>
                 <a:latin typeface="Arial"/>
                 <a:ea typeface="Arial"/>
@@ -2642,10 +2836,10 @@
       </p:sp>
       <p:sp>
         <p:nvSpPr>
-          <p:cNvPr id="11" name="HORMUZ-body">
-            <a:extLst xmlns:a="http://schemas.openxmlformats.org/drawingml/2006/main">
-              <a:ext uri="{FF2B5EF4-FFF2-40B4-BE49-F238E27FC236}">
-                <a16:creationId xmlns:a16="http://schemas.microsoft.com/office/drawing/2014/main" id="{1378BE8B-C5B7-4332-8BA8-F9622113C457}"/>
+          <p:cNvPr id="15" name="HORMUZ-body">
+            <a:extLst xmlns:a="http://schemas.openxmlformats.org/drawingml/2006/main">
+              <a:ext uri="{FF2B5EF4-FFF2-40B4-BE49-F238E27FC236}">
+                <a16:creationId xmlns:a16="http://schemas.microsoft.com/office/drawing/2014/main" id="{52B58E35-D437-4BE5-BE7F-54C32ABACB3B}"/>
               </a:ext>
             </a:extLst>
           </p:cNvPr>
@@ -2675,10 +2869,9 @@
           <a:lstStyle xmlns:a="http://schemas.openxmlformats.org/drawingml/2006/main"/>
           <a:p xmlns:a="http://schemas.openxmlformats.org/drawingml/2006/main">
             <a:pPr>
-              <a:buNone/>
               <a:defRPr sz="1800" b="0">
                 <a:solidFill>
-                  <a:srgbClr val="101B20"/>
+                  <a:srgbClr val="202723"/>
                 </a:solidFill>
                 <a:latin typeface="Arial"/>
                 <a:ea typeface="Arial"/>
@@ -2688,7 +2881,7 @@
             <a:r>
               <a:rPr sz="1800" b="0">
                 <a:solidFill>
-                  <a:srgbClr val="101B20"/>
+                  <a:srgbClr val="202723"/>
                 </a:solidFill>
                 <a:latin typeface="Arial"/>
                 <a:ea typeface="Arial"/>
@@ -2699,10 +2892,9 @@
           </a:p>
           <a:p xmlns:a="http://schemas.openxmlformats.org/drawingml/2006/main">
             <a:pPr>
-              <a:buNone/>
               <a:defRPr sz="1800" b="0">
                 <a:solidFill>
-                  <a:srgbClr val="101B20"/>
+                  <a:srgbClr val="202723"/>
                 </a:solidFill>
                 <a:latin typeface="Arial"/>
                 <a:ea typeface="Arial"/>
@@ -2712,7 +2904,7 @@
             <a:r>
               <a:rPr sz="1800" b="0">
                 <a:solidFill>
-                  <a:srgbClr val="101B20"/>
+                  <a:srgbClr val="202723"/>
                 </a:solidFill>
                 <a:latin typeface="Arial"/>
                 <a:ea typeface="Arial"/>
@@ -2725,10 +2917,10 @@
       </p:sp>
       <p:sp>
         <p:nvSpPr>
-          <p:cNvPr id="12" name="MODEL PROVIDER">
-            <a:extLst xmlns:a="http://schemas.openxmlformats.org/drawingml/2006/main">
-              <a:ext uri="{FF2B5EF4-FFF2-40B4-BE49-F238E27FC236}">
-                <a16:creationId xmlns:a16="http://schemas.microsoft.com/office/drawing/2014/main" id="{EAFAD07B-502F-46ED-B978-AE8557A172D0}"/>
+          <p:cNvPr id="16" name="MODEL PROVIDER">
+            <a:extLst xmlns:a="http://schemas.openxmlformats.org/drawingml/2006/main">
+              <a:ext uri="{FF2B5EF4-FFF2-40B4-BE49-F238E27FC236}">
+                <a16:creationId xmlns:a16="http://schemas.microsoft.com/office/drawing/2014/main" id="{5DD66781-2CAC-47FE-9D94-4732462A0BF0}"/>
               </a:ext>
             </a:extLst>
           </p:cNvPr>
@@ -2746,11 +2938,11 @@
             <a:avLst/>
           </a:prstGeom>
           <a:solidFill xmlns:a="http://schemas.openxmlformats.org/drawingml/2006/main">
-            <a:srgbClr val="FBFCF8"/>
+            <a:srgbClr val="FAFBF6"/>
           </a:solidFill>
           <a:ln xmlns:a="http://schemas.openxmlformats.org/drawingml/2006/main" w="9525">
             <a:solidFill>
-              <a:srgbClr val="D9E1DF"/>
+              <a:srgbClr val="D4DBCC"/>
             </a:solidFill>
             <a:prstDash val="solid"/>
           </a:ln>
@@ -2758,10 +2950,10 @@
       </p:sp>
       <p:sp>
         <p:nvSpPr>
-          <p:cNvPr id="13" name="MODEL PROVIDER-title">
-            <a:extLst xmlns:a="http://schemas.openxmlformats.org/drawingml/2006/main">
-              <a:ext uri="{FF2B5EF4-FFF2-40B4-BE49-F238E27FC236}">
-                <a16:creationId xmlns:a16="http://schemas.microsoft.com/office/drawing/2014/main" id="{2AE22301-CEFD-4C1E-AA44-19E3985B340E}"/>
+          <p:cNvPr id="17" name="MODEL PROVIDER-title">
+            <a:extLst xmlns:a="http://schemas.openxmlformats.org/drawingml/2006/main">
+              <a:ext uri="{FF2B5EF4-FFF2-40B4-BE49-F238E27FC236}">
+                <a16:creationId xmlns:a16="http://schemas.microsoft.com/office/drawing/2014/main" id="{A36BAE3C-4EB7-458E-AF6A-58AA3C7B02C7}"/>
               </a:ext>
             </a:extLst>
           </p:cNvPr>
@@ -2791,10 +2983,9 @@
           <a:lstStyle xmlns:a="http://schemas.openxmlformats.org/drawingml/2006/main"/>
           <a:p xmlns:a="http://schemas.openxmlformats.org/drawingml/2006/main">
             <a:pPr>
-              <a:buNone/>
               <a:defRPr sz="1650" b="1">
                 <a:solidFill>
-                  <a:srgbClr val="087F78"/>
+                  <a:srgbClr val="31684B"/>
                 </a:solidFill>
                 <a:latin typeface="Arial"/>
                 <a:ea typeface="Arial"/>
@@ -2804,7 +2995,7 @@
             <a:r>
               <a:rPr sz="1650" b="1">
                 <a:solidFill>
-                  <a:srgbClr val="087F78"/>
+                  <a:srgbClr val="31684B"/>
                 </a:solidFill>
                 <a:latin typeface="Arial"/>
                 <a:ea typeface="Arial"/>
@@ -2817,10 +3008,10 @@
       </p:sp>
       <p:sp>
         <p:nvSpPr>
-          <p:cNvPr id="14" name="MODEL PROVIDER-body">
-            <a:extLst xmlns:a="http://schemas.openxmlformats.org/drawingml/2006/main">
-              <a:ext uri="{FF2B5EF4-FFF2-40B4-BE49-F238E27FC236}">
-                <a16:creationId xmlns:a16="http://schemas.microsoft.com/office/drawing/2014/main" id="{24CFD9FC-5EB7-40CE-9D06-825AD8A99F39}"/>
+          <p:cNvPr id="18" name="MODEL PROVIDER-body">
+            <a:extLst xmlns:a="http://schemas.openxmlformats.org/drawingml/2006/main">
+              <a:ext uri="{FF2B5EF4-FFF2-40B4-BE49-F238E27FC236}">
+                <a16:creationId xmlns:a16="http://schemas.microsoft.com/office/drawing/2014/main" id="{7515595B-623C-4F2F-865D-8A698E5A6466}"/>
               </a:ext>
             </a:extLst>
           </p:cNvPr>
@@ -2850,10 +3041,9 @@
           <a:lstStyle xmlns:a="http://schemas.openxmlformats.org/drawingml/2006/main"/>
           <a:p xmlns:a="http://schemas.openxmlformats.org/drawingml/2006/main">
             <a:pPr>
-              <a:buNone/>
               <a:defRPr sz="1800" b="0">
                 <a:solidFill>
-                  <a:srgbClr val="101B20"/>
+                  <a:srgbClr val="202723"/>
                 </a:solidFill>
                 <a:latin typeface="Arial"/>
                 <a:ea typeface="Arial"/>
@@ -2863,7 +3053,7 @@
             <a:r>
               <a:rPr sz="1800" b="0">
                 <a:solidFill>
-                  <a:srgbClr val="101B20"/>
+                  <a:srgbClr val="202723"/>
                 </a:solidFill>
                 <a:latin typeface="Arial"/>
                 <a:ea typeface="Arial"/>
@@ -2874,10 +3064,9 @@
           </a:p>
           <a:p xmlns:a="http://schemas.openxmlformats.org/drawingml/2006/main">
             <a:pPr>
-              <a:buNone/>
               <a:defRPr sz="1800" b="0">
                 <a:solidFill>
-                  <a:srgbClr val="101B20"/>
+                  <a:srgbClr val="202723"/>
                 </a:solidFill>
                 <a:latin typeface="Arial"/>
                 <a:ea typeface="Arial"/>
@@ -2887,7 +3076,7 @@
             <a:r>
               <a:rPr sz="1800" b="0">
                 <a:solidFill>
-                  <a:srgbClr val="101B20"/>
+                  <a:srgbClr val="202723"/>
                 </a:solidFill>
                 <a:latin typeface="Arial"/>
                 <a:ea typeface="Arial"/>
@@ -2900,10 +3089,10 @@
       </p:sp>
       <p:sp>
         <p:nvSpPr>
-          <p:cNvPr id="15" name="metadata">
-            <a:extLst xmlns:a="http://schemas.openxmlformats.org/drawingml/2006/main">
-              <a:ext uri="{FF2B5EF4-FFF2-40B4-BE49-F238E27FC236}">
-                <a16:creationId xmlns:a16="http://schemas.microsoft.com/office/drawing/2014/main" id="{9240B609-B85B-4D77-881B-34016770E4FA}"/>
+          <p:cNvPr id="19" name="metadata">
+            <a:extLst xmlns:a="http://schemas.openxmlformats.org/drawingml/2006/main">
+              <a:ext uri="{FF2B5EF4-FFF2-40B4-BE49-F238E27FC236}">
+                <a16:creationId xmlns:a16="http://schemas.microsoft.com/office/drawing/2014/main" id="{8059FDA5-32EC-401D-8AC5-68E9717C20A6}"/>
               </a:ext>
             </a:extLst>
           </p:cNvPr>
@@ -2933,10 +3122,9 @@
           <a:lstStyle xmlns:a="http://schemas.openxmlformats.org/drawingml/2006/main"/>
           <a:p xmlns:a="http://schemas.openxmlformats.org/drawingml/2006/main">
             <a:pPr>
-              <a:buNone/>
               <a:defRPr sz="2400" b="1">
                 <a:solidFill>
-                  <a:srgbClr val="101B20"/>
+                  <a:srgbClr val="202723"/>
                 </a:solidFill>
                 <a:latin typeface="Arial"/>
                 <a:ea typeface="Arial"/>
@@ -2946,7 +3134,7 @@
             <a:r>
               <a:rPr sz="2400" b="1">
                 <a:solidFill>
-                  <a:srgbClr val="101B20"/>
+                  <a:srgbClr val="202723"/>
                 </a:solidFill>
                 <a:latin typeface="Arial"/>
                 <a:ea typeface="Arial"/>
@@ -2959,10 +3147,10 @@
       </p:sp>
       <p:sp>
         <p:nvSpPr>
-          <p:cNvPr id="16" name="boundary">
-            <a:extLst xmlns:a="http://schemas.openxmlformats.org/drawingml/2006/main">
-              <a:ext uri="{FF2B5EF4-FFF2-40B4-BE49-F238E27FC236}">
-                <a16:creationId xmlns:a16="http://schemas.microsoft.com/office/drawing/2014/main" id="{5450C886-9130-449C-A0A6-77CDDADBFBED}"/>
+          <p:cNvPr id="20" name="boundary">
+            <a:extLst xmlns:a="http://schemas.openxmlformats.org/drawingml/2006/main">
+              <a:ext uri="{FF2B5EF4-FFF2-40B4-BE49-F238E27FC236}">
+                <a16:creationId xmlns:a16="http://schemas.microsoft.com/office/drawing/2014/main" id="{30C1DF31-E220-4F59-B2B7-69741B8B4E24}"/>
               </a:ext>
             </a:extLst>
           </p:cNvPr>
@@ -2992,10 +3180,9 @@
           <a:lstStyle xmlns:a="http://schemas.openxmlformats.org/drawingml/2006/main"/>
           <a:p xmlns:a="http://schemas.openxmlformats.org/drawingml/2006/main">
             <a:pPr>
-              <a:buNone/>
               <a:defRPr sz="1875" b="0">
                 <a:solidFill>
-                  <a:srgbClr val="607077"/>
+                  <a:srgbClr val="5C6758"/>
                 </a:solidFill>
                 <a:latin typeface="Arial"/>
                 <a:ea typeface="Arial"/>
@@ -3005,7 +3192,7 @@
             <a:r>
               <a:rPr sz="1875" b="0">
                 <a:solidFill>
-                  <a:srgbClr val="607077"/>
+                  <a:srgbClr val="5C6758"/>
                 </a:solidFill>
                 <a:latin typeface="Arial"/>
                 <a:ea typeface="Arial"/>
@@ -3019,7 +3206,7 @@
     </p:spTree>
     <p:extLst>
       <p:ext uri="{BB962C8B-B14F-4D97-AF65-F5344CB8AC3E}">
-        <p14:creationId xmlns:p14="http://schemas.microsoft.com/office/powerpoint/2010/main" val="2142516326"/>
+        <p14:creationId xmlns:p14="http://schemas.microsoft.com/office/powerpoint/2010/main" val="1272595377"/>
       </p:ext>
     </p:extLst>
   </p:cSld>
@@ -3032,7 +3219,7 @@
     <p:bg>
       <p:bgPr>
         <a:solidFill xmlns:a="http://schemas.openxmlformats.org/drawingml/2006/main">
-          <a:srgbClr val="07171A"/>
+          <a:srgbClr val="24392D"/>
         </a:solidFill>
       </p:bgPr>
     </p:bg>
@@ -3047,10 +3234,137 @@
       </p:grpSpPr>
       <p:sp>
         <p:nvSpPr>
-          <p:cNvPr id="8" name="section">
-            <a:extLst xmlns:a="http://schemas.openxmlformats.org/drawingml/2006/main">
-              <a:ext uri="{FF2B5EF4-FFF2-40B4-BE49-F238E27FC236}">
-                <a16:creationId xmlns:a16="http://schemas.microsoft.com/office/drawing/2014/main" id="{67E2E88D-1D98-4372-A481-3635D195AABC}"/>
+          <p:cNvPr id="12" name="Hormuz mark boundary">
+            <a:extLst xmlns:a="http://schemas.openxmlformats.org/drawingml/2006/main">
+              <a:ext uri="{FF2B5EF4-FFF2-40B4-BE49-F238E27FC236}">
+                <a16:creationId xmlns:a16="http://schemas.microsoft.com/office/drawing/2014/main" id="{45EE2C09-73A4-4BE2-807E-C0F492AE02CA}"/>
+              </a:ext>
+            </a:extLst>
+          </p:cNvPr>
+          <p:cNvSpPr>
+            <a:spLocks xmlns:a="http://schemas.openxmlformats.org/drawingml/2006/main" noGrp="1"/>
+          </p:cNvSpPr>
+          <p:nvPr/>
+        </p:nvSpPr>
+        <p:spPr>
+          <a:xfrm xmlns:a="http://schemas.openxmlformats.org/drawingml/2006/main">
+            <a:off x="11201400" y="333375"/>
+            <a:ext cx="381000" cy="381000"/>
+          </a:xfrm>
+          <a:prstGeom xmlns:a="http://schemas.openxmlformats.org/drawingml/2006/main" prst="ellipse">
+            <a:avLst/>
+          </a:prstGeom>
+          <a:noFill xmlns:a="http://schemas.openxmlformats.org/drawingml/2006/main"/>
+          <a:ln xmlns:a="http://schemas.openxmlformats.org/drawingml/2006/main" w="9525">
+            <a:solidFill>
+              <a:srgbClr val="DCEDA6"/>
+            </a:solidFill>
+            <a:prstDash val="solid"/>
+          </a:ln>
+        </p:spPr>
+      </p:sp>
+      <p:sp>
+        <p:nvSpPr>
+          <p:cNvPr id="2" name="Hormuz mark bar 1">
+            <a:extLst xmlns:a="http://schemas.openxmlformats.org/drawingml/2006/main">
+              <a:ext uri="{FF2B5EF4-FFF2-40B4-BE49-F238E27FC236}">
+                <a16:creationId xmlns:a16="http://schemas.microsoft.com/office/drawing/2014/main" id="{70BD15C2-8662-45EE-9673-3387C97EA1E7}"/>
+              </a:ext>
+            </a:extLst>
+          </p:cNvPr>
+          <p:cNvSpPr>
+            <a:spLocks xmlns:a="http://schemas.openxmlformats.org/drawingml/2006/main" noGrp="1"/>
+          </p:cNvSpPr>
+          <p:nvPr/>
+        </p:nvSpPr>
+        <p:spPr>
+          <a:xfrm xmlns:a="http://schemas.openxmlformats.org/drawingml/2006/main">
+            <a:off x="11287125" y="476250"/>
+            <a:ext cx="47625" cy="95250"/>
+          </a:xfrm>
+          <a:prstGeom xmlns:a="http://schemas.openxmlformats.org/drawingml/2006/main" prst="roundRect">
+            <a:avLst>
+              <a:gd name="adj" fmla="val 50000"/>
+            </a:avLst>
+          </a:prstGeom>
+          <a:solidFill xmlns:a="http://schemas.openxmlformats.org/drawingml/2006/main">
+            <a:srgbClr val="DCEDA6"/>
+          </a:solidFill>
+          <a:ln xmlns:a="http://schemas.openxmlformats.org/drawingml/2006/main" w="0">
+            <a:noFill/>
+          </a:ln>
+        </p:spPr>
+      </p:sp>
+      <p:sp>
+        <p:nvSpPr>
+          <p:cNvPr id="3" name="Hormuz mark bar 2">
+            <a:extLst xmlns:a="http://schemas.openxmlformats.org/drawingml/2006/main">
+              <a:ext uri="{FF2B5EF4-FFF2-40B4-BE49-F238E27FC236}">
+                <a16:creationId xmlns:a16="http://schemas.microsoft.com/office/drawing/2014/main" id="{16EBA790-E1CC-41A8-844D-917477BC6131}"/>
+              </a:ext>
+            </a:extLst>
+          </p:cNvPr>
+          <p:cNvSpPr>
+            <a:spLocks xmlns:a="http://schemas.openxmlformats.org/drawingml/2006/main" noGrp="1"/>
+          </p:cNvSpPr>
+          <p:nvPr/>
+        </p:nvSpPr>
+        <p:spPr>
+          <a:xfrm xmlns:a="http://schemas.openxmlformats.org/drawingml/2006/main">
+            <a:off x="11363325" y="428625"/>
+            <a:ext cx="47625" cy="190500"/>
+          </a:xfrm>
+          <a:prstGeom xmlns:a="http://schemas.openxmlformats.org/drawingml/2006/main" prst="roundRect">
+            <a:avLst>
+              <a:gd name="adj" fmla="val 50000"/>
+            </a:avLst>
+          </a:prstGeom>
+          <a:solidFill xmlns:a="http://schemas.openxmlformats.org/drawingml/2006/main">
+            <a:srgbClr val="DCEDA6"/>
+          </a:solidFill>
+          <a:ln xmlns:a="http://schemas.openxmlformats.org/drawingml/2006/main" w="0">
+            <a:noFill/>
+          </a:ln>
+        </p:spPr>
+      </p:sp>
+      <p:sp>
+        <p:nvSpPr>
+          <p:cNvPr id="4" name="Hormuz mark bar 3">
+            <a:extLst xmlns:a="http://schemas.openxmlformats.org/drawingml/2006/main">
+              <a:ext uri="{FF2B5EF4-FFF2-40B4-BE49-F238E27FC236}">
+                <a16:creationId xmlns:a16="http://schemas.microsoft.com/office/drawing/2014/main" id="{959E6CB1-B11F-4646-AC78-CAD6F3FE7EA0}"/>
+              </a:ext>
+            </a:extLst>
+          </p:cNvPr>
+          <p:cNvSpPr>
+            <a:spLocks xmlns:a="http://schemas.openxmlformats.org/drawingml/2006/main" noGrp="1"/>
+          </p:cNvSpPr>
+          <p:nvPr/>
+        </p:nvSpPr>
+        <p:spPr>
+          <a:xfrm xmlns:a="http://schemas.openxmlformats.org/drawingml/2006/main">
+            <a:off x="11439525" y="457200"/>
+            <a:ext cx="47625" cy="133350"/>
+          </a:xfrm>
+          <a:prstGeom xmlns:a="http://schemas.openxmlformats.org/drawingml/2006/main" prst="roundRect">
+            <a:avLst>
+              <a:gd name="adj" fmla="val 50000"/>
+            </a:avLst>
+          </a:prstGeom>
+          <a:solidFill xmlns:a="http://schemas.openxmlformats.org/drawingml/2006/main">
+            <a:srgbClr val="DCEDA6"/>
+          </a:solidFill>
+          <a:ln xmlns:a="http://schemas.openxmlformats.org/drawingml/2006/main" w="0">
+            <a:noFill/>
+          </a:ln>
+        </p:spPr>
+      </p:sp>
+      <p:sp>
+        <p:nvSpPr>
+          <p:cNvPr id="5" name="section">
+            <a:extLst xmlns:a="http://schemas.openxmlformats.org/drawingml/2006/main">
+              <a:ext uri="{FF2B5EF4-FFF2-40B4-BE49-F238E27FC236}">
+                <a16:creationId xmlns:a16="http://schemas.microsoft.com/office/drawing/2014/main" id="{35C57F1D-47C2-4CB0-9232-FEA8E9D28270}"/>
               </a:ext>
             </a:extLst>
           </p:cNvPr>
@@ -3080,10 +3394,9 @@
           <a:lstStyle xmlns:a="http://schemas.openxmlformats.org/drawingml/2006/main"/>
           <a:p xmlns:a="http://schemas.openxmlformats.org/drawingml/2006/main">
             <a:pPr>
-              <a:buNone/>
               <a:defRPr sz="1425" b="1">
                 <a:solidFill>
-                  <a:srgbClr val="68E6DD"/>
+                  <a:srgbClr val="DCEDA6"/>
                 </a:solidFill>
                 <a:latin typeface="Arial"/>
                 <a:ea typeface="Arial"/>
@@ -3093,7 +3406,7 @@
             <a:r>
               <a:rPr sz="1425" b="1">
                 <a:solidFill>
-                  <a:srgbClr val="68E6DD"/>
+                  <a:srgbClr val="DCEDA6"/>
                 </a:solidFill>
                 <a:latin typeface="Arial"/>
                 <a:ea typeface="Arial"/>
@@ -3106,10 +3419,10 @@
       </p:sp>
       <p:sp>
         <p:nvSpPr>
-          <p:cNvPr id="2" name="takeaway">
-            <a:extLst xmlns:a="http://schemas.openxmlformats.org/drawingml/2006/main">
-              <a:ext uri="{FF2B5EF4-FFF2-40B4-BE49-F238E27FC236}">
-                <a16:creationId xmlns:a16="http://schemas.microsoft.com/office/drawing/2014/main" id="{DB8B4143-8FA4-46B7-BEB6-309BBA03B46C}"/>
+          <p:cNvPr id="6" name="takeaway">
+            <a:extLst xmlns:a="http://schemas.openxmlformats.org/drawingml/2006/main">
+              <a:ext uri="{FF2B5EF4-FFF2-40B4-BE49-F238E27FC236}">
+                <a16:creationId xmlns:a16="http://schemas.microsoft.com/office/drawing/2014/main" id="{64042A4E-8DF4-4715-8C21-018D0588A5D0}"/>
               </a:ext>
             </a:extLst>
           </p:cNvPr>
@@ -3139,10 +3452,9 @@
           <a:lstStyle xmlns:a="http://schemas.openxmlformats.org/drawingml/2006/main"/>
           <a:p xmlns:a="http://schemas.openxmlformats.org/drawingml/2006/main">
             <a:pPr>
-              <a:buNone/>
               <a:defRPr sz="3600" b="1">
                 <a:solidFill>
-                  <a:srgbClr val="FBFCF8"/>
+                  <a:srgbClr val="FAFBF6"/>
                 </a:solidFill>
                 <a:latin typeface="Arial"/>
                 <a:ea typeface="Arial"/>
@@ -3152,7 +3464,7 @@
             <a:r>
               <a:rPr sz="3600" b="1">
                 <a:solidFill>
-                  <a:srgbClr val="FBFCF8"/>
+                  <a:srgbClr val="FAFBF6"/>
                 </a:solidFill>
                 <a:latin typeface="Arial"/>
                 <a:ea typeface="Arial"/>
@@ -3165,10 +3477,10 @@
       </p:sp>
       <p:sp>
         <p:nvSpPr>
-          <p:cNvPr id="3" name="footer">
-            <a:extLst xmlns:a="http://schemas.openxmlformats.org/drawingml/2006/main">
-              <a:ext uri="{FF2B5EF4-FFF2-40B4-BE49-F238E27FC236}">
-                <a16:creationId xmlns:a16="http://schemas.microsoft.com/office/drawing/2014/main" id="{3DFA6764-C907-411A-AC2B-C3F64586B1AE}"/>
+          <p:cNvPr id="7" name="footer">
+            <a:extLst xmlns:a="http://schemas.openxmlformats.org/drawingml/2006/main">
+              <a:ext uri="{FF2B5EF4-FFF2-40B4-BE49-F238E27FC236}">
+                <a16:creationId xmlns:a16="http://schemas.microsoft.com/office/drawing/2014/main" id="{A0B47DF0-3CC1-41FB-8751-DDFBD6A5376E}"/>
               </a:ext>
             </a:extLst>
           </p:cNvPr>
@@ -3198,10 +3510,9 @@
           <a:lstStyle xmlns:a="http://schemas.openxmlformats.org/drawingml/2006/main"/>
           <a:p xmlns:a="http://schemas.openxmlformats.org/drawingml/2006/main">
             <a:pPr>
-              <a:buNone/>
               <a:defRPr sz="1275" b="0">
                 <a:solidFill>
-                  <a:srgbClr val="B9CCC7"/>
+                  <a:srgbClr val="DCE6D5"/>
                 </a:solidFill>
                 <a:latin typeface="Arial"/>
                 <a:ea typeface="Arial"/>
@@ -3211,45 +3522,23 @@
             <a:r>
               <a:rPr sz="1275" b="0">
                 <a:solidFill>
-                  <a:srgbClr val="B9CCC7"/>
-                </a:solidFill>
-                <a:latin typeface="Arial"/>
-                <a:ea typeface="Arial"/>
-                <a:cs typeface="Arial"/>
-              </a:rPr>
-              <a:t>HORMUZ  /  Mehrdad Zaker  /  </a:t>
-            </a:r>
-            <a:r>
-              <a:rPr sz="1275" b="0">
-                <a:solidFill>
-                  <a:srgbClr val="B9CCC7"/>
-                </a:solidFill>
-                <a:latin typeface="Arial"/>
-                <a:ea typeface="Arial"/>
-                <a:cs typeface="Arial"/>
-              </a:rPr>
-              <a:t>31 Aug 2026</a:t>
-            </a:r>
-            <a:r>
-              <a:rPr sz="1275" b="0">
-                <a:solidFill>
-                  <a:srgbClr val="B9CCC7"/>
-                </a:solidFill>
-                <a:latin typeface="Arial"/>
-                <a:ea typeface="Arial"/>
-                <a:cs typeface="Arial"/>
-              </a:rPr>
-              <a:t>                                      03 / 07</a:t>
-            </a:r>
-          </a:p>
-        </p:txBody>
-      </p:sp>
-      <p:sp>
-        <p:nvSpPr>
-          <p:cNvPr id="4" name="zero">
-            <a:extLst xmlns:a="http://schemas.openxmlformats.org/drawingml/2006/main">
-              <a:ext uri="{FF2B5EF4-FFF2-40B4-BE49-F238E27FC236}">
-                <a16:creationId xmlns:a16="http://schemas.microsoft.com/office/drawing/2014/main" id="{90CFE7DB-18D3-4038-8C44-C0BD470A4464}"/>
+                  <a:srgbClr val="DCE6D5"/>
+                </a:solidFill>
+                <a:latin typeface="Arial"/>
+                <a:ea typeface="Arial"/>
+                <a:cs typeface="Arial"/>
+              </a:rPr>
+              <a:t>HORMUZ  /  Mehrdad Zaker  /  September 2026                                      03 / 07</a:t>
+            </a:r>
+          </a:p>
+        </p:txBody>
+      </p:sp>
+      <p:sp>
+        <p:nvSpPr>
+          <p:cNvPr id="8" name="zero">
+            <a:extLst xmlns:a="http://schemas.openxmlformats.org/drawingml/2006/main">
+              <a:ext uri="{FF2B5EF4-FFF2-40B4-BE49-F238E27FC236}">
+                <a16:creationId xmlns:a16="http://schemas.microsoft.com/office/drawing/2014/main" id="{DD1F7526-AF44-4CEF-BD60-C6C18E2FC81A}"/>
               </a:ext>
             </a:extLst>
           </p:cNvPr>
@@ -3279,10 +3568,9 @@
           <a:lstStyle xmlns:a="http://schemas.openxmlformats.org/drawingml/2006/main"/>
           <a:p xmlns:a="http://schemas.openxmlformats.org/drawingml/2006/main">
             <a:pPr>
-              <a:buNone/>
               <a:defRPr sz="10500" b="1">
                 <a:solidFill>
-                  <a:srgbClr val="68E6DD"/>
+                  <a:srgbClr val="DCEDA6"/>
                 </a:solidFill>
                 <a:latin typeface="Arial"/>
                 <a:ea typeface="Arial"/>
@@ -3292,7 +3580,7 @@
             <a:r>
               <a:rPr sz="10500" b="1">
                 <a:solidFill>
-                  <a:srgbClr val="68E6DD"/>
+                  <a:srgbClr val="DCEDA6"/>
                 </a:solidFill>
                 <a:latin typeface="Arial"/>
                 <a:ea typeface="Arial"/>
@@ -3305,10 +3593,10 @@
       </p:sp>
       <p:sp>
         <p:nvSpPr>
-          <p:cNvPr id="5" name="zero-label">
-            <a:extLst xmlns:a="http://schemas.openxmlformats.org/drawingml/2006/main">
-              <a:ext uri="{FF2B5EF4-FFF2-40B4-BE49-F238E27FC236}">
-                <a16:creationId xmlns:a16="http://schemas.microsoft.com/office/drawing/2014/main" id="{C6725418-8CCB-40C1-8068-76203ACEB3D8}"/>
+          <p:cNvPr id="9" name="zero-label">
+            <a:extLst xmlns:a="http://schemas.openxmlformats.org/drawingml/2006/main">
+              <a:ext uri="{FF2B5EF4-FFF2-40B4-BE49-F238E27FC236}">
+                <a16:creationId xmlns:a16="http://schemas.microsoft.com/office/drawing/2014/main" id="{C9ADAC7D-0B3E-4D1A-A216-15459CC275D9}"/>
               </a:ext>
             </a:extLst>
           </p:cNvPr>
@@ -3338,10 +3626,9 @@
           <a:lstStyle xmlns:a="http://schemas.openxmlformats.org/drawingml/2006/main"/>
           <a:p xmlns:a="http://schemas.openxmlformats.org/drawingml/2006/main">
             <a:pPr>
-              <a:buNone/>
               <a:defRPr sz="2250" b="1">
                 <a:solidFill>
-                  <a:srgbClr val="FBFCF8"/>
+                  <a:srgbClr val="FAFBF6"/>
                 </a:solidFill>
                 <a:latin typeface="Arial"/>
                 <a:ea typeface="Arial"/>
@@ -3351,7 +3638,7 @@
             <a:r>
               <a:rPr sz="2250" b="1">
                 <a:solidFill>
-                  <a:srgbClr val="FBFCF8"/>
+                  <a:srgbClr val="FAFBF6"/>
                 </a:solidFill>
                 <a:latin typeface="Arial"/>
                 <a:ea typeface="Arial"/>
@@ -3364,10 +3651,10 @@
       </p:sp>
       <p:sp>
         <p:nvSpPr>
-          <p:cNvPr id="6" name="checks">
-            <a:extLst xmlns:a="http://schemas.openxmlformats.org/drawingml/2006/main">
-              <a:ext uri="{FF2B5EF4-FFF2-40B4-BE49-F238E27FC236}">
-                <a16:creationId xmlns:a16="http://schemas.microsoft.com/office/drawing/2014/main" id="{9944B5DD-5AF6-43F1-B2F3-C164B8F04F3E}"/>
+          <p:cNvPr id="10" name="checks">
+            <a:extLst xmlns:a="http://schemas.openxmlformats.org/drawingml/2006/main">
+              <a:ext uri="{FF2B5EF4-FFF2-40B4-BE49-F238E27FC236}">
+                <a16:creationId xmlns:a16="http://schemas.microsoft.com/office/drawing/2014/main" id="{19089C94-CB5E-492B-9210-3E1B96F983B6}"/>
               </a:ext>
             </a:extLst>
           </p:cNvPr>
@@ -3397,10 +3684,9 @@
           <a:lstStyle xmlns:a="http://schemas.openxmlformats.org/drawingml/2006/main"/>
           <a:p xmlns:a="http://schemas.openxmlformats.org/drawingml/2006/main">
             <a:pPr>
-              <a:buNone/>
               <a:defRPr sz="2325" b="0">
                 <a:solidFill>
-                  <a:srgbClr val="FBFCF8"/>
+                  <a:srgbClr val="FAFBF6"/>
                 </a:solidFill>
                 <a:latin typeface="Arial"/>
                 <a:ea typeface="Arial"/>
@@ -3410,7 +3696,7 @@
             <a:r>
               <a:rPr sz="2325" b="0">
                 <a:solidFill>
-                  <a:srgbClr val="FBFCF8"/>
+                  <a:srgbClr val="FAFBF6"/>
                 </a:solidFill>
                 <a:latin typeface="Arial"/>
                 <a:ea typeface="Arial"/>
@@ -3421,10 +3707,9 @@
           </a:p>
           <a:p xmlns:a="http://schemas.openxmlformats.org/drawingml/2006/main">
             <a:pPr>
-              <a:buNone/>
               <a:defRPr sz="2325" b="0">
                 <a:solidFill>
-                  <a:srgbClr val="FBFCF8"/>
+                  <a:srgbClr val="FAFBF6"/>
                 </a:solidFill>
                 <a:latin typeface="Arial"/>
                 <a:ea typeface="Arial"/>
@@ -3434,7 +3719,7 @@
             <a:r>
               <a:rPr sz="2325" b="0">
                 <a:solidFill>
-                  <a:srgbClr val="FBFCF8"/>
+                  <a:srgbClr val="FAFBF6"/>
                 </a:solidFill>
                 <a:latin typeface="Arial"/>
                 <a:ea typeface="Arial"/>
@@ -3445,10 +3730,9 @@
           </a:p>
           <a:p xmlns:a="http://schemas.openxmlformats.org/drawingml/2006/main">
             <a:pPr>
-              <a:buNone/>
               <a:defRPr sz="2325" b="0">
                 <a:solidFill>
-                  <a:srgbClr val="FBFCF8"/>
+                  <a:srgbClr val="FAFBF6"/>
                 </a:solidFill>
                 <a:latin typeface="Arial"/>
                 <a:ea typeface="Arial"/>
@@ -3458,7 +3742,7 @@
             <a:r>
               <a:rPr sz="2325" b="0">
                 <a:solidFill>
-                  <a:srgbClr val="FBFCF8"/>
+                  <a:srgbClr val="FAFBF6"/>
                 </a:solidFill>
                 <a:latin typeface="Arial"/>
                 <a:ea typeface="Arial"/>
@@ -3469,10 +3753,9 @@
           </a:p>
           <a:p xmlns:a="http://schemas.openxmlformats.org/drawingml/2006/main">
             <a:pPr>
-              <a:buNone/>
               <a:defRPr sz="2325" b="0">
                 <a:solidFill>
-                  <a:srgbClr val="FBFCF8"/>
+                  <a:srgbClr val="FAFBF6"/>
                 </a:solidFill>
                 <a:latin typeface="Arial"/>
                 <a:ea typeface="Arial"/>
@@ -3482,7 +3765,7 @@
             <a:r>
               <a:rPr sz="2325" b="0">
                 <a:solidFill>
-                  <a:srgbClr val="FBFCF8"/>
+                  <a:srgbClr val="FAFBF6"/>
                 </a:solidFill>
                 <a:latin typeface="Arial"/>
                 <a:ea typeface="Arial"/>
@@ -3495,10 +3778,10 @@
       </p:sp>
       <p:sp>
         <p:nvSpPr>
-          <p:cNvPr id="7" name="proof-boundary">
-            <a:extLst xmlns:a="http://schemas.openxmlformats.org/drawingml/2006/main">
-              <a:ext uri="{FF2B5EF4-FFF2-40B4-BE49-F238E27FC236}">
-                <a16:creationId xmlns:a16="http://schemas.microsoft.com/office/drawing/2014/main" id="{07AFF470-3E36-479E-A176-08478528C4F3}"/>
+          <p:cNvPr id="11" name="proof-boundary">
+            <a:extLst xmlns:a="http://schemas.openxmlformats.org/drawingml/2006/main">
+              <a:ext uri="{FF2B5EF4-FFF2-40B4-BE49-F238E27FC236}">
+                <a16:creationId xmlns:a16="http://schemas.microsoft.com/office/drawing/2014/main" id="{9541A6D1-BABF-438F-BC31-99C40056084F}"/>
               </a:ext>
             </a:extLst>
           </p:cNvPr>
@@ -3528,7 +3811,6 @@
           <a:lstStyle xmlns:a="http://schemas.openxmlformats.org/drawingml/2006/main"/>
           <a:p xmlns:a="http://schemas.openxmlformats.org/drawingml/2006/main">
             <a:pPr>
-              <a:buNone/>
               <a:defRPr sz="1875" b="0">
                 <a:solidFill>
                   <a:srgbClr val="D9E1DF"/>
@@ -3555,7 +3837,7 @@
     </p:spTree>
     <p:extLst>
       <p:ext uri="{BB962C8B-B14F-4D97-AF65-F5344CB8AC3E}">
-        <p14:creationId xmlns:p14="http://schemas.microsoft.com/office/powerpoint/2010/main" val="1021379177"/>
+        <p14:creationId xmlns:p14="http://schemas.microsoft.com/office/powerpoint/2010/main" val="34675123"/>
       </p:ext>
     </p:extLst>
   </p:cSld>
@@ -3568,7 +3850,7 @@
     <p:bg>
       <p:bgPr>
         <a:solidFill xmlns:a="http://schemas.openxmlformats.org/drawingml/2006/main">
-          <a:srgbClr val="F4F4EF"/>
+          <a:srgbClr val="F4F3EE"/>
         </a:solidFill>
       </p:bgPr>
     </p:bg>
@@ -3583,10 +3865,137 @@
       </p:grpSpPr>
       <p:sp>
         <p:nvSpPr>
-          <p:cNvPr id="9" name="section">
-            <a:extLst xmlns:a="http://schemas.openxmlformats.org/drawingml/2006/main">
-              <a:ext uri="{FF2B5EF4-FFF2-40B4-BE49-F238E27FC236}">
-                <a16:creationId xmlns:a16="http://schemas.microsoft.com/office/drawing/2014/main" id="{82C5106D-71B5-4483-A94D-28BAEAD13786}"/>
+          <p:cNvPr id="13" name="Hormuz mark boundary">
+            <a:extLst xmlns:a="http://schemas.openxmlformats.org/drawingml/2006/main">
+              <a:ext uri="{FF2B5EF4-FFF2-40B4-BE49-F238E27FC236}">
+                <a16:creationId xmlns:a16="http://schemas.microsoft.com/office/drawing/2014/main" id="{6701FAD1-A20B-4BF0-A5AB-A572601D070F}"/>
+              </a:ext>
+            </a:extLst>
+          </p:cNvPr>
+          <p:cNvSpPr>
+            <a:spLocks xmlns:a="http://schemas.openxmlformats.org/drawingml/2006/main" noGrp="1"/>
+          </p:cNvSpPr>
+          <p:nvPr/>
+        </p:nvSpPr>
+        <p:spPr>
+          <a:xfrm xmlns:a="http://schemas.openxmlformats.org/drawingml/2006/main">
+            <a:off x="11201400" y="333375"/>
+            <a:ext cx="381000" cy="381000"/>
+          </a:xfrm>
+          <a:prstGeom xmlns:a="http://schemas.openxmlformats.org/drawingml/2006/main" prst="ellipse">
+            <a:avLst/>
+          </a:prstGeom>
+          <a:noFill xmlns:a="http://schemas.openxmlformats.org/drawingml/2006/main"/>
+          <a:ln xmlns:a="http://schemas.openxmlformats.org/drawingml/2006/main" w="9525">
+            <a:solidFill>
+              <a:srgbClr val="31684B"/>
+            </a:solidFill>
+            <a:prstDash val="solid"/>
+          </a:ln>
+        </p:spPr>
+      </p:sp>
+      <p:sp>
+        <p:nvSpPr>
+          <p:cNvPr id="2" name="Hormuz mark bar 1">
+            <a:extLst xmlns:a="http://schemas.openxmlformats.org/drawingml/2006/main">
+              <a:ext uri="{FF2B5EF4-FFF2-40B4-BE49-F238E27FC236}">
+                <a16:creationId xmlns:a16="http://schemas.microsoft.com/office/drawing/2014/main" id="{6A375E20-C81B-4535-B978-C92C8442A289}"/>
+              </a:ext>
+            </a:extLst>
+          </p:cNvPr>
+          <p:cNvSpPr>
+            <a:spLocks xmlns:a="http://schemas.openxmlformats.org/drawingml/2006/main" noGrp="1"/>
+          </p:cNvSpPr>
+          <p:nvPr/>
+        </p:nvSpPr>
+        <p:spPr>
+          <a:xfrm xmlns:a="http://schemas.openxmlformats.org/drawingml/2006/main">
+            <a:off x="11287125" y="476250"/>
+            <a:ext cx="47625" cy="95250"/>
+          </a:xfrm>
+          <a:prstGeom xmlns:a="http://schemas.openxmlformats.org/drawingml/2006/main" prst="roundRect">
+            <a:avLst>
+              <a:gd name="adj" fmla="val 50000"/>
+            </a:avLst>
+          </a:prstGeom>
+          <a:solidFill xmlns:a="http://schemas.openxmlformats.org/drawingml/2006/main">
+            <a:srgbClr val="31684B"/>
+          </a:solidFill>
+          <a:ln xmlns:a="http://schemas.openxmlformats.org/drawingml/2006/main" w="0">
+            <a:noFill/>
+          </a:ln>
+        </p:spPr>
+      </p:sp>
+      <p:sp>
+        <p:nvSpPr>
+          <p:cNvPr id="3" name="Hormuz mark bar 2">
+            <a:extLst xmlns:a="http://schemas.openxmlformats.org/drawingml/2006/main">
+              <a:ext uri="{FF2B5EF4-FFF2-40B4-BE49-F238E27FC236}">
+                <a16:creationId xmlns:a16="http://schemas.microsoft.com/office/drawing/2014/main" id="{7ADAC536-60D1-4841-8F8D-C1C6F2EF68BA}"/>
+              </a:ext>
+            </a:extLst>
+          </p:cNvPr>
+          <p:cNvSpPr>
+            <a:spLocks xmlns:a="http://schemas.openxmlformats.org/drawingml/2006/main" noGrp="1"/>
+          </p:cNvSpPr>
+          <p:nvPr/>
+        </p:nvSpPr>
+        <p:spPr>
+          <a:xfrm xmlns:a="http://schemas.openxmlformats.org/drawingml/2006/main">
+            <a:off x="11363325" y="428625"/>
+            <a:ext cx="47625" cy="190500"/>
+          </a:xfrm>
+          <a:prstGeom xmlns:a="http://schemas.openxmlformats.org/drawingml/2006/main" prst="roundRect">
+            <a:avLst>
+              <a:gd name="adj" fmla="val 50000"/>
+            </a:avLst>
+          </a:prstGeom>
+          <a:solidFill xmlns:a="http://schemas.openxmlformats.org/drawingml/2006/main">
+            <a:srgbClr val="31684B"/>
+          </a:solidFill>
+          <a:ln xmlns:a="http://schemas.openxmlformats.org/drawingml/2006/main" w="0">
+            <a:noFill/>
+          </a:ln>
+        </p:spPr>
+      </p:sp>
+      <p:sp>
+        <p:nvSpPr>
+          <p:cNvPr id="4" name="Hormuz mark bar 3">
+            <a:extLst xmlns:a="http://schemas.openxmlformats.org/drawingml/2006/main">
+              <a:ext uri="{FF2B5EF4-FFF2-40B4-BE49-F238E27FC236}">
+                <a16:creationId xmlns:a16="http://schemas.microsoft.com/office/drawing/2014/main" id="{D62CE747-4E12-4276-A6A5-1A94F9E98888}"/>
+              </a:ext>
+            </a:extLst>
+          </p:cNvPr>
+          <p:cNvSpPr>
+            <a:spLocks xmlns:a="http://schemas.openxmlformats.org/drawingml/2006/main" noGrp="1"/>
+          </p:cNvSpPr>
+          <p:nvPr/>
+        </p:nvSpPr>
+        <p:spPr>
+          <a:xfrm xmlns:a="http://schemas.openxmlformats.org/drawingml/2006/main">
+            <a:off x="11439525" y="457200"/>
+            <a:ext cx="47625" cy="133350"/>
+          </a:xfrm>
+          <a:prstGeom xmlns:a="http://schemas.openxmlformats.org/drawingml/2006/main" prst="roundRect">
+            <a:avLst>
+              <a:gd name="adj" fmla="val 50000"/>
+            </a:avLst>
+          </a:prstGeom>
+          <a:solidFill xmlns:a="http://schemas.openxmlformats.org/drawingml/2006/main">
+            <a:srgbClr val="31684B"/>
+          </a:solidFill>
+          <a:ln xmlns:a="http://schemas.openxmlformats.org/drawingml/2006/main" w="0">
+            <a:noFill/>
+          </a:ln>
+        </p:spPr>
+      </p:sp>
+      <p:sp>
+        <p:nvSpPr>
+          <p:cNvPr id="5" name="section">
+            <a:extLst xmlns:a="http://schemas.openxmlformats.org/drawingml/2006/main">
+              <a:ext uri="{FF2B5EF4-FFF2-40B4-BE49-F238E27FC236}">
+                <a16:creationId xmlns:a16="http://schemas.microsoft.com/office/drawing/2014/main" id="{EA9BDE98-6D74-44B4-89ED-CD2CD2D5F5B5}"/>
               </a:ext>
             </a:extLst>
           </p:cNvPr>
@@ -3616,10 +4025,9 @@
           <a:lstStyle xmlns:a="http://schemas.openxmlformats.org/drawingml/2006/main"/>
           <a:p xmlns:a="http://schemas.openxmlformats.org/drawingml/2006/main">
             <a:pPr>
-              <a:buNone/>
               <a:defRPr sz="1425" b="1">
                 <a:solidFill>
-                  <a:srgbClr val="087F78"/>
+                  <a:srgbClr val="31684B"/>
                 </a:solidFill>
                 <a:latin typeface="Arial"/>
                 <a:ea typeface="Arial"/>
@@ -3629,7 +4037,7 @@
             <a:r>
               <a:rPr sz="1425" b="1">
                 <a:solidFill>
-                  <a:srgbClr val="087F78"/>
+                  <a:srgbClr val="31684B"/>
                 </a:solidFill>
                 <a:latin typeface="Arial"/>
                 <a:ea typeface="Arial"/>
@@ -3642,10 +4050,10 @@
       </p:sp>
       <p:sp>
         <p:nvSpPr>
-          <p:cNvPr id="2" name="takeaway">
-            <a:extLst xmlns:a="http://schemas.openxmlformats.org/drawingml/2006/main">
-              <a:ext uri="{FF2B5EF4-FFF2-40B4-BE49-F238E27FC236}">
-                <a16:creationId xmlns:a16="http://schemas.microsoft.com/office/drawing/2014/main" id="{AEB5BA57-F33C-480F-9D33-746D3F9E7883}"/>
+          <p:cNvPr id="6" name="takeaway">
+            <a:extLst xmlns:a="http://schemas.openxmlformats.org/drawingml/2006/main">
+              <a:ext uri="{FF2B5EF4-FFF2-40B4-BE49-F238E27FC236}">
+                <a16:creationId xmlns:a16="http://schemas.microsoft.com/office/drawing/2014/main" id="{BB5F7EF9-BC42-4880-9FF5-9E018BB63BBB}"/>
               </a:ext>
             </a:extLst>
           </p:cNvPr>
@@ -3675,10 +4083,9 @@
           <a:lstStyle xmlns:a="http://schemas.openxmlformats.org/drawingml/2006/main"/>
           <a:p xmlns:a="http://schemas.openxmlformats.org/drawingml/2006/main">
             <a:pPr>
-              <a:buNone/>
               <a:defRPr sz="3600" b="1">
                 <a:solidFill>
-                  <a:srgbClr val="101B20"/>
+                  <a:srgbClr val="202723"/>
                 </a:solidFill>
                 <a:latin typeface="Arial"/>
                 <a:ea typeface="Arial"/>
@@ -3688,7 +4095,7 @@
             <a:r>
               <a:rPr sz="3600" b="1">
                 <a:solidFill>
-                  <a:srgbClr val="101B20"/>
+                  <a:srgbClr val="202723"/>
                 </a:solidFill>
                 <a:latin typeface="Arial"/>
                 <a:ea typeface="Arial"/>
@@ -3701,10 +4108,10 @@
       </p:sp>
       <p:sp>
         <p:nvSpPr>
-          <p:cNvPr id="3" name="footer">
-            <a:extLst xmlns:a="http://schemas.openxmlformats.org/drawingml/2006/main">
-              <a:ext uri="{FF2B5EF4-FFF2-40B4-BE49-F238E27FC236}">
-                <a16:creationId xmlns:a16="http://schemas.microsoft.com/office/drawing/2014/main" id="{BFC78FAA-0B20-46E6-9546-497475CA46E9}"/>
+          <p:cNvPr id="7" name="footer">
+            <a:extLst xmlns:a="http://schemas.openxmlformats.org/drawingml/2006/main">
+              <a:ext uri="{FF2B5EF4-FFF2-40B4-BE49-F238E27FC236}">
+                <a16:creationId xmlns:a16="http://schemas.microsoft.com/office/drawing/2014/main" id="{CD344479-D377-41FA-8CF9-6B58B590BB3B}"/>
               </a:ext>
             </a:extLst>
           </p:cNvPr>
@@ -3734,10 +4141,9 @@
           <a:lstStyle xmlns:a="http://schemas.openxmlformats.org/drawingml/2006/main"/>
           <a:p xmlns:a="http://schemas.openxmlformats.org/drawingml/2006/main">
             <a:pPr>
-              <a:buNone/>
               <a:defRPr sz="1275" b="0">
                 <a:solidFill>
-                  <a:srgbClr val="607077"/>
+                  <a:srgbClr val="5C6758"/>
                 </a:solidFill>
                 <a:latin typeface="Arial"/>
                 <a:ea typeface="Arial"/>
@@ -3747,45 +4153,23 @@
             <a:r>
               <a:rPr sz="1275" b="0">
                 <a:solidFill>
-                  <a:srgbClr val="607077"/>
-                </a:solidFill>
-                <a:latin typeface="Arial"/>
-                <a:ea typeface="Arial"/>
-                <a:cs typeface="Arial"/>
-              </a:rPr>
-              <a:t>HORMUZ  /  Mehrdad Zaker  /  </a:t>
-            </a:r>
-            <a:r>
-              <a:rPr sz="1275" b="0">
-                <a:solidFill>
-                  <a:srgbClr val="607077"/>
-                </a:solidFill>
-                <a:latin typeface="Arial"/>
-                <a:ea typeface="Arial"/>
-                <a:cs typeface="Arial"/>
-              </a:rPr>
-              <a:t>31 Aug 2026</a:t>
-            </a:r>
-            <a:r>
-              <a:rPr sz="1275" b="0">
-                <a:solidFill>
-                  <a:srgbClr val="607077"/>
-                </a:solidFill>
-                <a:latin typeface="Arial"/>
-                <a:ea typeface="Arial"/>
-                <a:cs typeface="Arial"/>
-              </a:rPr>
-              <a:t>                                      04 / 07</a:t>
-            </a:r>
-          </a:p>
-        </p:txBody>
-      </p:sp>
-      <p:sp>
-        <p:nvSpPr>
-          <p:cNvPr id="4" name="oss-title">
-            <a:extLst xmlns:a="http://schemas.openxmlformats.org/drawingml/2006/main">
-              <a:ext uri="{FF2B5EF4-FFF2-40B4-BE49-F238E27FC236}">
-                <a16:creationId xmlns:a16="http://schemas.microsoft.com/office/drawing/2014/main" id="{EFDB35CF-9384-41D5-8063-6F1D62EB4A68}"/>
+                  <a:srgbClr val="5C6758"/>
+                </a:solidFill>
+                <a:latin typeface="Arial"/>
+                <a:ea typeface="Arial"/>
+                <a:cs typeface="Arial"/>
+              </a:rPr>
+              <a:t>HORMUZ  /  Mehrdad Zaker  /  September 2026                                      04 / 07</a:t>
+            </a:r>
+          </a:p>
+        </p:txBody>
+      </p:sp>
+      <p:sp>
+        <p:nvSpPr>
+          <p:cNvPr id="8" name="oss-title">
+            <a:extLst xmlns:a="http://schemas.openxmlformats.org/drawingml/2006/main">
+              <a:ext uri="{FF2B5EF4-FFF2-40B4-BE49-F238E27FC236}">
+                <a16:creationId xmlns:a16="http://schemas.microsoft.com/office/drawing/2014/main" id="{BAAC86F3-08AC-49A3-BFD4-B2E0B48210EB}"/>
               </a:ext>
             </a:extLst>
           </p:cNvPr>
@@ -3815,10 +4199,9 @@
           <a:lstStyle xmlns:a="http://schemas.openxmlformats.org/drawingml/2006/main"/>
           <a:p xmlns:a="http://schemas.openxmlformats.org/drawingml/2006/main">
             <a:pPr>
-              <a:buNone/>
               <a:defRPr sz="2550" b="1">
                 <a:solidFill>
-                  <a:srgbClr val="087F78"/>
+                  <a:srgbClr val="31684B"/>
                 </a:solidFill>
                 <a:latin typeface="Arial"/>
                 <a:ea typeface="Arial"/>
@@ -3828,7 +4211,7 @@
             <a:r>
               <a:rPr sz="2550" b="1">
                 <a:solidFill>
-                  <a:srgbClr val="087F78"/>
+                  <a:srgbClr val="31684B"/>
                 </a:solidFill>
                 <a:latin typeface="Arial"/>
                 <a:ea typeface="Arial"/>
@@ -3841,10 +4224,10 @@
       </p:sp>
       <p:sp>
         <p:nvSpPr>
-          <p:cNvPr id="5" name="oss-body">
-            <a:extLst xmlns:a="http://schemas.openxmlformats.org/drawingml/2006/main">
-              <a:ext uri="{FF2B5EF4-FFF2-40B4-BE49-F238E27FC236}">
-                <a16:creationId xmlns:a16="http://schemas.microsoft.com/office/drawing/2014/main" id="{7DA29F09-060D-4C3C-B075-6A1B1A0E00DE}"/>
+          <p:cNvPr id="9" name="oss-body">
+            <a:extLst xmlns:a="http://schemas.openxmlformats.org/drawingml/2006/main">
+              <a:ext uri="{FF2B5EF4-FFF2-40B4-BE49-F238E27FC236}">
+                <a16:creationId xmlns:a16="http://schemas.microsoft.com/office/drawing/2014/main" id="{5C4A57DE-1876-4784-8584-F2D456B2EE67}"/>
               </a:ext>
             </a:extLst>
           </p:cNvPr>
@@ -3874,10 +4257,9 @@
           <a:lstStyle xmlns:a="http://schemas.openxmlformats.org/drawingml/2006/main"/>
           <a:p xmlns:a="http://schemas.openxmlformats.org/drawingml/2006/main">
             <a:pPr>
-              <a:buNone/>
               <a:defRPr sz="2100" b="0">
                 <a:solidFill>
-                  <a:srgbClr val="101B20"/>
+                  <a:srgbClr val="202723"/>
                 </a:solidFill>
                 <a:latin typeface="Arial"/>
                 <a:ea typeface="Arial"/>
@@ -3887,7 +4269,7 @@
             <a:r>
               <a:rPr sz="2100" b="0">
                 <a:solidFill>
-                  <a:srgbClr val="101B20"/>
+                  <a:srgbClr val="202723"/>
                 </a:solidFill>
                 <a:latin typeface="Arial"/>
                 <a:ea typeface="Arial"/>
@@ -3898,10 +4280,9 @@
           </a:p>
           <a:p xmlns:a="http://schemas.openxmlformats.org/drawingml/2006/main">
             <a:pPr>
-              <a:buNone/>
               <a:defRPr sz="2100" b="0">
                 <a:solidFill>
-                  <a:srgbClr val="101B20"/>
+                  <a:srgbClr val="202723"/>
                 </a:solidFill>
                 <a:latin typeface="Arial"/>
                 <a:ea typeface="Arial"/>
@@ -3911,7 +4292,7 @@
             <a:r>
               <a:rPr sz="2100" b="0">
                 <a:solidFill>
-                  <a:srgbClr val="101B20"/>
+                  <a:srgbClr val="202723"/>
                 </a:solidFill>
                 <a:latin typeface="Arial"/>
                 <a:ea typeface="Arial"/>
@@ -3922,10 +4303,9 @@
           </a:p>
           <a:p xmlns:a="http://schemas.openxmlformats.org/drawingml/2006/main">
             <a:pPr>
-              <a:buNone/>
               <a:defRPr sz="2100" b="0">
                 <a:solidFill>
-                  <a:srgbClr val="101B20"/>
+                  <a:srgbClr val="202723"/>
                 </a:solidFill>
                 <a:latin typeface="Arial"/>
                 <a:ea typeface="Arial"/>
@@ -3935,7 +4315,7 @@
             <a:r>
               <a:rPr sz="2100" b="0">
                 <a:solidFill>
-                  <a:srgbClr val="101B20"/>
+                  <a:srgbClr val="202723"/>
                 </a:solidFill>
                 <a:latin typeface="Arial"/>
                 <a:ea typeface="Arial"/>
@@ -3946,10 +4326,9 @@
           </a:p>
           <a:p xmlns:a="http://schemas.openxmlformats.org/drawingml/2006/main">
             <a:pPr>
-              <a:buNone/>
               <a:defRPr sz="2100" b="0">
                 <a:solidFill>
-                  <a:srgbClr val="101B20"/>
+                  <a:srgbClr val="202723"/>
                 </a:solidFill>
                 <a:latin typeface="Arial"/>
                 <a:ea typeface="Arial"/>
@@ -3959,7 +4338,7 @@
             <a:r>
               <a:rPr sz="2100" b="0">
                 <a:solidFill>
-                  <a:srgbClr val="101B20"/>
+                  <a:srgbClr val="202723"/>
                 </a:solidFill>
                 <a:latin typeface="Arial"/>
                 <a:ea typeface="Arial"/>
@@ -3970,10 +4349,9 @@
           </a:p>
           <a:p xmlns:a="http://schemas.openxmlformats.org/drawingml/2006/main">
             <a:pPr>
-              <a:buNone/>
               <a:defRPr sz="2100" b="0">
                 <a:solidFill>
-                  <a:srgbClr val="101B20"/>
+                  <a:srgbClr val="202723"/>
                 </a:solidFill>
                 <a:latin typeface="Arial"/>
                 <a:ea typeface="Arial"/>
@@ -3983,7 +4361,7 @@
             <a:r>
               <a:rPr sz="2100" b="0">
                 <a:solidFill>
-                  <a:srgbClr val="101B20"/>
+                  <a:srgbClr val="202723"/>
                 </a:solidFill>
                 <a:latin typeface="Arial"/>
                 <a:ea typeface="Arial"/>
@@ -3996,10 +4374,10 @@
       </p:sp>
       <p:sp>
         <p:nvSpPr>
-          <p:cNvPr id="6" name="paid-title">
-            <a:extLst xmlns:a="http://schemas.openxmlformats.org/drawingml/2006/main">
-              <a:ext uri="{FF2B5EF4-FFF2-40B4-BE49-F238E27FC236}">
-                <a16:creationId xmlns:a16="http://schemas.microsoft.com/office/drawing/2014/main" id="{559B92B2-96CD-4768-AB6E-63F28F8691DD}"/>
+          <p:cNvPr id="10" name="paid-title">
+            <a:extLst xmlns:a="http://schemas.openxmlformats.org/drawingml/2006/main">
+              <a:ext uri="{FF2B5EF4-FFF2-40B4-BE49-F238E27FC236}">
+                <a16:creationId xmlns:a16="http://schemas.microsoft.com/office/drawing/2014/main" id="{B8BE6F32-7225-46E7-9526-D25625F1248C}"/>
               </a:ext>
             </a:extLst>
           </p:cNvPr>
@@ -4029,10 +4407,9 @@
           <a:lstStyle xmlns:a="http://schemas.openxmlformats.org/drawingml/2006/main"/>
           <a:p xmlns:a="http://schemas.openxmlformats.org/drawingml/2006/main">
             <a:pPr>
-              <a:buNone/>
               <a:defRPr sz="2550" b="1">
                 <a:solidFill>
-                  <a:srgbClr val="087F78"/>
+                  <a:srgbClr val="31684B"/>
                 </a:solidFill>
                 <a:latin typeface="Arial"/>
                 <a:ea typeface="Arial"/>
@@ -4042,7 +4419,7 @@
             <a:r>
               <a:rPr sz="2550" b="1">
                 <a:solidFill>
-                  <a:srgbClr val="087F78"/>
+                  <a:srgbClr val="31684B"/>
                 </a:solidFill>
                 <a:latin typeface="Arial"/>
                 <a:ea typeface="Arial"/>
@@ -4055,10 +4432,10 @@
       </p:sp>
       <p:sp>
         <p:nvSpPr>
-          <p:cNvPr id="7" name="paid-body">
-            <a:extLst xmlns:a="http://schemas.openxmlformats.org/drawingml/2006/main">
-              <a:ext uri="{FF2B5EF4-FFF2-40B4-BE49-F238E27FC236}">
-                <a16:creationId xmlns:a16="http://schemas.microsoft.com/office/drawing/2014/main" id="{C92D5713-09B1-4297-B7C3-8D615747722F}"/>
+          <p:cNvPr id="11" name="paid-body">
+            <a:extLst xmlns:a="http://schemas.openxmlformats.org/drawingml/2006/main">
+              <a:ext uri="{FF2B5EF4-FFF2-40B4-BE49-F238E27FC236}">
+                <a16:creationId xmlns:a16="http://schemas.microsoft.com/office/drawing/2014/main" id="{50B0CBEB-9AD7-4F51-803D-038EC6E20D57}"/>
               </a:ext>
             </a:extLst>
           </p:cNvPr>
@@ -4088,10 +4465,9 @@
           <a:lstStyle xmlns:a="http://schemas.openxmlformats.org/drawingml/2006/main"/>
           <a:p xmlns:a="http://schemas.openxmlformats.org/drawingml/2006/main">
             <a:pPr>
-              <a:buNone/>
               <a:defRPr sz="2100" b="0">
                 <a:solidFill>
-                  <a:srgbClr val="101B20"/>
+                  <a:srgbClr val="202723"/>
                 </a:solidFill>
                 <a:latin typeface="Arial"/>
                 <a:ea typeface="Arial"/>
@@ -4101,7 +4477,7 @@
             <a:r>
               <a:rPr sz="2100" b="0">
                 <a:solidFill>
-                  <a:srgbClr val="101B20"/>
+                  <a:srgbClr val="202723"/>
                 </a:solidFill>
                 <a:latin typeface="Arial"/>
                 <a:ea typeface="Arial"/>
@@ -4112,10 +4488,9 @@
           </a:p>
           <a:p xmlns:a="http://schemas.openxmlformats.org/drawingml/2006/main">
             <a:pPr>
-              <a:buNone/>
               <a:defRPr sz="2100" b="0">
                 <a:solidFill>
-                  <a:srgbClr val="101B20"/>
+                  <a:srgbClr val="202723"/>
                 </a:solidFill>
                 <a:latin typeface="Arial"/>
                 <a:ea typeface="Arial"/>
@@ -4125,7 +4500,7 @@
             <a:r>
               <a:rPr sz="2100" b="0">
                 <a:solidFill>
-                  <a:srgbClr val="101B20"/>
+                  <a:srgbClr val="202723"/>
                 </a:solidFill>
                 <a:latin typeface="Arial"/>
                 <a:ea typeface="Arial"/>
@@ -4136,10 +4511,9 @@
           </a:p>
           <a:p xmlns:a="http://schemas.openxmlformats.org/drawingml/2006/main">
             <a:pPr>
-              <a:buNone/>
               <a:defRPr sz="2100" b="0">
                 <a:solidFill>
-                  <a:srgbClr val="101B20"/>
+                  <a:srgbClr val="202723"/>
                 </a:solidFill>
                 <a:latin typeface="Arial"/>
                 <a:ea typeface="Arial"/>
@@ -4149,7 +4523,7 @@
             <a:r>
               <a:rPr sz="2100" b="0">
                 <a:solidFill>
-                  <a:srgbClr val="101B20"/>
+                  <a:srgbClr val="202723"/>
                 </a:solidFill>
                 <a:latin typeface="Arial"/>
                 <a:ea typeface="Arial"/>
@@ -4160,10 +4534,9 @@
           </a:p>
           <a:p xmlns:a="http://schemas.openxmlformats.org/drawingml/2006/main">
             <a:pPr>
-              <a:buNone/>
               <a:defRPr sz="2100" b="0">
                 <a:solidFill>
-                  <a:srgbClr val="101B20"/>
+                  <a:srgbClr val="202723"/>
                 </a:solidFill>
                 <a:latin typeface="Arial"/>
                 <a:ea typeface="Arial"/>
@@ -4173,7 +4546,7 @@
             <a:r>
               <a:rPr sz="2100" b="0">
                 <a:solidFill>
-                  <a:srgbClr val="101B20"/>
+                  <a:srgbClr val="202723"/>
                 </a:solidFill>
                 <a:latin typeface="Arial"/>
                 <a:ea typeface="Arial"/>
@@ -4184,10 +4557,9 @@
           </a:p>
           <a:p xmlns:a="http://schemas.openxmlformats.org/drawingml/2006/main">
             <a:pPr>
-              <a:buNone/>
               <a:defRPr sz="2100" b="0">
                 <a:solidFill>
-                  <a:srgbClr val="101B20"/>
+                  <a:srgbClr val="202723"/>
                 </a:solidFill>
                 <a:latin typeface="Arial"/>
                 <a:ea typeface="Arial"/>
@@ -4197,7 +4569,7 @@
             <a:r>
               <a:rPr sz="2100" b="0">
                 <a:solidFill>
-                  <a:srgbClr val="101B20"/>
+                  <a:srgbClr val="202723"/>
                 </a:solidFill>
                 <a:latin typeface="Arial"/>
                 <a:ea typeface="Arial"/>
@@ -4210,10 +4582,10 @@
       </p:sp>
       <p:sp>
         <p:nvSpPr>
-          <p:cNvPr id="8" name="same-core">
-            <a:extLst xmlns:a="http://schemas.openxmlformats.org/drawingml/2006/main">
-              <a:ext uri="{FF2B5EF4-FFF2-40B4-BE49-F238E27FC236}">
-                <a16:creationId xmlns:a16="http://schemas.microsoft.com/office/drawing/2014/main" id="{4CE26247-DDCF-407A-B812-AFC21B03F571}"/>
+          <p:cNvPr id="12" name="same-core">
+            <a:extLst xmlns:a="http://schemas.openxmlformats.org/drawingml/2006/main">
+              <a:ext uri="{FF2B5EF4-FFF2-40B4-BE49-F238E27FC236}">
+                <a16:creationId xmlns:a16="http://schemas.microsoft.com/office/drawing/2014/main" id="{472EB694-B21D-40DB-818E-B7AE3EDDE991}"/>
               </a:ext>
             </a:extLst>
           </p:cNvPr>
@@ -4243,10 +4615,9 @@
           <a:lstStyle xmlns:a="http://schemas.openxmlformats.org/drawingml/2006/main"/>
           <a:p xmlns:a="http://schemas.openxmlformats.org/drawingml/2006/main">
             <a:pPr>
-              <a:buNone/>
               <a:defRPr sz="1800" b="0">
                 <a:solidFill>
-                  <a:srgbClr val="607077"/>
+                  <a:srgbClr val="5C6758"/>
                 </a:solidFill>
                 <a:latin typeface="Arial"/>
                 <a:ea typeface="Arial"/>
@@ -4256,7 +4627,7 @@
             <a:r>
               <a:rPr sz="1800" b="0">
                 <a:solidFill>
-                  <a:srgbClr val="607077"/>
+                  <a:srgbClr val="5C6758"/>
                 </a:solidFill>
                 <a:latin typeface="Arial"/>
                 <a:ea typeface="Arial"/>
@@ -4270,7 +4641,7 @@
     </p:spTree>
     <p:extLst>
       <p:ext uri="{BB962C8B-B14F-4D97-AF65-F5344CB8AC3E}">
-        <p14:creationId xmlns:p14="http://schemas.microsoft.com/office/powerpoint/2010/main" val="1364267811"/>
+        <p14:creationId xmlns:p14="http://schemas.microsoft.com/office/powerpoint/2010/main" val="1760364097"/>
       </p:ext>
     </p:extLst>
   </p:cSld>
@@ -4283,7 +4654,7 @@
     <p:bg>
       <p:bgPr>
         <a:solidFill xmlns:a="http://schemas.openxmlformats.org/drawingml/2006/main">
-          <a:srgbClr val="F4F4EF"/>
+          <a:srgbClr val="F4F3EE"/>
         </a:solidFill>
       </p:bgPr>
     </p:bg>
@@ -4298,10 +4669,137 @@
       </p:grpSpPr>
       <p:sp>
         <p:nvSpPr>
-          <p:cNvPr id="8" name="section">
-            <a:extLst xmlns:a="http://schemas.openxmlformats.org/drawingml/2006/main">
-              <a:ext uri="{FF2B5EF4-FFF2-40B4-BE49-F238E27FC236}">
-                <a16:creationId xmlns:a16="http://schemas.microsoft.com/office/drawing/2014/main" id="{5976D8C6-4219-44BF-BFF3-DDD1D31CB8B2}"/>
+          <p:cNvPr id="12" name="Hormuz mark boundary">
+            <a:extLst xmlns:a="http://schemas.openxmlformats.org/drawingml/2006/main">
+              <a:ext uri="{FF2B5EF4-FFF2-40B4-BE49-F238E27FC236}">
+                <a16:creationId xmlns:a16="http://schemas.microsoft.com/office/drawing/2014/main" id="{82BA60F8-E48E-41A0-BF97-82F7B8FCC727}"/>
+              </a:ext>
+            </a:extLst>
+          </p:cNvPr>
+          <p:cNvSpPr>
+            <a:spLocks xmlns:a="http://schemas.openxmlformats.org/drawingml/2006/main" noGrp="1"/>
+          </p:cNvSpPr>
+          <p:nvPr/>
+        </p:nvSpPr>
+        <p:spPr>
+          <a:xfrm xmlns:a="http://schemas.openxmlformats.org/drawingml/2006/main">
+            <a:off x="11201400" y="333375"/>
+            <a:ext cx="381000" cy="381000"/>
+          </a:xfrm>
+          <a:prstGeom xmlns:a="http://schemas.openxmlformats.org/drawingml/2006/main" prst="ellipse">
+            <a:avLst/>
+          </a:prstGeom>
+          <a:noFill xmlns:a="http://schemas.openxmlformats.org/drawingml/2006/main"/>
+          <a:ln xmlns:a="http://schemas.openxmlformats.org/drawingml/2006/main" w="9525">
+            <a:solidFill>
+              <a:srgbClr val="31684B"/>
+            </a:solidFill>
+            <a:prstDash val="solid"/>
+          </a:ln>
+        </p:spPr>
+      </p:sp>
+      <p:sp>
+        <p:nvSpPr>
+          <p:cNvPr id="2" name="Hormuz mark bar 1">
+            <a:extLst xmlns:a="http://schemas.openxmlformats.org/drawingml/2006/main">
+              <a:ext uri="{FF2B5EF4-FFF2-40B4-BE49-F238E27FC236}">
+                <a16:creationId xmlns:a16="http://schemas.microsoft.com/office/drawing/2014/main" id="{F7BA9873-C35C-4C93-9DEF-1333732BE49C}"/>
+              </a:ext>
+            </a:extLst>
+          </p:cNvPr>
+          <p:cNvSpPr>
+            <a:spLocks xmlns:a="http://schemas.openxmlformats.org/drawingml/2006/main" noGrp="1"/>
+          </p:cNvSpPr>
+          <p:nvPr/>
+        </p:nvSpPr>
+        <p:spPr>
+          <a:xfrm xmlns:a="http://schemas.openxmlformats.org/drawingml/2006/main">
+            <a:off x="11287125" y="476250"/>
+            <a:ext cx="47625" cy="95250"/>
+          </a:xfrm>
+          <a:prstGeom xmlns:a="http://schemas.openxmlformats.org/drawingml/2006/main" prst="roundRect">
+            <a:avLst>
+              <a:gd name="adj" fmla="val 50000"/>
+            </a:avLst>
+          </a:prstGeom>
+          <a:solidFill xmlns:a="http://schemas.openxmlformats.org/drawingml/2006/main">
+            <a:srgbClr val="31684B"/>
+          </a:solidFill>
+          <a:ln xmlns:a="http://schemas.openxmlformats.org/drawingml/2006/main" w="0">
+            <a:noFill/>
+          </a:ln>
+        </p:spPr>
+      </p:sp>
+      <p:sp>
+        <p:nvSpPr>
+          <p:cNvPr id="3" name="Hormuz mark bar 2">
+            <a:extLst xmlns:a="http://schemas.openxmlformats.org/drawingml/2006/main">
+              <a:ext uri="{FF2B5EF4-FFF2-40B4-BE49-F238E27FC236}">
+                <a16:creationId xmlns:a16="http://schemas.microsoft.com/office/drawing/2014/main" id="{C683C0AC-E6C6-4365-8918-8D955AA578D3}"/>
+              </a:ext>
+            </a:extLst>
+          </p:cNvPr>
+          <p:cNvSpPr>
+            <a:spLocks xmlns:a="http://schemas.openxmlformats.org/drawingml/2006/main" noGrp="1"/>
+          </p:cNvSpPr>
+          <p:nvPr/>
+        </p:nvSpPr>
+        <p:spPr>
+          <a:xfrm xmlns:a="http://schemas.openxmlformats.org/drawingml/2006/main">
+            <a:off x="11363325" y="428625"/>
+            <a:ext cx="47625" cy="190500"/>
+          </a:xfrm>
+          <a:prstGeom xmlns:a="http://schemas.openxmlformats.org/drawingml/2006/main" prst="roundRect">
+            <a:avLst>
+              <a:gd name="adj" fmla="val 50000"/>
+            </a:avLst>
+          </a:prstGeom>
+          <a:solidFill xmlns:a="http://schemas.openxmlformats.org/drawingml/2006/main">
+            <a:srgbClr val="31684B"/>
+          </a:solidFill>
+          <a:ln xmlns:a="http://schemas.openxmlformats.org/drawingml/2006/main" w="0">
+            <a:noFill/>
+          </a:ln>
+        </p:spPr>
+      </p:sp>
+      <p:sp>
+        <p:nvSpPr>
+          <p:cNvPr id="4" name="Hormuz mark bar 3">
+            <a:extLst xmlns:a="http://schemas.openxmlformats.org/drawingml/2006/main">
+              <a:ext uri="{FF2B5EF4-FFF2-40B4-BE49-F238E27FC236}">
+                <a16:creationId xmlns:a16="http://schemas.microsoft.com/office/drawing/2014/main" id="{5188A792-E670-4BA8-86E4-2A7DF1AAC81A}"/>
+              </a:ext>
+            </a:extLst>
+          </p:cNvPr>
+          <p:cNvSpPr>
+            <a:spLocks xmlns:a="http://schemas.openxmlformats.org/drawingml/2006/main" noGrp="1"/>
+          </p:cNvSpPr>
+          <p:nvPr/>
+        </p:nvSpPr>
+        <p:spPr>
+          <a:xfrm xmlns:a="http://schemas.openxmlformats.org/drawingml/2006/main">
+            <a:off x="11439525" y="457200"/>
+            <a:ext cx="47625" cy="133350"/>
+          </a:xfrm>
+          <a:prstGeom xmlns:a="http://schemas.openxmlformats.org/drawingml/2006/main" prst="roundRect">
+            <a:avLst>
+              <a:gd name="adj" fmla="val 50000"/>
+            </a:avLst>
+          </a:prstGeom>
+          <a:solidFill xmlns:a="http://schemas.openxmlformats.org/drawingml/2006/main">
+            <a:srgbClr val="31684B"/>
+          </a:solidFill>
+          <a:ln xmlns:a="http://schemas.openxmlformats.org/drawingml/2006/main" w="0">
+            <a:noFill/>
+          </a:ln>
+        </p:spPr>
+      </p:sp>
+      <p:sp>
+        <p:nvSpPr>
+          <p:cNvPr id="5" name="section">
+            <a:extLst xmlns:a="http://schemas.openxmlformats.org/drawingml/2006/main">
+              <a:ext uri="{FF2B5EF4-FFF2-40B4-BE49-F238E27FC236}">
+                <a16:creationId xmlns:a16="http://schemas.microsoft.com/office/drawing/2014/main" id="{274BED0C-67A7-465D-A381-62A491117FD4}"/>
               </a:ext>
             </a:extLst>
           </p:cNvPr>
@@ -4331,10 +4829,9 @@
           <a:lstStyle xmlns:a="http://schemas.openxmlformats.org/drawingml/2006/main"/>
           <a:p xmlns:a="http://schemas.openxmlformats.org/drawingml/2006/main">
             <a:pPr>
-              <a:buNone/>
               <a:defRPr sz="1425" b="1">
                 <a:solidFill>
-                  <a:srgbClr val="087F78"/>
+                  <a:srgbClr val="31684B"/>
                 </a:solidFill>
                 <a:latin typeface="Arial"/>
                 <a:ea typeface="Arial"/>
@@ -4344,7 +4841,7 @@
             <a:r>
               <a:rPr sz="1425" b="1">
                 <a:solidFill>
-                  <a:srgbClr val="087F78"/>
+                  <a:srgbClr val="31684B"/>
                 </a:solidFill>
                 <a:latin typeface="Arial"/>
                 <a:ea typeface="Arial"/>
@@ -4357,10 +4854,10 @@
       </p:sp>
       <p:sp>
         <p:nvSpPr>
-          <p:cNvPr id="2" name="takeaway">
-            <a:extLst xmlns:a="http://schemas.openxmlformats.org/drawingml/2006/main">
-              <a:ext uri="{FF2B5EF4-FFF2-40B4-BE49-F238E27FC236}">
-                <a16:creationId xmlns:a16="http://schemas.microsoft.com/office/drawing/2014/main" id="{3A406360-4B36-4AC5-9D2D-F9D6E6A38A55}"/>
+          <p:cNvPr id="6" name="takeaway">
+            <a:extLst xmlns:a="http://schemas.openxmlformats.org/drawingml/2006/main">
+              <a:ext uri="{FF2B5EF4-FFF2-40B4-BE49-F238E27FC236}">
+                <a16:creationId xmlns:a16="http://schemas.microsoft.com/office/drawing/2014/main" id="{E09A70A2-41A1-4822-821A-83AB18A3B7BF}"/>
               </a:ext>
             </a:extLst>
           </p:cNvPr>
@@ -4390,10 +4887,9 @@
           <a:lstStyle xmlns:a="http://schemas.openxmlformats.org/drawingml/2006/main"/>
           <a:p xmlns:a="http://schemas.openxmlformats.org/drawingml/2006/main">
             <a:pPr>
-              <a:buNone/>
               <a:defRPr sz="3600" b="1">
                 <a:solidFill>
-                  <a:srgbClr val="101B20"/>
+                  <a:srgbClr val="202723"/>
                 </a:solidFill>
                 <a:latin typeface="Arial"/>
                 <a:ea typeface="Arial"/>
@@ -4403,7 +4899,7 @@
             <a:r>
               <a:rPr sz="3600" b="1">
                 <a:solidFill>
-                  <a:srgbClr val="101B20"/>
+                  <a:srgbClr val="202723"/>
                 </a:solidFill>
                 <a:latin typeface="Arial"/>
                 <a:ea typeface="Arial"/>
@@ -4416,10 +4912,10 @@
       </p:sp>
       <p:sp>
         <p:nvSpPr>
-          <p:cNvPr id="3" name="footer">
-            <a:extLst xmlns:a="http://schemas.openxmlformats.org/drawingml/2006/main">
-              <a:ext uri="{FF2B5EF4-FFF2-40B4-BE49-F238E27FC236}">
-                <a16:creationId xmlns:a16="http://schemas.microsoft.com/office/drawing/2014/main" id="{CB1A20B6-1B37-42CD-9944-F0FFD7CF05BA}"/>
+          <p:cNvPr id="7" name="footer">
+            <a:extLst xmlns:a="http://schemas.openxmlformats.org/drawingml/2006/main">
+              <a:ext uri="{FF2B5EF4-FFF2-40B4-BE49-F238E27FC236}">
+                <a16:creationId xmlns:a16="http://schemas.microsoft.com/office/drawing/2014/main" id="{55250360-B7C0-421F-A656-F21494B1A6CF}"/>
               </a:ext>
             </a:extLst>
           </p:cNvPr>
@@ -4449,10 +4945,9 @@
           <a:lstStyle xmlns:a="http://schemas.openxmlformats.org/drawingml/2006/main"/>
           <a:p xmlns:a="http://schemas.openxmlformats.org/drawingml/2006/main">
             <a:pPr>
-              <a:buNone/>
               <a:defRPr sz="1275" b="0">
                 <a:solidFill>
-                  <a:srgbClr val="607077"/>
+                  <a:srgbClr val="5C6758"/>
                 </a:solidFill>
                 <a:latin typeface="Arial"/>
                 <a:ea typeface="Arial"/>
@@ -4462,45 +4957,23 @@
             <a:r>
               <a:rPr sz="1275" b="0">
                 <a:solidFill>
-                  <a:srgbClr val="607077"/>
-                </a:solidFill>
-                <a:latin typeface="Arial"/>
-                <a:ea typeface="Arial"/>
-                <a:cs typeface="Arial"/>
-              </a:rPr>
-              <a:t>HORMUZ  /  Mehrdad Zaker  /  </a:t>
-            </a:r>
-            <a:r>
-              <a:rPr sz="1275" b="0">
-                <a:solidFill>
-                  <a:srgbClr val="607077"/>
-                </a:solidFill>
-                <a:latin typeface="Arial"/>
-                <a:ea typeface="Arial"/>
-                <a:cs typeface="Arial"/>
-              </a:rPr>
-              <a:t>31 Aug 2026</a:t>
-            </a:r>
-            <a:r>
-              <a:rPr sz="1275" b="0">
-                <a:solidFill>
-                  <a:srgbClr val="607077"/>
-                </a:solidFill>
-                <a:latin typeface="Arial"/>
-                <a:ea typeface="Arial"/>
-                <a:cs typeface="Arial"/>
-              </a:rPr>
-              <a:t>                                      05 / 07</a:t>
-            </a:r>
-          </a:p>
-        </p:txBody>
-      </p:sp>
-      <p:sp>
-        <p:nvSpPr>
-          <p:cNvPr id="4" name="release">
-            <a:extLst xmlns:a="http://schemas.openxmlformats.org/drawingml/2006/main">
-              <a:ext uri="{FF2B5EF4-FFF2-40B4-BE49-F238E27FC236}">
-                <a16:creationId xmlns:a16="http://schemas.microsoft.com/office/drawing/2014/main" id="{DB07CB5D-2A6E-4942-BB17-6656F16A5192}"/>
+                  <a:srgbClr val="5C6758"/>
+                </a:solidFill>
+                <a:latin typeface="Arial"/>
+                <a:ea typeface="Arial"/>
+                <a:cs typeface="Arial"/>
+              </a:rPr>
+              <a:t>HORMUZ  /  Mehrdad Zaker  /  September 2026                                      05 / 07</a:t>
+            </a:r>
+          </a:p>
+        </p:txBody>
+      </p:sp>
+      <p:sp>
+        <p:nvSpPr>
+          <p:cNvPr id="8" name="release">
+            <a:extLst xmlns:a="http://schemas.openxmlformats.org/drawingml/2006/main">
+              <a:ext uri="{FF2B5EF4-FFF2-40B4-BE49-F238E27FC236}">
+                <a16:creationId xmlns:a16="http://schemas.microsoft.com/office/drawing/2014/main" id="{4CEB40BA-5235-4561-B858-5404762FEE8C}"/>
               </a:ext>
             </a:extLst>
           </p:cNvPr>
@@ -4530,10 +5003,9 @@
           <a:lstStyle xmlns:a="http://schemas.openxmlformats.org/drawingml/2006/main"/>
           <a:p xmlns:a="http://schemas.openxmlformats.org/drawingml/2006/main">
             <a:pPr>
-              <a:buNone/>
               <a:defRPr sz="3150" b="1">
                 <a:solidFill>
-                  <a:srgbClr val="087F78"/>
+                  <a:srgbClr val="31684B"/>
                 </a:solidFill>
                 <a:latin typeface="Arial"/>
                 <a:ea typeface="Arial"/>
@@ -4543,7 +5015,7 @@
             <a:r>
               <a:rPr sz="3150" b="1">
                 <a:solidFill>
-                  <a:srgbClr val="087F78"/>
+                  <a:srgbClr val="31684B"/>
                 </a:solidFill>
                 <a:latin typeface="Arial"/>
                 <a:ea typeface="Arial"/>
@@ -4556,10 +5028,10 @@
       </p:sp>
       <p:sp>
         <p:nvSpPr>
-          <p:cNvPr id="5" name="oci">
-            <a:extLst xmlns:a="http://schemas.openxmlformats.org/drawingml/2006/main">
-              <a:ext uri="{FF2B5EF4-FFF2-40B4-BE49-F238E27FC236}">
-                <a16:creationId xmlns:a16="http://schemas.microsoft.com/office/drawing/2014/main" id="{4CA3EA19-0333-4A60-B005-A8B581166AD2}"/>
+          <p:cNvPr id="9" name="oci">
+            <a:extLst xmlns:a="http://schemas.openxmlformats.org/drawingml/2006/main">
+              <a:ext uri="{FF2B5EF4-FFF2-40B4-BE49-F238E27FC236}">
+                <a16:creationId xmlns:a16="http://schemas.microsoft.com/office/drawing/2014/main" id="{5D8B7181-E478-4000-81C8-0FCFA86C942A}"/>
               </a:ext>
             </a:extLst>
           </p:cNvPr>
@@ -4589,10 +5061,9 @@
           <a:lstStyle xmlns:a="http://schemas.openxmlformats.org/drawingml/2006/main"/>
           <a:p xmlns:a="http://schemas.openxmlformats.org/drawingml/2006/main">
             <a:pPr>
-              <a:buNone/>
               <a:defRPr sz="2100" b="0">
                 <a:solidFill>
-                  <a:srgbClr val="101B20"/>
+                  <a:srgbClr val="202723"/>
                 </a:solidFill>
                 <a:latin typeface="Arial"/>
                 <a:ea typeface="Arial"/>
@@ -4602,7 +5073,7 @@
             <a:r>
               <a:rPr sz="2100" b="0">
                 <a:solidFill>
-                  <a:srgbClr val="101B20"/>
+                  <a:srgbClr val="202723"/>
                 </a:solidFill>
                 <a:latin typeface="Arial"/>
                 <a:ea typeface="Arial"/>
@@ -4615,10 +5086,10 @@
       </p:sp>
       <p:sp>
         <p:nvSpPr>
-          <p:cNvPr id="6" name="operators">
-            <a:extLst xmlns:a="http://schemas.openxmlformats.org/drawingml/2006/main">
-              <a:ext uri="{FF2B5EF4-FFF2-40B4-BE49-F238E27FC236}">
-                <a16:creationId xmlns:a16="http://schemas.microsoft.com/office/drawing/2014/main" id="{C8CE3457-C887-48FF-BF54-D0E8CAA94A92}"/>
+          <p:cNvPr id="10" name="operators">
+            <a:extLst xmlns:a="http://schemas.openxmlformats.org/drawingml/2006/main">
+              <a:ext uri="{FF2B5EF4-FFF2-40B4-BE49-F238E27FC236}">
+                <a16:creationId xmlns:a16="http://schemas.microsoft.com/office/drawing/2014/main" id="{AFD69644-1BF8-4D60-8D4B-2071FA9CA191}"/>
               </a:ext>
             </a:extLst>
           </p:cNvPr>
@@ -4648,10 +5119,9 @@
           <a:lstStyle xmlns:a="http://schemas.openxmlformats.org/drawingml/2006/main"/>
           <a:p xmlns:a="http://schemas.openxmlformats.org/drawingml/2006/main">
             <a:pPr>
-              <a:buNone/>
               <a:defRPr sz="2325" b="1">
                 <a:solidFill>
-                  <a:srgbClr val="101B20"/>
+                  <a:srgbClr val="202723"/>
                 </a:solidFill>
                 <a:latin typeface="Arial"/>
                 <a:ea typeface="Arial"/>
@@ -4661,7 +5131,7 @@
             <a:r>
               <a:rPr sz="2325" b="1">
                 <a:solidFill>
-                  <a:srgbClr val="101B20"/>
+                  <a:srgbClr val="202723"/>
                 </a:solidFill>
                 <a:latin typeface="Arial"/>
                 <a:ea typeface="Arial"/>
@@ -4674,10 +5144,10 @@
       </p:sp>
       <p:sp>
         <p:nvSpPr>
-          <p:cNvPr id="7" name="nonclaims">
-            <a:extLst xmlns:a="http://schemas.openxmlformats.org/drawingml/2006/main">
-              <a:ext uri="{FF2B5EF4-FFF2-40B4-BE49-F238E27FC236}">
-                <a16:creationId xmlns:a16="http://schemas.microsoft.com/office/drawing/2014/main" id="{1EC00BBA-F812-48C4-8523-F9066475D122}"/>
+          <p:cNvPr id="11" name="nonclaims">
+            <a:extLst xmlns:a="http://schemas.openxmlformats.org/drawingml/2006/main">
+              <a:ext uri="{FF2B5EF4-FFF2-40B4-BE49-F238E27FC236}">
+                <a16:creationId xmlns:a16="http://schemas.microsoft.com/office/drawing/2014/main" id="{9C326810-3124-4B5D-A226-BC3C0D69417C}"/>
               </a:ext>
             </a:extLst>
           </p:cNvPr>
@@ -4707,10 +5177,9 @@
           <a:lstStyle xmlns:a="http://schemas.openxmlformats.org/drawingml/2006/main"/>
           <a:p xmlns:a="http://schemas.openxmlformats.org/drawingml/2006/main">
             <a:pPr>
-              <a:buNone/>
               <a:defRPr sz="1875" b="0">
                 <a:solidFill>
-                  <a:srgbClr val="607077"/>
+                  <a:srgbClr val="5C6758"/>
                 </a:solidFill>
                 <a:latin typeface="Arial"/>
                 <a:ea typeface="Arial"/>
@@ -4720,7 +5189,7 @@
             <a:r>
               <a:rPr sz="1875" b="0">
                 <a:solidFill>
-                  <a:srgbClr val="607077"/>
+                  <a:srgbClr val="5C6758"/>
                 </a:solidFill>
                 <a:latin typeface="Arial"/>
                 <a:ea typeface="Arial"/>
@@ -4734,7 +5203,7 @@
     </p:spTree>
     <p:extLst>
       <p:ext uri="{BB962C8B-B14F-4D97-AF65-F5344CB8AC3E}">
-        <p14:creationId xmlns:p14="http://schemas.microsoft.com/office/powerpoint/2010/main" val="898841519"/>
+        <p14:creationId xmlns:p14="http://schemas.microsoft.com/office/powerpoint/2010/main" val="537518997"/>
       </p:ext>
     </p:extLst>
   </p:cSld>
@@ -4747,7 +5216,7 @@
     <p:bg>
       <p:bgPr>
         <a:solidFill xmlns:a="http://schemas.openxmlformats.org/drawingml/2006/main">
-          <a:srgbClr val="F4F4EF"/>
+          <a:srgbClr val="F4F3EE"/>
         </a:solidFill>
       </p:bgPr>
     </p:bg>
@@ -4762,10 +5231,137 @@
       </p:grpSpPr>
       <p:sp>
         <p:nvSpPr>
-          <p:cNvPr id="14" name="section">
-            <a:extLst xmlns:a="http://schemas.openxmlformats.org/drawingml/2006/main">
-              <a:ext uri="{FF2B5EF4-FFF2-40B4-BE49-F238E27FC236}">
-                <a16:creationId xmlns:a16="http://schemas.microsoft.com/office/drawing/2014/main" id="{A672D13B-2F22-47D8-B2B3-37324461A7DA}"/>
+          <p:cNvPr id="18" name="Hormuz mark boundary">
+            <a:extLst xmlns:a="http://schemas.openxmlformats.org/drawingml/2006/main">
+              <a:ext uri="{FF2B5EF4-FFF2-40B4-BE49-F238E27FC236}">
+                <a16:creationId xmlns:a16="http://schemas.microsoft.com/office/drawing/2014/main" id="{7FF100A5-1E48-457D-91B2-17A23BB2E19A}"/>
+              </a:ext>
+            </a:extLst>
+          </p:cNvPr>
+          <p:cNvSpPr>
+            <a:spLocks xmlns:a="http://schemas.openxmlformats.org/drawingml/2006/main" noGrp="1"/>
+          </p:cNvSpPr>
+          <p:nvPr/>
+        </p:nvSpPr>
+        <p:spPr>
+          <a:xfrm xmlns:a="http://schemas.openxmlformats.org/drawingml/2006/main">
+            <a:off x="11201400" y="333375"/>
+            <a:ext cx="381000" cy="381000"/>
+          </a:xfrm>
+          <a:prstGeom xmlns:a="http://schemas.openxmlformats.org/drawingml/2006/main" prst="ellipse">
+            <a:avLst/>
+          </a:prstGeom>
+          <a:noFill xmlns:a="http://schemas.openxmlformats.org/drawingml/2006/main"/>
+          <a:ln xmlns:a="http://schemas.openxmlformats.org/drawingml/2006/main" w="9525">
+            <a:solidFill>
+              <a:srgbClr val="31684B"/>
+            </a:solidFill>
+            <a:prstDash val="solid"/>
+          </a:ln>
+        </p:spPr>
+      </p:sp>
+      <p:sp>
+        <p:nvSpPr>
+          <p:cNvPr id="2" name="Hormuz mark bar 1">
+            <a:extLst xmlns:a="http://schemas.openxmlformats.org/drawingml/2006/main">
+              <a:ext uri="{FF2B5EF4-FFF2-40B4-BE49-F238E27FC236}">
+                <a16:creationId xmlns:a16="http://schemas.microsoft.com/office/drawing/2014/main" id="{CFE84B2E-4659-41A8-9E53-3201378921CF}"/>
+              </a:ext>
+            </a:extLst>
+          </p:cNvPr>
+          <p:cNvSpPr>
+            <a:spLocks xmlns:a="http://schemas.openxmlformats.org/drawingml/2006/main" noGrp="1"/>
+          </p:cNvSpPr>
+          <p:nvPr/>
+        </p:nvSpPr>
+        <p:spPr>
+          <a:xfrm xmlns:a="http://schemas.openxmlformats.org/drawingml/2006/main">
+            <a:off x="11287125" y="476250"/>
+            <a:ext cx="47625" cy="95250"/>
+          </a:xfrm>
+          <a:prstGeom xmlns:a="http://schemas.openxmlformats.org/drawingml/2006/main" prst="roundRect">
+            <a:avLst>
+              <a:gd name="adj" fmla="val 50000"/>
+            </a:avLst>
+          </a:prstGeom>
+          <a:solidFill xmlns:a="http://schemas.openxmlformats.org/drawingml/2006/main">
+            <a:srgbClr val="31684B"/>
+          </a:solidFill>
+          <a:ln xmlns:a="http://schemas.openxmlformats.org/drawingml/2006/main" w="0">
+            <a:noFill/>
+          </a:ln>
+        </p:spPr>
+      </p:sp>
+      <p:sp>
+        <p:nvSpPr>
+          <p:cNvPr id="3" name="Hormuz mark bar 2">
+            <a:extLst xmlns:a="http://schemas.openxmlformats.org/drawingml/2006/main">
+              <a:ext uri="{FF2B5EF4-FFF2-40B4-BE49-F238E27FC236}">
+                <a16:creationId xmlns:a16="http://schemas.microsoft.com/office/drawing/2014/main" id="{BA77988F-27B6-4B6D-B067-E13FF5B59FAE}"/>
+              </a:ext>
+            </a:extLst>
+          </p:cNvPr>
+          <p:cNvSpPr>
+            <a:spLocks xmlns:a="http://schemas.openxmlformats.org/drawingml/2006/main" noGrp="1"/>
+          </p:cNvSpPr>
+          <p:nvPr/>
+        </p:nvSpPr>
+        <p:spPr>
+          <a:xfrm xmlns:a="http://schemas.openxmlformats.org/drawingml/2006/main">
+            <a:off x="11363325" y="428625"/>
+            <a:ext cx="47625" cy="190500"/>
+          </a:xfrm>
+          <a:prstGeom xmlns:a="http://schemas.openxmlformats.org/drawingml/2006/main" prst="roundRect">
+            <a:avLst>
+              <a:gd name="adj" fmla="val 50000"/>
+            </a:avLst>
+          </a:prstGeom>
+          <a:solidFill xmlns:a="http://schemas.openxmlformats.org/drawingml/2006/main">
+            <a:srgbClr val="31684B"/>
+          </a:solidFill>
+          <a:ln xmlns:a="http://schemas.openxmlformats.org/drawingml/2006/main" w="0">
+            <a:noFill/>
+          </a:ln>
+        </p:spPr>
+      </p:sp>
+      <p:sp>
+        <p:nvSpPr>
+          <p:cNvPr id="4" name="Hormuz mark bar 3">
+            <a:extLst xmlns:a="http://schemas.openxmlformats.org/drawingml/2006/main">
+              <a:ext uri="{FF2B5EF4-FFF2-40B4-BE49-F238E27FC236}">
+                <a16:creationId xmlns:a16="http://schemas.microsoft.com/office/drawing/2014/main" id="{13E2A8B4-D1BB-4498-8535-48651ADFB927}"/>
+              </a:ext>
+            </a:extLst>
+          </p:cNvPr>
+          <p:cNvSpPr>
+            <a:spLocks xmlns:a="http://schemas.openxmlformats.org/drawingml/2006/main" noGrp="1"/>
+          </p:cNvSpPr>
+          <p:nvPr/>
+        </p:nvSpPr>
+        <p:spPr>
+          <a:xfrm xmlns:a="http://schemas.openxmlformats.org/drawingml/2006/main">
+            <a:off x="11439525" y="457200"/>
+            <a:ext cx="47625" cy="133350"/>
+          </a:xfrm>
+          <a:prstGeom xmlns:a="http://schemas.openxmlformats.org/drawingml/2006/main" prst="roundRect">
+            <a:avLst>
+              <a:gd name="adj" fmla="val 50000"/>
+            </a:avLst>
+          </a:prstGeom>
+          <a:solidFill xmlns:a="http://schemas.openxmlformats.org/drawingml/2006/main">
+            <a:srgbClr val="31684B"/>
+          </a:solidFill>
+          <a:ln xmlns:a="http://schemas.openxmlformats.org/drawingml/2006/main" w="0">
+            <a:noFill/>
+          </a:ln>
+        </p:spPr>
+      </p:sp>
+      <p:sp>
+        <p:nvSpPr>
+          <p:cNvPr id="5" name="section">
+            <a:extLst xmlns:a="http://schemas.openxmlformats.org/drawingml/2006/main">
+              <a:ext uri="{FF2B5EF4-FFF2-40B4-BE49-F238E27FC236}">
+                <a16:creationId xmlns:a16="http://schemas.microsoft.com/office/drawing/2014/main" id="{B90C36A3-418B-4E46-9AAD-9C06C683C043}"/>
               </a:ext>
             </a:extLst>
           </p:cNvPr>
@@ -4795,10 +5391,9 @@
           <a:lstStyle xmlns:a="http://schemas.openxmlformats.org/drawingml/2006/main"/>
           <a:p xmlns:a="http://schemas.openxmlformats.org/drawingml/2006/main">
             <a:pPr>
-              <a:buNone/>
               <a:defRPr sz="1425" b="1">
                 <a:solidFill>
-                  <a:srgbClr val="087F78"/>
+                  <a:srgbClr val="31684B"/>
                 </a:solidFill>
                 <a:latin typeface="Arial"/>
                 <a:ea typeface="Arial"/>
@@ -4808,7 +5403,7 @@
             <a:r>
               <a:rPr sz="1425" b="1">
                 <a:solidFill>
-                  <a:srgbClr val="087F78"/>
+                  <a:srgbClr val="31684B"/>
                 </a:solidFill>
                 <a:latin typeface="Arial"/>
                 <a:ea typeface="Arial"/>
@@ -4821,10 +5416,10 @@
       </p:sp>
       <p:sp>
         <p:nvSpPr>
-          <p:cNvPr id="2" name="takeaway">
-            <a:extLst xmlns:a="http://schemas.openxmlformats.org/drawingml/2006/main">
-              <a:ext uri="{FF2B5EF4-FFF2-40B4-BE49-F238E27FC236}">
-                <a16:creationId xmlns:a16="http://schemas.microsoft.com/office/drawing/2014/main" id="{376FEEF3-9B4C-4E6F-BBD7-ABF9E3A27D97}"/>
+          <p:cNvPr id="6" name="takeaway">
+            <a:extLst xmlns:a="http://schemas.openxmlformats.org/drawingml/2006/main">
+              <a:ext uri="{FF2B5EF4-FFF2-40B4-BE49-F238E27FC236}">
+                <a16:creationId xmlns:a16="http://schemas.microsoft.com/office/drawing/2014/main" id="{CEDC67C9-8B63-4E2D-8A16-22006DB751F2}"/>
               </a:ext>
             </a:extLst>
           </p:cNvPr>
@@ -4854,10 +5449,9 @@
           <a:lstStyle xmlns:a="http://schemas.openxmlformats.org/drawingml/2006/main"/>
           <a:p xmlns:a="http://schemas.openxmlformats.org/drawingml/2006/main">
             <a:pPr>
-              <a:buNone/>
               <a:defRPr sz="3600" b="1">
                 <a:solidFill>
-                  <a:srgbClr val="101B20"/>
+                  <a:srgbClr val="202723"/>
                 </a:solidFill>
                 <a:latin typeface="Arial"/>
                 <a:ea typeface="Arial"/>
@@ -4867,7 +5461,7 @@
             <a:r>
               <a:rPr sz="3600" b="1">
                 <a:solidFill>
-                  <a:srgbClr val="101B20"/>
+                  <a:srgbClr val="202723"/>
                 </a:solidFill>
                 <a:latin typeface="Arial"/>
                 <a:ea typeface="Arial"/>
@@ -4880,10 +5474,10 @@
       </p:sp>
       <p:sp>
         <p:nvSpPr>
-          <p:cNvPr id="3" name="footer">
-            <a:extLst xmlns:a="http://schemas.openxmlformats.org/drawingml/2006/main">
-              <a:ext uri="{FF2B5EF4-FFF2-40B4-BE49-F238E27FC236}">
-                <a16:creationId xmlns:a16="http://schemas.microsoft.com/office/drawing/2014/main" id="{FB5285A5-2CF4-47FB-AB0A-475EC7D6FB5F}"/>
+          <p:cNvPr id="7" name="footer">
+            <a:extLst xmlns:a="http://schemas.openxmlformats.org/drawingml/2006/main">
+              <a:ext uri="{FF2B5EF4-FFF2-40B4-BE49-F238E27FC236}">
+                <a16:creationId xmlns:a16="http://schemas.microsoft.com/office/drawing/2014/main" id="{41574274-CEE7-46D6-8D87-CC25B7E22269}"/>
               </a:ext>
             </a:extLst>
           </p:cNvPr>
@@ -4913,10 +5507,9 @@
           <a:lstStyle xmlns:a="http://schemas.openxmlformats.org/drawingml/2006/main"/>
           <a:p xmlns:a="http://schemas.openxmlformats.org/drawingml/2006/main">
             <a:pPr>
-              <a:buNone/>
               <a:defRPr sz="1275" b="0">
                 <a:solidFill>
-                  <a:srgbClr val="607077"/>
+                  <a:srgbClr val="5C6758"/>
                 </a:solidFill>
                 <a:latin typeface="Arial"/>
                 <a:ea typeface="Arial"/>
@@ -4926,45 +5519,23 @@
             <a:r>
               <a:rPr sz="1275" b="0">
                 <a:solidFill>
-                  <a:srgbClr val="607077"/>
-                </a:solidFill>
-                <a:latin typeface="Arial"/>
-                <a:ea typeface="Arial"/>
-                <a:cs typeface="Arial"/>
-              </a:rPr>
-              <a:t>HORMUZ  /  Mehrdad Zaker  /  </a:t>
-            </a:r>
-            <a:r>
-              <a:rPr sz="1275" b="0">
-                <a:solidFill>
-                  <a:srgbClr val="607077"/>
-                </a:solidFill>
-                <a:latin typeface="Arial"/>
-                <a:ea typeface="Arial"/>
-                <a:cs typeface="Arial"/>
-              </a:rPr>
-              <a:t>31 Aug 2026</a:t>
-            </a:r>
-            <a:r>
-              <a:rPr sz="1275" b="0">
-                <a:solidFill>
-                  <a:srgbClr val="607077"/>
-                </a:solidFill>
-                <a:latin typeface="Arial"/>
-                <a:ea typeface="Arial"/>
-                <a:cs typeface="Arial"/>
-              </a:rPr>
-              <a:t>                                      06 / 07</a:t>
-            </a:r>
-          </a:p>
-        </p:txBody>
-      </p:sp>
-      <p:sp>
-        <p:nvSpPr>
-          <p:cNvPr id="4" name="phase-01">
-            <a:extLst xmlns:a="http://schemas.openxmlformats.org/drawingml/2006/main">
-              <a:ext uri="{FF2B5EF4-FFF2-40B4-BE49-F238E27FC236}">
-                <a16:creationId xmlns:a16="http://schemas.microsoft.com/office/drawing/2014/main" id="{24DB61EF-6823-44E7-83EA-801A22E58EFC}"/>
+                  <a:srgbClr val="5C6758"/>
+                </a:solidFill>
+                <a:latin typeface="Arial"/>
+                <a:ea typeface="Arial"/>
+                <a:cs typeface="Arial"/>
+              </a:rPr>
+              <a:t>HORMUZ  /  Mehrdad Zaker  /  September 2026                                      06 / 07</a:t>
+            </a:r>
+          </a:p>
+        </p:txBody>
+      </p:sp>
+      <p:sp>
+        <p:nvSpPr>
+          <p:cNvPr id="8" name="phase-01">
+            <a:extLst xmlns:a="http://schemas.openxmlformats.org/drawingml/2006/main">
+              <a:ext uri="{FF2B5EF4-FFF2-40B4-BE49-F238E27FC236}">
+                <a16:creationId xmlns:a16="http://schemas.microsoft.com/office/drawing/2014/main" id="{0C18BF1D-A1DA-4C3B-A5A8-10C0BF2FE210}"/>
               </a:ext>
             </a:extLst>
           </p:cNvPr>
@@ -4994,10 +5565,9 @@
           <a:lstStyle xmlns:a="http://schemas.openxmlformats.org/drawingml/2006/main"/>
           <a:p xmlns:a="http://schemas.openxmlformats.org/drawingml/2006/main">
             <a:pPr>
-              <a:buNone/>
               <a:defRPr sz="4050" b="1">
                 <a:solidFill>
-                  <a:srgbClr val="087F78"/>
+                  <a:srgbClr val="31684B"/>
                 </a:solidFill>
                 <a:latin typeface="Arial"/>
                 <a:ea typeface="Arial"/>
@@ -5007,7 +5577,7 @@
             <a:r>
               <a:rPr sz="4050" b="1">
                 <a:solidFill>
-                  <a:srgbClr val="087F78"/>
+                  <a:srgbClr val="31684B"/>
                 </a:solidFill>
                 <a:latin typeface="Arial"/>
                 <a:ea typeface="Arial"/>
@@ -5020,10 +5590,10 @@
       </p:sp>
       <p:sp>
         <p:nvSpPr>
-          <p:cNvPr id="5" name="phase-title-01">
-            <a:extLst xmlns:a="http://schemas.openxmlformats.org/drawingml/2006/main">
-              <a:ext uri="{FF2B5EF4-FFF2-40B4-BE49-F238E27FC236}">
-                <a16:creationId xmlns:a16="http://schemas.microsoft.com/office/drawing/2014/main" id="{79DAC194-3B53-4E37-805E-0D5A9CC84B87}"/>
+          <p:cNvPr id="9" name="phase-title-01">
+            <a:extLst xmlns:a="http://schemas.openxmlformats.org/drawingml/2006/main">
+              <a:ext uri="{FF2B5EF4-FFF2-40B4-BE49-F238E27FC236}">
+                <a16:creationId xmlns:a16="http://schemas.microsoft.com/office/drawing/2014/main" id="{F37A19FA-4D61-4AA3-ACA3-564DAE2FCBC4}"/>
               </a:ext>
             </a:extLst>
           </p:cNvPr>
@@ -5053,10 +5623,9 @@
           <a:lstStyle xmlns:a="http://schemas.openxmlformats.org/drawingml/2006/main"/>
           <a:p xmlns:a="http://schemas.openxmlformats.org/drawingml/2006/main">
             <a:pPr>
-              <a:buNone/>
               <a:defRPr sz="2325" b="1">
                 <a:solidFill>
-                  <a:srgbClr val="101B20"/>
+                  <a:srgbClr val="202723"/>
                 </a:solidFill>
                 <a:latin typeface="Arial"/>
                 <a:ea typeface="Arial"/>
@@ -5066,7 +5635,7 @@
             <a:r>
               <a:rPr sz="2325" b="1">
                 <a:solidFill>
-                  <a:srgbClr val="101B20"/>
+                  <a:srgbClr val="202723"/>
                 </a:solidFill>
                 <a:latin typeface="Arial"/>
                 <a:ea typeface="Arial"/>
@@ -5079,10 +5648,10 @@
       </p:sp>
       <p:sp>
         <p:nvSpPr>
-          <p:cNvPr id="6" name="phase-body-01">
-            <a:extLst xmlns:a="http://schemas.openxmlformats.org/drawingml/2006/main">
-              <a:ext uri="{FF2B5EF4-FFF2-40B4-BE49-F238E27FC236}">
-                <a16:creationId xmlns:a16="http://schemas.microsoft.com/office/drawing/2014/main" id="{7CF5F6F6-9A18-4229-B73E-72753F1FA5F6}"/>
+          <p:cNvPr id="10" name="phase-body-01">
+            <a:extLst xmlns:a="http://schemas.openxmlformats.org/drawingml/2006/main">
+              <a:ext uri="{FF2B5EF4-FFF2-40B4-BE49-F238E27FC236}">
+                <a16:creationId xmlns:a16="http://schemas.microsoft.com/office/drawing/2014/main" id="{953BA0C1-DD1A-4FFA-81AE-55449AC357C3}"/>
               </a:ext>
             </a:extLst>
           </p:cNvPr>
@@ -5112,10 +5681,9 @@
           <a:lstStyle xmlns:a="http://schemas.openxmlformats.org/drawingml/2006/main"/>
           <a:p xmlns:a="http://schemas.openxmlformats.org/drawingml/2006/main">
             <a:pPr>
-              <a:buNone/>
               <a:defRPr sz="1950" b="0">
                 <a:solidFill>
-                  <a:srgbClr val="101B20"/>
+                  <a:srgbClr val="202723"/>
                 </a:solidFill>
                 <a:latin typeface="Arial"/>
                 <a:ea typeface="Arial"/>
@@ -5125,7 +5693,7 @@
             <a:r>
               <a:rPr sz="1950" b="0">
                 <a:solidFill>
-                  <a:srgbClr val="101B20"/>
+                  <a:srgbClr val="202723"/>
                 </a:solidFill>
                 <a:latin typeface="Arial"/>
                 <a:ea typeface="Arial"/>
@@ -5138,10 +5706,10 @@
       </p:sp>
       <p:sp>
         <p:nvSpPr>
-          <p:cNvPr id="7" name="phase-02">
-            <a:extLst xmlns:a="http://schemas.openxmlformats.org/drawingml/2006/main">
-              <a:ext uri="{FF2B5EF4-FFF2-40B4-BE49-F238E27FC236}">
-                <a16:creationId xmlns:a16="http://schemas.microsoft.com/office/drawing/2014/main" id="{84E85E8E-2DCF-4E55-A0AD-F3F9F35BE8AD}"/>
+          <p:cNvPr id="11" name="phase-02">
+            <a:extLst xmlns:a="http://schemas.openxmlformats.org/drawingml/2006/main">
+              <a:ext uri="{FF2B5EF4-FFF2-40B4-BE49-F238E27FC236}">
+                <a16:creationId xmlns:a16="http://schemas.microsoft.com/office/drawing/2014/main" id="{B8F2BB3D-1CD6-4324-BB8B-47FE8014D64D}"/>
               </a:ext>
             </a:extLst>
           </p:cNvPr>
@@ -5171,10 +5739,9 @@
           <a:lstStyle xmlns:a="http://schemas.openxmlformats.org/drawingml/2006/main"/>
           <a:p xmlns:a="http://schemas.openxmlformats.org/drawingml/2006/main">
             <a:pPr>
-              <a:buNone/>
               <a:defRPr sz="4050" b="1">
                 <a:solidFill>
-                  <a:srgbClr val="087F78"/>
+                  <a:srgbClr val="31684B"/>
                 </a:solidFill>
                 <a:latin typeface="Arial"/>
                 <a:ea typeface="Arial"/>
@@ -5184,7 +5751,7 @@
             <a:r>
               <a:rPr sz="4050" b="1">
                 <a:solidFill>
-                  <a:srgbClr val="087F78"/>
+                  <a:srgbClr val="31684B"/>
                 </a:solidFill>
                 <a:latin typeface="Arial"/>
                 <a:ea typeface="Arial"/>
@@ -5197,10 +5764,10 @@
       </p:sp>
       <p:sp>
         <p:nvSpPr>
-          <p:cNvPr id="8" name="phase-title-02">
-            <a:extLst xmlns:a="http://schemas.openxmlformats.org/drawingml/2006/main">
-              <a:ext uri="{FF2B5EF4-FFF2-40B4-BE49-F238E27FC236}">
-                <a16:creationId xmlns:a16="http://schemas.microsoft.com/office/drawing/2014/main" id="{D85ED308-3B8E-43C9-92A3-3D407D1730ED}"/>
+          <p:cNvPr id="12" name="phase-title-02">
+            <a:extLst xmlns:a="http://schemas.openxmlformats.org/drawingml/2006/main">
+              <a:ext uri="{FF2B5EF4-FFF2-40B4-BE49-F238E27FC236}">
+                <a16:creationId xmlns:a16="http://schemas.microsoft.com/office/drawing/2014/main" id="{8F8811D2-88CD-4313-9980-A03B548F3564}"/>
               </a:ext>
             </a:extLst>
           </p:cNvPr>
@@ -5230,10 +5797,9 @@
           <a:lstStyle xmlns:a="http://schemas.openxmlformats.org/drawingml/2006/main"/>
           <a:p xmlns:a="http://schemas.openxmlformats.org/drawingml/2006/main">
             <a:pPr>
-              <a:buNone/>
               <a:defRPr sz="2325" b="1">
                 <a:solidFill>
-                  <a:srgbClr val="101B20"/>
+                  <a:srgbClr val="202723"/>
                 </a:solidFill>
                 <a:latin typeface="Arial"/>
                 <a:ea typeface="Arial"/>
@@ -5243,7 +5809,7 @@
             <a:r>
               <a:rPr sz="2325" b="1">
                 <a:solidFill>
-                  <a:srgbClr val="101B20"/>
+                  <a:srgbClr val="202723"/>
                 </a:solidFill>
                 <a:latin typeface="Arial"/>
                 <a:ea typeface="Arial"/>
@@ -5256,10 +5822,10 @@
       </p:sp>
       <p:sp>
         <p:nvSpPr>
-          <p:cNvPr id="9" name="phase-body-02">
-            <a:extLst xmlns:a="http://schemas.openxmlformats.org/drawingml/2006/main">
-              <a:ext uri="{FF2B5EF4-FFF2-40B4-BE49-F238E27FC236}">
-                <a16:creationId xmlns:a16="http://schemas.microsoft.com/office/drawing/2014/main" id="{D2A6368C-1BD2-4F5B-AE6B-6E9C7EBDC68E}"/>
+          <p:cNvPr id="13" name="phase-body-02">
+            <a:extLst xmlns:a="http://schemas.openxmlformats.org/drawingml/2006/main">
+              <a:ext uri="{FF2B5EF4-FFF2-40B4-BE49-F238E27FC236}">
+                <a16:creationId xmlns:a16="http://schemas.microsoft.com/office/drawing/2014/main" id="{70A3A507-384E-43D1-A9B3-DA6FA77F64F1}"/>
               </a:ext>
             </a:extLst>
           </p:cNvPr>
@@ -5289,10 +5855,9 @@
           <a:lstStyle xmlns:a="http://schemas.openxmlformats.org/drawingml/2006/main"/>
           <a:p xmlns:a="http://schemas.openxmlformats.org/drawingml/2006/main">
             <a:pPr>
-              <a:buNone/>
               <a:defRPr sz="1950" b="0">
                 <a:solidFill>
-                  <a:srgbClr val="101B20"/>
+                  <a:srgbClr val="202723"/>
                 </a:solidFill>
                 <a:latin typeface="Arial"/>
                 <a:ea typeface="Arial"/>
@@ -5302,7 +5867,7 @@
             <a:r>
               <a:rPr sz="1950" b="0">
                 <a:solidFill>
-                  <a:srgbClr val="101B20"/>
+                  <a:srgbClr val="202723"/>
                 </a:solidFill>
                 <a:latin typeface="Arial"/>
                 <a:ea typeface="Arial"/>
@@ -5315,10 +5880,10 @@
       </p:sp>
       <p:sp>
         <p:nvSpPr>
-          <p:cNvPr id="10" name="phase-03">
-            <a:extLst xmlns:a="http://schemas.openxmlformats.org/drawingml/2006/main">
-              <a:ext uri="{FF2B5EF4-FFF2-40B4-BE49-F238E27FC236}">
-                <a16:creationId xmlns:a16="http://schemas.microsoft.com/office/drawing/2014/main" id="{00B7D47E-2A8E-4FC6-A009-36E57C9EAF27}"/>
+          <p:cNvPr id="14" name="phase-03">
+            <a:extLst xmlns:a="http://schemas.openxmlformats.org/drawingml/2006/main">
+              <a:ext uri="{FF2B5EF4-FFF2-40B4-BE49-F238E27FC236}">
+                <a16:creationId xmlns:a16="http://schemas.microsoft.com/office/drawing/2014/main" id="{67FA1F05-D398-454C-86BB-F63D3DF4EE6A}"/>
               </a:ext>
             </a:extLst>
           </p:cNvPr>
@@ -5348,10 +5913,9 @@
           <a:lstStyle xmlns:a="http://schemas.openxmlformats.org/drawingml/2006/main"/>
           <a:p xmlns:a="http://schemas.openxmlformats.org/drawingml/2006/main">
             <a:pPr>
-              <a:buNone/>
               <a:defRPr sz="4050" b="1">
                 <a:solidFill>
-                  <a:srgbClr val="087F78"/>
+                  <a:srgbClr val="31684B"/>
                 </a:solidFill>
                 <a:latin typeface="Arial"/>
                 <a:ea typeface="Arial"/>
@@ -5361,7 +5925,7 @@
             <a:r>
               <a:rPr sz="4050" b="1">
                 <a:solidFill>
-                  <a:srgbClr val="087F78"/>
+                  <a:srgbClr val="31684B"/>
                 </a:solidFill>
                 <a:latin typeface="Arial"/>
                 <a:ea typeface="Arial"/>
@@ -5374,10 +5938,10 @@
       </p:sp>
       <p:sp>
         <p:nvSpPr>
-          <p:cNvPr id="11" name="phase-title-03">
-            <a:extLst xmlns:a="http://schemas.openxmlformats.org/drawingml/2006/main">
-              <a:ext uri="{FF2B5EF4-FFF2-40B4-BE49-F238E27FC236}">
-                <a16:creationId xmlns:a16="http://schemas.microsoft.com/office/drawing/2014/main" id="{219D47EA-9F6F-485B-BA86-FF8006533F15}"/>
+          <p:cNvPr id="15" name="phase-title-03">
+            <a:extLst xmlns:a="http://schemas.openxmlformats.org/drawingml/2006/main">
+              <a:ext uri="{FF2B5EF4-FFF2-40B4-BE49-F238E27FC236}">
+                <a16:creationId xmlns:a16="http://schemas.microsoft.com/office/drawing/2014/main" id="{BEADE460-14C1-4BEA-AC8B-E1EE1D0614A3}"/>
               </a:ext>
             </a:extLst>
           </p:cNvPr>
@@ -5407,10 +5971,9 @@
           <a:lstStyle xmlns:a="http://schemas.openxmlformats.org/drawingml/2006/main"/>
           <a:p xmlns:a="http://schemas.openxmlformats.org/drawingml/2006/main">
             <a:pPr>
-              <a:buNone/>
               <a:defRPr sz="2325" b="1">
                 <a:solidFill>
-                  <a:srgbClr val="101B20"/>
+                  <a:srgbClr val="202723"/>
                 </a:solidFill>
                 <a:latin typeface="Arial"/>
                 <a:ea typeface="Arial"/>
@@ -5420,7 +5983,7 @@
             <a:r>
               <a:rPr sz="2325" b="1">
                 <a:solidFill>
-                  <a:srgbClr val="101B20"/>
+                  <a:srgbClr val="202723"/>
                 </a:solidFill>
                 <a:latin typeface="Arial"/>
                 <a:ea typeface="Arial"/>
@@ -5433,10 +5996,10 @@
       </p:sp>
       <p:sp>
         <p:nvSpPr>
-          <p:cNvPr id="12" name="phase-body-03">
-            <a:extLst xmlns:a="http://schemas.openxmlformats.org/drawingml/2006/main">
-              <a:ext uri="{FF2B5EF4-FFF2-40B4-BE49-F238E27FC236}">
-                <a16:creationId xmlns:a16="http://schemas.microsoft.com/office/drawing/2014/main" id="{5BCE8CF9-E643-4887-B479-EF9EB9C41381}"/>
+          <p:cNvPr id="16" name="phase-body-03">
+            <a:extLst xmlns:a="http://schemas.openxmlformats.org/drawingml/2006/main">
+              <a:ext uri="{FF2B5EF4-FFF2-40B4-BE49-F238E27FC236}">
+                <a16:creationId xmlns:a16="http://schemas.microsoft.com/office/drawing/2014/main" id="{6B55D9E2-B978-45A9-BF48-6F16A66841BA}"/>
               </a:ext>
             </a:extLst>
           </p:cNvPr>
@@ -5466,10 +6029,9 @@
           <a:lstStyle xmlns:a="http://schemas.openxmlformats.org/drawingml/2006/main"/>
           <a:p xmlns:a="http://schemas.openxmlformats.org/drawingml/2006/main">
             <a:pPr>
-              <a:buNone/>
               <a:defRPr sz="1950" b="0">
                 <a:solidFill>
-                  <a:srgbClr val="101B20"/>
+                  <a:srgbClr val="202723"/>
                 </a:solidFill>
                 <a:latin typeface="Arial"/>
                 <a:ea typeface="Arial"/>
@@ -5479,7 +6041,7 @@
             <a:r>
               <a:rPr sz="1950" b="0">
                 <a:solidFill>
-                  <a:srgbClr val="101B20"/>
+                  <a:srgbClr val="202723"/>
                 </a:solidFill>
                 <a:latin typeface="Arial"/>
                 <a:ea typeface="Arial"/>
@@ -5492,10 +6054,10 @@
       </p:sp>
       <p:sp>
         <p:nvSpPr>
-          <p:cNvPr id="13" name="pilot-boundary">
-            <a:extLst xmlns:a="http://schemas.openxmlformats.org/drawingml/2006/main">
-              <a:ext uri="{FF2B5EF4-FFF2-40B4-BE49-F238E27FC236}">
-                <a16:creationId xmlns:a16="http://schemas.microsoft.com/office/drawing/2014/main" id="{2B06F01F-54CA-467E-9E82-50A647A75BF6}"/>
+          <p:cNvPr id="17" name="pilot-boundary">
+            <a:extLst xmlns:a="http://schemas.openxmlformats.org/drawingml/2006/main">
+              <a:ext uri="{FF2B5EF4-FFF2-40B4-BE49-F238E27FC236}">
+                <a16:creationId xmlns:a16="http://schemas.microsoft.com/office/drawing/2014/main" id="{5DE5169D-4EDC-4629-8417-C23DCE5A019E}"/>
               </a:ext>
             </a:extLst>
           </p:cNvPr>
@@ -5525,10 +6087,9 @@
           <a:lstStyle xmlns:a="http://schemas.openxmlformats.org/drawingml/2006/main"/>
           <a:p xmlns:a="http://schemas.openxmlformats.org/drawingml/2006/main">
             <a:pPr>
-              <a:buNone/>
               <a:defRPr sz="1650" b="0">
                 <a:solidFill>
-                  <a:srgbClr val="607077"/>
+                  <a:srgbClr val="5C6758"/>
                 </a:solidFill>
                 <a:latin typeface="Arial"/>
                 <a:ea typeface="Arial"/>
@@ -5538,7 +6099,7 @@
             <a:r>
               <a:rPr sz="1650" b="0">
                 <a:solidFill>
-                  <a:srgbClr val="607077"/>
+                  <a:srgbClr val="5C6758"/>
                 </a:solidFill>
                 <a:latin typeface="Arial"/>
                 <a:ea typeface="Arial"/>
@@ -5552,7 +6113,7 @@
     </p:spTree>
     <p:extLst>
       <p:ext uri="{BB962C8B-B14F-4D97-AF65-F5344CB8AC3E}">
-        <p14:creationId xmlns:p14="http://schemas.microsoft.com/office/powerpoint/2010/main" val="2021497656"/>
+        <p14:creationId xmlns:p14="http://schemas.microsoft.com/office/powerpoint/2010/main" val="1296140042"/>
       </p:ext>
     </p:extLst>
   </p:cSld>
@@ -5565,7 +6126,7 @@
     <p:bg>
       <p:bgPr>
         <a:solidFill xmlns:a="http://schemas.openxmlformats.org/drawingml/2006/main">
-          <a:srgbClr val="07171A"/>
+          <a:srgbClr val="24392D"/>
         </a:solidFill>
       </p:bgPr>
     </p:bg>
@@ -5580,10 +6141,137 @@
       </p:grpSpPr>
       <p:sp>
         <p:nvSpPr>
-          <p:cNvPr id="7" name="section">
-            <a:extLst xmlns:a="http://schemas.openxmlformats.org/drawingml/2006/main">
-              <a:ext uri="{FF2B5EF4-FFF2-40B4-BE49-F238E27FC236}">
-                <a16:creationId xmlns:a16="http://schemas.microsoft.com/office/drawing/2014/main" id="{7A1EAE71-81FF-451D-AD7D-36E329C73429}"/>
+          <p:cNvPr id="11" name="Hormuz mark boundary">
+            <a:extLst xmlns:a="http://schemas.openxmlformats.org/drawingml/2006/main">
+              <a:ext uri="{FF2B5EF4-FFF2-40B4-BE49-F238E27FC236}">
+                <a16:creationId xmlns:a16="http://schemas.microsoft.com/office/drawing/2014/main" id="{7A33625F-7897-453F-9B1D-63758C74E241}"/>
+              </a:ext>
+            </a:extLst>
+          </p:cNvPr>
+          <p:cNvSpPr>
+            <a:spLocks xmlns:a="http://schemas.openxmlformats.org/drawingml/2006/main" noGrp="1"/>
+          </p:cNvSpPr>
+          <p:nvPr/>
+        </p:nvSpPr>
+        <p:spPr>
+          <a:xfrm xmlns:a="http://schemas.openxmlformats.org/drawingml/2006/main">
+            <a:off x="11201400" y="333375"/>
+            <a:ext cx="381000" cy="381000"/>
+          </a:xfrm>
+          <a:prstGeom xmlns:a="http://schemas.openxmlformats.org/drawingml/2006/main" prst="ellipse">
+            <a:avLst/>
+          </a:prstGeom>
+          <a:noFill xmlns:a="http://schemas.openxmlformats.org/drawingml/2006/main"/>
+          <a:ln xmlns:a="http://schemas.openxmlformats.org/drawingml/2006/main" w="9525">
+            <a:solidFill>
+              <a:srgbClr val="DCEDA6"/>
+            </a:solidFill>
+            <a:prstDash val="solid"/>
+          </a:ln>
+        </p:spPr>
+      </p:sp>
+      <p:sp>
+        <p:nvSpPr>
+          <p:cNvPr id="2" name="Hormuz mark bar 1">
+            <a:extLst xmlns:a="http://schemas.openxmlformats.org/drawingml/2006/main">
+              <a:ext uri="{FF2B5EF4-FFF2-40B4-BE49-F238E27FC236}">
+                <a16:creationId xmlns:a16="http://schemas.microsoft.com/office/drawing/2014/main" id="{834E8796-98E0-4871-8696-64021AEA154F}"/>
+              </a:ext>
+            </a:extLst>
+          </p:cNvPr>
+          <p:cNvSpPr>
+            <a:spLocks xmlns:a="http://schemas.openxmlformats.org/drawingml/2006/main" noGrp="1"/>
+          </p:cNvSpPr>
+          <p:nvPr/>
+        </p:nvSpPr>
+        <p:spPr>
+          <a:xfrm xmlns:a="http://schemas.openxmlformats.org/drawingml/2006/main">
+            <a:off x="11287125" y="476250"/>
+            <a:ext cx="47625" cy="95250"/>
+          </a:xfrm>
+          <a:prstGeom xmlns:a="http://schemas.openxmlformats.org/drawingml/2006/main" prst="roundRect">
+            <a:avLst>
+              <a:gd name="adj" fmla="val 50000"/>
+            </a:avLst>
+          </a:prstGeom>
+          <a:solidFill xmlns:a="http://schemas.openxmlformats.org/drawingml/2006/main">
+            <a:srgbClr val="DCEDA6"/>
+          </a:solidFill>
+          <a:ln xmlns:a="http://schemas.openxmlformats.org/drawingml/2006/main" w="0">
+            <a:noFill/>
+          </a:ln>
+        </p:spPr>
+      </p:sp>
+      <p:sp>
+        <p:nvSpPr>
+          <p:cNvPr id="3" name="Hormuz mark bar 2">
+            <a:extLst xmlns:a="http://schemas.openxmlformats.org/drawingml/2006/main">
+              <a:ext uri="{FF2B5EF4-FFF2-40B4-BE49-F238E27FC236}">
+                <a16:creationId xmlns:a16="http://schemas.microsoft.com/office/drawing/2014/main" id="{52202C97-7226-4E66-8B4E-FBF2D338C676}"/>
+              </a:ext>
+            </a:extLst>
+          </p:cNvPr>
+          <p:cNvSpPr>
+            <a:spLocks xmlns:a="http://schemas.openxmlformats.org/drawingml/2006/main" noGrp="1"/>
+          </p:cNvSpPr>
+          <p:nvPr/>
+        </p:nvSpPr>
+        <p:spPr>
+          <a:xfrm xmlns:a="http://schemas.openxmlformats.org/drawingml/2006/main">
+            <a:off x="11363325" y="428625"/>
+            <a:ext cx="47625" cy="190500"/>
+          </a:xfrm>
+          <a:prstGeom xmlns:a="http://schemas.openxmlformats.org/drawingml/2006/main" prst="roundRect">
+            <a:avLst>
+              <a:gd name="adj" fmla="val 50000"/>
+            </a:avLst>
+          </a:prstGeom>
+          <a:solidFill xmlns:a="http://schemas.openxmlformats.org/drawingml/2006/main">
+            <a:srgbClr val="DCEDA6"/>
+          </a:solidFill>
+          <a:ln xmlns:a="http://schemas.openxmlformats.org/drawingml/2006/main" w="0">
+            <a:noFill/>
+          </a:ln>
+        </p:spPr>
+      </p:sp>
+      <p:sp>
+        <p:nvSpPr>
+          <p:cNvPr id="4" name="Hormuz mark bar 3">
+            <a:extLst xmlns:a="http://schemas.openxmlformats.org/drawingml/2006/main">
+              <a:ext uri="{FF2B5EF4-FFF2-40B4-BE49-F238E27FC236}">
+                <a16:creationId xmlns:a16="http://schemas.microsoft.com/office/drawing/2014/main" id="{D1789038-A2FE-46FE-8D38-11461431DB2F}"/>
+              </a:ext>
+            </a:extLst>
+          </p:cNvPr>
+          <p:cNvSpPr>
+            <a:spLocks xmlns:a="http://schemas.openxmlformats.org/drawingml/2006/main" noGrp="1"/>
+          </p:cNvSpPr>
+          <p:nvPr/>
+        </p:nvSpPr>
+        <p:spPr>
+          <a:xfrm xmlns:a="http://schemas.openxmlformats.org/drawingml/2006/main">
+            <a:off x="11439525" y="457200"/>
+            <a:ext cx="47625" cy="133350"/>
+          </a:xfrm>
+          <a:prstGeom xmlns:a="http://schemas.openxmlformats.org/drawingml/2006/main" prst="roundRect">
+            <a:avLst>
+              <a:gd name="adj" fmla="val 50000"/>
+            </a:avLst>
+          </a:prstGeom>
+          <a:solidFill xmlns:a="http://schemas.openxmlformats.org/drawingml/2006/main">
+            <a:srgbClr val="DCEDA6"/>
+          </a:solidFill>
+          <a:ln xmlns:a="http://schemas.openxmlformats.org/drawingml/2006/main" w="0">
+            <a:noFill/>
+          </a:ln>
+        </p:spPr>
+      </p:sp>
+      <p:sp>
+        <p:nvSpPr>
+          <p:cNvPr id="5" name="section">
+            <a:extLst xmlns:a="http://schemas.openxmlformats.org/drawingml/2006/main">
+              <a:ext uri="{FF2B5EF4-FFF2-40B4-BE49-F238E27FC236}">
+                <a16:creationId xmlns:a16="http://schemas.microsoft.com/office/drawing/2014/main" id="{2335B92C-726C-4E41-BD37-3DD2B9450835}"/>
               </a:ext>
             </a:extLst>
           </p:cNvPr>
@@ -5613,10 +6301,9 @@
           <a:lstStyle xmlns:a="http://schemas.openxmlformats.org/drawingml/2006/main"/>
           <a:p xmlns:a="http://schemas.openxmlformats.org/drawingml/2006/main">
             <a:pPr>
-              <a:buNone/>
               <a:defRPr sz="1425" b="1">
                 <a:solidFill>
-                  <a:srgbClr val="68E6DD"/>
+                  <a:srgbClr val="DCEDA6"/>
                 </a:solidFill>
                 <a:latin typeface="Arial"/>
                 <a:ea typeface="Arial"/>
@@ -5626,7 +6313,7 @@
             <a:r>
               <a:rPr sz="1425" b="1">
                 <a:solidFill>
-                  <a:srgbClr val="68E6DD"/>
+                  <a:srgbClr val="DCEDA6"/>
                 </a:solidFill>
                 <a:latin typeface="Arial"/>
                 <a:ea typeface="Arial"/>
@@ -5639,10 +6326,10 @@
       </p:sp>
       <p:sp>
         <p:nvSpPr>
-          <p:cNvPr id="2" name="takeaway">
-            <a:extLst xmlns:a="http://schemas.openxmlformats.org/drawingml/2006/main">
-              <a:ext uri="{FF2B5EF4-FFF2-40B4-BE49-F238E27FC236}">
-                <a16:creationId xmlns:a16="http://schemas.microsoft.com/office/drawing/2014/main" id="{FC081351-9A90-4EF8-8271-C9EEC41CCBEA}"/>
+          <p:cNvPr id="6" name="takeaway">
+            <a:extLst xmlns:a="http://schemas.openxmlformats.org/drawingml/2006/main">
+              <a:ext uri="{FF2B5EF4-FFF2-40B4-BE49-F238E27FC236}">
+                <a16:creationId xmlns:a16="http://schemas.microsoft.com/office/drawing/2014/main" id="{BE693FC7-8F5B-4372-9796-50526E0DAF6B}"/>
               </a:ext>
             </a:extLst>
           </p:cNvPr>
@@ -5672,10 +6359,9 @@
           <a:lstStyle xmlns:a="http://schemas.openxmlformats.org/drawingml/2006/main"/>
           <a:p xmlns:a="http://schemas.openxmlformats.org/drawingml/2006/main">
             <a:pPr>
-              <a:buNone/>
               <a:defRPr sz="3600" b="1">
                 <a:solidFill>
-                  <a:srgbClr val="FBFCF8"/>
+                  <a:srgbClr val="FAFBF6"/>
                 </a:solidFill>
                 <a:latin typeface="Arial"/>
                 <a:ea typeface="Arial"/>
@@ -5685,7 +6371,7 @@
             <a:r>
               <a:rPr sz="3600" b="1">
                 <a:solidFill>
-                  <a:srgbClr val="FBFCF8"/>
+                  <a:srgbClr val="FAFBF6"/>
                 </a:solidFill>
                 <a:latin typeface="Arial"/>
                 <a:ea typeface="Arial"/>
@@ -5698,10 +6384,10 @@
       </p:sp>
       <p:sp>
         <p:nvSpPr>
-          <p:cNvPr id="3" name="footer">
-            <a:extLst xmlns:a="http://schemas.openxmlformats.org/drawingml/2006/main">
-              <a:ext uri="{FF2B5EF4-FFF2-40B4-BE49-F238E27FC236}">
-                <a16:creationId xmlns:a16="http://schemas.microsoft.com/office/drawing/2014/main" id="{20EAC2AF-6053-4AF8-AF72-67634E0447A4}"/>
+          <p:cNvPr id="7" name="footer">
+            <a:extLst xmlns:a="http://schemas.openxmlformats.org/drawingml/2006/main">
+              <a:ext uri="{FF2B5EF4-FFF2-40B4-BE49-F238E27FC236}">
+                <a16:creationId xmlns:a16="http://schemas.microsoft.com/office/drawing/2014/main" id="{0153BEC5-F63D-4C18-A426-62F21AEB3B9E}"/>
               </a:ext>
             </a:extLst>
           </p:cNvPr>
@@ -5731,10 +6417,9 @@
           <a:lstStyle xmlns:a="http://schemas.openxmlformats.org/drawingml/2006/main"/>
           <a:p xmlns:a="http://schemas.openxmlformats.org/drawingml/2006/main">
             <a:pPr>
-              <a:buNone/>
               <a:defRPr sz="1275" b="0">
                 <a:solidFill>
-                  <a:srgbClr val="B9CCC7"/>
+                  <a:srgbClr val="DCE6D5"/>
                 </a:solidFill>
                 <a:latin typeface="Arial"/>
                 <a:ea typeface="Arial"/>
@@ -5744,45 +6429,23 @@
             <a:r>
               <a:rPr sz="1275" b="0">
                 <a:solidFill>
-                  <a:srgbClr val="B9CCC7"/>
-                </a:solidFill>
-                <a:latin typeface="Arial"/>
-                <a:ea typeface="Arial"/>
-                <a:cs typeface="Arial"/>
-              </a:rPr>
-              <a:t>HORMUZ  /  Mehrdad Zaker  /  </a:t>
-            </a:r>
-            <a:r>
-              <a:rPr sz="1275" b="0">
-                <a:solidFill>
-                  <a:srgbClr val="B9CCC7"/>
-                </a:solidFill>
-                <a:latin typeface="Arial"/>
-                <a:ea typeface="Arial"/>
-                <a:cs typeface="Arial"/>
-              </a:rPr>
-              <a:t>31 Aug 2026</a:t>
-            </a:r>
-            <a:r>
-              <a:rPr sz="1275" b="0">
-                <a:solidFill>
-                  <a:srgbClr val="B9CCC7"/>
-                </a:solidFill>
-                <a:latin typeface="Arial"/>
-                <a:ea typeface="Arial"/>
-                <a:cs typeface="Arial"/>
-              </a:rPr>
-              <a:t>                                      07 / 07</a:t>
-            </a:r>
-          </a:p>
-        </p:txBody>
-      </p:sp>
-      <p:sp>
-        <p:nvSpPr>
-          <p:cNvPr id="4" name="next-step">
-            <a:extLst xmlns:a="http://schemas.openxmlformats.org/drawingml/2006/main">
-              <a:ext uri="{FF2B5EF4-FFF2-40B4-BE49-F238E27FC236}">
-                <a16:creationId xmlns:a16="http://schemas.microsoft.com/office/drawing/2014/main" id="{DA949742-C010-468E-B9BC-0AB7C04C2B80}"/>
+                  <a:srgbClr val="DCE6D5"/>
+                </a:solidFill>
+                <a:latin typeface="Arial"/>
+                <a:ea typeface="Arial"/>
+                <a:cs typeface="Arial"/>
+              </a:rPr>
+              <a:t>HORMUZ  /  Mehrdad Zaker  /  September 2026                                      07 / 07</a:t>
+            </a:r>
+          </a:p>
+        </p:txBody>
+      </p:sp>
+      <p:sp>
+        <p:nvSpPr>
+          <p:cNvPr id="8" name="next-step">
+            <a:extLst xmlns:a="http://schemas.openxmlformats.org/drawingml/2006/main">
+              <a:ext uri="{FF2B5EF4-FFF2-40B4-BE49-F238E27FC236}">
+                <a16:creationId xmlns:a16="http://schemas.microsoft.com/office/drawing/2014/main" id="{B5AD76F6-0655-4E41-89CF-BA630CD86778}"/>
               </a:ext>
             </a:extLst>
           </p:cNvPr>
@@ -5812,10 +6475,9 @@
           <a:lstStyle xmlns:a="http://schemas.openxmlformats.org/drawingml/2006/main"/>
           <a:p xmlns:a="http://schemas.openxmlformats.org/drawingml/2006/main">
             <a:pPr>
-              <a:buNone/>
               <a:defRPr sz="3300" b="0">
                 <a:solidFill>
-                  <a:srgbClr val="FBFCF8"/>
+                  <a:srgbClr val="FAFBF6"/>
                 </a:solidFill>
                 <a:latin typeface="Arial"/>
                 <a:ea typeface="Arial"/>
@@ -5825,7 +6487,7 @@
             <a:r>
               <a:rPr sz="3300" b="0">
                 <a:solidFill>
-                  <a:srgbClr val="FBFCF8"/>
+                  <a:srgbClr val="FAFBF6"/>
                 </a:solidFill>
                 <a:latin typeface="Arial"/>
                 <a:ea typeface="Arial"/>
@@ -5836,10 +6498,9 @@
           </a:p>
           <a:p xmlns:a="http://schemas.openxmlformats.org/drawingml/2006/main">
             <a:pPr>
-              <a:buNone/>
               <a:defRPr sz="3300" b="0">
                 <a:solidFill>
-                  <a:srgbClr val="FBFCF8"/>
+                  <a:srgbClr val="FAFBF6"/>
                 </a:solidFill>
                 <a:latin typeface="Arial"/>
                 <a:ea typeface="Arial"/>
@@ -5849,7 +6510,7 @@
             <a:r>
               <a:rPr sz="3300" b="0">
                 <a:solidFill>
-                  <a:srgbClr val="FBFCF8"/>
+                  <a:srgbClr val="FAFBF6"/>
                 </a:solidFill>
                 <a:latin typeface="Arial"/>
                 <a:ea typeface="Arial"/>
@@ -5860,10 +6521,9 @@
           </a:p>
           <a:p xmlns:a="http://schemas.openxmlformats.org/drawingml/2006/main">
             <a:pPr>
-              <a:buNone/>
               <a:defRPr sz="3300" b="0">
                 <a:solidFill>
-                  <a:srgbClr val="FBFCF8"/>
+                  <a:srgbClr val="FAFBF6"/>
                 </a:solidFill>
                 <a:latin typeface="Arial"/>
                 <a:ea typeface="Arial"/>
@@ -5873,7 +6533,7 @@
             <a:r>
               <a:rPr sz="3300" b="0">
                 <a:solidFill>
-                  <a:srgbClr val="FBFCF8"/>
+                  <a:srgbClr val="FAFBF6"/>
                 </a:solidFill>
                 <a:latin typeface="Arial"/>
                 <a:ea typeface="Arial"/>
@@ -5886,10 +6546,10 @@
       </p:sp>
       <p:sp>
         <p:nvSpPr>
-          <p:cNvPr id="5" name="contact">
-            <a:extLst xmlns:a="http://schemas.openxmlformats.org/drawingml/2006/main">
-              <a:ext uri="{FF2B5EF4-FFF2-40B4-BE49-F238E27FC236}">
-                <a16:creationId xmlns:a16="http://schemas.microsoft.com/office/drawing/2014/main" id="{226A77C1-1481-42AC-AFF0-5A72E13FADD8}"/>
+          <p:cNvPr id="9" name="contact">
+            <a:extLst xmlns:a="http://schemas.openxmlformats.org/drawingml/2006/main">
+              <a:ext uri="{FF2B5EF4-FFF2-40B4-BE49-F238E27FC236}">
+                <a16:creationId xmlns:a16="http://schemas.microsoft.com/office/drawing/2014/main" id="{72C633C7-F8A6-41BE-B1FE-37828623C26D}"/>
               </a:ext>
             </a:extLst>
           </p:cNvPr>
@@ -5919,10 +6579,9 @@
           <a:lstStyle xmlns:a="http://schemas.openxmlformats.org/drawingml/2006/main"/>
           <a:p xmlns:a="http://schemas.openxmlformats.org/drawingml/2006/main">
             <a:pPr>
-              <a:buNone/>
               <a:defRPr sz="2325" b="1">
                 <a:solidFill>
-                  <a:srgbClr val="68E6DD"/>
+                  <a:srgbClr val="DCEDA6"/>
                 </a:solidFill>
                 <a:latin typeface="Arial"/>
                 <a:ea typeface="Arial"/>
@@ -5932,7 +6591,7 @@
             <a:r>
               <a:rPr sz="2325" b="1">
                 <a:solidFill>
-                  <a:srgbClr val="68E6DD"/>
+                  <a:srgbClr val="DCEDA6"/>
                 </a:solidFill>
                 <a:latin typeface="Arial"/>
                 <a:ea typeface="Arial"/>
@@ -5943,10 +6602,9 @@
           </a:p>
           <a:p xmlns:a="http://schemas.openxmlformats.org/drawingml/2006/main">
             <a:pPr>
-              <a:buNone/>
               <a:defRPr sz="2325" b="1">
                 <a:solidFill>
-                  <a:srgbClr val="68E6DD"/>
+                  <a:srgbClr val="DCEDA6"/>
                 </a:solidFill>
                 <a:latin typeface="Arial"/>
                 <a:ea typeface="Arial"/>
@@ -5956,7 +6614,7 @@
             <a:r>
               <a:rPr sz="2325" b="1">
                 <a:solidFill>
-                  <a:srgbClr val="68E6DD"/>
+                  <a:srgbClr val="DCEDA6"/>
                 </a:solidFill>
                 <a:latin typeface="Arial"/>
                 <a:ea typeface="Arial"/>
@@ -5969,10 +6627,10 @@
       </p:sp>
       <p:sp>
         <p:nvSpPr>
-          <p:cNvPr id="6" name="website">
-            <a:extLst xmlns:a="http://schemas.openxmlformats.org/drawingml/2006/main">
-              <a:ext uri="{FF2B5EF4-FFF2-40B4-BE49-F238E27FC236}">
-                <a16:creationId xmlns:a16="http://schemas.microsoft.com/office/drawing/2014/main" id="{43A110DE-D781-4D6D-AF92-78BAEC645DF0}"/>
+          <p:cNvPr id="10" name="website">
+            <a:extLst xmlns:a="http://schemas.openxmlformats.org/drawingml/2006/main">
+              <a:ext uri="{FF2B5EF4-FFF2-40B4-BE49-F238E27FC236}">
+                <a16:creationId xmlns:a16="http://schemas.microsoft.com/office/drawing/2014/main" id="{873E3563-38B9-40B0-B4E5-BB417E569BB1}"/>
               </a:ext>
             </a:extLst>
           </p:cNvPr>
@@ -6002,7 +6660,6 @@
           <a:lstStyle xmlns:a="http://schemas.openxmlformats.org/drawingml/2006/main"/>
           <a:p xmlns:a="http://schemas.openxmlformats.org/drawingml/2006/main">
             <a:pPr>
-              <a:buNone/>
               <a:defRPr sz="1875" b="0">
                 <a:solidFill>
                   <a:srgbClr val="D9E1DF"/>
@@ -6029,7 +6686,7 @@
     </p:spTree>
     <p:extLst>
       <p:ext uri="{BB962C8B-B14F-4D97-AF65-F5344CB8AC3E}">
-        <p14:creationId xmlns:p14="http://schemas.microsoft.com/office/powerpoint/2010/main" val="983716078"/>
+        <p14:creationId xmlns:p14="http://schemas.microsoft.com/office/powerpoint/2010/main" val="1628276503"/>
       </p:ext>
     </p:extLst>
   </p:cSld>

</xml_diff>

<commit_message>
Clarify pilot pricing, conversion CTAs, and Neuralint ownership
</commit_message>
<xml_diff>
--- a/website/public/downloads/hormuz-buyer-briefing.pptx
+++ b/website/public/downloads/hormuz-buyer-briefing.pptx
@@ -2,19 +2,19 @@
 <file path=ppt/presentation.xml><?xml version="1.0" encoding="utf-8"?>
 <p:presentation xmlns:p="http://schemas.openxmlformats.org/presentationml/2006/main">
   <p:sldMasterIdLst>
-    <p:sldMasterId xmlns:r="http://schemas.openxmlformats.org/officeDocument/2006/relationships" id="2147483648" r:id="Ra58a792eb9f748a1"/>
+    <p:sldMasterId xmlns:r="http://schemas.openxmlformats.org/officeDocument/2006/relationships" id="2147483648" r:id="Rcd0c7e07e38e41b3"/>
   </p:sldMasterIdLst>
   <p:notesMasterIdLst>
-    <p:notesMasterId xmlns:r="http://schemas.openxmlformats.org/officeDocument/2006/relationships" r:id="Rff52f76960504176"/>
+    <p:notesMasterId xmlns:r="http://schemas.openxmlformats.org/officeDocument/2006/relationships" r:id="Rbcf5be65bfd24bbd"/>
   </p:notesMasterIdLst>
   <p:sldIdLst>
-    <p:sldId xmlns:r="http://schemas.openxmlformats.org/officeDocument/2006/relationships" id="256" r:id="R7ccfffa425794952"/>
-    <p:sldId xmlns:r="http://schemas.openxmlformats.org/officeDocument/2006/relationships" id="257" r:id="Ra1cef080f5cd484b"/>
-    <p:sldId xmlns:r="http://schemas.openxmlformats.org/officeDocument/2006/relationships" id="258" r:id="Ra7bcd4de67484574"/>
-    <p:sldId xmlns:r="http://schemas.openxmlformats.org/officeDocument/2006/relationships" id="259" r:id="R1cd4d01bb4c348fc"/>
-    <p:sldId xmlns:r="http://schemas.openxmlformats.org/officeDocument/2006/relationships" id="260" r:id="R2e05c9081aa4453d"/>
-    <p:sldId xmlns:r="http://schemas.openxmlformats.org/officeDocument/2006/relationships" id="261" r:id="R42e74a7881c34e99"/>
-    <p:sldId xmlns:r="http://schemas.openxmlformats.org/officeDocument/2006/relationships" id="262" r:id="R8c2582dc1d95408c"/>
+    <p:sldId xmlns:r="http://schemas.openxmlformats.org/officeDocument/2006/relationships" id="256" r:id="R7a8054394795479f"/>
+    <p:sldId xmlns:r="http://schemas.openxmlformats.org/officeDocument/2006/relationships" id="257" r:id="R20531e4fea7646a6"/>
+    <p:sldId xmlns:r="http://schemas.openxmlformats.org/officeDocument/2006/relationships" id="258" r:id="Rd520fa6987eb4d73"/>
+    <p:sldId xmlns:r="http://schemas.openxmlformats.org/officeDocument/2006/relationships" id="259" r:id="R76120a6307804c4c"/>
+    <p:sldId xmlns:r="http://schemas.openxmlformats.org/officeDocument/2006/relationships" id="260" r:id="Re8a19d8fcfd14355"/>
+    <p:sldId xmlns:r="http://schemas.openxmlformats.org/officeDocument/2006/relationships" id="261" r:id="Rc1aa2f99143447ed"/>
+    <p:sldId xmlns:r="http://schemas.openxmlformats.org/officeDocument/2006/relationships" id="262" r:id="R4eaff636ae2e4d3f"/>
   </p:sldIdLst>
   <p:sldSz cx="12192000" cy="6858000"/>
   <p:notesSz cx="6858000" cy="9144000"/>
@@ -1116,7 +1116,7 @@
   </p:cSld>
   <p:clrMap bg1="lt1" tx1="dk1" bg2="lt2" tx2="dk2" accent1="accent1" accent2="accent2" accent3="accent3" accent4="accent4" accent5="accent5" accent6="accent6" hlink="hlink" folHlink="folHlink"/>
   <p:sldLayoutIdLst>
-    <p:sldLayoutId xmlns:r="http://schemas.openxmlformats.org/officeDocument/2006/relationships" id="2147483649" r:id="R3660d6fd5adc45c1"/>
+    <p:sldLayoutId xmlns:r="http://schemas.openxmlformats.org/officeDocument/2006/relationships" id="2147483649" r:id="R8e0878a4228741fb"/>
   </p:sldLayoutIdLst>
   <p:txStyles>
     <p:titleStyle>
@@ -1664,10 +1664,10 @@
       </p:grpSpPr>
       <p:sp>
         <p:nvSpPr>
-          <p:cNvPr id="10" name="Hormuz mark boundary">
-            <a:extLst xmlns:a="http://schemas.openxmlformats.org/drawingml/2006/main">
-              <a:ext uri="{FF2B5EF4-FFF2-40B4-BE49-F238E27FC236}">
-                <a16:creationId xmlns:a16="http://schemas.microsoft.com/office/drawing/2014/main" id="{C6B9E46E-061A-4D5C-82B8-8682FFAAAB4C}"/>
+          <p:cNvPr id="11" name="Hormuz mark boundary">
+            <a:extLst xmlns:a="http://schemas.openxmlformats.org/drawingml/2006/main">
+              <a:ext uri="{FF2B5EF4-FFF2-40B4-BE49-F238E27FC236}">
+                <a16:creationId xmlns:a16="http://schemas.microsoft.com/office/drawing/2014/main" id="{B0BF9A4E-E4B8-4521-8622-39C249134BEF}"/>
               </a:ext>
             </a:extLst>
           </p:cNvPr>
@@ -1698,7 +1698,7 @@
           <p:cNvPr id="2" name="Hormuz mark bar 1">
             <a:extLst xmlns:a="http://schemas.openxmlformats.org/drawingml/2006/main">
               <a:ext uri="{FF2B5EF4-FFF2-40B4-BE49-F238E27FC236}">
-                <a16:creationId xmlns:a16="http://schemas.microsoft.com/office/drawing/2014/main" id="{C537582A-8AC9-4C27-91E2-439F78ED5DC1}"/>
+                <a16:creationId xmlns:a16="http://schemas.microsoft.com/office/drawing/2014/main" id="{EF0088F8-7E6E-402B-AD04-7606A2BD4261}"/>
               </a:ext>
             </a:extLst>
           </p:cNvPr>
@@ -1730,7 +1730,7 @@
           <p:cNvPr id="3" name="Hormuz mark bar 2">
             <a:extLst xmlns:a="http://schemas.openxmlformats.org/drawingml/2006/main">
               <a:ext uri="{FF2B5EF4-FFF2-40B4-BE49-F238E27FC236}">
-                <a16:creationId xmlns:a16="http://schemas.microsoft.com/office/drawing/2014/main" id="{7D2D332A-6CA9-4953-9BFF-A5F722B5A01C}"/>
+                <a16:creationId xmlns:a16="http://schemas.microsoft.com/office/drawing/2014/main" id="{54380220-0332-4DC2-98B2-95143AD7C399}"/>
               </a:ext>
             </a:extLst>
           </p:cNvPr>
@@ -1762,7 +1762,7 @@
           <p:cNvPr id="4" name="Hormuz mark bar 3">
             <a:extLst xmlns:a="http://schemas.openxmlformats.org/drawingml/2006/main">
               <a:ext uri="{FF2B5EF4-FFF2-40B4-BE49-F238E27FC236}">
-                <a16:creationId xmlns:a16="http://schemas.microsoft.com/office/drawing/2014/main" id="{5BC66629-64FE-44A2-BD8B-52BC59971833}"/>
+                <a16:creationId xmlns:a16="http://schemas.microsoft.com/office/drawing/2014/main" id="{7258B745-79AC-462C-A959-91AB67CCEDEB}"/>
               </a:ext>
             </a:extLst>
           </p:cNvPr>
@@ -1794,7 +1794,7 @@
           <p:cNvPr id="5" name="section">
             <a:extLst xmlns:a="http://schemas.openxmlformats.org/drawingml/2006/main">
               <a:ext uri="{FF2B5EF4-FFF2-40B4-BE49-F238E27FC236}">
-                <a16:creationId xmlns:a16="http://schemas.microsoft.com/office/drawing/2014/main" id="{D2671048-3259-40FE-9154-6A2D7246F4E5}"/>
+                <a16:creationId xmlns:a16="http://schemas.microsoft.com/office/drawing/2014/main" id="{572C6C87-0550-4928-9512-30BFE602C035}"/>
               </a:ext>
             </a:extLst>
           </p:cNvPr>
@@ -1852,7 +1852,7 @@
           <p:cNvPr id="6" name="footer">
             <a:extLst xmlns:a="http://schemas.openxmlformats.org/drawingml/2006/main">
               <a:ext uri="{FF2B5EF4-FFF2-40B4-BE49-F238E27FC236}">
-                <a16:creationId xmlns:a16="http://schemas.microsoft.com/office/drawing/2014/main" id="{B28698F4-B9C0-4E60-8363-FE63B8E104D2}"/>
+                <a16:creationId xmlns:a16="http://schemas.microsoft.com/office/drawing/2014/main" id="{4D898725-1652-4974-827E-B54240544021}"/>
               </a:ext>
             </a:extLst>
           </p:cNvPr>
@@ -1864,7 +1864,7 @@
         <p:spPr>
           <a:xfrm xmlns:a="http://schemas.openxmlformats.org/drawingml/2006/main">
             <a:off x="609600" y="6400800"/>
-            <a:ext cx="10972800" cy="228600"/>
+            <a:ext cx="9525000" cy="228600"/>
           </a:xfrm>
           <a:prstGeom xmlns:a="http://schemas.openxmlformats.org/drawingml/2006/main" prst="rect">
             <a:avLst/>
@@ -1900,29 +1900,29 @@
                 <a:ea typeface="Arial"/>
                 <a:cs typeface="Arial"/>
               </a:rPr>
-              <a:t>HORMUZ  /  Mehrdad Zaker  /  September 2026                                      01 / 07</a:t>
-            </a:r>
-          </a:p>
-        </p:txBody>
-      </p:sp>
-      <p:sp>
-        <p:nvSpPr>
-          <p:cNvPr id="7" name="cover-title">
-            <a:extLst xmlns:a="http://schemas.openxmlformats.org/drawingml/2006/main">
-              <a:ext uri="{FF2B5EF4-FFF2-40B4-BE49-F238E27FC236}">
-                <a16:creationId xmlns:a16="http://schemas.microsoft.com/office/drawing/2014/main" id="{AA1A8ABC-C81E-409A-AD7D-7DB1A24B0FB5}"/>
-              </a:ext>
-            </a:extLst>
-          </p:cNvPr>
-          <p:cNvSpPr>
-            <a:spLocks xmlns:a="http://schemas.openxmlformats.org/drawingml/2006/main" noGrp="1"/>
-          </p:cNvSpPr>
-          <p:nvPr/>
-        </p:nvSpPr>
-        <p:spPr>
-          <a:xfrm xmlns:a="http://schemas.openxmlformats.org/drawingml/2006/main">
-            <a:off x="609600" y="1485900"/>
-            <a:ext cx="10858500" cy="2114550"/>
+              <a:t>HORMUZ  /  A product of Neuralint  /  Mehrdad Zaker  /  September 2026</a:t>
+            </a:r>
+          </a:p>
+        </p:txBody>
+      </p:sp>
+      <p:sp>
+        <p:nvSpPr>
+          <p:cNvPr id="7" name="page-number">
+            <a:extLst xmlns:a="http://schemas.openxmlformats.org/drawingml/2006/main">
+              <a:ext uri="{FF2B5EF4-FFF2-40B4-BE49-F238E27FC236}">
+                <a16:creationId xmlns:a16="http://schemas.microsoft.com/office/drawing/2014/main" id="{84637D8D-E2A7-40F2-9D48-C9064B11C6C9}"/>
+              </a:ext>
+            </a:extLst>
+          </p:cNvPr>
+          <p:cNvSpPr>
+            <a:spLocks xmlns:a="http://schemas.openxmlformats.org/drawingml/2006/main" noGrp="1"/>
+          </p:cNvSpPr>
+          <p:nvPr/>
+        </p:nvSpPr>
+        <p:spPr>
+          <a:xfrm xmlns:a="http://schemas.openxmlformats.org/drawingml/2006/main">
+            <a:off x="10972800" y="6400800"/>
+            <a:ext cx="609600" cy="228600"/>
           </a:xfrm>
           <a:prstGeom xmlns:a="http://schemas.openxmlformats.org/drawingml/2006/main" prst="rect">
             <a:avLst/>
@@ -1940,70 +1940,47 @@
           <a:lstStyle xmlns:a="http://schemas.openxmlformats.org/drawingml/2006/main"/>
           <a:p xmlns:a="http://schemas.openxmlformats.org/drawingml/2006/main">
             <a:pPr>
-              <a:defRPr sz="5700" b="1">
-                <a:solidFill>
-                  <a:srgbClr val="FAFBF6"/>
-                </a:solidFill>
-                <a:latin typeface="Arial"/>
-                <a:ea typeface="Arial"/>
-                <a:cs typeface="Arial"/>
-              </a:defRPr>
-            </a:pPr>
-            <a:r>
-              <a:rPr sz="5700" b="1">
-                <a:solidFill>
-                  <a:srgbClr val="FAFBF6"/>
-                </a:solidFill>
-                <a:latin typeface="Arial"/>
-                <a:ea typeface="Arial"/>
-                <a:cs typeface="Arial"/>
-              </a:rPr>
-              <a:t>Give your team AI.</a:t>
-            </a:r>
-          </a:p>
-          <a:p xmlns:a="http://schemas.openxmlformats.org/drawingml/2006/main">
-            <a:pPr>
-              <a:defRPr sz="5700" b="1">
-                <a:solidFill>
-                  <a:srgbClr val="FAFBF6"/>
-                </a:solidFill>
-                <a:latin typeface="Arial"/>
-                <a:ea typeface="Arial"/>
-                <a:cs typeface="Arial"/>
-              </a:defRPr>
-            </a:pPr>
-            <a:r>
-              <a:rPr sz="5700" b="1">
-                <a:solidFill>
-                  <a:srgbClr val="FAFBF6"/>
-                </a:solidFill>
-                <a:latin typeface="Arial"/>
-                <a:ea typeface="Arial"/>
-                <a:cs typeface="Arial"/>
-              </a:rPr>
-              <a:t>Keep control.</a:t>
-            </a:r>
-          </a:p>
-        </p:txBody>
-      </p:sp>
-      <p:sp>
-        <p:nvSpPr>
-          <p:cNvPr id="8" name="cover-summary">
-            <a:extLst xmlns:a="http://schemas.openxmlformats.org/drawingml/2006/main">
-              <a:ext uri="{FF2B5EF4-FFF2-40B4-BE49-F238E27FC236}">
-                <a16:creationId xmlns:a16="http://schemas.microsoft.com/office/drawing/2014/main" id="{13D1DF7D-FFFD-4A29-B8EE-0FFAF8E39172}"/>
-              </a:ext>
-            </a:extLst>
-          </p:cNvPr>
-          <p:cNvSpPr>
-            <a:spLocks xmlns:a="http://schemas.openxmlformats.org/drawingml/2006/main" noGrp="1"/>
-          </p:cNvSpPr>
-          <p:nvPr/>
-        </p:nvSpPr>
-        <p:spPr>
-          <a:xfrm xmlns:a="http://schemas.openxmlformats.org/drawingml/2006/main">
-            <a:off x="647700" y="4171950"/>
-            <a:ext cx="10572750" cy="1009650"/>
+              <a:defRPr sz="1275" b="0">
+                <a:solidFill>
+                  <a:srgbClr val="DCE6D5"/>
+                </a:solidFill>
+                <a:latin typeface="Arial"/>
+                <a:ea typeface="Arial"/>
+                <a:cs typeface="Arial"/>
+              </a:defRPr>
+            </a:pPr>
+            <a:r>
+              <a:rPr sz="1275" b="0">
+                <a:solidFill>
+                  <a:srgbClr val="DCE6D5"/>
+                </a:solidFill>
+                <a:latin typeface="Arial"/>
+                <a:ea typeface="Arial"/>
+                <a:cs typeface="Arial"/>
+              </a:rPr>
+              <a:t>01 / 07</a:t>
+            </a:r>
+          </a:p>
+        </p:txBody>
+      </p:sp>
+      <p:sp>
+        <p:nvSpPr>
+          <p:cNvPr id="8" name="cover-title">
+            <a:extLst xmlns:a="http://schemas.openxmlformats.org/drawingml/2006/main">
+              <a:ext uri="{FF2B5EF4-FFF2-40B4-BE49-F238E27FC236}">
+                <a16:creationId xmlns:a16="http://schemas.microsoft.com/office/drawing/2014/main" id="{EA793445-A2FD-48AF-88D2-FED2573CCC6C}"/>
+              </a:ext>
+            </a:extLst>
+          </p:cNvPr>
+          <p:cNvSpPr>
+            <a:spLocks xmlns:a="http://schemas.openxmlformats.org/drawingml/2006/main" noGrp="1"/>
+          </p:cNvSpPr>
+          <p:nvPr/>
+        </p:nvSpPr>
+        <p:spPr>
+          <a:xfrm xmlns:a="http://schemas.openxmlformats.org/drawingml/2006/main">
+            <a:off x="609600" y="1485900"/>
+            <a:ext cx="10858500" cy="2114550"/>
           </a:xfrm>
           <a:prstGeom xmlns:a="http://schemas.openxmlformats.org/drawingml/2006/main" prst="rect">
             <a:avLst/>
@@ -2021,70 +1998,70 @@
           <a:lstStyle xmlns:a="http://schemas.openxmlformats.org/drawingml/2006/main"/>
           <a:p xmlns:a="http://schemas.openxmlformats.org/drawingml/2006/main">
             <a:pPr>
-              <a:defRPr sz="2325" b="0">
-                <a:solidFill>
-                  <a:srgbClr val="D9E1DF"/>
-                </a:solidFill>
-                <a:latin typeface="Arial"/>
-                <a:ea typeface="Arial"/>
-                <a:cs typeface="Arial"/>
-              </a:defRPr>
-            </a:pPr>
-            <a:r>
-              <a:rPr sz="2325" b="0">
-                <a:solidFill>
-                  <a:srgbClr val="D9E1DF"/>
-                </a:solidFill>
-                <a:latin typeface="Arial"/>
-                <a:ea typeface="Arial"/>
-                <a:cs typeface="Arial"/>
-              </a:rPr>
-              <a:t>Self-hosted policy, budgets, secret controls,</a:t>
-            </a:r>
-          </a:p>
-          <a:p xmlns:a="http://schemas.openxmlformats.org/drawingml/2006/main">
-            <a:pPr>
-              <a:defRPr sz="2325" b="0">
-                <a:solidFill>
-                  <a:srgbClr val="D9E1DF"/>
-                </a:solidFill>
-                <a:latin typeface="Arial"/>
-                <a:ea typeface="Arial"/>
-                <a:cs typeface="Arial"/>
-              </a:defRPr>
-            </a:pPr>
-            <a:r>
-              <a:rPr sz="2325" b="0">
-                <a:solidFill>
-                  <a:srgbClr val="D9E1DF"/>
-                </a:solidFill>
-                <a:latin typeface="Arial"/>
-                <a:ea typeface="Arial"/>
-                <a:cs typeface="Arial"/>
-              </a:rPr>
-              <a:t>and metadata-only evidence for Codex and Claude Code.</a:t>
-            </a:r>
-          </a:p>
-        </p:txBody>
-      </p:sp>
-      <p:sp>
-        <p:nvSpPr>
-          <p:cNvPr id="9" name="cover-boundary">
-            <a:extLst xmlns:a="http://schemas.openxmlformats.org/drawingml/2006/main">
-              <a:ext uri="{FF2B5EF4-FFF2-40B4-BE49-F238E27FC236}">
-                <a16:creationId xmlns:a16="http://schemas.microsoft.com/office/drawing/2014/main" id="{827AD065-2713-4FFF-8235-79A85510AF8E}"/>
-              </a:ext>
-            </a:extLst>
-          </p:cNvPr>
-          <p:cNvSpPr>
-            <a:spLocks xmlns:a="http://schemas.openxmlformats.org/drawingml/2006/main" noGrp="1"/>
-          </p:cNvSpPr>
-          <p:nvPr/>
-        </p:nvSpPr>
-        <p:spPr>
-          <a:xfrm xmlns:a="http://schemas.openxmlformats.org/drawingml/2006/main">
-            <a:off x="647700" y="5543550"/>
-            <a:ext cx="10572750" cy="400050"/>
+              <a:defRPr sz="5700" b="1">
+                <a:solidFill>
+                  <a:srgbClr val="FAFBF6"/>
+                </a:solidFill>
+                <a:latin typeface="Arial"/>
+                <a:ea typeface="Arial"/>
+                <a:cs typeface="Arial"/>
+              </a:defRPr>
+            </a:pPr>
+            <a:r>
+              <a:rPr sz="5700" b="1">
+                <a:solidFill>
+                  <a:srgbClr val="FAFBF6"/>
+                </a:solidFill>
+                <a:latin typeface="Arial"/>
+                <a:ea typeface="Arial"/>
+                <a:cs typeface="Arial"/>
+              </a:rPr>
+              <a:t>Give your team AI.</a:t>
+            </a:r>
+          </a:p>
+          <a:p xmlns:a="http://schemas.openxmlformats.org/drawingml/2006/main">
+            <a:pPr>
+              <a:defRPr sz="5700" b="1">
+                <a:solidFill>
+                  <a:srgbClr val="FAFBF6"/>
+                </a:solidFill>
+                <a:latin typeface="Arial"/>
+                <a:ea typeface="Arial"/>
+                <a:cs typeface="Arial"/>
+              </a:defRPr>
+            </a:pPr>
+            <a:r>
+              <a:rPr sz="5700" b="1">
+                <a:solidFill>
+                  <a:srgbClr val="FAFBF6"/>
+                </a:solidFill>
+                <a:latin typeface="Arial"/>
+                <a:ea typeface="Arial"/>
+                <a:cs typeface="Arial"/>
+              </a:rPr>
+              <a:t>Keep control.</a:t>
+            </a:r>
+          </a:p>
+        </p:txBody>
+      </p:sp>
+      <p:sp>
+        <p:nvSpPr>
+          <p:cNvPr id="9" name="cover-summary">
+            <a:extLst xmlns:a="http://schemas.openxmlformats.org/drawingml/2006/main">
+              <a:ext uri="{FF2B5EF4-FFF2-40B4-BE49-F238E27FC236}">
+                <a16:creationId xmlns:a16="http://schemas.microsoft.com/office/drawing/2014/main" id="{1A22AF0D-1E44-434B-B1ED-2ED8695F9C89}"/>
+              </a:ext>
+            </a:extLst>
+          </p:cNvPr>
+          <p:cNvSpPr>
+            <a:spLocks xmlns:a="http://schemas.openxmlformats.org/drawingml/2006/main" noGrp="1"/>
+          </p:cNvSpPr>
+          <p:nvPr/>
+        </p:nvSpPr>
+        <p:spPr>
+          <a:xfrm xmlns:a="http://schemas.openxmlformats.org/drawingml/2006/main">
+            <a:off x="647700" y="4171950"/>
+            <a:ext cx="10572750" cy="1009650"/>
           </a:xfrm>
           <a:prstGeom xmlns:a="http://schemas.openxmlformats.org/drawingml/2006/main" prst="rect">
             <a:avLst/>
@@ -2102,6 +2079,87 @@
           <a:lstStyle xmlns:a="http://schemas.openxmlformats.org/drawingml/2006/main"/>
           <a:p xmlns:a="http://schemas.openxmlformats.org/drawingml/2006/main">
             <a:pPr>
+              <a:defRPr sz="2325" b="0">
+                <a:solidFill>
+                  <a:srgbClr val="D9E1DF"/>
+                </a:solidFill>
+                <a:latin typeface="Arial"/>
+                <a:ea typeface="Arial"/>
+                <a:cs typeface="Arial"/>
+              </a:defRPr>
+            </a:pPr>
+            <a:r>
+              <a:rPr sz="2325" b="0">
+                <a:solidFill>
+                  <a:srgbClr val="D9E1DF"/>
+                </a:solidFill>
+                <a:latin typeface="Arial"/>
+                <a:ea typeface="Arial"/>
+                <a:cs typeface="Arial"/>
+              </a:rPr>
+              <a:t>Self-hosted policy, budgets, secret controls,</a:t>
+            </a:r>
+          </a:p>
+          <a:p xmlns:a="http://schemas.openxmlformats.org/drawingml/2006/main">
+            <a:pPr>
+              <a:defRPr sz="2325" b="0">
+                <a:solidFill>
+                  <a:srgbClr val="D9E1DF"/>
+                </a:solidFill>
+                <a:latin typeface="Arial"/>
+                <a:ea typeface="Arial"/>
+                <a:cs typeface="Arial"/>
+              </a:defRPr>
+            </a:pPr>
+            <a:r>
+              <a:rPr sz="2325" b="0">
+                <a:solidFill>
+                  <a:srgbClr val="D9E1DF"/>
+                </a:solidFill>
+                <a:latin typeface="Arial"/>
+                <a:ea typeface="Arial"/>
+                <a:cs typeface="Arial"/>
+              </a:rPr>
+              <a:t>and metadata-only evidence for Codex and Claude Code.</a:t>
+            </a:r>
+          </a:p>
+        </p:txBody>
+      </p:sp>
+      <p:sp>
+        <p:nvSpPr>
+          <p:cNvPr id="10" name="cover-boundary">
+            <a:extLst xmlns:a="http://schemas.openxmlformats.org/drawingml/2006/main">
+              <a:ext uri="{FF2B5EF4-FFF2-40B4-BE49-F238E27FC236}">
+                <a16:creationId xmlns:a16="http://schemas.microsoft.com/office/drawing/2014/main" id="{13E2D2F9-7272-4063-8C42-BF8EF3C897CA}"/>
+              </a:ext>
+            </a:extLst>
+          </p:cNvPr>
+          <p:cNvSpPr>
+            <a:spLocks xmlns:a="http://schemas.openxmlformats.org/drawingml/2006/main" noGrp="1"/>
+          </p:cNvSpPr>
+          <p:nvPr/>
+        </p:nvSpPr>
+        <p:spPr>
+          <a:xfrm xmlns:a="http://schemas.openxmlformats.org/drawingml/2006/main">
+            <a:off x="647700" y="5543550"/>
+            <a:ext cx="10572750" cy="400050"/>
+          </a:xfrm>
+          <a:prstGeom xmlns:a="http://schemas.openxmlformats.org/drawingml/2006/main" prst="rect">
+            <a:avLst/>
+          </a:prstGeom>
+          <a:noFill xmlns:a="http://schemas.openxmlformats.org/drawingml/2006/main"/>
+          <a:ln xmlns:a="http://schemas.openxmlformats.org/drawingml/2006/main" w="0">
+            <a:noFill/>
+            <a:prstDash val="solid"/>
+          </a:ln>
+        </p:spPr>
+        <p:txBody>
+          <a:bodyPr xmlns:a="http://schemas.openxmlformats.org/drawingml/2006/main" wrap="square" lIns="0" tIns="0" rIns="0" bIns="0">
+            <a:noAutofit/>
+          </a:bodyPr>
+          <a:lstStyle xmlns:a="http://schemas.openxmlformats.org/drawingml/2006/main"/>
+          <a:p xmlns:a="http://schemas.openxmlformats.org/drawingml/2006/main">
+            <a:pPr>
               <a:defRPr sz="1875" b="1">
                 <a:solidFill>
                   <a:srgbClr val="DCEDA6"/>
@@ -2128,7 +2186,7 @@
     </p:spTree>
     <p:extLst>
       <p:ext uri="{BB962C8B-B14F-4D97-AF65-F5344CB8AC3E}">
-        <p14:creationId xmlns:p14="http://schemas.microsoft.com/office/powerpoint/2010/main" val="274228205"/>
+        <p14:creationId xmlns:p14="http://schemas.microsoft.com/office/powerpoint/2010/main" val="257141337"/>
       </p:ext>
     </p:extLst>
   </p:cSld>
@@ -2156,10 +2214,10 @@
       </p:grpSpPr>
       <p:sp>
         <p:nvSpPr>
-          <p:cNvPr id="21" name="Hormuz mark boundary">
-            <a:extLst xmlns:a="http://schemas.openxmlformats.org/drawingml/2006/main">
-              <a:ext uri="{FF2B5EF4-FFF2-40B4-BE49-F238E27FC236}">
-                <a16:creationId xmlns:a16="http://schemas.microsoft.com/office/drawing/2014/main" id="{9DC2F23B-2BDC-4C2E-A316-1B3211C52606}"/>
+          <p:cNvPr id="22" name="Hormuz mark boundary">
+            <a:extLst xmlns:a="http://schemas.openxmlformats.org/drawingml/2006/main">
+              <a:ext uri="{FF2B5EF4-FFF2-40B4-BE49-F238E27FC236}">
+                <a16:creationId xmlns:a16="http://schemas.microsoft.com/office/drawing/2014/main" id="{C616B305-D674-47A7-843B-73F2782E2D30}"/>
               </a:ext>
             </a:extLst>
           </p:cNvPr>
@@ -2190,7 +2248,7 @@
           <p:cNvPr id="2" name="Hormuz mark bar 1">
             <a:extLst xmlns:a="http://schemas.openxmlformats.org/drawingml/2006/main">
               <a:ext uri="{FF2B5EF4-FFF2-40B4-BE49-F238E27FC236}">
-                <a16:creationId xmlns:a16="http://schemas.microsoft.com/office/drawing/2014/main" id="{3974FD04-8C31-4FF8-B519-C23EA3ECD2A1}"/>
+                <a16:creationId xmlns:a16="http://schemas.microsoft.com/office/drawing/2014/main" id="{F2620ED3-5197-48AD-857A-E734EB7C97FE}"/>
               </a:ext>
             </a:extLst>
           </p:cNvPr>
@@ -2222,7 +2280,7 @@
           <p:cNvPr id="3" name="Hormuz mark bar 2">
             <a:extLst xmlns:a="http://schemas.openxmlformats.org/drawingml/2006/main">
               <a:ext uri="{FF2B5EF4-FFF2-40B4-BE49-F238E27FC236}">
-                <a16:creationId xmlns:a16="http://schemas.microsoft.com/office/drawing/2014/main" id="{A500391C-75EE-4941-8568-84F15E22BBE4}"/>
+                <a16:creationId xmlns:a16="http://schemas.microsoft.com/office/drawing/2014/main" id="{A1F88F53-8E71-4813-9EA8-ACB15D614416}"/>
               </a:ext>
             </a:extLst>
           </p:cNvPr>
@@ -2254,7 +2312,7 @@
           <p:cNvPr id="4" name="Hormuz mark bar 3">
             <a:extLst xmlns:a="http://schemas.openxmlformats.org/drawingml/2006/main">
               <a:ext uri="{FF2B5EF4-FFF2-40B4-BE49-F238E27FC236}">
-                <a16:creationId xmlns:a16="http://schemas.microsoft.com/office/drawing/2014/main" id="{E51702F0-D634-457B-9BB6-22341D3E4534}"/>
+                <a16:creationId xmlns:a16="http://schemas.microsoft.com/office/drawing/2014/main" id="{6D49C5F2-DDE0-4C3D-A31C-50C1167174D6}"/>
               </a:ext>
             </a:extLst>
           </p:cNvPr>
@@ -2286,7 +2344,7 @@
           <p:cNvPr id="5" name="section">
             <a:extLst xmlns:a="http://schemas.openxmlformats.org/drawingml/2006/main">
               <a:ext uri="{FF2B5EF4-FFF2-40B4-BE49-F238E27FC236}">
-                <a16:creationId xmlns:a16="http://schemas.microsoft.com/office/drawing/2014/main" id="{FD27D398-BC93-4B1D-B5F1-CE1B797F0D46}"/>
+                <a16:creationId xmlns:a16="http://schemas.microsoft.com/office/drawing/2014/main" id="{5F583A0B-7F92-408F-B34A-13E9CCB8EE23}"/>
               </a:ext>
             </a:extLst>
           </p:cNvPr>
@@ -2344,7 +2402,7 @@
           <p:cNvPr id="6" name="takeaway">
             <a:extLst xmlns:a="http://schemas.openxmlformats.org/drawingml/2006/main">
               <a:ext uri="{FF2B5EF4-FFF2-40B4-BE49-F238E27FC236}">
-                <a16:creationId xmlns:a16="http://schemas.microsoft.com/office/drawing/2014/main" id="{78015F71-9063-4000-8F20-9E51CB1FEFC7}"/>
+                <a16:creationId xmlns:a16="http://schemas.microsoft.com/office/drawing/2014/main" id="{89294B07-40D8-4888-B1B7-8DAD5BCCD9EE}"/>
               </a:ext>
             </a:extLst>
           </p:cNvPr>
@@ -2402,7 +2460,7 @@
           <p:cNvPr id="7" name="footer">
             <a:extLst xmlns:a="http://schemas.openxmlformats.org/drawingml/2006/main">
               <a:ext uri="{FF2B5EF4-FFF2-40B4-BE49-F238E27FC236}">
-                <a16:creationId xmlns:a16="http://schemas.microsoft.com/office/drawing/2014/main" id="{68610D9D-BDBF-4D9B-A018-7DAB67B245F9}"/>
+                <a16:creationId xmlns:a16="http://schemas.microsoft.com/office/drawing/2014/main" id="{63E1982C-E102-4D86-B9EB-7BB490E5EFF0}"/>
               </a:ext>
             </a:extLst>
           </p:cNvPr>
@@ -2414,7 +2472,7 @@
         <p:spPr>
           <a:xfrm xmlns:a="http://schemas.openxmlformats.org/drawingml/2006/main">
             <a:off x="609600" y="6400800"/>
-            <a:ext cx="10972800" cy="228600"/>
+            <a:ext cx="9525000" cy="228600"/>
           </a:xfrm>
           <a:prstGeom xmlns:a="http://schemas.openxmlformats.org/drawingml/2006/main" prst="rect">
             <a:avLst/>
@@ -2450,29 +2508,29 @@
                 <a:ea typeface="Arial"/>
                 <a:cs typeface="Arial"/>
               </a:rPr>
-              <a:t>HORMUZ  /  Mehrdad Zaker  /  September 2026                                      02 / 07</a:t>
-            </a:r>
-          </a:p>
-        </p:txBody>
-      </p:sp>
-      <p:sp>
-        <p:nvSpPr>
-          <p:cNvPr id="8" name="arrow-one">
-            <a:extLst xmlns:a="http://schemas.openxmlformats.org/drawingml/2006/main">
-              <a:ext uri="{FF2B5EF4-FFF2-40B4-BE49-F238E27FC236}">
-                <a16:creationId xmlns:a16="http://schemas.microsoft.com/office/drawing/2014/main" id="{8627FC9A-7685-4943-B076-979A3E4E185C}"/>
-              </a:ext>
-            </a:extLst>
-          </p:cNvPr>
-          <p:cNvSpPr>
-            <a:spLocks xmlns:a="http://schemas.openxmlformats.org/drawingml/2006/main" noGrp="1"/>
-          </p:cNvSpPr>
-          <p:nvPr/>
-        </p:nvSpPr>
-        <p:spPr>
-          <a:xfrm xmlns:a="http://schemas.openxmlformats.org/drawingml/2006/main">
-            <a:off x="3695700" y="2962275"/>
-            <a:ext cx="571500" cy="666750"/>
+              <a:t>HORMUZ  /  A product of Neuralint  /  Mehrdad Zaker  /  September 2026</a:t>
+            </a:r>
+          </a:p>
+        </p:txBody>
+      </p:sp>
+      <p:sp>
+        <p:nvSpPr>
+          <p:cNvPr id="8" name="page-number">
+            <a:extLst xmlns:a="http://schemas.openxmlformats.org/drawingml/2006/main">
+              <a:ext uri="{FF2B5EF4-FFF2-40B4-BE49-F238E27FC236}">
+                <a16:creationId xmlns:a16="http://schemas.microsoft.com/office/drawing/2014/main" id="{20E6A3A5-0105-4711-A6F9-55750AF8F5E0}"/>
+              </a:ext>
+            </a:extLst>
+          </p:cNvPr>
+          <p:cNvSpPr>
+            <a:spLocks xmlns:a="http://schemas.openxmlformats.org/drawingml/2006/main" noGrp="1"/>
+          </p:cNvSpPr>
+          <p:nvPr/>
+        </p:nvSpPr>
+        <p:spPr>
+          <a:xfrm xmlns:a="http://schemas.openxmlformats.org/drawingml/2006/main">
+            <a:off x="10972800" y="6400800"/>
+            <a:ext cx="609600" cy="228600"/>
           </a:xfrm>
           <a:prstGeom xmlns:a="http://schemas.openxmlformats.org/drawingml/2006/main" prst="rect">
             <a:avLst/>
@@ -2490,46 +2548,46 @@
           <a:lstStyle xmlns:a="http://schemas.openxmlformats.org/drawingml/2006/main"/>
           <a:p xmlns:a="http://schemas.openxmlformats.org/drawingml/2006/main">
             <a:pPr>
-              <a:defRPr sz="3450" b="0">
-                <a:solidFill>
-                  <a:srgbClr val="31684B"/>
-                </a:solidFill>
-                <a:latin typeface="Arial"/>
-                <a:ea typeface="Arial"/>
-                <a:cs typeface="Arial"/>
-              </a:defRPr>
-            </a:pPr>
-            <a:r>
-              <a:rPr sz="3450" b="0">
-                <a:solidFill>
-                  <a:srgbClr val="31684B"/>
-                </a:solidFill>
-                <a:latin typeface="Arial"/>
-                <a:ea typeface="Arial"/>
-                <a:cs typeface="Arial"/>
-              </a:rPr>
-              <a:t>→</a:t>
-            </a:r>
-          </a:p>
-        </p:txBody>
-      </p:sp>
-      <p:sp>
-        <p:nvSpPr>
-          <p:cNvPr id="9" name="arrow-two">
-            <a:extLst xmlns:a="http://schemas.openxmlformats.org/drawingml/2006/main">
-              <a:ext uri="{FF2B5EF4-FFF2-40B4-BE49-F238E27FC236}">
-                <a16:creationId xmlns:a16="http://schemas.microsoft.com/office/drawing/2014/main" id="{4D8BECAC-EA68-488C-818C-460CFF8882F5}"/>
-              </a:ext>
-            </a:extLst>
-          </p:cNvPr>
-          <p:cNvSpPr>
-            <a:spLocks xmlns:a="http://schemas.openxmlformats.org/drawingml/2006/main" noGrp="1"/>
-          </p:cNvSpPr>
-          <p:nvPr/>
-        </p:nvSpPr>
-        <p:spPr>
-          <a:xfrm xmlns:a="http://schemas.openxmlformats.org/drawingml/2006/main">
-            <a:off x="7839075" y="2962275"/>
+              <a:defRPr sz="1275" b="0">
+                <a:solidFill>
+                  <a:srgbClr val="5C6758"/>
+                </a:solidFill>
+                <a:latin typeface="Arial"/>
+                <a:ea typeface="Arial"/>
+                <a:cs typeface="Arial"/>
+              </a:defRPr>
+            </a:pPr>
+            <a:r>
+              <a:rPr sz="1275" b="0">
+                <a:solidFill>
+                  <a:srgbClr val="5C6758"/>
+                </a:solidFill>
+                <a:latin typeface="Arial"/>
+                <a:ea typeface="Arial"/>
+                <a:cs typeface="Arial"/>
+              </a:rPr>
+              <a:t>02 / 07</a:t>
+            </a:r>
+          </a:p>
+        </p:txBody>
+      </p:sp>
+      <p:sp>
+        <p:nvSpPr>
+          <p:cNvPr id="9" name="arrow-one">
+            <a:extLst xmlns:a="http://schemas.openxmlformats.org/drawingml/2006/main">
+              <a:ext uri="{FF2B5EF4-FFF2-40B4-BE49-F238E27FC236}">
+                <a16:creationId xmlns:a16="http://schemas.microsoft.com/office/drawing/2014/main" id="{7B53CAF2-30C5-488F-8E30-959273B21063}"/>
+              </a:ext>
+            </a:extLst>
+          </p:cNvPr>
+          <p:cNvSpPr>
+            <a:spLocks xmlns:a="http://schemas.openxmlformats.org/drawingml/2006/main" noGrp="1"/>
+          </p:cNvSpPr>
+          <p:nvPr/>
+        </p:nvSpPr>
+        <p:spPr>
+          <a:xfrm xmlns:a="http://schemas.openxmlformats.org/drawingml/2006/main">
+            <a:off x="3695700" y="2962275"/>
             <a:ext cx="571500" cy="666750"/>
           </a:xfrm>
           <a:prstGeom xmlns:a="http://schemas.openxmlformats.org/drawingml/2006/main" prst="rect">
@@ -2573,10 +2631,68 @@
       </p:sp>
       <p:sp>
         <p:nvSpPr>
-          <p:cNvPr id="10" name="EMPLOYEE CLIENT">
-            <a:extLst xmlns:a="http://schemas.openxmlformats.org/drawingml/2006/main">
-              <a:ext uri="{FF2B5EF4-FFF2-40B4-BE49-F238E27FC236}">
-                <a16:creationId xmlns:a16="http://schemas.microsoft.com/office/drawing/2014/main" id="{3C747C19-9256-430F-A723-53A6B34CF6F7}"/>
+          <p:cNvPr id="10" name="arrow-two">
+            <a:extLst xmlns:a="http://schemas.openxmlformats.org/drawingml/2006/main">
+              <a:ext uri="{FF2B5EF4-FFF2-40B4-BE49-F238E27FC236}">
+                <a16:creationId xmlns:a16="http://schemas.microsoft.com/office/drawing/2014/main" id="{C245EF8B-E895-421E-A83F-ADB4768634F9}"/>
+              </a:ext>
+            </a:extLst>
+          </p:cNvPr>
+          <p:cNvSpPr>
+            <a:spLocks xmlns:a="http://schemas.openxmlformats.org/drawingml/2006/main" noGrp="1"/>
+          </p:cNvSpPr>
+          <p:nvPr/>
+        </p:nvSpPr>
+        <p:spPr>
+          <a:xfrm xmlns:a="http://schemas.openxmlformats.org/drawingml/2006/main">
+            <a:off x="7839075" y="2962275"/>
+            <a:ext cx="571500" cy="666750"/>
+          </a:xfrm>
+          <a:prstGeom xmlns:a="http://schemas.openxmlformats.org/drawingml/2006/main" prst="rect">
+            <a:avLst/>
+          </a:prstGeom>
+          <a:noFill xmlns:a="http://schemas.openxmlformats.org/drawingml/2006/main"/>
+          <a:ln xmlns:a="http://schemas.openxmlformats.org/drawingml/2006/main" w="0">
+            <a:noFill/>
+            <a:prstDash val="solid"/>
+          </a:ln>
+        </p:spPr>
+        <p:txBody>
+          <a:bodyPr xmlns:a="http://schemas.openxmlformats.org/drawingml/2006/main" wrap="square" lIns="0" tIns="0" rIns="0" bIns="0">
+            <a:noAutofit/>
+          </a:bodyPr>
+          <a:lstStyle xmlns:a="http://schemas.openxmlformats.org/drawingml/2006/main"/>
+          <a:p xmlns:a="http://schemas.openxmlformats.org/drawingml/2006/main">
+            <a:pPr>
+              <a:defRPr sz="3450" b="0">
+                <a:solidFill>
+                  <a:srgbClr val="31684B"/>
+                </a:solidFill>
+                <a:latin typeface="Arial"/>
+                <a:ea typeface="Arial"/>
+                <a:cs typeface="Arial"/>
+              </a:defRPr>
+            </a:pPr>
+            <a:r>
+              <a:rPr sz="3450" b="0">
+                <a:solidFill>
+                  <a:srgbClr val="31684B"/>
+                </a:solidFill>
+                <a:latin typeface="Arial"/>
+                <a:ea typeface="Arial"/>
+                <a:cs typeface="Arial"/>
+              </a:rPr>
+              <a:t>→</a:t>
+            </a:r>
+          </a:p>
+        </p:txBody>
+      </p:sp>
+      <p:sp>
+        <p:nvSpPr>
+          <p:cNvPr id="11" name="EMPLOYEE CLIENT">
+            <a:extLst xmlns:a="http://schemas.openxmlformats.org/drawingml/2006/main">
+              <a:ext uri="{FF2B5EF4-FFF2-40B4-BE49-F238E27FC236}">
+                <a16:creationId xmlns:a16="http://schemas.microsoft.com/office/drawing/2014/main" id="{EBA64CCD-4C42-47AB-A18A-3AF042D2F6A1}"/>
               </a:ext>
             </a:extLst>
           </p:cNvPr>
@@ -2606,10 +2722,10 @@
       </p:sp>
       <p:sp>
         <p:nvSpPr>
-          <p:cNvPr id="11" name="EMPLOYEE CLIENT-title">
-            <a:extLst xmlns:a="http://schemas.openxmlformats.org/drawingml/2006/main">
-              <a:ext uri="{FF2B5EF4-FFF2-40B4-BE49-F238E27FC236}">
-                <a16:creationId xmlns:a16="http://schemas.microsoft.com/office/drawing/2014/main" id="{A7424B47-425A-4D2D-BCE7-F29BC10282C4}"/>
+          <p:cNvPr id="12" name="EMPLOYEE CLIENT-title">
+            <a:extLst xmlns:a="http://schemas.openxmlformats.org/drawingml/2006/main">
+              <a:ext uri="{FF2B5EF4-FFF2-40B4-BE49-F238E27FC236}">
+                <a16:creationId xmlns:a16="http://schemas.microsoft.com/office/drawing/2014/main" id="{1C5E2250-BD72-4A8A-AFE2-F1B22E6027CC}"/>
               </a:ext>
             </a:extLst>
           </p:cNvPr>
@@ -2664,10 +2780,10 @@
       </p:sp>
       <p:sp>
         <p:nvSpPr>
-          <p:cNvPr id="12" name="EMPLOYEE CLIENT-body">
-            <a:extLst xmlns:a="http://schemas.openxmlformats.org/drawingml/2006/main">
-              <a:ext uri="{FF2B5EF4-FFF2-40B4-BE49-F238E27FC236}">
-                <a16:creationId xmlns:a16="http://schemas.microsoft.com/office/drawing/2014/main" id="{59AC9921-B93D-4365-8846-B501545BD5EB}"/>
+          <p:cNvPr id="13" name="EMPLOYEE CLIENT-body">
+            <a:extLst xmlns:a="http://schemas.openxmlformats.org/drawingml/2006/main">
+              <a:ext uri="{FF2B5EF4-FFF2-40B4-BE49-F238E27FC236}">
+                <a16:creationId xmlns:a16="http://schemas.microsoft.com/office/drawing/2014/main" id="{FABEBE93-2670-4B15-93C8-B6FB4D04620C}"/>
               </a:ext>
             </a:extLst>
           </p:cNvPr>
@@ -2745,10 +2861,10 @@
       </p:sp>
       <p:sp>
         <p:nvSpPr>
-          <p:cNvPr id="13" name="HORMUZ">
-            <a:extLst xmlns:a="http://schemas.openxmlformats.org/drawingml/2006/main">
-              <a:ext uri="{FF2B5EF4-FFF2-40B4-BE49-F238E27FC236}">
-                <a16:creationId xmlns:a16="http://schemas.microsoft.com/office/drawing/2014/main" id="{4538982A-C968-4F17-A8ED-29674AC2F0A4}"/>
+          <p:cNvPr id="14" name="HORMUZ">
+            <a:extLst xmlns:a="http://schemas.openxmlformats.org/drawingml/2006/main">
+              <a:ext uri="{FF2B5EF4-FFF2-40B4-BE49-F238E27FC236}">
+                <a16:creationId xmlns:a16="http://schemas.microsoft.com/office/drawing/2014/main" id="{8CB34AFD-36A7-4997-9CA3-A4BC4527E7A9}"/>
               </a:ext>
             </a:extLst>
           </p:cNvPr>
@@ -2778,10 +2894,10 @@
       </p:sp>
       <p:sp>
         <p:nvSpPr>
-          <p:cNvPr id="14" name="HORMUZ-title">
-            <a:extLst xmlns:a="http://schemas.openxmlformats.org/drawingml/2006/main">
-              <a:ext uri="{FF2B5EF4-FFF2-40B4-BE49-F238E27FC236}">
-                <a16:creationId xmlns:a16="http://schemas.microsoft.com/office/drawing/2014/main" id="{55E814F5-2C95-4AE9-85F9-23C16A3164A4}"/>
+          <p:cNvPr id="15" name="HORMUZ-title">
+            <a:extLst xmlns:a="http://schemas.openxmlformats.org/drawingml/2006/main">
+              <a:ext uri="{FF2B5EF4-FFF2-40B4-BE49-F238E27FC236}">
+                <a16:creationId xmlns:a16="http://schemas.microsoft.com/office/drawing/2014/main" id="{7849F456-3F2F-4FC6-A3AB-4129EC5030F6}"/>
               </a:ext>
             </a:extLst>
           </p:cNvPr>
@@ -2836,10 +2952,10 @@
       </p:sp>
       <p:sp>
         <p:nvSpPr>
-          <p:cNvPr id="15" name="HORMUZ-body">
-            <a:extLst xmlns:a="http://schemas.openxmlformats.org/drawingml/2006/main">
-              <a:ext uri="{FF2B5EF4-FFF2-40B4-BE49-F238E27FC236}">
-                <a16:creationId xmlns:a16="http://schemas.microsoft.com/office/drawing/2014/main" id="{52B58E35-D437-4BE5-BE7F-54C32ABACB3B}"/>
+          <p:cNvPr id="16" name="HORMUZ-body">
+            <a:extLst xmlns:a="http://schemas.openxmlformats.org/drawingml/2006/main">
+              <a:ext uri="{FF2B5EF4-FFF2-40B4-BE49-F238E27FC236}">
+                <a16:creationId xmlns:a16="http://schemas.microsoft.com/office/drawing/2014/main" id="{68B17EBC-7A76-4FB3-A33B-DE1B515967D2}"/>
               </a:ext>
             </a:extLst>
           </p:cNvPr>
@@ -2917,10 +3033,10 @@
       </p:sp>
       <p:sp>
         <p:nvSpPr>
-          <p:cNvPr id="16" name="MODEL PROVIDER">
-            <a:extLst xmlns:a="http://schemas.openxmlformats.org/drawingml/2006/main">
-              <a:ext uri="{FF2B5EF4-FFF2-40B4-BE49-F238E27FC236}">
-                <a16:creationId xmlns:a16="http://schemas.microsoft.com/office/drawing/2014/main" id="{5DD66781-2CAC-47FE-9D94-4732462A0BF0}"/>
+          <p:cNvPr id="17" name="MODEL PROVIDER">
+            <a:extLst xmlns:a="http://schemas.openxmlformats.org/drawingml/2006/main">
+              <a:ext uri="{FF2B5EF4-FFF2-40B4-BE49-F238E27FC236}">
+                <a16:creationId xmlns:a16="http://schemas.microsoft.com/office/drawing/2014/main" id="{0A344401-14F5-45F2-B130-9A4B15F44DD3}"/>
               </a:ext>
             </a:extLst>
           </p:cNvPr>
@@ -2950,10 +3066,10 @@
       </p:sp>
       <p:sp>
         <p:nvSpPr>
-          <p:cNvPr id="17" name="MODEL PROVIDER-title">
-            <a:extLst xmlns:a="http://schemas.openxmlformats.org/drawingml/2006/main">
-              <a:ext uri="{FF2B5EF4-FFF2-40B4-BE49-F238E27FC236}">
-                <a16:creationId xmlns:a16="http://schemas.microsoft.com/office/drawing/2014/main" id="{A36BAE3C-4EB7-458E-AF6A-58AA3C7B02C7}"/>
+          <p:cNvPr id="18" name="MODEL PROVIDER-title">
+            <a:extLst xmlns:a="http://schemas.openxmlformats.org/drawingml/2006/main">
+              <a:ext uri="{FF2B5EF4-FFF2-40B4-BE49-F238E27FC236}">
+                <a16:creationId xmlns:a16="http://schemas.microsoft.com/office/drawing/2014/main" id="{5B9EA19E-1824-4CDA-A304-F944375144C6}"/>
               </a:ext>
             </a:extLst>
           </p:cNvPr>
@@ -3008,10 +3124,10 @@
       </p:sp>
       <p:sp>
         <p:nvSpPr>
-          <p:cNvPr id="18" name="MODEL PROVIDER-body">
-            <a:extLst xmlns:a="http://schemas.openxmlformats.org/drawingml/2006/main">
-              <a:ext uri="{FF2B5EF4-FFF2-40B4-BE49-F238E27FC236}">
-                <a16:creationId xmlns:a16="http://schemas.microsoft.com/office/drawing/2014/main" id="{7515595B-623C-4F2F-865D-8A698E5A6466}"/>
+          <p:cNvPr id="19" name="MODEL PROVIDER-body">
+            <a:extLst xmlns:a="http://schemas.openxmlformats.org/drawingml/2006/main">
+              <a:ext uri="{FF2B5EF4-FFF2-40B4-BE49-F238E27FC236}">
+                <a16:creationId xmlns:a16="http://schemas.microsoft.com/office/drawing/2014/main" id="{B9F38047-5181-4262-8CF6-AF5F58EB1DA2}"/>
               </a:ext>
             </a:extLst>
           </p:cNvPr>
@@ -3089,10 +3205,10 @@
       </p:sp>
       <p:sp>
         <p:nvSpPr>
-          <p:cNvPr id="19" name="metadata">
-            <a:extLst xmlns:a="http://schemas.openxmlformats.org/drawingml/2006/main">
-              <a:ext uri="{FF2B5EF4-FFF2-40B4-BE49-F238E27FC236}">
-                <a16:creationId xmlns:a16="http://schemas.microsoft.com/office/drawing/2014/main" id="{8059FDA5-32EC-401D-8AC5-68E9717C20A6}"/>
+          <p:cNvPr id="20" name="metadata">
+            <a:extLst xmlns:a="http://schemas.openxmlformats.org/drawingml/2006/main">
+              <a:ext uri="{FF2B5EF4-FFF2-40B4-BE49-F238E27FC236}">
+                <a16:creationId xmlns:a16="http://schemas.microsoft.com/office/drawing/2014/main" id="{DD3377E4-448F-41CC-B9C1-A1AB8D1ADFFD}"/>
               </a:ext>
             </a:extLst>
           </p:cNvPr>
@@ -3147,10 +3263,10 @@
       </p:sp>
       <p:sp>
         <p:nvSpPr>
-          <p:cNvPr id="20" name="boundary">
-            <a:extLst xmlns:a="http://schemas.openxmlformats.org/drawingml/2006/main">
-              <a:ext uri="{FF2B5EF4-FFF2-40B4-BE49-F238E27FC236}">
-                <a16:creationId xmlns:a16="http://schemas.microsoft.com/office/drawing/2014/main" id="{30C1DF31-E220-4F59-B2B7-69741B8B4E24}"/>
+          <p:cNvPr id="21" name="boundary">
+            <a:extLst xmlns:a="http://schemas.openxmlformats.org/drawingml/2006/main">
+              <a:ext uri="{FF2B5EF4-FFF2-40B4-BE49-F238E27FC236}">
+                <a16:creationId xmlns:a16="http://schemas.microsoft.com/office/drawing/2014/main" id="{1FA0D41D-CAB6-4F35-B856-21E57CF9D2E2}"/>
               </a:ext>
             </a:extLst>
           </p:cNvPr>
@@ -3206,7 +3322,7 @@
     </p:spTree>
     <p:extLst>
       <p:ext uri="{BB962C8B-B14F-4D97-AF65-F5344CB8AC3E}">
-        <p14:creationId xmlns:p14="http://schemas.microsoft.com/office/powerpoint/2010/main" val="1272595377"/>
+        <p14:creationId xmlns:p14="http://schemas.microsoft.com/office/powerpoint/2010/main" val="2093276171"/>
       </p:ext>
     </p:extLst>
   </p:cSld>
@@ -3234,10 +3350,10 @@
       </p:grpSpPr>
       <p:sp>
         <p:nvSpPr>
-          <p:cNvPr id="12" name="Hormuz mark boundary">
-            <a:extLst xmlns:a="http://schemas.openxmlformats.org/drawingml/2006/main">
-              <a:ext uri="{FF2B5EF4-FFF2-40B4-BE49-F238E27FC236}">
-                <a16:creationId xmlns:a16="http://schemas.microsoft.com/office/drawing/2014/main" id="{45EE2C09-73A4-4BE2-807E-C0F492AE02CA}"/>
+          <p:cNvPr id="13" name="Hormuz mark boundary">
+            <a:extLst xmlns:a="http://schemas.openxmlformats.org/drawingml/2006/main">
+              <a:ext uri="{FF2B5EF4-FFF2-40B4-BE49-F238E27FC236}">
+                <a16:creationId xmlns:a16="http://schemas.microsoft.com/office/drawing/2014/main" id="{279A3BFD-BF0E-42C1-B1B1-0983E9ACE8BC}"/>
               </a:ext>
             </a:extLst>
           </p:cNvPr>
@@ -3268,7 +3384,7 @@
           <p:cNvPr id="2" name="Hormuz mark bar 1">
             <a:extLst xmlns:a="http://schemas.openxmlformats.org/drawingml/2006/main">
               <a:ext uri="{FF2B5EF4-FFF2-40B4-BE49-F238E27FC236}">
-                <a16:creationId xmlns:a16="http://schemas.microsoft.com/office/drawing/2014/main" id="{70BD15C2-8662-45EE-9673-3387C97EA1E7}"/>
+                <a16:creationId xmlns:a16="http://schemas.microsoft.com/office/drawing/2014/main" id="{242500A5-A78C-4276-BE7A-F142904061B9}"/>
               </a:ext>
             </a:extLst>
           </p:cNvPr>
@@ -3300,7 +3416,7 @@
           <p:cNvPr id="3" name="Hormuz mark bar 2">
             <a:extLst xmlns:a="http://schemas.openxmlformats.org/drawingml/2006/main">
               <a:ext uri="{FF2B5EF4-FFF2-40B4-BE49-F238E27FC236}">
-                <a16:creationId xmlns:a16="http://schemas.microsoft.com/office/drawing/2014/main" id="{16EBA790-E1CC-41A8-844D-917477BC6131}"/>
+                <a16:creationId xmlns:a16="http://schemas.microsoft.com/office/drawing/2014/main" id="{B3AC06E0-0B74-4BCC-8C92-319A03C6BEED}"/>
               </a:ext>
             </a:extLst>
           </p:cNvPr>
@@ -3332,7 +3448,7 @@
           <p:cNvPr id="4" name="Hormuz mark bar 3">
             <a:extLst xmlns:a="http://schemas.openxmlformats.org/drawingml/2006/main">
               <a:ext uri="{FF2B5EF4-FFF2-40B4-BE49-F238E27FC236}">
-                <a16:creationId xmlns:a16="http://schemas.microsoft.com/office/drawing/2014/main" id="{959E6CB1-B11F-4646-AC78-CAD6F3FE7EA0}"/>
+                <a16:creationId xmlns:a16="http://schemas.microsoft.com/office/drawing/2014/main" id="{78790558-2A3B-4A11-B07C-4AD2F0003DC3}"/>
               </a:ext>
             </a:extLst>
           </p:cNvPr>
@@ -3364,7 +3480,7 @@
           <p:cNvPr id="5" name="section">
             <a:extLst xmlns:a="http://schemas.openxmlformats.org/drawingml/2006/main">
               <a:ext uri="{FF2B5EF4-FFF2-40B4-BE49-F238E27FC236}">
-                <a16:creationId xmlns:a16="http://schemas.microsoft.com/office/drawing/2014/main" id="{35C57F1D-47C2-4CB0-9232-FEA8E9D28270}"/>
+                <a16:creationId xmlns:a16="http://schemas.microsoft.com/office/drawing/2014/main" id="{C1ECAE55-81F7-4950-8F59-362475F72073}"/>
               </a:ext>
             </a:extLst>
           </p:cNvPr>
@@ -3422,7 +3538,7 @@
           <p:cNvPr id="6" name="takeaway">
             <a:extLst xmlns:a="http://schemas.openxmlformats.org/drawingml/2006/main">
               <a:ext uri="{FF2B5EF4-FFF2-40B4-BE49-F238E27FC236}">
-                <a16:creationId xmlns:a16="http://schemas.microsoft.com/office/drawing/2014/main" id="{64042A4E-8DF4-4715-8C21-018D0588A5D0}"/>
+                <a16:creationId xmlns:a16="http://schemas.microsoft.com/office/drawing/2014/main" id="{BDD23D6F-7B13-4717-967F-6D7E81311E02}"/>
               </a:ext>
             </a:extLst>
           </p:cNvPr>
@@ -3480,7 +3596,7 @@
           <p:cNvPr id="7" name="footer">
             <a:extLst xmlns:a="http://schemas.openxmlformats.org/drawingml/2006/main">
               <a:ext uri="{FF2B5EF4-FFF2-40B4-BE49-F238E27FC236}">
-                <a16:creationId xmlns:a16="http://schemas.microsoft.com/office/drawing/2014/main" id="{A0B47DF0-3CC1-41FB-8751-DDFBD6A5376E}"/>
+                <a16:creationId xmlns:a16="http://schemas.microsoft.com/office/drawing/2014/main" id="{D86C3A45-C9E4-4329-ADFB-2F06E4364766}"/>
               </a:ext>
             </a:extLst>
           </p:cNvPr>
@@ -3492,7 +3608,7 @@
         <p:spPr>
           <a:xfrm xmlns:a="http://schemas.openxmlformats.org/drawingml/2006/main">
             <a:off x="609600" y="6400800"/>
-            <a:ext cx="10972800" cy="228600"/>
+            <a:ext cx="9525000" cy="228600"/>
           </a:xfrm>
           <a:prstGeom xmlns:a="http://schemas.openxmlformats.org/drawingml/2006/main" prst="rect">
             <a:avLst/>
@@ -3528,29 +3644,29 @@
                 <a:ea typeface="Arial"/>
                 <a:cs typeface="Arial"/>
               </a:rPr>
-              <a:t>HORMUZ  /  Mehrdad Zaker  /  September 2026                                      03 / 07</a:t>
-            </a:r>
-          </a:p>
-        </p:txBody>
-      </p:sp>
-      <p:sp>
-        <p:nvSpPr>
-          <p:cNvPr id="8" name="zero">
-            <a:extLst xmlns:a="http://schemas.openxmlformats.org/drawingml/2006/main">
-              <a:ext uri="{FF2B5EF4-FFF2-40B4-BE49-F238E27FC236}">
-                <a16:creationId xmlns:a16="http://schemas.microsoft.com/office/drawing/2014/main" id="{DD1F7526-AF44-4CEF-BD60-C6C18E2FC81A}"/>
-              </a:ext>
-            </a:extLst>
-          </p:cNvPr>
-          <p:cNvSpPr>
-            <a:spLocks xmlns:a="http://schemas.openxmlformats.org/drawingml/2006/main" noGrp="1"/>
-          </p:cNvSpPr>
-          <p:nvPr/>
-        </p:nvSpPr>
-        <p:spPr>
-          <a:xfrm xmlns:a="http://schemas.openxmlformats.org/drawingml/2006/main">
-            <a:off x="609600" y="2552700"/>
-            <a:ext cx="2095500" cy="1543050"/>
+              <a:t>HORMUZ  /  A product of Neuralint  /  Mehrdad Zaker  /  September 2026</a:t>
+            </a:r>
+          </a:p>
+        </p:txBody>
+      </p:sp>
+      <p:sp>
+        <p:nvSpPr>
+          <p:cNvPr id="8" name="page-number">
+            <a:extLst xmlns:a="http://schemas.openxmlformats.org/drawingml/2006/main">
+              <a:ext uri="{FF2B5EF4-FFF2-40B4-BE49-F238E27FC236}">
+                <a16:creationId xmlns:a16="http://schemas.microsoft.com/office/drawing/2014/main" id="{5E738AA0-F411-4D81-926F-B60EEBFC2BFE}"/>
+              </a:ext>
+            </a:extLst>
+          </p:cNvPr>
+          <p:cNvSpPr>
+            <a:spLocks xmlns:a="http://schemas.openxmlformats.org/drawingml/2006/main" noGrp="1"/>
+          </p:cNvSpPr>
+          <p:nvPr/>
+        </p:nvSpPr>
+        <p:spPr>
+          <a:xfrm xmlns:a="http://schemas.openxmlformats.org/drawingml/2006/main">
+            <a:off x="10972800" y="6400800"/>
+            <a:ext cx="609600" cy="228600"/>
           </a:xfrm>
           <a:prstGeom xmlns:a="http://schemas.openxmlformats.org/drawingml/2006/main" prst="rect">
             <a:avLst/>
@@ -3568,47 +3684,47 @@
           <a:lstStyle xmlns:a="http://schemas.openxmlformats.org/drawingml/2006/main"/>
           <a:p xmlns:a="http://schemas.openxmlformats.org/drawingml/2006/main">
             <a:pPr>
-              <a:defRPr sz="10500" b="1">
-                <a:solidFill>
-                  <a:srgbClr val="DCEDA6"/>
-                </a:solidFill>
-                <a:latin typeface="Arial"/>
-                <a:ea typeface="Arial"/>
-                <a:cs typeface="Arial"/>
-              </a:defRPr>
-            </a:pPr>
-            <a:r>
-              <a:rPr sz="10500" b="1">
-                <a:solidFill>
-                  <a:srgbClr val="DCEDA6"/>
-                </a:solidFill>
-                <a:latin typeface="Arial"/>
-                <a:ea typeface="Arial"/>
-                <a:cs typeface="Arial"/>
-              </a:rPr>
-              <a:t>0</a:t>
-            </a:r>
-          </a:p>
-        </p:txBody>
-      </p:sp>
-      <p:sp>
-        <p:nvSpPr>
-          <p:cNvPr id="9" name="zero-label">
-            <a:extLst xmlns:a="http://schemas.openxmlformats.org/drawingml/2006/main">
-              <a:ext uri="{FF2B5EF4-FFF2-40B4-BE49-F238E27FC236}">
-                <a16:creationId xmlns:a16="http://schemas.microsoft.com/office/drawing/2014/main" id="{C9ADAC7D-0B3E-4D1A-A216-15459CC275D9}"/>
-              </a:ext>
-            </a:extLst>
-          </p:cNvPr>
-          <p:cNvSpPr>
-            <a:spLocks xmlns:a="http://schemas.openxmlformats.org/drawingml/2006/main" noGrp="1"/>
-          </p:cNvSpPr>
-          <p:nvPr/>
-        </p:nvSpPr>
-        <p:spPr>
-          <a:xfrm xmlns:a="http://schemas.openxmlformats.org/drawingml/2006/main">
-            <a:off x="609600" y="4248150"/>
-            <a:ext cx="3429000" cy="666750"/>
+              <a:defRPr sz="1275" b="0">
+                <a:solidFill>
+                  <a:srgbClr val="DCE6D5"/>
+                </a:solidFill>
+                <a:latin typeface="Arial"/>
+                <a:ea typeface="Arial"/>
+                <a:cs typeface="Arial"/>
+              </a:defRPr>
+            </a:pPr>
+            <a:r>
+              <a:rPr sz="1275" b="0">
+                <a:solidFill>
+                  <a:srgbClr val="DCE6D5"/>
+                </a:solidFill>
+                <a:latin typeface="Arial"/>
+                <a:ea typeface="Arial"/>
+                <a:cs typeface="Arial"/>
+              </a:rPr>
+              <a:t>03 / 07</a:t>
+            </a:r>
+          </a:p>
+        </p:txBody>
+      </p:sp>
+      <p:sp>
+        <p:nvSpPr>
+          <p:cNvPr id="9" name="zero">
+            <a:extLst xmlns:a="http://schemas.openxmlformats.org/drawingml/2006/main">
+              <a:ext uri="{FF2B5EF4-FFF2-40B4-BE49-F238E27FC236}">
+                <a16:creationId xmlns:a16="http://schemas.microsoft.com/office/drawing/2014/main" id="{C84849C1-7A7D-462D-8DA5-76DDBF7ED86C}"/>
+              </a:ext>
+            </a:extLst>
+          </p:cNvPr>
+          <p:cNvSpPr>
+            <a:spLocks xmlns:a="http://schemas.openxmlformats.org/drawingml/2006/main" noGrp="1"/>
+          </p:cNvSpPr>
+          <p:nvPr/>
+        </p:nvSpPr>
+        <p:spPr>
+          <a:xfrm xmlns:a="http://schemas.openxmlformats.org/drawingml/2006/main">
+            <a:off x="609600" y="2552700"/>
+            <a:ext cx="2095500" cy="1543050"/>
           </a:xfrm>
           <a:prstGeom xmlns:a="http://schemas.openxmlformats.org/drawingml/2006/main" prst="rect">
             <a:avLst/>
@@ -3626,47 +3742,47 @@
           <a:lstStyle xmlns:a="http://schemas.openxmlformats.org/drawingml/2006/main"/>
           <a:p xmlns:a="http://schemas.openxmlformats.org/drawingml/2006/main">
             <a:pPr>
-              <a:defRPr sz="2250" b="1">
-                <a:solidFill>
-                  <a:srgbClr val="FAFBF6"/>
-                </a:solidFill>
-                <a:latin typeface="Arial"/>
-                <a:ea typeface="Arial"/>
-                <a:cs typeface="Arial"/>
-              </a:defRPr>
-            </a:pPr>
-            <a:r>
-              <a:rPr sz="2250" b="1">
-                <a:solidFill>
-                  <a:srgbClr val="FAFBF6"/>
-                </a:solidFill>
-                <a:latin typeface="Arial"/>
-                <a:ea typeface="Arial"/>
-                <a:cs typeface="Arial"/>
-              </a:rPr>
-              <a:t>external provider calls</a:t>
-            </a:r>
-          </a:p>
-        </p:txBody>
-      </p:sp>
-      <p:sp>
-        <p:nvSpPr>
-          <p:cNvPr id="10" name="checks">
-            <a:extLst xmlns:a="http://schemas.openxmlformats.org/drawingml/2006/main">
-              <a:ext uri="{FF2B5EF4-FFF2-40B4-BE49-F238E27FC236}">
-                <a16:creationId xmlns:a16="http://schemas.microsoft.com/office/drawing/2014/main" id="{19089C94-CB5E-492B-9210-3E1B96F983B6}"/>
-              </a:ext>
-            </a:extLst>
-          </p:cNvPr>
-          <p:cNvSpPr>
-            <a:spLocks xmlns:a="http://schemas.openxmlformats.org/drawingml/2006/main" noGrp="1"/>
-          </p:cNvSpPr>
-          <p:nvPr/>
-        </p:nvSpPr>
-        <p:spPr>
-          <a:xfrm xmlns:a="http://schemas.openxmlformats.org/drawingml/2006/main">
-            <a:off x="4686300" y="2533650"/>
-            <a:ext cx="6705600" cy="2400300"/>
+              <a:defRPr sz="10500" b="1">
+                <a:solidFill>
+                  <a:srgbClr val="DCEDA6"/>
+                </a:solidFill>
+                <a:latin typeface="Arial"/>
+                <a:ea typeface="Arial"/>
+                <a:cs typeface="Arial"/>
+              </a:defRPr>
+            </a:pPr>
+            <a:r>
+              <a:rPr sz="10500" b="1">
+                <a:solidFill>
+                  <a:srgbClr val="DCEDA6"/>
+                </a:solidFill>
+                <a:latin typeface="Arial"/>
+                <a:ea typeface="Arial"/>
+                <a:cs typeface="Arial"/>
+              </a:rPr>
+              <a:t>0</a:t>
+            </a:r>
+          </a:p>
+        </p:txBody>
+      </p:sp>
+      <p:sp>
+        <p:nvSpPr>
+          <p:cNvPr id="10" name="zero-label">
+            <a:extLst xmlns:a="http://schemas.openxmlformats.org/drawingml/2006/main">
+              <a:ext uri="{FF2B5EF4-FFF2-40B4-BE49-F238E27FC236}">
+                <a16:creationId xmlns:a16="http://schemas.microsoft.com/office/drawing/2014/main" id="{0EA22C6B-5151-426B-8934-4A4D4C35C222}"/>
+              </a:ext>
+            </a:extLst>
+          </p:cNvPr>
+          <p:cNvSpPr>
+            <a:spLocks xmlns:a="http://schemas.openxmlformats.org/drawingml/2006/main" noGrp="1"/>
+          </p:cNvSpPr>
+          <p:nvPr/>
+        </p:nvSpPr>
+        <p:spPr>
+          <a:xfrm xmlns:a="http://schemas.openxmlformats.org/drawingml/2006/main">
+            <a:off x="609600" y="4248150"/>
+            <a:ext cx="3429000" cy="666750"/>
           </a:xfrm>
           <a:prstGeom xmlns:a="http://schemas.openxmlformats.org/drawingml/2006/main" prst="rect">
             <a:avLst/>
@@ -3684,7 +3800,7 @@
           <a:lstStyle xmlns:a="http://schemas.openxmlformats.org/drawingml/2006/main"/>
           <a:p xmlns:a="http://schemas.openxmlformats.org/drawingml/2006/main">
             <a:pPr>
-              <a:defRPr sz="2325" b="0">
+              <a:defRPr sz="2250" b="1">
                 <a:solidFill>
                   <a:srgbClr val="FAFBF6"/>
                 </a:solidFill>
@@ -3694,7 +3810,7 @@
               </a:defRPr>
             </a:pPr>
             <a:r>
-              <a:rPr sz="2325" b="0">
+              <a:rPr sz="2250" b="1">
                 <a:solidFill>
                   <a:srgbClr val="FAFBF6"/>
                 </a:solidFill>
@@ -3702,98 +3818,29 @@
                 <a:ea typeface="Arial"/>
                 <a:cs typeface="Arial"/>
               </a:rPr>
-              <a:t>Allow an approved request</a:t>
-            </a:r>
-          </a:p>
-          <a:p xmlns:a="http://schemas.openxmlformats.org/drawingml/2006/main">
-            <a:pPr>
-              <a:defRPr sz="2325" b="0">
-                <a:solidFill>
-                  <a:srgbClr val="FAFBF6"/>
-                </a:solidFill>
-                <a:latin typeface="Arial"/>
-                <a:ea typeface="Arial"/>
-                <a:cs typeface="Arial"/>
-              </a:defRPr>
-            </a:pPr>
-            <a:r>
-              <a:rPr sz="2325" b="0">
-                <a:solidFill>
-                  <a:srgbClr val="FAFBF6"/>
-                </a:solidFill>
-                <a:latin typeface="Arial"/>
-                <a:ea typeface="Arial"/>
-                <a:cs typeface="Arial"/>
-              </a:rPr>
-              <a:t>Reroute and cap an unapproved model</a:t>
-            </a:r>
-          </a:p>
-          <a:p xmlns:a="http://schemas.openxmlformats.org/drawingml/2006/main">
-            <a:pPr>
-              <a:defRPr sz="2325" b="0">
-                <a:solidFill>
-                  <a:srgbClr val="FAFBF6"/>
-                </a:solidFill>
-                <a:latin typeface="Arial"/>
-                <a:ea typeface="Arial"/>
-                <a:cs typeface="Arial"/>
-              </a:defRPr>
-            </a:pPr>
-            <a:r>
-              <a:rPr sz="2325" b="0">
-                <a:solidFill>
-                  <a:srgbClr val="FAFBF6"/>
-                </a:solidFill>
-                <a:latin typeface="Arial"/>
-                <a:ea typeface="Arial"/>
-                <a:cs typeface="Arial"/>
-              </a:rPr>
-              <a:t>Redact a detected secret before egress</a:t>
-            </a:r>
-          </a:p>
-          <a:p xmlns:a="http://schemas.openxmlformats.org/drawingml/2006/main">
-            <a:pPr>
-              <a:defRPr sz="2325" b="0">
-                <a:solidFill>
-                  <a:srgbClr val="FAFBF6"/>
-                </a:solidFill>
-                <a:latin typeface="Arial"/>
-                <a:ea typeface="Arial"/>
-                <a:cs typeface="Arial"/>
-              </a:defRPr>
-            </a:pPr>
-            <a:r>
-              <a:rPr sz="2325" b="0">
-                <a:solidFill>
-                  <a:srgbClr val="FAFBF6"/>
-                </a:solidFill>
-                <a:latin typeface="Arial"/>
-                <a:ea typeface="Arial"/>
-                <a:cs typeface="Arial"/>
-              </a:rPr>
-              <a:t>Deny without an upstream call</a:t>
-            </a:r>
-          </a:p>
-        </p:txBody>
-      </p:sp>
-      <p:sp>
-        <p:nvSpPr>
-          <p:cNvPr id="11" name="proof-boundary">
-            <a:extLst xmlns:a="http://schemas.openxmlformats.org/drawingml/2006/main">
-              <a:ext uri="{FF2B5EF4-FFF2-40B4-BE49-F238E27FC236}">
-                <a16:creationId xmlns:a16="http://schemas.microsoft.com/office/drawing/2014/main" id="{9541A6D1-BABF-438F-BC31-99C40056084F}"/>
-              </a:ext>
-            </a:extLst>
-          </p:cNvPr>
-          <p:cNvSpPr>
-            <a:spLocks xmlns:a="http://schemas.openxmlformats.org/drawingml/2006/main" noGrp="1"/>
-          </p:cNvSpPr>
-          <p:nvPr/>
-        </p:nvSpPr>
-        <p:spPr>
-          <a:xfrm xmlns:a="http://schemas.openxmlformats.org/drawingml/2006/main">
-            <a:off x="609600" y="5267325"/>
-            <a:ext cx="10972800" cy="819150"/>
+              <a:t>external provider calls</a:t>
+            </a:r>
+          </a:p>
+        </p:txBody>
+      </p:sp>
+      <p:sp>
+        <p:nvSpPr>
+          <p:cNvPr id="11" name="checks">
+            <a:extLst xmlns:a="http://schemas.openxmlformats.org/drawingml/2006/main">
+              <a:ext uri="{FF2B5EF4-FFF2-40B4-BE49-F238E27FC236}">
+                <a16:creationId xmlns:a16="http://schemas.microsoft.com/office/drawing/2014/main" id="{5004E058-0859-48BA-869B-93098F96915C}"/>
+              </a:ext>
+            </a:extLst>
+          </p:cNvPr>
+          <p:cNvSpPr>
+            <a:spLocks xmlns:a="http://schemas.openxmlformats.org/drawingml/2006/main" noGrp="1"/>
+          </p:cNvSpPr>
+          <p:nvPr/>
+        </p:nvSpPr>
+        <p:spPr>
+          <a:xfrm xmlns:a="http://schemas.openxmlformats.org/drawingml/2006/main">
+            <a:off x="4686300" y="2533650"/>
+            <a:ext cx="6705600" cy="2400300"/>
           </a:xfrm>
           <a:prstGeom xmlns:a="http://schemas.openxmlformats.org/drawingml/2006/main" prst="rect">
             <a:avLst/>
@@ -3811,6 +3858,133 @@
           <a:lstStyle xmlns:a="http://schemas.openxmlformats.org/drawingml/2006/main"/>
           <a:p xmlns:a="http://schemas.openxmlformats.org/drawingml/2006/main">
             <a:pPr>
+              <a:defRPr sz="2325" b="0">
+                <a:solidFill>
+                  <a:srgbClr val="FAFBF6"/>
+                </a:solidFill>
+                <a:latin typeface="Arial"/>
+                <a:ea typeface="Arial"/>
+                <a:cs typeface="Arial"/>
+              </a:defRPr>
+            </a:pPr>
+            <a:r>
+              <a:rPr sz="2325" b="0">
+                <a:solidFill>
+                  <a:srgbClr val="FAFBF6"/>
+                </a:solidFill>
+                <a:latin typeface="Arial"/>
+                <a:ea typeface="Arial"/>
+                <a:cs typeface="Arial"/>
+              </a:rPr>
+              <a:t>Allow an approved request</a:t>
+            </a:r>
+          </a:p>
+          <a:p xmlns:a="http://schemas.openxmlformats.org/drawingml/2006/main">
+            <a:pPr>
+              <a:defRPr sz="2325" b="0">
+                <a:solidFill>
+                  <a:srgbClr val="FAFBF6"/>
+                </a:solidFill>
+                <a:latin typeface="Arial"/>
+                <a:ea typeface="Arial"/>
+                <a:cs typeface="Arial"/>
+              </a:defRPr>
+            </a:pPr>
+            <a:r>
+              <a:rPr sz="2325" b="0">
+                <a:solidFill>
+                  <a:srgbClr val="FAFBF6"/>
+                </a:solidFill>
+                <a:latin typeface="Arial"/>
+                <a:ea typeface="Arial"/>
+                <a:cs typeface="Arial"/>
+              </a:rPr>
+              <a:t>Reroute and cap an unapproved model</a:t>
+            </a:r>
+          </a:p>
+          <a:p xmlns:a="http://schemas.openxmlformats.org/drawingml/2006/main">
+            <a:pPr>
+              <a:defRPr sz="2325" b="0">
+                <a:solidFill>
+                  <a:srgbClr val="FAFBF6"/>
+                </a:solidFill>
+                <a:latin typeface="Arial"/>
+                <a:ea typeface="Arial"/>
+                <a:cs typeface="Arial"/>
+              </a:defRPr>
+            </a:pPr>
+            <a:r>
+              <a:rPr sz="2325" b="0">
+                <a:solidFill>
+                  <a:srgbClr val="FAFBF6"/>
+                </a:solidFill>
+                <a:latin typeface="Arial"/>
+                <a:ea typeface="Arial"/>
+                <a:cs typeface="Arial"/>
+              </a:rPr>
+              <a:t>Redact a detected secret before egress</a:t>
+            </a:r>
+          </a:p>
+          <a:p xmlns:a="http://schemas.openxmlformats.org/drawingml/2006/main">
+            <a:pPr>
+              <a:defRPr sz="2325" b="0">
+                <a:solidFill>
+                  <a:srgbClr val="FAFBF6"/>
+                </a:solidFill>
+                <a:latin typeface="Arial"/>
+                <a:ea typeface="Arial"/>
+                <a:cs typeface="Arial"/>
+              </a:defRPr>
+            </a:pPr>
+            <a:r>
+              <a:rPr sz="2325" b="0">
+                <a:solidFill>
+                  <a:srgbClr val="FAFBF6"/>
+                </a:solidFill>
+                <a:latin typeface="Arial"/>
+                <a:ea typeface="Arial"/>
+                <a:cs typeface="Arial"/>
+              </a:rPr>
+              <a:t>Deny without an upstream call</a:t>
+            </a:r>
+          </a:p>
+        </p:txBody>
+      </p:sp>
+      <p:sp>
+        <p:nvSpPr>
+          <p:cNvPr id="12" name="proof-boundary">
+            <a:extLst xmlns:a="http://schemas.openxmlformats.org/drawingml/2006/main">
+              <a:ext uri="{FF2B5EF4-FFF2-40B4-BE49-F238E27FC236}">
+                <a16:creationId xmlns:a16="http://schemas.microsoft.com/office/drawing/2014/main" id="{0FAACA9B-D1CD-44F6-92A8-4BCEFDDB46B4}"/>
+              </a:ext>
+            </a:extLst>
+          </p:cNvPr>
+          <p:cNvSpPr>
+            <a:spLocks xmlns:a="http://schemas.openxmlformats.org/drawingml/2006/main" noGrp="1"/>
+          </p:cNvSpPr>
+          <p:nvPr/>
+        </p:nvSpPr>
+        <p:spPr>
+          <a:xfrm xmlns:a="http://schemas.openxmlformats.org/drawingml/2006/main">
+            <a:off x="609600" y="5267325"/>
+            <a:ext cx="10972800" cy="819150"/>
+          </a:xfrm>
+          <a:prstGeom xmlns:a="http://schemas.openxmlformats.org/drawingml/2006/main" prst="rect">
+            <a:avLst/>
+          </a:prstGeom>
+          <a:noFill xmlns:a="http://schemas.openxmlformats.org/drawingml/2006/main"/>
+          <a:ln xmlns:a="http://schemas.openxmlformats.org/drawingml/2006/main" w="0">
+            <a:noFill/>
+            <a:prstDash val="solid"/>
+          </a:ln>
+        </p:spPr>
+        <p:txBody>
+          <a:bodyPr xmlns:a="http://schemas.openxmlformats.org/drawingml/2006/main" wrap="square" lIns="0" tIns="0" rIns="0" bIns="0">
+            <a:noAutofit/>
+          </a:bodyPr>
+          <a:lstStyle xmlns:a="http://schemas.openxmlformats.org/drawingml/2006/main"/>
+          <a:p xmlns:a="http://schemas.openxmlformats.org/drawingml/2006/main">
+            <a:pPr>
               <a:defRPr sz="1875" b="0">
                 <a:solidFill>
                   <a:srgbClr val="D9E1DF"/>
@@ -3837,7 +4011,7 @@
     </p:spTree>
     <p:extLst>
       <p:ext uri="{BB962C8B-B14F-4D97-AF65-F5344CB8AC3E}">
-        <p14:creationId xmlns:p14="http://schemas.microsoft.com/office/powerpoint/2010/main" val="34675123"/>
+        <p14:creationId xmlns:p14="http://schemas.microsoft.com/office/powerpoint/2010/main" val="1057595032"/>
       </p:ext>
     </p:extLst>
   </p:cSld>
@@ -3865,10 +4039,10 @@
       </p:grpSpPr>
       <p:sp>
         <p:nvSpPr>
-          <p:cNvPr id="13" name="Hormuz mark boundary">
-            <a:extLst xmlns:a="http://schemas.openxmlformats.org/drawingml/2006/main">
-              <a:ext uri="{FF2B5EF4-FFF2-40B4-BE49-F238E27FC236}">
-                <a16:creationId xmlns:a16="http://schemas.microsoft.com/office/drawing/2014/main" id="{6701FAD1-A20B-4BF0-A5AB-A572601D070F}"/>
+          <p:cNvPr id="14" name="Hormuz mark boundary">
+            <a:extLst xmlns:a="http://schemas.openxmlformats.org/drawingml/2006/main">
+              <a:ext uri="{FF2B5EF4-FFF2-40B4-BE49-F238E27FC236}">
+                <a16:creationId xmlns:a16="http://schemas.microsoft.com/office/drawing/2014/main" id="{D002D86A-4D7D-4013-9413-4BC45C5C9EC4}"/>
               </a:ext>
             </a:extLst>
           </p:cNvPr>
@@ -3899,7 +4073,7 @@
           <p:cNvPr id="2" name="Hormuz mark bar 1">
             <a:extLst xmlns:a="http://schemas.openxmlformats.org/drawingml/2006/main">
               <a:ext uri="{FF2B5EF4-FFF2-40B4-BE49-F238E27FC236}">
-                <a16:creationId xmlns:a16="http://schemas.microsoft.com/office/drawing/2014/main" id="{6A375E20-C81B-4535-B978-C92C8442A289}"/>
+                <a16:creationId xmlns:a16="http://schemas.microsoft.com/office/drawing/2014/main" id="{8DF9FF7F-CF66-467A-AF40-DAEA03F3290D}"/>
               </a:ext>
             </a:extLst>
           </p:cNvPr>
@@ -3931,7 +4105,7 @@
           <p:cNvPr id="3" name="Hormuz mark bar 2">
             <a:extLst xmlns:a="http://schemas.openxmlformats.org/drawingml/2006/main">
               <a:ext uri="{FF2B5EF4-FFF2-40B4-BE49-F238E27FC236}">
-                <a16:creationId xmlns:a16="http://schemas.microsoft.com/office/drawing/2014/main" id="{7ADAC536-60D1-4841-8F8D-C1C6F2EF68BA}"/>
+                <a16:creationId xmlns:a16="http://schemas.microsoft.com/office/drawing/2014/main" id="{DABAFD9D-1C7B-4ADB-9B31-C6F6F9EBB8F7}"/>
               </a:ext>
             </a:extLst>
           </p:cNvPr>
@@ -3963,7 +4137,7 @@
           <p:cNvPr id="4" name="Hormuz mark bar 3">
             <a:extLst xmlns:a="http://schemas.openxmlformats.org/drawingml/2006/main">
               <a:ext uri="{FF2B5EF4-FFF2-40B4-BE49-F238E27FC236}">
-                <a16:creationId xmlns:a16="http://schemas.microsoft.com/office/drawing/2014/main" id="{D62CE747-4E12-4276-A6A5-1A94F9E98888}"/>
+                <a16:creationId xmlns:a16="http://schemas.microsoft.com/office/drawing/2014/main" id="{96F04905-E795-4140-9483-AE835B8998DD}"/>
               </a:ext>
             </a:extLst>
           </p:cNvPr>
@@ -3995,7 +4169,7 @@
           <p:cNvPr id="5" name="section">
             <a:extLst xmlns:a="http://schemas.openxmlformats.org/drawingml/2006/main">
               <a:ext uri="{FF2B5EF4-FFF2-40B4-BE49-F238E27FC236}">
-                <a16:creationId xmlns:a16="http://schemas.microsoft.com/office/drawing/2014/main" id="{EA9BDE98-6D74-44B4-89ED-CD2CD2D5F5B5}"/>
+                <a16:creationId xmlns:a16="http://schemas.microsoft.com/office/drawing/2014/main" id="{A6DEB700-49C4-49A4-AF2F-C220173C0989}"/>
               </a:ext>
             </a:extLst>
           </p:cNvPr>
@@ -4053,7 +4227,7 @@
           <p:cNvPr id="6" name="takeaway">
             <a:extLst xmlns:a="http://schemas.openxmlformats.org/drawingml/2006/main">
               <a:ext uri="{FF2B5EF4-FFF2-40B4-BE49-F238E27FC236}">
-                <a16:creationId xmlns:a16="http://schemas.microsoft.com/office/drawing/2014/main" id="{BB5F7EF9-BC42-4880-9FF5-9E018BB63BBB}"/>
+                <a16:creationId xmlns:a16="http://schemas.microsoft.com/office/drawing/2014/main" id="{C4DBF591-92E5-4CD4-8FA8-1BFE844AAC54}"/>
               </a:ext>
             </a:extLst>
           </p:cNvPr>
@@ -4111,7 +4285,7 @@
           <p:cNvPr id="7" name="footer">
             <a:extLst xmlns:a="http://schemas.openxmlformats.org/drawingml/2006/main">
               <a:ext uri="{FF2B5EF4-FFF2-40B4-BE49-F238E27FC236}">
-                <a16:creationId xmlns:a16="http://schemas.microsoft.com/office/drawing/2014/main" id="{CD344479-D377-41FA-8CF9-6B58B590BB3B}"/>
+                <a16:creationId xmlns:a16="http://schemas.microsoft.com/office/drawing/2014/main" id="{FB81E9A3-EB12-41CA-99DE-7AA52300399F}"/>
               </a:ext>
             </a:extLst>
           </p:cNvPr>
@@ -4123,7 +4297,7 @@
         <p:spPr>
           <a:xfrm xmlns:a="http://schemas.openxmlformats.org/drawingml/2006/main">
             <a:off x="609600" y="6400800"/>
-            <a:ext cx="10972800" cy="228600"/>
+            <a:ext cx="9525000" cy="228600"/>
           </a:xfrm>
           <a:prstGeom xmlns:a="http://schemas.openxmlformats.org/drawingml/2006/main" prst="rect">
             <a:avLst/>
@@ -4159,29 +4333,29 @@
                 <a:ea typeface="Arial"/>
                 <a:cs typeface="Arial"/>
               </a:rPr>
-              <a:t>HORMUZ  /  Mehrdad Zaker  /  September 2026                                      04 / 07</a:t>
-            </a:r>
-          </a:p>
-        </p:txBody>
-      </p:sp>
-      <p:sp>
-        <p:nvSpPr>
-          <p:cNvPr id="8" name="oss-title">
-            <a:extLst xmlns:a="http://schemas.openxmlformats.org/drawingml/2006/main">
-              <a:ext uri="{FF2B5EF4-FFF2-40B4-BE49-F238E27FC236}">
-                <a16:creationId xmlns:a16="http://schemas.microsoft.com/office/drawing/2014/main" id="{BAAC86F3-08AC-49A3-BFD4-B2E0B48210EB}"/>
-              </a:ext>
-            </a:extLst>
-          </p:cNvPr>
-          <p:cNvSpPr>
-            <a:spLocks xmlns:a="http://schemas.openxmlformats.org/drawingml/2006/main" noGrp="1"/>
-          </p:cNvSpPr>
-          <p:nvPr/>
-        </p:nvSpPr>
-        <p:spPr>
-          <a:xfrm xmlns:a="http://schemas.openxmlformats.org/drawingml/2006/main">
-            <a:off x="609600" y="2552700"/>
-            <a:ext cx="4895850" cy="476250"/>
+              <a:t>HORMUZ  /  A product of Neuralint  /  Mehrdad Zaker  /  September 2026</a:t>
+            </a:r>
+          </a:p>
+        </p:txBody>
+      </p:sp>
+      <p:sp>
+        <p:nvSpPr>
+          <p:cNvPr id="8" name="page-number">
+            <a:extLst xmlns:a="http://schemas.openxmlformats.org/drawingml/2006/main">
+              <a:ext uri="{FF2B5EF4-FFF2-40B4-BE49-F238E27FC236}">
+                <a16:creationId xmlns:a16="http://schemas.microsoft.com/office/drawing/2014/main" id="{91057037-058E-47AD-A9D0-0BCD9D03E15B}"/>
+              </a:ext>
+            </a:extLst>
+          </p:cNvPr>
+          <p:cNvSpPr>
+            <a:spLocks xmlns:a="http://schemas.openxmlformats.org/drawingml/2006/main" noGrp="1"/>
+          </p:cNvSpPr>
+          <p:nvPr/>
+        </p:nvSpPr>
+        <p:spPr>
+          <a:xfrm xmlns:a="http://schemas.openxmlformats.org/drawingml/2006/main">
+            <a:off x="10972800" y="6400800"/>
+            <a:ext cx="609600" cy="228600"/>
           </a:xfrm>
           <a:prstGeom xmlns:a="http://schemas.openxmlformats.org/drawingml/2006/main" prst="rect">
             <a:avLst/>
@@ -4199,47 +4373,47 @@
           <a:lstStyle xmlns:a="http://schemas.openxmlformats.org/drawingml/2006/main"/>
           <a:p xmlns:a="http://schemas.openxmlformats.org/drawingml/2006/main">
             <a:pPr>
-              <a:defRPr sz="2550" b="1">
-                <a:solidFill>
-                  <a:srgbClr val="31684B"/>
-                </a:solidFill>
-                <a:latin typeface="Arial"/>
-                <a:ea typeface="Arial"/>
-                <a:cs typeface="Arial"/>
-              </a:defRPr>
-            </a:pPr>
-            <a:r>
-              <a:rPr sz="2550" b="1">
-                <a:solidFill>
-                  <a:srgbClr val="31684B"/>
-                </a:solidFill>
-                <a:latin typeface="Arial"/>
-                <a:ea typeface="Arial"/>
-                <a:cs typeface="Arial"/>
-              </a:rPr>
-              <a:t>Apache-2.0 product</a:t>
-            </a:r>
-          </a:p>
-        </p:txBody>
-      </p:sp>
-      <p:sp>
-        <p:nvSpPr>
-          <p:cNvPr id="9" name="oss-body">
-            <a:extLst xmlns:a="http://schemas.openxmlformats.org/drawingml/2006/main">
-              <a:ext uri="{FF2B5EF4-FFF2-40B4-BE49-F238E27FC236}">
-                <a16:creationId xmlns:a16="http://schemas.microsoft.com/office/drawing/2014/main" id="{5C4A57DE-1876-4784-8584-F2D456B2EE67}"/>
-              </a:ext>
-            </a:extLst>
-          </p:cNvPr>
-          <p:cNvSpPr>
-            <a:spLocks xmlns:a="http://schemas.openxmlformats.org/drawingml/2006/main" noGrp="1"/>
-          </p:cNvSpPr>
-          <p:nvPr/>
-        </p:nvSpPr>
-        <p:spPr>
-          <a:xfrm xmlns:a="http://schemas.openxmlformats.org/drawingml/2006/main">
-            <a:off x="609600" y="3209925"/>
-            <a:ext cx="4914900" cy="2133600"/>
+              <a:defRPr sz="1275" b="0">
+                <a:solidFill>
+                  <a:srgbClr val="5C6758"/>
+                </a:solidFill>
+                <a:latin typeface="Arial"/>
+                <a:ea typeface="Arial"/>
+                <a:cs typeface="Arial"/>
+              </a:defRPr>
+            </a:pPr>
+            <a:r>
+              <a:rPr sz="1275" b="0">
+                <a:solidFill>
+                  <a:srgbClr val="5C6758"/>
+                </a:solidFill>
+                <a:latin typeface="Arial"/>
+                <a:ea typeface="Arial"/>
+                <a:cs typeface="Arial"/>
+              </a:rPr>
+              <a:t>04 / 07</a:t>
+            </a:r>
+          </a:p>
+        </p:txBody>
+      </p:sp>
+      <p:sp>
+        <p:nvSpPr>
+          <p:cNvPr id="9" name="oss-title">
+            <a:extLst xmlns:a="http://schemas.openxmlformats.org/drawingml/2006/main">
+              <a:ext uri="{FF2B5EF4-FFF2-40B4-BE49-F238E27FC236}">
+                <a16:creationId xmlns:a16="http://schemas.microsoft.com/office/drawing/2014/main" id="{2BE7EA69-4982-44A9-AF60-0B214D4824C5}"/>
+              </a:ext>
+            </a:extLst>
+          </p:cNvPr>
+          <p:cNvSpPr>
+            <a:spLocks xmlns:a="http://schemas.openxmlformats.org/drawingml/2006/main" noGrp="1"/>
+          </p:cNvSpPr>
+          <p:nvPr/>
+        </p:nvSpPr>
+        <p:spPr>
+          <a:xfrm xmlns:a="http://schemas.openxmlformats.org/drawingml/2006/main">
+            <a:off x="609600" y="2552700"/>
+            <a:ext cx="4895850" cy="476250"/>
           </a:xfrm>
           <a:prstGeom xmlns:a="http://schemas.openxmlformats.org/drawingml/2006/main" prst="rect">
             <a:avLst/>
@@ -4257,139 +4431,47 @@
           <a:lstStyle xmlns:a="http://schemas.openxmlformats.org/drawingml/2006/main"/>
           <a:p xmlns:a="http://schemas.openxmlformats.org/drawingml/2006/main">
             <a:pPr>
-              <a:defRPr sz="2100" b="0">
-                <a:solidFill>
-                  <a:srgbClr val="202723"/>
-                </a:solidFill>
-                <a:latin typeface="Arial"/>
-                <a:ea typeface="Arial"/>
-                <a:cs typeface="Arial"/>
-              </a:defRPr>
-            </a:pPr>
-            <a:r>
-              <a:rPr sz="2100" b="0">
-                <a:solidFill>
-                  <a:srgbClr val="202723"/>
-                </a:solidFill>
-                <a:latin typeface="Arial"/>
-                <a:ea typeface="Arial"/>
-                <a:cs typeface="Arial"/>
-              </a:rPr>
-              <a:t>Gateway and client paths</a:t>
-            </a:r>
-          </a:p>
-          <a:p xmlns:a="http://schemas.openxmlformats.org/drawingml/2006/main">
-            <a:pPr>
-              <a:defRPr sz="2100" b="0">
-                <a:solidFill>
-                  <a:srgbClr val="202723"/>
-                </a:solidFill>
-                <a:latin typeface="Arial"/>
-                <a:ea typeface="Arial"/>
-                <a:cs typeface="Arial"/>
-              </a:defRPr>
-            </a:pPr>
-            <a:r>
-              <a:rPr sz="2100" b="0">
-                <a:solidFill>
-                  <a:srgbClr val="202723"/>
-                </a:solidFill>
-                <a:latin typeface="Arial"/>
-                <a:ea typeface="Arial"/>
-                <a:cs typeface="Arial"/>
-              </a:rPr>
-              <a:t>OIDC JWT verification</a:t>
-            </a:r>
-          </a:p>
-          <a:p xmlns:a="http://schemas.openxmlformats.org/drawingml/2006/main">
-            <a:pPr>
-              <a:defRPr sz="2100" b="0">
-                <a:solidFill>
-                  <a:srgbClr val="202723"/>
-                </a:solidFill>
-                <a:latin typeface="Arial"/>
-                <a:ea typeface="Arial"/>
-                <a:cs typeface="Arial"/>
-              </a:defRPr>
-            </a:pPr>
-            <a:r>
-              <a:rPr sz="2100" b="0">
-                <a:solidFill>
-                  <a:srgbClr val="202723"/>
-                </a:solidFill>
-                <a:latin typeface="Arial"/>
-                <a:ea typeface="Arial"/>
-                <a:cs typeface="Arial"/>
-              </a:rPr>
-              <a:t>Policy overlays and budgets</a:t>
-            </a:r>
-          </a:p>
-          <a:p xmlns:a="http://schemas.openxmlformats.org/drawingml/2006/main">
-            <a:pPr>
-              <a:defRPr sz="2100" b="0">
-                <a:solidFill>
-                  <a:srgbClr val="202723"/>
-                </a:solidFill>
-                <a:latin typeface="Arial"/>
-                <a:ea typeface="Arial"/>
-                <a:cs typeface="Arial"/>
-              </a:defRPr>
-            </a:pPr>
-            <a:r>
-              <a:rPr sz="2100" b="0">
-                <a:solidFill>
-                  <a:srgbClr val="202723"/>
-                </a:solidFill>
-                <a:latin typeface="Arial"/>
-                <a:ea typeface="Arial"/>
-                <a:cs typeface="Arial"/>
-              </a:rPr>
-              <a:t>Deterministic secret controls</a:t>
-            </a:r>
-          </a:p>
-          <a:p xmlns:a="http://schemas.openxmlformats.org/drawingml/2006/main">
-            <a:pPr>
-              <a:defRPr sz="2100" b="0">
-                <a:solidFill>
-                  <a:srgbClr val="202723"/>
-                </a:solidFill>
-                <a:latin typeface="Arial"/>
-                <a:ea typeface="Arial"/>
-                <a:cs typeface="Arial"/>
-              </a:defRPr>
-            </a:pPr>
-            <a:r>
-              <a:rPr sz="2100" b="0">
-                <a:solidFill>
-                  <a:srgbClr val="202723"/>
-                </a:solidFill>
-                <a:latin typeface="Arial"/>
-                <a:ea typeface="Arial"/>
-                <a:cs typeface="Arial"/>
-              </a:rPr>
-              <a:t>Usage reports and evidence</a:t>
-            </a:r>
-          </a:p>
-        </p:txBody>
-      </p:sp>
-      <p:sp>
-        <p:nvSpPr>
-          <p:cNvPr id="10" name="paid-title">
-            <a:extLst xmlns:a="http://schemas.openxmlformats.org/drawingml/2006/main">
-              <a:ext uri="{FF2B5EF4-FFF2-40B4-BE49-F238E27FC236}">
-                <a16:creationId xmlns:a16="http://schemas.microsoft.com/office/drawing/2014/main" id="{B8BE6F32-7225-46E7-9526-D25625F1248C}"/>
-              </a:ext>
-            </a:extLst>
-          </p:cNvPr>
-          <p:cNvSpPr>
-            <a:spLocks xmlns:a="http://schemas.openxmlformats.org/drawingml/2006/main" noGrp="1"/>
-          </p:cNvSpPr>
-          <p:nvPr/>
-        </p:nvSpPr>
-        <p:spPr>
-          <a:xfrm xmlns:a="http://schemas.openxmlformats.org/drawingml/2006/main">
-            <a:off x="6515100" y="2552700"/>
-            <a:ext cx="5067300" cy="476250"/>
+              <a:defRPr sz="2550" b="1">
+                <a:solidFill>
+                  <a:srgbClr val="31684B"/>
+                </a:solidFill>
+                <a:latin typeface="Arial"/>
+                <a:ea typeface="Arial"/>
+                <a:cs typeface="Arial"/>
+              </a:defRPr>
+            </a:pPr>
+            <a:r>
+              <a:rPr sz="2550" b="1">
+                <a:solidFill>
+                  <a:srgbClr val="31684B"/>
+                </a:solidFill>
+                <a:latin typeface="Arial"/>
+                <a:ea typeface="Arial"/>
+                <a:cs typeface="Arial"/>
+              </a:rPr>
+              <a:t>Apache-2.0 product</a:t>
+            </a:r>
+          </a:p>
+        </p:txBody>
+      </p:sp>
+      <p:sp>
+        <p:nvSpPr>
+          <p:cNvPr id="10" name="oss-body">
+            <a:extLst xmlns:a="http://schemas.openxmlformats.org/drawingml/2006/main">
+              <a:ext uri="{FF2B5EF4-FFF2-40B4-BE49-F238E27FC236}">
+                <a16:creationId xmlns:a16="http://schemas.microsoft.com/office/drawing/2014/main" id="{48B82B0E-A82C-4C5B-8A5E-3452E70C3C9A}"/>
+              </a:ext>
+            </a:extLst>
+          </p:cNvPr>
+          <p:cNvSpPr>
+            <a:spLocks xmlns:a="http://schemas.openxmlformats.org/drawingml/2006/main" noGrp="1"/>
+          </p:cNvSpPr>
+          <p:nvPr/>
+        </p:nvSpPr>
+        <p:spPr>
+          <a:xfrm xmlns:a="http://schemas.openxmlformats.org/drawingml/2006/main">
+            <a:off x="609600" y="3209925"/>
+            <a:ext cx="4914900" cy="2133600"/>
           </a:xfrm>
           <a:prstGeom xmlns:a="http://schemas.openxmlformats.org/drawingml/2006/main" prst="rect">
             <a:avLst/>
@@ -4407,47 +4489,139 @@
           <a:lstStyle xmlns:a="http://schemas.openxmlformats.org/drawingml/2006/main"/>
           <a:p xmlns:a="http://schemas.openxmlformats.org/drawingml/2006/main">
             <a:pPr>
-              <a:defRPr sz="2550" b="1">
-                <a:solidFill>
-                  <a:srgbClr val="31684B"/>
-                </a:solidFill>
-                <a:latin typeface="Arial"/>
-                <a:ea typeface="Arial"/>
-                <a:cs typeface="Arial"/>
-              </a:defRPr>
-            </a:pPr>
-            <a:r>
-              <a:rPr sz="2550" b="1">
-                <a:solidFill>
-                  <a:srgbClr val="31684B"/>
-                </a:solidFill>
-                <a:latin typeface="Arial"/>
-                <a:ea typeface="Arial"/>
-                <a:cs typeface="Arial"/>
-              </a:rPr>
-              <a:t>Scoped engagement</a:t>
-            </a:r>
-          </a:p>
-        </p:txBody>
-      </p:sp>
-      <p:sp>
-        <p:nvSpPr>
-          <p:cNvPr id="11" name="paid-body">
-            <a:extLst xmlns:a="http://schemas.openxmlformats.org/drawingml/2006/main">
-              <a:ext uri="{FF2B5EF4-FFF2-40B4-BE49-F238E27FC236}">
-                <a16:creationId xmlns:a16="http://schemas.microsoft.com/office/drawing/2014/main" id="{50B0CBEB-9AD7-4F51-803D-038EC6E20D57}"/>
-              </a:ext>
-            </a:extLst>
-          </p:cNvPr>
-          <p:cNvSpPr>
-            <a:spLocks xmlns:a="http://schemas.openxmlformats.org/drawingml/2006/main" noGrp="1"/>
-          </p:cNvSpPr>
-          <p:nvPr/>
-        </p:nvSpPr>
-        <p:spPr>
-          <a:xfrm xmlns:a="http://schemas.openxmlformats.org/drawingml/2006/main">
-            <a:off x="6515100" y="3209925"/>
-            <a:ext cx="5067300" cy="2133600"/>
+              <a:defRPr sz="2100" b="0">
+                <a:solidFill>
+                  <a:srgbClr val="202723"/>
+                </a:solidFill>
+                <a:latin typeface="Arial"/>
+                <a:ea typeface="Arial"/>
+                <a:cs typeface="Arial"/>
+              </a:defRPr>
+            </a:pPr>
+            <a:r>
+              <a:rPr sz="2100" b="0">
+                <a:solidFill>
+                  <a:srgbClr val="202723"/>
+                </a:solidFill>
+                <a:latin typeface="Arial"/>
+                <a:ea typeface="Arial"/>
+                <a:cs typeface="Arial"/>
+              </a:rPr>
+              <a:t>Gateway and client paths</a:t>
+            </a:r>
+          </a:p>
+          <a:p xmlns:a="http://schemas.openxmlformats.org/drawingml/2006/main">
+            <a:pPr>
+              <a:defRPr sz="2100" b="0">
+                <a:solidFill>
+                  <a:srgbClr val="202723"/>
+                </a:solidFill>
+                <a:latin typeface="Arial"/>
+                <a:ea typeface="Arial"/>
+                <a:cs typeface="Arial"/>
+              </a:defRPr>
+            </a:pPr>
+            <a:r>
+              <a:rPr sz="2100" b="0">
+                <a:solidFill>
+                  <a:srgbClr val="202723"/>
+                </a:solidFill>
+                <a:latin typeface="Arial"/>
+                <a:ea typeface="Arial"/>
+                <a:cs typeface="Arial"/>
+              </a:rPr>
+              <a:t>OIDC JWT verification</a:t>
+            </a:r>
+          </a:p>
+          <a:p xmlns:a="http://schemas.openxmlformats.org/drawingml/2006/main">
+            <a:pPr>
+              <a:defRPr sz="2100" b="0">
+                <a:solidFill>
+                  <a:srgbClr val="202723"/>
+                </a:solidFill>
+                <a:latin typeface="Arial"/>
+                <a:ea typeface="Arial"/>
+                <a:cs typeface="Arial"/>
+              </a:defRPr>
+            </a:pPr>
+            <a:r>
+              <a:rPr sz="2100" b="0">
+                <a:solidFill>
+                  <a:srgbClr val="202723"/>
+                </a:solidFill>
+                <a:latin typeface="Arial"/>
+                <a:ea typeface="Arial"/>
+                <a:cs typeface="Arial"/>
+              </a:rPr>
+              <a:t>Policy overlays and budgets</a:t>
+            </a:r>
+          </a:p>
+          <a:p xmlns:a="http://schemas.openxmlformats.org/drawingml/2006/main">
+            <a:pPr>
+              <a:defRPr sz="2100" b="0">
+                <a:solidFill>
+                  <a:srgbClr val="202723"/>
+                </a:solidFill>
+                <a:latin typeface="Arial"/>
+                <a:ea typeface="Arial"/>
+                <a:cs typeface="Arial"/>
+              </a:defRPr>
+            </a:pPr>
+            <a:r>
+              <a:rPr sz="2100" b="0">
+                <a:solidFill>
+                  <a:srgbClr val="202723"/>
+                </a:solidFill>
+                <a:latin typeface="Arial"/>
+                <a:ea typeface="Arial"/>
+                <a:cs typeface="Arial"/>
+              </a:rPr>
+              <a:t>Deterministic secret controls</a:t>
+            </a:r>
+          </a:p>
+          <a:p xmlns:a="http://schemas.openxmlformats.org/drawingml/2006/main">
+            <a:pPr>
+              <a:defRPr sz="2100" b="0">
+                <a:solidFill>
+                  <a:srgbClr val="202723"/>
+                </a:solidFill>
+                <a:latin typeface="Arial"/>
+                <a:ea typeface="Arial"/>
+                <a:cs typeface="Arial"/>
+              </a:defRPr>
+            </a:pPr>
+            <a:r>
+              <a:rPr sz="2100" b="0">
+                <a:solidFill>
+                  <a:srgbClr val="202723"/>
+                </a:solidFill>
+                <a:latin typeface="Arial"/>
+                <a:ea typeface="Arial"/>
+                <a:cs typeface="Arial"/>
+              </a:rPr>
+              <a:t>Usage reports and evidence</a:t>
+            </a:r>
+          </a:p>
+        </p:txBody>
+      </p:sp>
+      <p:sp>
+        <p:nvSpPr>
+          <p:cNvPr id="11" name="paid-title">
+            <a:extLst xmlns:a="http://schemas.openxmlformats.org/drawingml/2006/main">
+              <a:ext uri="{FF2B5EF4-FFF2-40B4-BE49-F238E27FC236}">
+                <a16:creationId xmlns:a16="http://schemas.microsoft.com/office/drawing/2014/main" id="{25145E82-B9E9-493A-8AE9-5D9CE411CC63}"/>
+              </a:ext>
+            </a:extLst>
+          </p:cNvPr>
+          <p:cNvSpPr>
+            <a:spLocks xmlns:a="http://schemas.openxmlformats.org/drawingml/2006/main" noGrp="1"/>
+          </p:cNvSpPr>
+          <p:nvPr/>
+        </p:nvSpPr>
+        <p:spPr>
+          <a:xfrm xmlns:a="http://schemas.openxmlformats.org/drawingml/2006/main">
+            <a:off x="6515100" y="2552700"/>
+            <a:ext cx="5067300" cy="476250"/>
           </a:xfrm>
           <a:prstGeom xmlns:a="http://schemas.openxmlformats.org/drawingml/2006/main" prst="rect">
             <a:avLst/>
@@ -4465,139 +4639,47 @@
           <a:lstStyle xmlns:a="http://schemas.openxmlformats.org/drawingml/2006/main"/>
           <a:p xmlns:a="http://schemas.openxmlformats.org/drawingml/2006/main">
             <a:pPr>
-              <a:defRPr sz="2100" b="0">
-                <a:solidFill>
-                  <a:srgbClr val="202723"/>
-                </a:solidFill>
-                <a:latin typeface="Arial"/>
-                <a:ea typeface="Arial"/>
-                <a:cs typeface="Arial"/>
-              </a:defRPr>
-            </a:pPr>
-            <a:r>
-              <a:rPr sz="2100" b="0">
-                <a:solidFill>
-                  <a:srgbClr val="202723"/>
-                </a:solidFill>
-                <a:latin typeface="Arial"/>
-                <a:ea typeface="Arial"/>
-                <a:cs typeface="Arial"/>
-              </a:rPr>
-              <a:t>Workflow and control mapping</a:t>
-            </a:r>
-          </a:p>
-          <a:p xmlns:a="http://schemas.openxmlformats.org/drawingml/2006/main">
-            <a:pPr>
-              <a:defRPr sz="2100" b="0">
-                <a:solidFill>
-                  <a:srgbClr val="202723"/>
-                </a:solidFill>
-                <a:latin typeface="Arial"/>
-                <a:ea typeface="Arial"/>
-                <a:cs typeface="Arial"/>
-              </a:defRPr>
-            </a:pPr>
-            <a:r>
-              <a:rPr sz="2100" b="0">
-                <a:solidFill>
-                  <a:srgbClr val="202723"/>
-                </a:solidFill>
-                <a:latin typeface="Arial"/>
-                <a:ea typeface="Arial"/>
-                <a:cs typeface="Arial"/>
-              </a:rPr>
-              <a:t>Configuration and integration help</a:t>
-            </a:r>
-          </a:p>
-          <a:p xmlns:a="http://schemas.openxmlformats.org/drawingml/2006/main">
-            <a:pPr>
-              <a:defRPr sz="2100" b="0">
-                <a:solidFill>
-                  <a:srgbClr val="202723"/>
-                </a:solidFill>
-                <a:latin typeface="Arial"/>
-                <a:ea typeface="Arial"/>
-                <a:cs typeface="Arial"/>
-              </a:defRPr>
-            </a:pPr>
-            <a:r>
-              <a:rPr sz="2100" b="0">
-                <a:solidFill>
-                  <a:srgbClr val="202723"/>
-                </a:solidFill>
-                <a:latin typeface="Arial"/>
-                <a:ea typeface="Arial"/>
-                <a:cs typeface="Arial"/>
-              </a:rPr>
-              <a:t>Agreed non-production checks</a:t>
-            </a:r>
-          </a:p>
-          <a:p xmlns:a="http://schemas.openxmlformats.org/drawingml/2006/main">
-            <a:pPr>
-              <a:defRPr sz="2100" b="0">
-                <a:solidFill>
-                  <a:srgbClr val="202723"/>
-                </a:solidFill>
-                <a:latin typeface="Arial"/>
-                <a:ea typeface="Arial"/>
-                <a:cs typeface="Arial"/>
-              </a:defRPr>
-            </a:pPr>
-            <a:r>
-              <a:rPr sz="2100" b="0">
-                <a:solidFill>
-                  <a:srgbClr val="202723"/>
-                </a:solidFill>
-                <a:latin typeface="Arial"/>
-                <a:ea typeface="Arial"/>
-                <a:cs typeface="Arial"/>
-              </a:rPr>
-              <a:t>Evidence pack and gap review</a:t>
-            </a:r>
-          </a:p>
-          <a:p xmlns:a="http://schemas.openxmlformats.org/drawingml/2006/main">
-            <a:pPr>
-              <a:defRPr sz="2100" b="0">
-                <a:solidFill>
-                  <a:srgbClr val="202723"/>
-                </a:solidFill>
-                <a:latin typeface="Arial"/>
-                <a:ea typeface="Arial"/>
-                <a:cs typeface="Arial"/>
-              </a:defRPr>
-            </a:pPr>
-            <a:r>
-              <a:rPr sz="2100" b="0">
-                <a:solidFill>
-                  <a:srgbClr val="202723"/>
-                </a:solidFill>
-                <a:latin typeface="Arial"/>
-                <a:ea typeface="Arial"/>
-                <a:cs typeface="Arial"/>
-              </a:rPr>
-              <a:t>Operator handoff</a:t>
-            </a:r>
-          </a:p>
-        </p:txBody>
-      </p:sp>
-      <p:sp>
-        <p:nvSpPr>
-          <p:cNvPr id="12" name="same-core">
-            <a:extLst xmlns:a="http://schemas.openxmlformats.org/drawingml/2006/main">
-              <a:ext uri="{FF2B5EF4-FFF2-40B4-BE49-F238E27FC236}">
-                <a16:creationId xmlns:a16="http://schemas.microsoft.com/office/drawing/2014/main" id="{472EB694-B21D-40DB-818E-B7AE3EDDE991}"/>
-              </a:ext>
-            </a:extLst>
-          </p:cNvPr>
-          <p:cNvSpPr>
-            <a:spLocks xmlns:a="http://schemas.openxmlformats.org/drawingml/2006/main" noGrp="1"/>
-          </p:cNvSpPr>
-          <p:nvPr/>
-        </p:nvSpPr>
-        <p:spPr>
-          <a:xfrm xmlns:a="http://schemas.openxmlformats.org/drawingml/2006/main">
-            <a:off x="609600" y="5600700"/>
-            <a:ext cx="10972800" cy="647700"/>
+              <a:defRPr sz="2550" b="1">
+                <a:solidFill>
+                  <a:srgbClr val="31684B"/>
+                </a:solidFill>
+                <a:latin typeface="Arial"/>
+                <a:ea typeface="Arial"/>
+                <a:cs typeface="Arial"/>
+              </a:defRPr>
+            </a:pPr>
+            <a:r>
+              <a:rPr sz="2550" b="1">
+                <a:solidFill>
+                  <a:srgbClr val="31684B"/>
+                </a:solidFill>
+                <a:latin typeface="Arial"/>
+                <a:ea typeface="Arial"/>
+                <a:cs typeface="Arial"/>
+              </a:rPr>
+              <a:t>90-day pilot · $15,000</a:t>
+            </a:r>
+          </a:p>
+        </p:txBody>
+      </p:sp>
+      <p:sp>
+        <p:nvSpPr>
+          <p:cNvPr id="12" name="paid-body">
+            <a:extLst xmlns:a="http://schemas.openxmlformats.org/drawingml/2006/main">
+              <a:ext uri="{FF2B5EF4-FFF2-40B4-BE49-F238E27FC236}">
+                <a16:creationId xmlns:a16="http://schemas.microsoft.com/office/drawing/2014/main" id="{E64D9F00-E499-4918-B60C-C0B6C81C8388}"/>
+              </a:ext>
+            </a:extLst>
+          </p:cNvPr>
+          <p:cNvSpPr>
+            <a:spLocks xmlns:a="http://schemas.openxmlformats.org/drawingml/2006/main" noGrp="1"/>
+          </p:cNvSpPr>
+          <p:nvPr/>
+        </p:nvSpPr>
+        <p:spPr>
+          <a:xfrm xmlns:a="http://schemas.openxmlformats.org/drawingml/2006/main">
+            <a:off x="6515100" y="3209925"/>
+            <a:ext cx="5067300" cy="2133600"/>
           </a:xfrm>
           <a:prstGeom xmlns:a="http://schemas.openxmlformats.org/drawingml/2006/main" prst="rect">
             <a:avLst/>
@@ -4615,6 +4697,156 @@
           <a:lstStyle xmlns:a="http://schemas.openxmlformats.org/drawingml/2006/main"/>
           <a:p xmlns:a="http://schemas.openxmlformats.org/drawingml/2006/main">
             <a:pPr>
+              <a:defRPr sz="2100" b="0">
+                <a:solidFill>
+                  <a:srgbClr val="202723"/>
+                </a:solidFill>
+                <a:latin typeface="Arial"/>
+                <a:ea typeface="Arial"/>
+                <a:cs typeface="Arial"/>
+              </a:defRPr>
+            </a:pPr>
+            <a:r>
+              <a:rPr sz="2100" b="0">
+                <a:solidFill>
+                  <a:srgbClr val="202723"/>
+                </a:solidFill>
+                <a:latin typeface="Arial"/>
+                <a:ea typeface="Arial"/>
+                <a:cs typeface="Arial"/>
+              </a:rPr>
+              <a:t>Workflow and control mapping</a:t>
+            </a:r>
+          </a:p>
+          <a:p xmlns:a="http://schemas.openxmlformats.org/drawingml/2006/main">
+            <a:pPr>
+              <a:defRPr sz="2100" b="0">
+                <a:solidFill>
+                  <a:srgbClr val="202723"/>
+                </a:solidFill>
+                <a:latin typeface="Arial"/>
+                <a:ea typeface="Arial"/>
+                <a:cs typeface="Arial"/>
+              </a:defRPr>
+            </a:pPr>
+            <a:r>
+              <a:rPr sz="2100" b="0">
+                <a:solidFill>
+                  <a:srgbClr val="202723"/>
+                </a:solidFill>
+                <a:latin typeface="Arial"/>
+                <a:ea typeface="Arial"/>
+                <a:cs typeface="Arial"/>
+              </a:rPr>
+              <a:t>Configuration and integration help</a:t>
+            </a:r>
+          </a:p>
+          <a:p xmlns:a="http://schemas.openxmlformats.org/drawingml/2006/main">
+            <a:pPr>
+              <a:defRPr sz="2100" b="0">
+                <a:solidFill>
+                  <a:srgbClr val="202723"/>
+                </a:solidFill>
+                <a:latin typeface="Arial"/>
+                <a:ea typeface="Arial"/>
+                <a:cs typeface="Arial"/>
+              </a:defRPr>
+            </a:pPr>
+            <a:r>
+              <a:rPr sz="2100" b="0">
+                <a:solidFill>
+                  <a:srgbClr val="202723"/>
+                </a:solidFill>
+                <a:latin typeface="Arial"/>
+                <a:ea typeface="Arial"/>
+                <a:cs typeface="Arial"/>
+              </a:rPr>
+              <a:t>Agreed non-production checks</a:t>
+            </a:r>
+          </a:p>
+          <a:p xmlns:a="http://schemas.openxmlformats.org/drawingml/2006/main">
+            <a:pPr>
+              <a:defRPr sz="2100" b="0">
+                <a:solidFill>
+                  <a:srgbClr val="202723"/>
+                </a:solidFill>
+                <a:latin typeface="Arial"/>
+                <a:ea typeface="Arial"/>
+                <a:cs typeface="Arial"/>
+              </a:defRPr>
+            </a:pPr>
+            <a:r>
+              <a:rPr sz="2100" b="0">
+                <a:solidFill>
+                  <a:srgbClr val="202723"/>
+                </a:solidFill>
+                <a:latin typeface="Arial"/>
+                <a:ea typeface="Arial"/>
+                <a:cs typeface="Arial"/>
+              </a:rPr>
+              <a:t>Evidence pack and gap review</a:t>
+            </a:r>
+          </a:p>
+          <a:p xmlns:a="http://schemas.openxmlformats.org/drawingml/2006/main">
+            <a:pPr>
+              <a:defRPr sz="2100" b="0">
+                <a:solidFill>
+                  <a:srgbClr val="202723"/>
+                </a:solidFill>
+                <a:latin typeface="Arial"/>
+                <a:ea typeface="Arial"/>
+                <a:cs typeface="Arial"/>
+              </a:defRPr>
+            </a:pPr>
+            <a:r>
+              <a:rPr sz="2100" b="0">
+                <a:solidFill>
+                  <a:srgbClr val="202723"/>
+                </a:solidFill>
+                <a:latin typeface="Arial"/>
+                <a:ea typeface="Arial"/>
+                <a:cs typeface="Arial"/>
+              </a:rPr>
+              <a:t>Operator handoff</a:t>
+            </a:r>
+          </a:p>
+        </p:txBody>
+      </p:sp>
+      <p:sp>
+        <p:nvSpPr>
+          <p:cNvPr id="13" name="same-core">
+            <a:extLst xmlns:a="http://schemas.openxmlformats.org/drawingml/2006/main">
+              <a:ext uri="{FF2B5EF4-FFF2-40B4-BE49-F238E27FC236}">
+                <a16:creationId xmlns:a16="http://schemas.microsoft.com/office/drawing/2014/main" id="{AB4CC30F-EACE-4E3C-A585-BDBB418B56C9}"/>
+              </a:ext>
+            </a:extLst>
+          </p:cNvPr>
+          <p:cNvSpPr>
+            <a:spLocks xmlns:a="http://schemas.openxmlformats.org/drawingml/2006/main" noGrp="1"/>
+          </p:cNvSpPr>
+          <p:nvPr/>
+        </p:nvSpPr>
+        <p:spPr>
+          <a:xfrm xmlns:a="http://schemas.openxmlformats.org/drawingml/2006/main">
+            <a:off x="609600" y="5600700"/>
+            <a:ext cx="10972800" cy="647700"/>
+          </a:xfrm>
+          <a:prstGeom xmlns:a="http://schemas.openxmlformats.org/drawingml/2006/main" prst="rect">
+            <a:avLst/>
+          </a:prstGeom>
+          <a:noFill xmlns:a="http://schemas.openxmlformats.org/drawingml/2006/main"/>
+          <a:ln xmlns:a="http://schemas.openxmlformats.org/drawingml/2006/main" w="0">
+            <a:noFill/>
+            <a:prstDash val="solid"/>
+          </a:ln>
+        </p:spPr>
+        <p:txBody>
+          <a:bodyPr xmlns:a="http://schemas.openxmlformats.org/drawingml/2006/main" wrap="square" lIns="0" tIns="0" rIns="0" bIns="0">
+            <a:noAutofit/>
+          </a:bodyPr>
+          <a:lstStyle xmlns:a="http://schemas.openxmlformats.org/drawingml/2006/main"/>
+          <a:p xmlns:a="http://schemas.openxmlformats.org/drawingml/2006/main">
+            <a:pPr>
               <a:defRPr sz="1800" b="0">
                 <a:solidFill>
                   <a:srgbClr val="5C6758"/>
@@ -4633,7 +4865,7 @@
                 <a:ea typeface="Arial"/>
                 <a:cs typeface="Arial"/>
               </a:rPr>
-              <a:t>Same open core. Customer-operated infrastructure. Price, capacity, support hours, response targets, and terms agreed before work.</a:t>
+              <a:t>USD · one team, one workflow. Optional support from $2,000/month. Provider usage, infrastructure, and applicable taxes are additional.</a:t>
             </a:r>
           </a:p>
         </p:txBody>
@@ -4641,7 +4873,7 @@
     </p:spTree>
     <p:extLst>
       <p:ext uri="{BB962C8B-B14F-4D97-AF65-F5344CB8AC3E}">
-        <p14:creationId xmlns:p14="http://schemas.microsoft.com/office/powerpoint/2010/main" val="1760364097"/>
+        <p14:creationId xmlns:p14="http://schemas.microsoft.com/office/powerpoint/2010/main" val="1027642876"/>
       </p:ext>
     </p:extLst>
   </p:cSld>
@@ -4669,10 +4901,10 @@
       </p:grpSpPr>
       <p:sp>
         <p:nvSpPr>
-          <p:cNvPr id="12" name="Hormuz mark boundary">
-            <a:extLst xmlns:a="http://schemas.openxmlformats.org/drawingml/2006/main">
-              <a:ext uri="{FF2B5EF4-FFF2-40B4-BE49-F238E27FC236}">
-                <a16:creationId xmlns:a16="http://schemas.microsoft.com/office/drawing/2014/main" id="{82BA60F8-E48E-41A0-BF97-82F7B8FCC727}"/>
+          <p:cNvPr id="13" name="Hormuz mark boundary">
+            <a:extLst xmlns:a="http://schemas.openxmlformats.org/drawingml/2006/main">
+              <a:ext uri="{FF2B5EF4-FFF2-40B4-BE49-F238E27FC236}">
+                <a16:creationId xmlns:a16="http://schemas.microsoft.com/office/drawing/2014/main" id="{38529B8C-6DD1-48AB-A155-EC9C83666202}"/>
               </a:ext>
             </a:extLst>
           </p:cNvPr>
@@ -4703,7 +4935,7 @@
           <p:cNvPr id="2" name="Hormuz mark bar 1">
             <a:extLst xmlns:a="http://schemas.openxmlformats.org/drawingml/2006/main">
               <a:ext uri="{FF2B5EF4-FFF2-40B4-BE49-F238E27FC236}">
-                <a16:creationId xmlns:a16="http://schemas.microsoft.com/office/drawing/2014/main" id="{F7BA9873-C35C-4C93-9DEF-1333732BE49C}"/>
+                <a16:creationId xmlns:a16="http://schemas.microsoft.com/office/drawing/2014/main" id="{FC629D12-FF25-4EE5-8FCC-FD71EAD84FB0}"/>
               </a:ext>
             </a:extLst>
           </p:cNvPr>
@@ -4735,7 +4967,7 @@
           <p:cNvPr id="3" name="Hormuz mark bar 2">
             <a:extLst xmlns:a="http://schemas.openxmlformats.org/drawingml/2006/main">
               <a:ext uri="{FF2B5EF4-FFF2-40B4-BE49-F238E27FC236}">
-                <a16:creationId xmlns:a16="http://schemas.microsoft.com/office/drawing/2014/main" id="{C683C0AC-E6C6-4365-8918-8D955AA578D3}"/>
+                <a16:creationId xmlns:a16="http://schemas.microsoft.com/office/drawing/2014/main" id="{03522793-D55F-4DE7-8410-35596C92BDCE}"/>
               </a:ext>
             </a:extLst>
           </p:cNvPr>
@@ -4767,7 +4999,7 @@
           <p:cNvPr id="4" name="Hormuz mark bar 3">
             <a:extLst xmlns:a="http://schemas.openxmlformats.org/drawingml/2006/main">
               <a:ext uri="{FF2B5EF4-FFF2-40B4-BE49-F238E27FC236}">
-                <a16:creationId xmlns:a16="http://schemas.microsoft.com/office/drawing/2014/main" id="{5188A792-E670-4BA8-86E4-2A7DF1AAC81A}"/>
+                <a16:creationId xmlns:a16="http://schemas.microsoft.com/office/drawing/2014/main" id="{CEAB5B2D-50DC-46B3-80EC-E977FB5DBB32}"/>
               </a:ext>
             </a:extLst>
           </p:cNvPr>
@@ -4799,7 +5031,7 @@
           <p:cNvPr id="5" name="section">
             <a:extLst xmlns:a="http://schemas.openxmlformats.org/drawingml/2006/main">
               <a:ext uri="{FF2B5EF4-FFF2-40B4-BE49-F238E27FC236}">
-                <a16:creationId xmlns:a16="http://schemas.microsoft.com/office/drawing/2014/main" id="{274BED0C-67A7-465D-A381-62A491117FD4}"/>
+                <a16:creationId xmlns:a16="http://schemas.microsoft.com/office/drawing/2014/main" id="{57E2B7DB-A528-4B5D-A7AD-9F44198835C4}"/>
               </a:ext>
             </a:extLst>
           </p:cNvPr>
@@ -4857,7 +5089,7 @@
           <p:cNvPr id="6" name="takeaway">
             <a:extLst xmlns:a="http://schemas.openxmlformats.org/drawingml/2006/main">
               <a:ext uri="{FF2B5EF4-FFF2-40B4-BE49-F238E27FC236}">
-                <a16:creationId xmlns:a16="http://schemas.microsoft.com/office/drawing/2014/main" id="{E09A70A2-41A1-4822-821A-83AB18A3B7BF}"/>
+                <a16:creationId xmlns:a16="http://schemas.microsoft.com/office/drawing/2014/main" id="{4C59ABBD-6CA8-4C06-B334-DDC180591784}"/>
               </a:ext>
             </a:extLst>
           </p:cNvPr>
@@ -4915,7 +5147,7 @@
           <p:cNvPr id="7" name="footer">
             <a:extLst xmlns:a="http://schemas.openxmlformats.org/drawingml/2006/main">
               <a:ext uri="{FF2B5EF4-FFF2-40B4-BE49-F238E27FC236}">
-                <a16:creationId xmlns:a16="http://schemas.microsoft.com/office/drawing/2014/main" id="{55250360-B7C0-421F-A656-F21494B1A6CF}"/>
+                <a16:creationId xmlns:a16="http://schemas.microsoft.com/office/drawing/2014/main" id="{13970EDB-2AFC-4B9B-8D86-1F55CF47B049}"/>
               </a:ext>
             </a:extLst>
           </p:cNvPr>
@@ -4927,7 +5159,7 @@
         <p:spPr>
           <a:xfrm xmlns:a="http://schemas.openxmlformats.org/drawingml/2006/main">
             <a:off x="609600" y="6400800"/>
-            <a:ext cx="10972800" cy="228600"/>
+            <a:ext cx="9525000" cy="228600"/>
           </a:xfrm>
           <a:prstGeom xmlns:a="http://schemas.openxmlformats.org/drawingml/2006/main" prst="rect">
             <a:avLst/>
@@ -4963,29 +5195,29 @@
                 <a:ea typeface="Arial"/>
                 <a:cs typeface="Arial"/>
               </a:rPr>
-              <a:t>HORMUZ  /  Mehrdad Zaker  /  September 2026                                      05 / 07</a:t>
-            </a:r>
-          </a:p>
-        </p:txBody>
-      </p:sp>
-      <p:sp>
-        <p:nvSpPr>
-          <p:cNvPr id="8" name="release">
-            <a:extLst xmlns:a="http://schemas.openxmlformats.org/drawingml/2006/main">
-              <a:ext uri="{FF2B5EF4-FFF2-40B4-BE49-F238E27FC236}">
-                <a16:creationId xmlns:a16="http://schemas.microsoft.com/office/drawing/2014/main" id="{4CEB40BA-5235-4561-B858-5404762FEE8C}"/>
-              </a:ext>
-            </a:extLst>
-          </p:cNvPr>
-          <p:cNvSpPr>
-            <a:spLocks xmlns:a="http://schemas.openxmlformats.org/drawingml/2006/main" noGrp="1"/>
-          </p:cNvSpPr>
-          <p:nvPr/>
-        </p:nvSpPr>
-        <p:spPr>
-          <a:xfrm xmlns:a="http://schemas.openxmlformats.org/drawingml/2006/main">
-            <a:off x="609600" y="2552700"/>
-            <a:ext cx="10972800" cy="609600"/>
+              <a:t>HORMUZ  /  A product of Neuralint  /  Mehrdad Zaker  /  September 2026</a:t>
+            </a:r>
+          </a:p>
+        </p:txBody>
+      </p:sp>
+      <p:sp>
+        <p:nvSpPr>
+          <p:cNvPr id="8" name="page-number">
+            <a:extLst xmlns:a="http://schemas.openxmlformats.org/drawingml/2006/main">
+              <a:ext uri="{FF2B5EF4-FFF2-40B4-BE49-F238E27FC236}">
+                <a16:creationId xmlns:a16="http://schemas.microsoft.com/office/drawing/2014/main" id="{789160AD-0629-490C-9B1B-F9E898C302DA}"/>
+              </a:ext>
+            </a:extLst>
+          </p:cNvPr>
+          <p:cNvSpPr>
+            <a:spLocks xmlns:a="http://schemas.openxmlformats.org/drawingml/2006/main" noGrp="1"/>
+          </p:cNvSpPr>
+          <p:nvPr/>
+        </p:nvSpPr>
+        <p:spPr>
+          <a:xfrm xmlns:a="http://schemas.openxmlformats.org/drawingml/2006/main">
+            <a:off x="10972800" y="6400800"/>
+            <a:ext cx="609600" cy="228600"/>
           </a:xfrm>
           <a:prstGeom xmlns:a="http://schemas.openxmlformats.org/drawingml/2006/main" prst="rect">
             <a:avLst/>
@@ -5003,47 +5235,47 @@
           <a:lstStyle xmlns:a="http://schemas.openxmlformats.org/drawingml/2006/main"/>
           <a:p xmlns:a="http://schemas.openxmlformats.org/drawingml/2006/main">
             <a:pPr>
-              <a:defRPr sz="3150" b="1">
-                <a:solidFill>
-                  <a:srgbClr val="31684B"/>
-                </a:solidFill>
-                <a:latin typeface="Arial"/>
-                <a:ea typeface="Arial"/>
-                <a:cs typeface="Arial"/>
-              </a:defRPr>
-            </a:pPr>
-            <a:r>
-              <a:rPr sz="3150" b="1">
-                <a:solidFill>
-                  <a:srgbClr val="31684B"/>
-                </a:solidFill>
-                <a:latin typeface="Arial"/>
-                <a:ea typeface="Arial"/>
-                <a:cs typeface="Arial"/>
-              </a:rPr>
-              <a:t>v1.0.0 source contracts</a:t>
-            </a:r>
-          </a:p>
-        </p:txBody>
-      </p:sp>
-      <p:sp>
-        <p:nvSpPr>
-          <p:cNvPr id="9" name="oci">
-            <a:extLst xmlns:a="http://schemas.openxmlformats.org/drawingml/2006/main">
-              <a:ext uri="{FF2B5EF4-FFF2-40B4-BE49-F238E27FC236}">
-                <a16:creationId xmlns:a16="http://schemas.microsoft.com/office/drawing/2014/main" id="{5D8B7181-E478-4000-81C8-0FCFA86C942A}"/>
-              </a:ext>
-            </a:extLst>
-          </p:cNvPr>
-          <p:cNvSpPr>
-            <a:spLocks xmlns:a="http://schemas.openxmlformats.org/drawingml/2006/main" noGrp="1"/>
-          </p:cNvSpPr>
-          <p:nvPr/>
-        </p:nvSpPr>
-        <p:spPr>
-          <a:xfrm xmlns:a="http://schemas.openxmlformats.org/drawingml/2006/main">
-            <a:off x="609600" y="3295650"/>
-            <a:ext cx="10972800" cy="495300"/>
+              <a:defRPr sz="1275" b="0">
+                <a:solidFill>
+                  <a:srgbClr val="5C6758"/>
+                </a:solidFill>
+                <a:latin typeface="Arial"/>
+                <a:ea typeface="Arial"/>
+                <a:cs typeface="Arial"/>
+              </a:defRPr>
+            </a:pPr>
+            <a:r>
+              <a:rPr sz="1275" b="0">
+                <a:solidFill>
+                  <a:srgbClr val="5C6758"/>
+                </a:solidFill>
+                <a:latin typeface="Arial"/>
+                <a:ea typeface="Arial"/>
+                <a:cs typeface="Arial"/>
+              </a:rPr>
+              <a:t>05 / 07</a:t>
+            </a:r>
+          </a:p>
+        </p:txBody>
+      </p:sp>
+      <p:sp>
+        <p:nvSpPr>
+          <p:cNvPr id="9" name="release">
+            <a:extLst xmlns:a="http://schemas.openxmlformats.org/drawingml/2006/main">
+              <a:ext uri="{FF2B5EF4-FFF2-40B4-BE49-F238E27FC236}">
+                <a16:creationId xmlns:a16="http://schemas.microsoft.com/office/drawing/2014/main" id="{04995EB8-AF83-4A42-95F4-E09ADA394300}"/>
+              </a:ext>
+            </a:extLst>
+          </p:cNvPr>
+          <p:cNvSpPr>
+            <a:spLocks xmlns:a="http://schemas.openxmlformats.org/drawingml/2006/main" noGrp="1"/>
+          </p:cNvSpPr>
+          <p:nvPr/>
+        </p:nvSpPr>
+        <p:spPr>
+          <a:xfrm xmlns:a="http://schemas.openxmlformats.org/drawingml/2006/main">
+            <a:off x="609600" y="2552700"/>
+            <a:ext cx="10972800" cy="609600"/>
           </a:xfrm>
           <a:prstGeom xmlns:a="http://schemas.openxmlformats.org/drawingml/2006/main" prst="rect">
             <a:avLst/>
@@ -5061,47 +5293,47 @@
           <a:lstStyle xmlns:a="http://schemas.openxmlformats.org/drawingml/2006/main"/>
           <a:p xmlns:a="http://schemas.openxmlformats.org/drawingml/2006/main">
             <a:pPr>
-              <a:defRPr sz="2100" b="0">
-                <a:solidFill>
-                  <a:srgbClr val="202723"/>
-                </a:solidFill>
-                <a:latin typeface="Arial"/>
-                <a:ea typeface="Arial"/>
-                <a:cs typeface="Arial"/>
-              </a:defRPr>
-            </a:pPr>
-            <a:r>
-              <a:rPr sz="2100" b="0">
-                <a:solidFill>
-                  <a:srgbClr val="202723"/>
-                </a:solidFill>
-                <a:latin typeface="Arial"/>
-                <a:ea typeface="Arial"/>
-                <a:cs typeface="Arial"/>
-              </a:rPr>
-              <a:t>Signed OCI v0.1.3 linux/amd64 is a separate reference stream.</a:t>
-            </a:r>
-          </a:p>
-        </p:txBody>
-      </p:sp>
-      <p:sp>
-        <p:nvSpPr>
-          <p:cNvPr id="10" name="operators">
-            <a:extLst xmlns:a="http://schemas.openxmlformats.org/drawingml/2006/main">
-              <a:ext uri="{FF2B5EF4-FFF2-40B4-BE49-F238E27FC236}">
-                <a16:creationId xmlns:a16="http://schemas.microsoft.com/office/drawing/2014/main" id="{AFD69644-1BF8-4D60-8D4B-2071FA9CA191}"/>
-              </a:ext>
-            </a:extLst>
-          </p:cNvPr>
-          <p:cNvSpPr>
-            <a:spLocks xmlns:a="http://schemas.openxmlformats.org/drawingml/2006/main" noGrp="1"/>
-          </p:cNvSpPr>
-          <p:nvPr/>
-        </p:nvSpPr>
-        <p:spPr>
-          <a:xfrm xmlns:a="http://schemas.openxmlformats.org/drawingml/2006/main">
-            <a:off x="609600" y="4114800"/>
-            <a:ext cx="10972800" cy="971550"/>
+              <a:defRPr sz="3150" b="1">
+                <a:solidFill>
+                  <a:srgbClr val="31684B"/>
+                </a:solidFill>
+                <a:latin typeface="Arial"/>
+                <a:ea typeface="Arial"/>
+                <a:cs typeface="Arial"/>
+              </a:defRPr>
+            </a:pPr>
+            <a:r>
+              <a:rPr sz="3150" b="1">
+                <a:solidFill>
+                  <a:srgbClr val="31684B"/>
+                </a:solidFill>
+                <a:latin typeface="Arial"/>
+                <a:ea typeface="Arial"/>
+                <a:cs typeface="Arial"/>
+              </a:rPr>
+              <a:t>v1.0.0 source contracts</a:t>
+            </a:r>
+          </a:p>
+        </p:txBody>
+      </p:sp>
+      <p:sp>
+        <p:nvSpPr>
+          <p:cNvPr id="10" name="oci">
+            <a:extLst xmlns:a="http://schemas.openxmlformats.org/drawingml/2006/main">
+              <a:ext uri="{FF2B5EF4-FFF2-40B4-BE49-F238E27FC236}">
+                <a16:creationId xmlns:a16="http://schemas.microsoft.com/office/drawing/2014/main" id="{446426B3-E045-4995-87E3-34E43FA824F9}"/>
+              </a:ext>
+            </a:extLst>
+          </p:cNvPr>
+          <p:cNvSpPr>
+            <a:spLocks xmlns:a="http://schemas.openxmlformats.org/drawingml/2006/main" noGrp="1"/>
+          </p:cNvSpPr>
+          <p:nvPr/>
+        </p:nvSpPr>
+        <p:spPr>
+          <a:xfrm xmlns:a="http://schemas.openxmlformats.org/drawingml/2006/main">
+            <a:off x="609600" y="3295650"/>
+            <a:ext cx="10972800" cy="495300"/>
           </a:xfrm>
           <a:prstGeom xmlns:a="http://schemas.openxmlformats.org/drawingml/2006/main" prst="rect">
             <a:avLst/>
@@ -5119,7 +5351,7 @@
           <a:lstStyle xmlns:a="http://schemas.openxmlformats.org/drawingml/2006/main"/>
           <a:p xmlns:a="http://schemas.openxmlformats.org/drawingml/2006/main">
             <a:pPr>
-              <a:defRPr sz="2325" b="1">
+              <a:defRPr sz="2100" b="0">
                 <a:solidFill>
                   <a:srgbClr val="202723"/>
                 </a:solidFill>
@@ -5129,7 +5361,7 @@
               </a:defRPr>
             </a:pPr>
             <a:r>
-              <a:rPr sz="2325" b="1">
+              <a:rPr sz="2100" b="0">
                 <a:solidFill>
                   <a:srgbClr val="202723"/>
                 </a:solidFill>
@@ -5137,29 +5369,29 @@
                 <a:ea typeface="Arial"/>
                 <a:cs typeface="Arial"/>
               </a:rPr>
-              <a:t>You still qualify TLS, custody, retention, backups, recovery, availability, access controls, and independent security review in your environment.</a:t>
-            </a:r>
-          </a:p>
-        </p:txBody>
-      </p:sp>
-      <p:sp>
-        <p:nvSpPr>
-          <p:cNvPr id="11" name="nonclaims">
-            <a:extLst xmlns:a="http://schemas.openxmlformats.org/drawingml/2006/main">
-              <a:ext uri="{FF2B5EF4-FFF2-40B4-BE49-F238E27FC236}">
-                <a16:creationId xmlns:a16="http://schemas.microsoft.com/office/drawing/2014/main" id="{9C326810-3124-4B5D-A226-BC3C0D69417C}"/>
-              </a:ext>
-            </a:extLst>
-          </p:cNvPr>
-          <p:cNvSpPr>
-            <a:spLocks xmlns:a="http://schemas.openxmlformats.org/drawingml/2006/main" noGrp="1"/>
-          </p:cNvSpPr>
-          <p:nvPr/>
-        </p:nvSpPr>
-        <p:spPr>
-          <a:xfrm xmlns:a="http://schemas.openxmlformats.org/drawingml/2006/main">
-            <a:off x="609600" y="5419725"/>
-            <a:ext cx="10972800" cy="771525"/>
+              <a:t>Signed OCI v0.1.3 linux/amd64 is a separate reference stream.</a:t>
+            </a:r>
+          </a:p>
+        </p:txBody>
+      </p:sp>
+      <p:sp>
+        <p:nvSpPr>
+          <p:cNvPr id="11" name="operators">
+            <a:extLst xmlns:a="http://schemas.openxmlformats.org/drawingml/2006/main">
+              <a:ext uri="{FF2B5EF4-FFF2-40B4-BE49-F238E27FC236}">
+                <a16:creationId xmlns:a16="http://schemas.microsoft.com/office/drawing/2014/main" id="{5E0B17BE-F452-4E0B-9523-EDCBD118E36F}"/>
+              </a:ext>
+            </a:extLst>
+          </p:cNvPr>
+          <p:cNvSpPr>
+            <a:spLocks xmlns:a="http://schemas.openxmlformats.org/drawingml/2006/main" noGrp="1"/>
+          </p:cNvSpPr>
+          <p:nvPr/>
+        </p:nvSpPr>
+        <p:spPr>
+          <a:xfrm xmlns:a="http://schemas.openxmlformats.org/drawingml/2006/main">
+            <a:off x="609600" y="4114800"/>
+            <a:ext cx="10972800" cy="971550"/>
           </a:xfrm>
           <a:prstGeom xmlns:a="http://schemas.openxmlformats.org/drawingml/2006/main" prst="rect">
             <a:avLst/>
@@ -5177,6 +5409,64 @@
           <a:lstStyle xmlns:a="http://schemas.openxmlformats.org/drawingml/2006/main"/>
           <a:p xmlns:a="http://schemas.openxmlformats.org/drawingml/2006/main">
             <a:pPr>
+              <a:defRPr sz="2325" b="1">
+                <a:solidFill>
+                  <a:srgbClr val="202723"/>
+                </a:solidFill>
+                <a:latin typeface="Arial"/>
+                <a:ea typeface="Arial"/>
+                <a:cs typeface="Arial"/>
+              </a:defRPr>
+            </a:pPr>
+            <a:r>
+              <a:rPr sz="2325" b="1">
+                <a:solidFill>
+                  <a:srgbClr val="202723"/>
+                </a:solidFill>
+                <a:latin typeface="Arial"/>
+                <a:ea typeface="Arial"/>
+                <a:cs typeface="Arial"/>
+              </a:rPr>
+              <a:t>You still qualify TLS, custody, retention, backups, recovery, availability, access controls, and independent security review in your environment.</a:t>
+            </a:r>
+          </a:p>
+        </p:txBody>
+      </p:sp>
+      <p:sp>
+        <p:nvSpPr>
+          <p:cNvPr id="12" name="nonclaims">
+            <a:extLst xmlns:a="http://schemas.openxmlformats.org/drawingml/2006/main">
+              <a:ext uri="{FF2B5EF4-FFF2-40B4-BE49-F238E27FC236}">
+                <a16:creationId xmlns:a16="http://schemas.microsoft.com/office/drawing/2014/main" id="{55714865-0A4D-4D4D-92CF-4C8C0A90CCD0}"/>
+              </a:ext>
+            </a:extLst>
+          </p:cNvPr>
+          <p:cNvSpPr>
+            <a:spLocks xmlns:a="http://schemas.openxmlformats.org/drawingml/2006/main" noGrp="1"/>
+          </p:cNvSpPr>
+          <p:nvPr/>
+        </p:nvSpPr>
+        <p:spPr>
+          <a:xfrm xmlns:a="http://schemas.openxmlformats.org/drawingml/2006/main">
+            <a:off x="609600" y="5419725"/>
+            <a:ext cx="10972800" cy="771525"/>
+          </a:xfrm>
+          <a:prstGeom xmlns:a="http://schemas.openxmlformats.org/drawingml/2006/main" prst="rect">
+            <a:avLst/>
+          </a:prstGeom>
+          <a:noFill xmlns:a="http://schemas.openxmlformats.org/drawingml/2006/main"/>
+          <a:ln xmlns:a="http://schemas.openxmlformats.org/drawingml/2006/main" w="0">
+            <a:noFill/>
+            <a:prstDash val="solid"/>
+          </a:ln>
+        </p:spPr>
+        <p:txBody>
+          <a:bodyPr xmlns:a="http://schemas.openxmlformats.org/drawingml/2006/main" wrap="square" lIns="0" tIns="0" rIns="0" bIns="0">
+            <a:noAutofit/>
+          </a:bodyPr>
+          <a:lstStyle xmlns:a="http://schemas.openxmlformats.org/drawingml/2006/main"/>
+          <a:p xmlns:a="http://schemas.openxmlformats.org/drawingml/2006/main">
+            <a:pPr>
               <a:defRPr sz="1875" b="0">
                 <a:solidFill>
                   <a:srgbClr val="5C6758"/>
@@ -5203,7 +5493,7 @@
     </p:spTree>
     <p:extLst>
       <p:ext uri="{BB962C8B-B14F-4D97-AF65-F5344CB8AC3E}">
-        <p14:creationId xmlns:p14="http://schemas.microsoft.com/office/powerpoint/2010/main" val="537518997"/>
+        <p14:creationId xmlns:p14="http://schemas.microsoft.com/office/powerpoint/2010/main" val="1223543956"/>
       </p:ext>
     </p:extLst>
   </p:cSld>
@@ -5231,10 +5521,10 @@
       </p:grpSpPr>
       <p:sp>
         <p:nvSpPr>
-          <p:cNvPr id="18" name="Hormuz mark boundary">
-            <a:extLst xmlns:a="http://schemas.openxmlformats.org/drawingml/2006/main">
-              <a:ext uri="{FF2B5EF4-FFF2-40B4-BE49-F238E27FC236}">
-                <a16:creationId xmlns:a16="http://schemas.microsoft.com/office/drawing/2014/main" id="{7FF100A5-1E48-457D-91B2-17A23BB2E19A}"/>
+          <p:cNvPr id="19" name="Hormuz mark boundary">
+            <a:extLst xmlns:a="http://schemas.openxmlformats.org/drawingml/2006/main">
+              <a:ext uri="{FF2B5EF4-FFF2-40B4-BE49-F238E27FC236}">
+                <a16:creationId xmlns:a16="http://schemas.microsoft.com/office/drawing/2014/main" id="{E8000EB6-088A-4268-84B4-9DC862C3752B}"/>
               </a:ext>
             </a:extLst>
           </p:cNvPr>
@@ -5265,7 +5555,7 @@
           <p:cNvPr id="2" name="Hormuz mark bar 1">
             <a:extLst xmlns:a="http://schemas.openxmlformats.org/drawingml/2006/main">
               <a:ext uri="{FF2B5EF4-FFF2-40B4-BE49-F238E27FC236}">
-                <a16:creationId xmlns:a16="http://schemas.microsoft.com/office/drawing/2014/main" id="{CFE84B2E-4659-41A8-9E53-3201378921CF}"/>
+                <a16:creationId xmlns:a16="http://schemas.microsoft.com/office/drawing/2014/main" id="{52EBD7E2-070D-47B7-AD51-DD36EB7A3FC1}"/>
               </a:ext>
             </a:extLst>
           </p:cNvPr>
@@ -5297,7 +5587,7 @@
           <p:cNvPr id="3" name="Hormuz mark bar 2">
             <a:extLst xmlns:a="http://schemas.openxmlformats.org/drawingml/2006/main">
               <a:ext uri="{FF2B5EF4-FFF2-40B4-BE49-F238E27FC236}">
-                <a16:creationId xmlns:a16="http://schemas.microsoft.com/office/drawing/2014/main" id="{BA77988F-27B6-4B6D-B067-E13FF5B59FAE}"/>
+                <a16:creationId xmlns:a16="http://schemas.microsoft.com/office/drawing/2014/main" id="{06F3567A-B671-4C99-BD52-FF1E7F53ED43}"/>
               </a:ext>
             </a:extLst>
           </p:cNvPr>
@@ -5329,7 +5619,7 @@
           <p:cNvPr id="4" name="Hormuz mark bar 3">
             <a:extLst xmlns:a="http://schemas.openxmlformats.org/drawingml/2006/main">
               <a:ext uri="{FF2B5EF4-FFF2-40B4-BE49-F238E27FC236}">
-                <a16:creationId xmlns:a16="http://schemas.microsoft.com/office/drawing/2014/main" id="{13E2A8B4-D1BB-4498-8535-48651ADFB927}"/>
+                <a16:creationId xmlns:a16="http://schemas.microsoft.com/office/drawing/2014/main" id="{2226E4F3-627D-4A7B-9DB3-D8391D5125C5}"/>
               </a:ext>
             </a:extLst>
           </p:cNvPr>
@@ -5361,7 +5651,7 @@
           <p:cNvPr id="5" name="section">
             <a:extLst xmlns:a="http://schemas.openxmlformats.org/drawingml/2006/main">
               <a:ext uri="{FF2B5EF4-FFF2-40B4-BE49-F238E27FC236}">
-                <a16:creationId xmlns:a16="http://schemas.microsoft.com/office/drawing/2014/main" id="{B90C36A3-418B-4E46-9AAD-9C06C683C043}"/>
+                <a16:creationId xmlns:a16="http://schemas.microsoft.com/office/drawing/2014/main" id="{443588CD-FF48-44F7-8A1A-436B829D0CB7}"/>
               </a:ext>
             </a:extLst>
           </p:cNvPr>
@@ -5419,7 +5709,7 @@
           <p:cNvPr id="6" name="takeaway">
             <a:extLst xmlns:a="http://schemas.openxmlformats.org/drawingml/2006/main">
               <a:ext uri="{FF2B5EF4-FFF2-40B4-BE49-F238E27FC236}">
-                <a16:creationId xmlns:a16="http://schemas.microsoft.com/office/drawing/2014/main" id="{CEDC67C9-8B63-4E2D-8A16-22006DB751F2}"/>
+                <a16:creationId xmlns:a16="http://schemas.microsoft.com/office/drawing/2014/main" id="{4AAD8345-0483-49CA-A1DB-538123B26F01}"/>
               </a:ext>
             </a:extLst>
           </p:cNvPr>
@@ -5477,7 +5767,7 @@
           <p:cNvPr id="7" name="footer">
             <a:extLst xmlns:a="http://schemas.openxmlformats.org/drawingml/2006/main">
               <a:ext uri="{FF2B5EF4-FFF2-40B4-BE49-F238E27FC236}">
-                <a16:creationId xmlns:a16="http://schemas.microsoft.com/office/drawing/2014/main" id="{41574274-CEE7-46D6-8D87-CC25B7E22269}"/>
+                <a16:creationId xmlns:a16="http://schemas.microsoft.com/office/drawing/2014/main" id="{5253A6CD-434B-4A81-B858-1C3E1C022C5D}"/>
               </a:ext>
             </a:extLst>
           </p:cNvPr>
@@ -5489,7 +5779,7 @@
         <p:spPr>
           <a:xfrm xmlns:a="http://schemas.openxmlformats.org/drawingml/2006/main">
             <a:off x="609600" y="6400800"/>
-            <a:ext cx="10972800" cy="228600"/>
+            <a:ext cx="9525000" cy="228600"/>
           </a:xfrm>
           <a:prstGeom xmlns:a="http://schemas.openxmlformats.org/drawingml/2006/main" prst="rect">
             <a:avLst/>
@@ -5525,29 +5815,29 @@
                 <a:ea typeface="Arial"/>
                 <a:cs typeface="Arial"/>
               </a:rPr>
-              <a:t>HORMUZ  /  Mehrdad Zaker  /  September 2026                                      06 / 07</a:t>
-            </a:r>
-          </a:p>
-        </p:txBody>
-      </p:sp>
-      <p:sp>
-        <p:nvSpPr>
-          <p:cNvPr id="8" name="phase-01">
-            <a:extLst xmlns:a="http://schemas.openxmlformats.org/drawingml/2006/main">
-              <a:ext uri="{FF2B5EF4-FFF2-40B4-BE49-F238E27FC236}">
-                <a16:creationId xmlns:a16="http://schemas.microsoft.com/office/drawing/2014/main" id="{0C18BF1D-A1DA-4C3B-A5A8-10C0BF2FE210}"/>
-              </a:ext>
-            </a:extLst>
-          </p:cNvPr>
-          <p:cNvSpPr>
-            <a:spLocks xmlns:a="http://schemas.openxmlformats.org/drawingml/2006/main" noGrp="1"/>
-          </p:cNvSpPr>
-          <p:nvPr/>
-        </p:nvSpPr>
-        <p:spPr>
-          <a:xfrm xmlns:a="http://schemas.openxmlformats.org/drawingml/2006/main">
-            <a:off x="609600" y="2543175"/>
-            <a:ext cx="990600" cy="666750"/>
+              <a:t>HORMUZ  /  A product of Neuralint  /  Mehrdad Zaker  /  September 2026</a:t>
+            </a:r>
+          </a:p>
+        </p:txBody>
+      </p:sp>
+      <p:sp>
+        <p:nvSpPr>
+          <p:cNvPr id="8" name="page-number">
+            <a:extLst xmlns:a="http://schemas.openxmlformats.org/drawingml/2006/main">
+              <a:ext uri="{FF2B5EF4-FFF2-40B4-BE49-F238E27FC236}">
+                <a16:creationId xmlns:a16="http://schemas.microsoft.com/office/drawing/2014/main" id="{31F78D1C-806A-434F-BE45-C624446FA28E}"/>
+              </a:ext>
+            </a:extLst>
+          </p:cNvPr>
+          <p:cNvSpPr>
+            <a:spLocks xmlns:a="http://schemas.openxmlformats.org/drawingml/2006/main" noGrp="1"/>
+          </p:cNvSpPr>
+          <p:nvPr/>
+        </p:nvSpPr>
+        <p:spPr>
+          <a:xfrm xmlns:a="http://schemas.openxmlformats.org/drawingml/2006/main">
+            <a:off x="10972800" y="6400800"/>
+            <a:ext cx="609600" cy="228600"/>
           </a:xfrm>
           <a:prstGeom xmlns:a="http://schemas.openxmlformats.org/drawingml/2006/main" prst="rect">
             <a:avLst/>
@@ -5565,47 +5855,47 @@
           <a:lstStyle xmlns:a="http://schemas.openxmlformats.org/drawingml/2006/main"/>
           <a:p xmlns:a="http://schemas.openxmlformats.org/drawingml/2006/main">
             <a:pPr>
-              <a:defRPr sz="4050" b="1">
-                <a:solidFill>
-                  <a:srgbClr val="31684B"/>
-                </a:solidFill>
-                <a:latin typeface="Arial"/>
-                <a:ea typeface="Arial"/>
-                <a:cs typeface="Arial"/>
-              </a:defRPr>
-            </a:pPr>
-            <a:r>
-              <a:rPr sz="4050" b="1">
-                <a:solidFill>
-                  <a:srgbClr val="31684B"/>
-                </a:solidFill>
-                <a:latin typeface="Arial"/>
-                <a:ea typeface="Arial"/>
-                <a:cs typeface="Arial"/>
-              </a:rPr>
-              <a:t>01</a:t>
-            </a:r>
-          </a:p>
-        </p:txBody>
-      </p:sp>
-      <p:sp>
-        <p:nvSpPr>
-          <p:cNvPr id="9" name="phase-title-01">
-            <a:extLst xmlns:a="http://schemas.openxmlformats.org/drawingml/2006/main">
-              <a:ext uri="{FF2B5EF4-FFF2-40B4-BE49-F238E27FC236}">
-                <a16:creationId xmlns:a16="http://schemas.microsoft.com/office/drawing/2014/main" id="{F37A19FA-4D61-4AA3-ACA3-564DAE2FCBC4}"/>
-              </a:ext>
-            </a:extLst>
-          </p:cNvPr>
-          <p:cNvSpPr>
-            <a:spLocks xmlns:a="http://schemas.openxmlformats.org/drawingml/2006/main" noGrp="1"/>
-          </p:cNvSpPr>
-          <p:nvPr/>
-        </p:nvSpPr>
-        <p:spPr>
-          <a:xfrm xmlns:a="http://schemas.openxmlformats.org/drawingml/2006/main">
-            <a:off x="1943100" y="2543175"/>
-            <a:ext cx="9639300" cy="400050"/>
+              <a:defRPr sz="1275" b="0">
+                <a:solidFill>
+                  <a:srgbClr val="5C6758"/>
+                </a:solidFill>
+                <a:latin typeface="Arial"/>
+                <a:ea typeface="Arial"/>
+                <a:cs typeface="Arial"/>
+              </a:defRPr>
+            </a:pPr>
+            <a:r>
+              <a:rPr sz="1275" b="0">
+                <a:solidFill>
+                  <a:srgbClr val="5C6758"/>
+                </a:solidFill>
+                <a:latin typeface="Arial"/>
+                <a:ea typeface="Arial"/>
+                <a:cs typeface="Arial"/>
+              </a:rPr>
+              <a:t>06 / 07</a:t>
+            </a:r>
+          </a:p>
+        </p:txBody>
+      </p:sp>
+      <p:sp>
+        <p:nvSpPr>
+          <p:cNvPr id="9" name="phase-01">
+            <a:extLst xmlns:a="http://schemas.openxmlformats.org/drawingml/2006/main">
+              <a:ext uri="{FF2B5EF4-FFF2-40B4-BE49-F238E27FC236}">
+                <a16:creationId xmlns:a16="http://schemas.microsoft.com/office/drawing/2014/main" id="{550DB0B3-C7D9-41C3-B443-08DD41398328}"/>
+              </a:ext>
+            </a:extLst>
+          </p:cNvPr>
+          <p:cNvSpPr>
+            <a:spLocks xmlns:a="http://schemas.openxmlformats.org/drawingml/2006/main" noGrp="1"/>
+          </p:cNvSpPr>
+          <p:nvPr/>
+        </p:nvSpPr>
+        <p:spPr>
+          <a:xfrm xmlns:a="http://schemas.openxmlformats.org/drawingml/2006/main">
+            <a:off x="609600" y="2543175"/>
+            <a:ext cx="990600" cy="666750"/>
           </a:xfrm>
           <a:prstGeom xmlns:a="http://schemas.openxmlformats.org/drawingml/2006/main" prst="rect">
             <a:avLst/>
@@ -5623,47 +5913,47 @@
           <a:lstStyle xmlns:a="http://schemas.openxmlformats.org/drawingml/2006/main"/>
           <a:p xmlns:a="http://schemas.openxmlformats.org/drawingml/2006/main">
             <a:pPr>
-              <a:defRPr sz="2325" b="1">
-                <a:solidFill>
-                  <a:srgbClr val="202723"/>
-                </a:solidFill>
-                <a:latin typeface="Arial"/>
-                <a:ea typeface="Arial"/>
-                <a:cs typeface="Arial"/>
-              </a:defRPr>
-            </a:pPr>
-            <a:r>
-              <a:rPr sz="2325" b="1">
-                <a:solidFill>
-                  <a:srgbClr val="202723"/>
-                </a:solidFill>
-                <a:latin typeface="Arial"/>
-                <a:ea typeface="Arial"/>
-                <a:cs typeface="Arial"/>
-              </a:rPr>
-              <a:t>Days 1–15 / Map</a:t>
-            </a:r>
-          </a:p>
-        </p:txBody>
-      </p:sp>
-      <p:sp>
-        <p:nvSpPr>
-          <p:cNvPr id="10" name="phase-body-01">
-            <a:extLst xmlns:a="http://schemas.openxmlformats.org/drawingml/2006/main">
-              <a:ext uri="{FF2B5EF4-FFF2-40B4-BE49-F238E27FC236}">
-                <a16:creationId xmlns:a16="http://schemas.microsoft.com/office/drawing/2014/main" id="{953BA0C1-DD1A-4FFA-81AE-55449AC357C3}"/>
-              </a:ext>
-            </a:extLst>
-          </p:cNvPr>
-          <p:cNvSpPr>
-            <a:spLocks xmlns:a="http://schemas.openxmlformats.org/drawingml/2006/main" noGrp="1"/>
-          </p:cNvSpPr>
-          <p:nvPr/>
-        </p:nvSpPr>
-        <p:spPr>
-          <a:xfrm xmlns:a="http://schemas.openxmlformats.org/drawingml/2006/main">
-            <a:off x="1943100" y="3019425"/>
-            <a:ext cx="9639300" cy="428625"/>
+              <a:defRPr sz="4050" b="1">
+                <a:solidFill>
+                  <a:srgbClr val="31684B"/>
+                </a:solidFill>
+                <a:latin typeface="Arial"/>
+                <a:ea typeface="Arial"/>
+                <a:cs typeface="Arial"/>
+              </a:defRPr>
+            </a:pPr>
+            <a:r>
+              <a:rPr sz="4050" b="1">
+                <a:solidFill>
+                  <a:srgbClr val="31684B"/>
+                </a:solidFill>
+                <a:latin typeface="Arial"/>
+                <a:ea typeface="Arial"/>
+                <a:cs typeface="Arial"/>
+              </a:rPr>
+              <a:t>01</a:t>
+            </a:r>
+          </a:p>
+        </p:txBody>
+      </p:sp>
+      <p:sp>
+        <p:nvSpPr>
+          <p:cNvPr id="10" name="phase-title-01">
+            <a:extLst xmlns:a="http://schemas.openxmlformats.org/drawingml/2006/main">
+              <a:ext uri="{FF2B5EF4-FFF2-40B4-BE49-F238E27FC236}">
+                <a16:creationId xmlns:a16="http://schemas.microsoft.com/office/drawing/2014/main" id="{E7B8A1F9-4FDC-4FE1-83B8-2535C31832ED}"/>
+              </a:ext>
+            </a:extLst>
+          </p:cNvPr>
+          <p:cNvSpPr>
+            <a:spLocks xmlns:a="http://schemas.openxmlformats.org/drawingml/2006/main" noGrp="1"/>
+          </p:cNvSpPr>
+          <p:nvPr/>
+        </p:nvSpPr>
+        <p:spPr>
+          <a:xfrm xmlns:a="http://schemas.openxmlformats.org/drawingml/2006/main">
+            <a:off x="1943100" y="2543175"/>
+            <a:ext cx="9639300" cy="400050"/>
           </a:xfrm>
           <a:prstGeom xmlns:a="http://schemas.openxmlformats.org/drawingml/2006/main" prst="rect">
             <a:avLst/>
@@ -5681,7 +5971,7 @@
           <a:lstStyle xmlns:a="http://schemas.openxmlformats.org/drawingml/2006/main"/>
           <a:p xmlns:a="http://schemas.openxmlformats.org/drawingml/2006/main">
             <a:pPr>
-              <a:defRPr sz="1950" b="0">
+              <a:defRPr sz="2325" b="1">
                 <a:solidFill>
                   <a:srgbClr val="202723"/>
                 </a:solidFill>
@@ -5691,7 +5981,7 @@
               </a:defRPr>
             </a:pPr>
             <a:r>
-              <a:rPr sz="1950" b="0">
+              <a:rPr sz="2325" b="1">
                 <a:solidFill>
                   <a:srgbClr val="202723"/>
                 </a:solidFill>
@@ -5699,29 +5989,29 @@
                 <a:ea typeface="Arial"/>
                 <a:cs typeface="Arial"/>
               </a:rPr>
-              <a:t>Control map, prerequisites, and agreed acceptance criteria.</a:t>
-            </a:r>
-          </a:p>
-        </p:txBody>
-      </p:sp>
-      <p:sp>
-        <p:nvSpPr>
-          <p:cNvPr id="11" name="phase-02">
-            <a:extLst xmlns:a="http://schemas.openxmlformats.org/drawingml/2006/main">
-              <a:ext uri="{FF2B5EF4-FFF2-40B4-BE49-F238E27FC236}">
-                <a16:creationId xmlns:a16="http://schemas.microsoft.com/office/drawing/2014/main" id="{B8F2BB3D-1CD6-4324-BB8B-47FE8014D64D}"/>
-              </a:ext>
-            </a:extLst>
-          </p:cNvPr>
-          <p:cNvSpPr>
-            <a:spLocks xmlns:a="http://schemas.openxmlformats.org/drawingml/2006/main" noGrp="1"/>
-          </p:cNvSpPr>
-          <p:nvPr/>
-        </p:nvSpPr>
-        <p:spPr>
-          <a:xfrm xmlns:a="http://schemas.openxmlformats.org/drawingml/2006/main">
-            <a:off x="609600" y="3609975"/>
-            <a:ext cx="990600" cy="666750"/>
+              <a:t>Days 1–15 / Map</a:t>
+            </a:r>
+          </a:p>
+        </p:txBody>
+      </p:sp>
+      <p:sp>
+        <p:nvSpPr>
+          <p:cNvPr id="11" name="phase-body-01">
+            <a:extLst xmlns:a="http://schemas.openxmlformats.org/drawingml/2006/main">
+              <a:ext uri="{FF2B5EF4-FFF2-40B4-BE49-F238E27FC236}">
+                <a16:creationId xmlns:a16="http://schemas.microsoft.com/office/drawing/2014/main" id="{9BC4AD9D-D9C7-46F5-AA12-0F858053552C}"/>
+              </a:ext>
+            </a:extLst>
+          </p:cNvPr>
+          <p:cNvSpPr>
+            <a:spLocks xmlns:a="http://schemas.openxmlformats.org/drawingml/2006/main" noGrp="1"/>
+          </p:cNvSpPr>
+          <p:nvPr/>
+        </p:nvSpPr>
+        <p:spPr>
+          <a:xfrm xmlns:a="http://schemas.openxmlformats.org/drawingml/2006/main">
+            <a:off x="1943100" y="3019425"/>
+            <a:ext cx="9639300" cy="428625"/>
           </a:xfrm>
           <a:prstGeom xmlns:a="http://schemas.openxmlformats.org/drawingml/2006/main" prst="rect">
             <a:avLst/>
@@ -5739,47 +6029,47 @@
           <a:lstStyle xmlns:a="http://schemas.openxmlformats.org/drawingml/2006/main"/>
           <a:p xmlns:a="http://schemas.openxmlformats.org/drawingml/2006/main">
             <a:pPr>
-              <a:defRPr sz="4050" b="1">
-                <a:solidFill>
-                  <a:srgbClr val="31684B"/>
-                </a:solidFill>
-                <a:latin typeface="Arial"/>
-                <a:ea typeface="Arial"/>
-                <a:cs typeface="Arial"/>
-              </a:defRPr>
-            </a:pPr>
-            <a:r>
-              <a:rPr sz="4050" b="1">
-                <a:solidFill>
-                  <a:srgbClr val="31684B"/>
-                </a:solidFill>
-                <a:latin typeface="Arial"/>
-                <a:ea typeface="Arial"/>
-                <a:cs typeface="Arial"/>
-              </a:rPr>
-              <a:t>02</a:t>
-            </a:r>
-          </a:p>
-        </p:txBody>
-      </p:sp>
-      <p:sp>
-        <p:nvSpPr>
-          <p:cNvPr id="12" name="phase-title-02">
-            <a:extLst xmlns:a="http://schemas.openxmlformats.org/drawingml/2006/main">
-              <a:ext uri="{FF2B5EF4-FFF2-40B4-BE49-F238E27FC236}">
-                <a16:creationId xmlns:a16="http://schemas.microsoft.com/office/drawing/2014/main" id="{8F8811D2-88CD-4313-9980-A03B548F3564}"/>
-              </a:ext>
-            </a:extLst>
-          </p:cNvPr>
-          <p:cNvSpPr>
-            <a:spLocks xmlns:a="http://schemas.openxmlformats.org/drawingml/2006/main" noGrp="1"/>
-          </p:cNvSpPr>
-          <p:nvPr/>
-        </p:nvSpPr>
-        <p:spPr>
-          <a:xfrm xmlns:a="http://schemas.openxmlformats.org/drawingml/2006/main">
-            <a:off x="1943100" y="3609975"/>
-            <a:ext cx="9639300" cy="400050"/>
+              <a:defRPr sz="1950" b="0">
+                <a:solidFill>
+                  <a:srgbClr val="202723"/>
+                </a:solidFill>
+                <a:latin typeface="Arial"/>
+                <a:ea typeface="Arial"/>
+                <a:cs typeface="Arial"/>
+              </a:defRPr>
+            </a:pPr>
+            <a:r>
+              <a:rPr sz="1950" b="0">
+                <a:solidFill>
+                  <a:srgbClr val="202723"/>
+                </a:solidFill>
+                <a:latin typeface="Arial"/>
+                <a:ea typeface="Arial"/>
+                <a:cs typeface="Arial"/>
+              </a:rPr>
+              <a:t>Control map, prerequisites, and agreed acceptance criteria.</a:t>
+            </a:r>
+          </a:p>
+        </p:txBody>
+      </p:sp>
+      <p:sp>
+        <p:nvSpPr>
+          <p:cNvPr id="12" name="phase-02">
+            <a:extLst xmlns:a="http://schemas.openxmlformats.org/drawingml/2006/main">
+              <a:ext uri="{FF2B5EF4-FFF2-40B4-BE49-F238E27FC236}">
+                <a16:creationId xmlns:a16="http://schemas.microsoft.com/office/drawing/2014/main" id="{101BF7FB-437F-46BF-A691-817191BC4340}"/>
+              </a:ext>
+            </a:extLst>
+          </p:cNvPr>
+          <p:cNvSpPr>
+            <a:spLocks xmlns:a="http://schemas.openxmlformats.org/drawingml/2006/main" noGrp="1"/>
+          </p:cNvSpPr>
+          <p:nvPr/>
+        </p:nvSpPr>
+        <p:spPr>
+          <a:xfrm xmlns:a="http://schemas.openxmlformats.org/drawingml/2006/main">
+            <a:off x="609600" y="3609975"/>
+            <a:ext cx="990600" cy="666750"/>
           </a:xfrm>
           <a:prstGeom xmlns:a="http://schemas.openxmlformats.org/drawingml/2006/main" prst="rect">
             <a:avLst/>
@@ -5797,47 +6087,47 @@
           <a:lstStyle xmlns:a="http://schemas.openxmlformats.org/drawingml/2006/main"/>
           <a:p xmlns:a="http://schemas.openxmlformats.org/drawingml/2006/main">
             <a:pPr>
-              <a:defRPr sz="2325" b="1">
-                <a:solidFill>
-                  <a:srgbClr val="202723"/>
-                </a:solidFill>
-                <a:latin typeface="Arial"/>
-                <a:ea typeface="Arial"/>
-                <a:cs typeface="Arial"/>
-              </a:defRPr>
-            </a:pPr>
-            <a:r>
-              <a:rPr sz="2325" b="1">
-                <a:solidFill>
-                  <a:srgbClr val="202723"/>
-                </a:solidFill>
-                <a:latin typeface="Arial"/>
-                <a:ea typeface="Arial"/>
-                <a:cs typeface="Arial"/>
-              </a:rPr>
-              <a:t>Days 16–45 / Prove</a:t>
-            </a:r>
-          </a:p>
-        </p:txBody>
-      </p:sp>
-      <p:sp>
-        <p:nvSpPr>
-          <p:cNvPr id="13" name="phase-body-02">
-            <a:extLst xmlns:a="http://schemas.openxmlformats.org/drawingml/2006/main">
-              <a:ext uri="{FF2B5EF4-FFF2-40B4-BE49-F238E27FC236}">
-                <a16:creationId xmlns:a16="http://schemas.microsoft.com/office/drawing/2014/main" id="{70A3A507-384E-43D1-A9B3-DA6FA77F64F1}"/>
-              </a:ext>
-            </a:extLst>
-          </p:cNvPr>
-          <p:cNvSpPr>
-            <a:spLocks xmlns:a="http://schemas.openxmlformats.org/drawingml/2006/main" noGrp="1"/>
-          </p:cNvSpPr>
-          <p:nvPr/>
-        </p:nvSpPr>
-        <p:spPr>
-          <a:xfrm xmlns:a="http://schemas.openxmlformats.org/drawingml/2006/main">
-            <a:off x="1943100" y="4086225"/>
-            <a:ext cx="9639300" cy="428625"/>
+              <a:defRPr sz="4050" b="1">
+                <a:solidFill>
+                  <a:srgbClr val="31684B"/>
+                </a:solidFill>
+                <a:latin typeface="Arial"/>
+                <a:ea typeface="Arial"/>
+                <a:cs typeface="Arial"/>
+              </a:defRPr>
+            </a:pPr>
+            <a:r>
+              <a:rPr sz="4050" b="1">
+                <a:solidFill>
+                  <a:srgbClr val="31684B"/>
+                </a:solidFill>
+                <a:latin typeface="Arial"/>
+                <a:ea typeface="Arial"/>
+                <a:cs typeface="Arial"/>
+              </a:rPr>
+              <a:t>02</a:t>
+            </a:r>
+          </a:p>
+        </p:txBody>
+      </p:sp>
+      <p:sp>
+        <p:nvSpPr>
+          <p:cNvPr id="13" name="phase-title-02">
+            <a:extLst xmlns:a="http://schemas.openxmlformats.org/drawingml/2006/main">
+              <a:ext uri="{FF2B5EF4-FFF2-40B4-BE49-F238E27FC236}">
+                <a16:creationId xmlns:a16="http://schemas.microsoft.com/office/drawing/2014/main" id="{3B199FC9-34F7-4CF8-A737-831D32B262E5}"/>
+              </a:ext>
+            </a:extLst>
+          </p:cNvPr>
+          <p:cNvSpPr>
+            <a:spLocks xmlns:a="http://schemas.openxmlformats.org/drawingml/2006/main" noGrp="1"/>
+          </p:cNvSpPr>
+          <p:nvPr/>
+        </p:nvSpPr>
+        <p:spPr>
+          <a:xfrm xmlns:a="http://schemas.openxmlformats.org/drawingml/2006/main">
+            <a:off x="1943100" y="3609975"/>
+            <a:ext cx="9639300" cy="400050"/>
           </a:xfrm>
           <a:prstGeom xmlns:a="http://schemas.openxmlformats.org/drawingml/2006/main" prst="rect">
             <a:avLst/>
@@ -5855,7 +6145,7 @@
           <a:lstStyle xmlns:a="http://schemas.openxmlformats.org/drawingml/2006/main"/>
           <a:p xmlns:a="http://schemas.openxmlformats.org/drawingml/2006/main">
             <a:pPr>
-              <a:defRPr sz="1950" b="0">
+              <a:defRPr sz="2325" b="1">
                 <a:solidFill>
                   <a:srgbClr val="202723"/>
                 </a:solidFill>
@@ -5865,7 +6155,7 @@
               </a:defRPr>
             </a:pPr>
             <a:r>
-              <a:rPr sz="1950" b="0">
+              <a:rPr sz="2325" b="1">
                 <a:solidFill>
                   <a:srgbClr val="202723"/>
                 </a:solidFill>
@@ -5873,29 +6163,29 @@
                 <a:ea typeface="Arial"/>
                 <a:cs typeface="Arial"/>
               </a:rPr>
-              <a:t>One non-production integration, evidence pack, and issue log.</a:t>
-            </a:r>
-          </a:p>
-        </p:txBody>
-      </p:sp>
-      <p:sp>
-        <p:nvSpPr>
-          <p:cNvPr id="14" name="phase-03">
-            <a:extLst xmlns:a="http://schemas.openxmlformats.org/drawingml/2006/main">
-              <a:ext uri="{FF2B5EF4-FFF2-40B4-BE49-F238E27FC236}">
-                <a16:creationId xmlns:a16="http://schemas.microsoft.com/office/drawing/2014/main" id="{67FA1F05-D398-454C-86BB-F63D3DF4EE6A}"/>
-              </a:ext>
-            </a:extLst>
-          </p:cNvPr>
-          <p:cNvSpPr>
-            <a:spLocks xmlns:a="http://schemas.openxmlformats.org/drawingml/2006/main" noGrp="1"/>
-          </p:cNvSpPr>
-          <p:nvPr/>
-        </p:nvSpPr>
-        <p:spPr>
-          <a:xfrm xmlns:a="http://schemas.openxmlformats.org/drawingml/2006/main">
-            <a:off x="609600" y="4676775"/>
-            <a:ext cx="990600" cy="666750"/>
+              <a:t>Days 16–45 / Prove</a:t>
+            </a:r>
+          </a:p>
+        </p:txBody>
+      </p:sp>
+      <p:sp>
+        <p:nvSpPr>
+          <p:cNvPr id="14" name="phase-body-02">
+            <a:extLst xmlns:a="http://schemas.openxmlformats.org/drawingml/2006/main">
+              <a:ext uri="{FF2B5EF4-FFF2-40B4-BE49-F238E27FC236}">
+                <a16:creationId xmlns:a16="http://schemas.microsoft.com/office/drawing/2014/main" id="{92DE5B6D-1764-4BBD-9D74-B92EE4AA21BC}"/>
+              </a:ext>
+            </a:extLst>
+          </p:cNvPr>
+          <p:cNvSpPr>
+            <a:spLocks xmlns:a="http://schemas.openxmlformats.org/drawingml/2006/main" noGrp="1"/>
+          </p:cNvSpPr>
+          <p:nvPr/>
+        </p:nvSpPr>
+        <p:spPr>
+          <a:xfrm xmlns:a="http://schemas.openxmlformats.org/drawingml/2006/main">
+            <a:off x="1943100" y="4086225"/>
+            <a:ext cx="9639300" cy="428625"/>
           </a:xfrm>
           <a:prstGeom xmlns:a="http://schemas.openxmlformats.org/drawingml/2006/main" prst="rect">
             <a:avLst/>
@@ -5913,47 +6203,47 @@
           <a:lstStyle xmlns:a="http://schemas.openxmlformats.org/drawingml/2006/main"/>
           <a:p xmlns:a="http://schemas.openxmlformats.org/drawingml/2006/main">
             <a:pPr>
-              <a:defRPr sz="4050" b="1">
-                <a:solidFill>
-                  <a:srgbClr val="31684B"/>
-                </a:solidFill>
-                <a:latin typeface="Arial"/>
-                <a:ea typeface="Arial"/>
-                <a:cs typeface="Arial"/>
-              </a:defRPr>
-            </a:pPr>
-            <a:r>
-              <a:rPr sz="4050" b="1">
-                <a:solidFill>
-                  <a:srgbClr val="31684B"/>
-                </a:solidFill>
-                <a:latin typeface="Arial"/>
-                <a:ea typeface="Arial"/>
-                <a:cs typeface="Arial"/>
-              </a:rPr>
-              <a:t>03</a:t>
-            </a:r>
-          </a:p>
-        </p:txBody>
-      </p:sp>
-      <p:sp>
-        <p:nvSpPr>
-          <p:cNvPr id="15" name="phase-title-03">
-            <a:extLst xmlns:a="http://schemas.openxmlformats.org/drawingml/2006/main">
-              <a:ext uri="{FF2B5EF4-FFF2-40B4-BE49-F238E27FC236}">
-                <a16:creationId xmlns:a16="http://schemas.microsoft.com/office/drawing/2014/main" id="{BEADE460-14C1-4BEA-AC8B-E1EE1D0614A3}"/>
-              </a:ext>
-            </a:extLst>
-          </p:cNvPr>
-          <p:cNvSpPr>
-            <a:spLocks xmlns:a="http://schemas.openxmlformats.org/drawingml/2006/main" noGrp="1"/>
-          </p:cNvSpPr>
-          <p:nvPr/>
-        </p:nvSpPr>
-        <p:spPr>
-          <a:xfrm xmlns:a="http://schemas.openxmlformats.org/drawingml/2006/main">
-            <a:off x="1943100" y="4676775"/>
-            <a:ext cx="9639300" cy="400050"/>
+              <a:defRPr sz="1950" b="0">
+                <a:solidFill>
+                  <a:srgbClr val="202723"/>
+                </a:solidFill>
+                <a:latin typeface="Arial"/>
+                <a:ea typeface="Arial"/>
+                <a:cs typeface="Arial"/>
+              </a:defRPr>
+            </a:pPr>
+            <a:r>
+              <a:rPr sz="1950" b="0">
+                <a:solidFill>
+                  <a:srgbClr val="202723"/>
+                </a:solidFill>
+                <a:latin typeface="Arial"/>
+                <a:ea typeface="Arial"/>
+                <a:cs typeface="Arial"/>
+              </a:rPr>
+              <a:t>One non-production integration, evidence pack, and issue log.</a:t>
+            </a:r>
+          </a:p>
+        </p:txBody>
+      </p:sp>
+      <p:sp>
+        <p:nvSpPr>
+          <p:cNvPr id="15" name="phase-03">
+            <a:extLst xmlns:a="http://schemas.openxmlformats.org/drawingml/2006/main">
+              <a:ext uri="{FF2B5EF4-FFF2-40B4-BE49-F238E27FC236}">
+                <a16:creationId xmlns:a16="http://schemas.microsoft.com/office/drawing/2014/main" id="{20CD735D-8E03-4493-8673-BD26920608B3}"/>
+              </a:ext>
+            </a:extLst>
+          </p:cNvPr>
+          <p:cNvSpPr>
+            <a:spLocks xmlns:a="http://schemas.openxmlformats.org/drawingml/2006/main" noGrp="1"/>
+          </p:cNvSpPr>
+          <p:nvPr/>
+        </p:nvSpPr>
+        <p:spPr>
+          <a:xfrm xmlns:a="http://schemas.openxmlformats.org/drawingml/2006/main">
+            <a:off x="609600" y="4676775"/>
+            <a:ext cx="990600" cy="666750"/>
           </a:xfrm>
           <a:prstGeom xmlns:a="http://schemas.openxmlformats.org/drawingml/2006/main" prst="rect">
             <a:avLst/>
@@ -5971,47 +6261,47 @@
           <a:lstStyle xmlns:a="http://schemas.openxmlformats.org/drawingml/2006/main"/>
           <a:p xmlns:a="http://schemas.openxmlformats.org/drawingml/2006/main">
             <a:pPr>
-              <a:defRPr sz="2325" b="1">
-                <a:solidFill>
-                  <a:srgbClr val="202723"/>
-                </a:solidFill>
-                <a:latin typeface="Arial"/>
-                <a:ea typeface="Arial"/>
-                <a:cs typeface="Arial"/>
-              </a:defRPr>
-            </a:pPr>
-            <a:r>
-              <a:rPr sz="2325" b="1">
-                <a:solidFill>
-                  <a:srgbClr val="202723"/>
-                </a:solidFill>
-                <a:latin typeface="Arial"/>
-                <a:ea typeface="Arial"/>
-                <a:cs typeface="Arial"/>
-              </a:rPr>
-              <a:t>Days 46–90 / Decide</a:t>
-            </a:r>
-          </a:p>
-        </p:txBody>
-      </p:sp>
-      <p:sp>
-        <p:nvSpPr>
-          <p:cNvPr id="16" name="phase-body-03">
-            <a:extLst xmlns:a="http://schemas.openxmlformats.org/drawingml/2006/main">
-              <a:ext uri="{FF2B5EF4-FFF2-40B4-BE49-F238E27FC236}">
-                <a16:creationId xmlns:a16="http://schemas.microsoft.com/office/drawing/2014/main" id="{6B55D9E2-B978-45A9-BF48-6F16A66841BA}"/>
-              </a:ext>
-            </a:extLst>
-          </p:cNvPr>
-          <p:cNvSpPr>
-            <a:spLocks xmlns:a="http://schemas.openxmlformats.org/drawingml/2006/main" noGrp="1"/>
-          </p:cNvSpPr>
-          <p:nvPr/>
-        </p:nvSpPr>
-        <p:spPr>
-          <a:xfrm xmlns:a="http://schemas.openxmlformats.org/drawingml/2006/main">
-            <a:off x="1943100" y="5153025"/>
-            <a:ext cx="9639300" cy="428625"/>
+              <a:defRPr sz="4050" b="1">
+                <a:solidFill>
+                  <a:srgbClr val="31684B"/>
+                </a:solidFill>
+                <a:latin typeface="Arial"/>
+                <a:ea typeface="Arial"/>
+                <a:cs typeface="Arial"/>
+              </a:defRPr>
+            </a:pPr>
+            <a:r>
+              <a:rPr sz="4050" b="1">
+                <a:solidFill>
+                  <a:srgbClr val="31684B"/>
+                </a:solidFill>
+                <a:latin typeface="Arial"/>
+                <a:ea typeface="Arial"/>
+                <a:cs typeface="Arial"/>
+              </a:rPr>
+              <a:t>03</a:t>
+            </a:r>
+          </a:p>
+        </p:txBody>
+      </p:sp>
+      <p:sp>
+        <p:nvSpPr>
+          <p:cNvPr id="16" name="phase-title-03">
+            <a:extLst xmlns:a="http://schemas.openxmlformats.org/drawingml/2006/main">
+              <a:ext uri="{FF2B5EF4-FFF2-40B4-BE49-F238E27FC236}">
+                <a16:creationId xmlns:a16="http://schemas.microsoft.com/office/drawing/2014/main" id="{7440107E-FC99-4BFE-A6C7-176829F164D3}"/>
+              </a:ext>
+            </a:extLst>
+          </p:cNvPr>
+          <p:cNvSpPr>
+            <a:spLocks xmlns:a="http://schemas.openxmlformats.org/drawingml/2006/main" noGrp="1"/>
+          </p:cNvSpPr>
+          <p:nvPr/>
+        </p:nvSpPr>
+        <p:spPr>
+          <a:xfrm xmlns:a="http://schemas.openxmlformats.org/drawingml/2006/main">
+            <a:off x="1943100" y="4676775"/>
+            <a:ext cx="9639300" cy="400050"/>
           </a:xfrm>
           <a:prstGeom xmlns:a="http://schemas.openxmlformats.org/drawingml/2006/main" prst="rect">
             <a:avLst/>
@@ -6029,7 +6319,7 @@
           <a:lstStyle xmlns:a="http://schemas.openxmlformats.org/drawingml/2006/main"/>
           <a:p xmlns:a="http://schemas.openxmlformats.org/drawingml/2006/main">
             <a:pPr>
-              <a:defRPr sz="1950" b="0">
+              <a:defRPr sz="2325" b="1">
                 <a:solidFill>
                   <a:srgbClr val="202723"/>
                 </a:solidFill>
@@ -6039,7 +6329,7 @@
               </a:defRPr>
             </a:pPr>
             <a:r>
-              <a:rPr sz="1950" b="0">
+              <a:rPr sz="2325" b="1">
                 <a:solidFill>
                   <a:srgbClr val="202723"/>
                 </a:solidFill>
@@ -6047,29 +6337,29 @@
                 <a:ea typeface="Arial"/>
                 <a:cs typeface="Arial"/>
               </a:rPr>
-              <a:t>Go/no-go decision, named gap owners, and operator handoff.</a:t>
-            </a:r>
-          </a:p>
-        </p:txBody>
-      </p:sp>
-      <p:sp>
-        <p:nvSpPr>
-          <p:cNvPr id="17" name="pilot-boundary">
-            <a:extLst xmlns:a="http://schemas.openxmlformats.org/drawingml/2006/main">
-              <a:ext uri="{FF2B5EF4-FFF2-40B4-BE49-F238E27FC236}">
-                <a16:creationId xmlns:a16="http://schemas.microsoft.com/office/drawing/2014/main" id="{5DE5169D-4EDC-4629-8417-C23DCE5A019E}"/>
-              </a:ext>
-            </a:extLst>
-          </p:cNvPr>
-          <p:cNvSpPr>
-            <a:spLocks xmlns:a="http://schemas.openxmlformats.org/drawingml/2006/main" noGrp="1"/>
-          </p:cNvSpPr>
-          <p:nvPr/>
-        </p:nvSpPr>
-        <p:spPr>
-          <a:xfrm xmlns:a="http://schemas.openxmlformats.org/drawingml/2006/main">
-            <a:off x="609600" y="5905500"/>
-            <a:ext cx="10972800" cy="381000"/>
+              <a:t>Days 46–90 / Decide</a:t>
+            </a:r>
+          </a:p>
+        </p:txBody>
+      </p:sp>
+      <p:sp>
+        <p:nvSpPr>
+          <p:cNvPr id="17" name="phase-body-03">
+            <a:extLst xmlns:a="http://schemas.openxmlformats.org/drawingml/2006/main">
+              <a:ext uri="{FF2B5EF4-FFF2-40B4-BE49-F238E27FC236}">
+                <a16:creationId xmlns:a16="http://schemas.microsoft.com/office/drawing/2014/main" id="{817F79B8-028B-4D34-B34D-6C27C8205ACF}"/>
+              </a:ext>
+            </a:extLst>
+          </p:cNvPr>
+          <p:cNvSpPr>
+            <a:spLocks xmlns:a="http://schemas.openxmlformats.org/drawingml/2006/main" noGrp="1"/>
+          </p:cNvSpPr>
+          <p:nvPr/>
+        </p:nvSpPr>
+        <p:spPr>
+          <a:xfrm xmlns:a="http://schemas.openxmlformats.org/drawingml/2006/main">
+            <a:off x="1943100" y="5153025"/>
+            <a:ext cx="9639300" cy="428625"/>
           </a:xfrm>
           <a:prstGeom xmlns:a="http://schemas.openxmlformats.org/drawingml/2006/main" prst="rect">
             <a:avLst/>
@@ -6087,6 +6377,64 @@
           <a:lstStyle xmlns:a="http://schemas.openxmlformats.org/drawingml/2006/main"/>
           <a:p xmlns:a="http://schemas.openxmlformats.org/drawingml/2006/main">
             <a:pPr>
+              <a:defRPr sz="1950" b="0">
+                <a:solidFill>
+                  <a:srgbClr val="202723"/>
+                </a:solidFill>
+                <a:latin typeface="Arial"/>
+                <a:ea typeface="Arial"/>
+                <a:cs typeface="Arial"/>
+              </a:defRPr>
+            </a:pPr>
+            <a:r>
+              <a:rPr sz="1950" b="0">
+                <a:solidFill>
+                  <a:srgbClr val="202723"/>
+                </a:solidFill>
+                <a:latin typeface="Arial"/>
+                <a:ea typeface="Arial"/>
+                <a:cs typeface="Arial"/>
+              </a:rPr>
+              <a:t>Go/no-go decision, named gap owners, and operator handoff.</a:t>
+            </a:r>
+          </a:p>
+        </p:txBody>
+      </p:sp>
+      <p:sp>
+        <p:nvSpPr>
+          <p:cNvPr id="18" name="pilot-boundary">
+            <a:extLst xmlns:a="http://schemas.openxmlformats.org/drawingml/2006/main">
+              <a:ext uri="{FF2B5EF4-FFF2-40B4-BE49-F238E27FC236}">
+                <a16:creationId xmlns:a16="http://schemas.microsoft.com/office/drawing/2014/main" id="{C764D2E0-5168-4BEF-A09C-96560F467494}"/>
+              </a:ext>
+            </a:extLst>
+          </p:cNvPr>
+          <p:cNvSpPr>
+            <a:spLocks xmlns:a="http://schemas.openxmlformats.org/drawingml/2006/main" noGrp="1"/>
+          </p:cNvSpPr>
+          <p:nvPr/>
+        </p:nvSpPr>
+        <p:spPr>
+          <a:xfrm xmlns:a="http://schemas.openxmlformats.org/drawingml/2006/main">
+            <a:off x="609600" y="5905500"/>
+            <a:ext cx="10972800" cy="381000"/>
+          </a:xfrm>
+          <a:prstGeom xmlns:a="http://schemas.openxmlformats.org/drawingml/2006/main" prst="rect">
+            <a:avLst/>
+          </a:prstGeom>
+          <a:noFill xmlns:a="http://schemas.openxmlformats.org/drawingml/2006/main"/>
+          <a:ln xmlns:a="http://schemas.openxmlformats.org/drawingml/2006/main" w="0">
+            <a:noFill/>
+            <a:prstDash val="solid"/>
+          </a:ln>
+        </p:spPr>
+        <p:txBody>
+          <a:bodyPr xmlns:a="http://schemas.openxmlformats.org/drawingml/2006/main" wrap="square" lIns="0" tIns="0" rIns="0" bIns="0">
+            <a:noAutofit/>
+          </a:bodyPr>
+          <a:lstStyle xmlns:a="http://schemas.openxmlformats.org/drawingml/2006/main"/>
+          <a:p xmlns:a="http://schemas.openxmlformats.org/drawingml/2006/main">
+            <a:pPr>
               <a:defRPr sz="1650" b="0">
                 <a:solidFill>
                   <a:srgbClr val="5C6758"/>
@@ -6113,7 +6461,7 @@
     </p:spTree>
     <p:extLst>
       <p:ext uri="{BB962C8B-B14F-4D97-AF65-F5344CB8AC3E}">
-        <p14:creationId xmlns:p14="http://schemas.microsoft.com/office/powerpoint/2010/main" val="1296140042"/>
+        <p14:creationId xmlns:p14="http://schemas.microsoft.com/office/powerpoint/2010/main" val="1544896850"/>
       </p:ext>
     </p:extLst>
   </p:cSld>
@@ -6141,10 +6489,10 @@
       </p:grpSpPr>
       <p:sp>
         <p:nvSpPr>
-          <p:cNvPr id="11" name="Hormuz mark boundary">
-            <a:extLst xmlns:a="http://schemas.openxmlformats.org/drawingml/2006/main">
-              <a:ext uri="{FF2B5EF4-FFF2-40B4-BE49-F238E27FC236}">
-                <a16:creationId xmlns:a16="http://schemas.microsoft.com/office/drawing/2014/main" id="{7A33625F-7897-453F-9B1D-63758C74E241}"/>
+          <p:cNvPr id="12" name="Hormuz mark boundary">
+            <a:extLst xmlns:a="http://schemas.openxmlformats.org/drawingml/2006/main">
+              <a:ext uri="{FF2B5EF4-FFF2-40B4-BE49-F238E27FC236}">
+                <a16:creationId xmlns:a16="http://schemas.microsoft.com/office/drawing/2014/main" id="{1866E042-7D9E-4508-B94C-C97686025ACB}"/>
               </a:ext>
             </a:extLst>
           </p:cNvPr>
@@ -6175,7 +6523,7 @@
           <p:cNvPr id="2" name="Hormuz mark bar 1">
             <a:extLst xmlns:a="http://schemas.openxmlformats.org/drawingml/2006/main">
               <a:ext uri="{FF2B5EF4-FFF2-40B4-BE49-F238E27FC236}">
-                <a16:creationId xmlns:a16="http://schemas.microsoft.com/office/drawing/2014/main" id="{834E8796-98E0-4871-8696-64021AEA154F}"/>
+                <a16:creationId xmlns:a16="http://schemas.microsoft.com/office/drawing/2014/main" id="{1A0EB7BF-3228-46EC-8247-FC4C9CAB6BE3}"/>
               </a:ext>
             </a:extLst>
           </p:cNvPr>
@@ -6207,7 +6555,7 @@
           <p:cNvPr id="3" name="Hormuz mark bar 2">
             <a:extLst xmlns:a="http://schemas.openxmlformats.org/drawingml/2006/main">
               <a:ext uri="{FF2B5EF4-FFF2-40B4-BE49-F238E27FC236}">
-                <a16:creationId xmlns:a16="http://schemas.microsoft.com/office/drawing/2014/main" id="{52202C97-7226-4E66-8B4E-FBF2D338C676}"/>
+                <a16:creationId xmlns:a16="http://schemas.microsoft.com/office/drawing/2014/main" id="{EE9D4311-9E6E-4A1C-91D9-66A35E74A2F4}"/>
               </a:ext>
             </a:extLst>
           </p:cNvPr>
@@ -6239,7 +6587,7 @@
           <p:cNvPr id="4" name="Hormuz mark bar 3">
             <a:extLst xmlns:a="http://schemas.openxmlformats.org/drawingml/2006/main">
               <a:ext uri="{FF2B5EF4-FFF2-40B4-BE49-F238E27FC236}">
-                <a16:creationId xmlns:a16="http://schemas.microsoft.com/office/drawing/2014/main" id="{D1789038-A2FE-46FE-8D38-11461431DB2F}"/>
+                <a16:creationId xmlns:a16="http://schemas.microsoft.com/office/drawing/2014/main" id="{35EB695D-A5F9-458B-A10E-FE8D9397DEF5}"/>
               </a:ext>
             </a:extLst>
           </p:cNvPr>
@@ -6271,7 +6619,7 @@
           <p:cNvPr id="5" name="section">
             <a:extLst xmlns:a="http://schemas.openxmlformats.org/drawingml/2006/main">
               <a:ext uri="{FF2B5EF4-FFF2-40B4-BE49-F238E27FC236}">
-                <a16:creationId xmlns:a16="http://schemas.microsoft.com/office/drawing/2014/main" id="{2335B92C-726C-4E41-BD37-3DD2B9450835}"/>
+                <a16:creationId xmlns:a16="http://schemas.microsoft.com/office/drawing/2014/main" id="{34A8E6D3-DBF9-4998-AC5C-772616443F57}"/>
               </a:ext>
             </a:extLst>
           </p:cNvPr>
@@ -6329,7 +6677,7 @@
           <p:cNvPr id="6" name="takeaway">
             <a:extLst xmlns:a="http://schemas.openxmlformats.org/drawingml/2006/main">
               <a:ext uri="{FF2B5EF4-FFF2-40B4-BE49-F238E27FC236}">
-                <a16:creationId xmlns:a16="http://schemas.microsoft.com/office/drawing/2014/main" id="{BE693FC7-8F5B-4372-9796-50526E0DAF6B}"/>
+                <a16:creationId xmlns:a16="http://schemas.microsoft.com/office/drawing/2014/main" id="{5F284DE5-2CBE-44BC-AF5D-7FCCFAB9DD18}"/>
               </a:ext>
             </a:extLst>
           </p:cNvPr>
@@ -6387,7 +6735,7 @@
           <p:cNvPr id="7" name="footer">
             <a:extLst xmlns:a="http://schemas.openxmlformats.org/drawingml/2006/main">
               <a:ext uri="{FF2B5EF4-FFF2-40B4-BE49-F238E27FC236}">
-                <a16:creationId xmlns:a16="http://schemas.microsoft.com/office/drawing/2014/main" id="{0153BEC5-F63D-4C18-A426-62F21AEB3B9E}"/>
+                <a16:creationId xmlns:a16="http://schemas.microsoft.com/office/drawing/2014/main" id="{89E207F7-81C6-437A-B775-B727A211AAC2}"/>
               </a:ext>
             </a:extLst>
           </p:cNvPr>
@@ -6399,7 +6747,7 @@
         <p:spPr>
           <a:xfrm xmlns:a="http://schemas.openxmlformats.org/drawingml/2006/main">
             <a:off x="609600" y="6400800"/>
-            <a:ext cx="10972800" cy="228600"/>
+            <a:ext cx="9525000" cy="228600"/>
           </a:xfrm>
           <a:prstGeom xmlns:a="http://schemas.openxmlformats.org/drawingml/2006/main" prst="rect">
             <a:avLst/>
@@ -6435,29 +6783,29 @@
                 <a:ea typeface="Arial"/>
                 <a:cs typeface="Arial"/>
               </a:rPr>
-              <a:t>HORMUZ  /  Mehrdad Zaker  /  September 2026                                      07 / 07</a:t>
-            </a:r>
-          </a:p>
-        </p:txBody>
-      </p:sp>
-      <p:sp>
-        <p:nvSpPr>
-          <p:cNvPr id="8" name="next-step">
-            <a:extLst xmlns:a="http://schemas.openxmlformats.org/drawingml/2006/main">
-              <a:ext uri="{FF2B5EF4-FFF2-40B4-BE49-F238E27FC236}">
-                <a16:creationId xmlns:a16="http://schemas.microsoft.com/office/drawing/2014/main" id="{B5AD76F6-0655-4E41-89CF-BA630CD86778}"/>
-              </a:ext>
-            </a:extLst>
-          </p:cNvPr>
-          <p:cNvSpPr>
-            <a:spLocks xmlns:a="http://schemas.openxmlformats.org/drawingml/2006/main" noGrp="1"/>
-          </p:cNvSpPr>
-          <p:nvPr/>
-        </p:nvSpPr>
-        <p:spPr>
-          <a:xfrm xmlns:a="http://schemas.openxmlformats.org/drawingml/2006/main">
-            <a:off x="609600" y="2667000"/>
-            <a:ext cx="10858500" cy="1885950"/>
+              <a:t>HORMUZ  /  A product of Neuralint  /  Mehrdad Zaker  /  September 2026</a:t>
+            </a:r>
+          </a:p>
+        </p:txBody>
+      </p:sp>
+      <p:sp>
+        <p:nvSpPr>
+          <p:cNvPr id="8" name="page-number">
+            <a:extLst xmlns:a="http://schemas.openxmlformats.org/drawingml/2006/main">
+              <a:ext uri="{FF2B5EF4-FFF2-40B4-BE49-F238E27FC236}">
+                <a16:creationId xmlns:a16="http://schemas.microsoft.com/office/drawing/2014/main" id="{774D8CBC-73B1-4CBE-99C5-891603F84959}"/>
+              </a:ext>
+            </a:extLst>
+          </p:cNvPr>
+          <p:cNvSpPr>
+            <a:spLocks xmlns:a="http://schemas.openxmlformats.org/drawingml/2006/main" noGrp="1"/>
+          </p:cNvSpPr>
+          <p:nvPr/>
+        </p:nvSpPr>
+        <p:spPr>
+          <a:xfrm xmlns:a="http://schemas.openxmlformats.org/drawingml/2006/main">
+            <a:off x="10972800" y="6400800"/>
+            <a:ext cx="609600" cy="228600"/>
           </a:xfrm>
           <a:prstGeom xmlns:a="http://schemas.openxmlformats.org/drawingml/2006/main" prst="rect">
             <a:avLst/>
@@ -6475,93 +6823,47 @@
           <a:lstStyle xmlns:a="http://schemas.openxmlformats.org/drawingml/2006/main"/>
           <a:p xmlns:a="http://schemas.openxmlformats.org/drawingml/2006/main">
             <a:pPr>
-              <a:defRPr sz="3300" b="0">
-                <a:solidFill>
-                  <a:srgbClr val="FAFBF6"/>
-                </a:solidFill>
-                <a:latin typeface="Arial"/>
-                <a:ea typeface="Arial"/>
-                <a:cs typeface="Arial"/>
-              </a:defRPr>
-            </a:pPr>
-            <a:r>
-              <a:rPr sz="3300" b="0">
-                <a:solidFill>
-                  <a:srgbClr val="FAFBF6"/>
-                </a:solidFill>
-                <a:latin typeface="Arial"/>
-                <a:ea typeface="Arial"/>
-                <a:cs typeface="Arial"/>
-              </a:rPr>
-              <a:t>Which client? Which team?</a:t>
-            </a:r>
-          </a:p>
-          <a:p xmlns:a="http://schemas.openxmlformats.org/drawingml/2006/main">
-            <a:pPr>
-              <a:defRPr sz="3300" b="0">
-                <a:solidFill>
-                  <a:srgbClr val="FAFBF6"/>
-                </a:solidFill>
-                <a:latin typeface="Arial"/>
-                <a:ea typeface="Arial"/>
-                <a:cs typeface="Arial"/>
-              </a:defRPr>
-            </a:pPr>
-            <a:r>
-              <a:rPr sz="3300" b="0">
-                <a:solidFill>
-                  <a:srgbClr val="FAFBF6"/>
-                </a:solidFill>
-                <a:latin typeface="Arial"/>
-                <a:ea typeface="Arial"/>
-                <a:cs typeface="Arial"/>
-              </a:rPr>
-              <a:t>Which control is missing?</a:t>
-            </a:r>
-          </a:p>
-          <a:p xmlns:a="http://schemas.openxmlformats.org/drawingml/2006/main">
-            <a:pPr>
-              <a:defRPr sz="3300" b="0">
-                <a:solidFill>
-                  <a:srgbClr val="FAFBF6"/>
-                </a:solidFill>
-                <a:latin typeface="Arial"/>
-                <a:ea typeface="Arial"/>
-                <a:cs typeface="Arial"/>
-              </a:defRPr>
-            </a:pPr>
-            <a:r>
-              <a:rPr sz="3300" b="0">
-                <a:solidFill>
-                  <a:srgbClr val="FAFBF6"/>
-                </a:solidFill>
-                <a:latin typeface="Arial"/>
-                <a:ea typeface="Arial"/>
-                <a:cs typeface="Arial"/>
-              </a:rPr>
-              <a:t>Who operates the route?</a:t>
-            </a:r>
-          </a:p>
-        </p:txBody>
-      </p:sp>
-      <p:sp>
-        <p:nvSpPr>
-          <p:cNvPr id="9" name="contact">
-            <a:extLst xmlns:a="http://schemas.openxmlformats.org/drawingml/2006/main">
-              <a:ext uri="{FF2B5EF4-FFF2-40B4-BE49-F238E27FC236}">
-                <a16:creationId xmlns:a16="http://schemas.microsoft.com/office/drawing/2014/main" id="{72C633C7-F8A6-41BE-B1FE-37828623C26D}"/>
-              </a:ext>
-            </a:extLst>
-          </p:cNvPr>
-          <p:cNvSpPr>
-            <a:spLocks xmlns:a="http://schemas.openxmlformats.org/drawingml/2006/main" noGrp="1"/>
-          </p:cNvSpPr>
-          <p:nvPr/>
-        </p:nvSpPr>
-        <p:spPr>
-          <a:xfrm xmlns:a="http://schemas.openxmlformats.org/drawingml/2006/main">
-            <a:off x="609600" y="4857750"/>
-            <a:ext cx="10858500" cy="819150"/>
+              <a:defRPr sz="1275" b="0">
+                <a:solidFill>
+                  <a:srgbClr val="DCE6D5"/>
+                </a:solidFill>
+                <a:latin typeface="Arial"/>
+                <a:ea typeface="Arial"/>
+                <a:cs typeface="Arial"/>
+              </a:defRPr>
+            </a:pPr>
+            <a:r>
+              <a:rPr sz="1275" b="0">
+                <a:solidFill>
+                  <a:srgbClr val="DCE6D5"/>
+                </a:solidFill>
+                <a:latin typeface="Arial"/>
+                <a:ea typeface="Arial"/>
+                <a:cs typeface="Arial"/>
+              </a:rPr>
+              <a:t>07 / 07</a:t>
+            </a:r>
+          </a:p>
+        </p:txBody>
+      </p:sp>
+      <p:sp>
+        <p:nvSpPr>
+          <p:cNvPr id="9" name="next-step">
+            <a:extLst xmlns:a="http://schemas.openxmlformats.org/drawingml/2006/main">
+              <a:ext uri="{FF2B5EF4-FFF2-40B4-BE49-F238E27FC236}">
+                <a16:creationId xmlns:a16="http://schemas.microsoft.com/office/drawing/2014/main" id="{89EE2300-DF5F-4A39-AD60-53C0BF2F4923}"/>
+              </a:ext>
+            </a:extLst>
+          </p:cNvPr>
+          <p:cNvSpPr>
+            <a:spLocks xmlns:a="http://schemas.openxmlformats.org/drawingml/2006/main" noGrp="1"/>
+          </p:cNvSpPr>
+          <p:nvPr/>
+        </p:nvSpPr>
+        <p:spPr>
+          <a:xfrm xmlns:a="http://schemas.openxmlformats.org/drawingml/2006/main">
+            <a:off x="609600" y="2667000"/>
+            <a:ext cx="10858500" cy="1885950"/>
           </a:xfrm>
           <a:prstGeom xmlns:a="http://schemas.openxmlformats.org/drawingml/2006/main" prst="rect">
             <a:avLst/>
@@ -6579,70 +6881,93 @@
           <a:lstStyle xmlns:a="http://schemas.openxmlformats.org/drawingml/2006/main"/>
           <a:p xmlns:a="http://schemas.openxmlformats.org/drawingml/2006/main">
             <a:pPr>
-              <a:defRPr sz="2325" b="1">
-                <a:solidFill>
-                  <a:srgbClr val="DCEDA6"/>
-                </a:solidFill>
-                <a:latin typeface="Arial"/>
-                <a:ea typeface="Arial"/>
-                <a:cs typeface="Arial"/>
-              </a:defRPr>
-            </a:pPr>
-            <a:r>
-              <a:rPr sz="2325" b="1">
-                <a:solidFill>
-                  <a:srgbClr val="DCEDA6"/>
-                </a:solidFill>
-                <a:latin typeface="Arial"/>
-                <a:ea typeface="Arial"/>
-                <a:cs typeface="Arial"/>
-              </a:rPr>
-              <a:t>Mehrdad Zaker</a:t>
-            </a:r>
-          </a:p>
-          <a:p xmlns:a="http://schemas.openxmlformats.org/drawingml/2006/main">
-            <a:pPr>
-              <a:defRPr sz="2325" b="1">
-                <a:solidFill>
-                  <a:srgbClr val="DCEDA6"/>
-                </a:solidFill>
-                <a:latin typeface="Arial"/>
-                <a:ea typeface="Arial"/>
-                <a:cs typeface="Arial"/>
-              </a:defRPr>
-            </a:pPr>
-            <a:r>
-              <a:rPr sz="2325" b="1">
-                <a:solidFill>
-                  <a:srgbClr val="DCEDA6"/>
-                </a:solidFill>
-                <a:latin typeface="Arial"/>
-                <a:ea typeface="Arial"/>
-                <a:cs typeface="Arial"/>
-              </a:rPr>
-              <a:t>zaker.mehrdad@gmail.com</a:t>
-            </a:r>
-          </a:p>
-        </p:txBody>
-      </p:sp>
-      <p:sp>
-        <p:nvSpPr>
-          <p:cNvPr id="10" name="website">
-            <a:extLst xmlns:a="http://schemas.openxmlformats.org/drawingml/2006/main">
-              <a:ext uri="{FF2B5EF4-FFF2-40B4-BE49-F238E27FC236}">
-                <a16:creationId xmlns:a16="http://schemas.microsoft.com/office/drawing/2014/main" id="{873E3563-38B9-40B0-B4E5-BB417E569BB1}"/>
-              </a:ext>
-            </a:extLst>
-          </p:cNvPr>
-          <p:cNvSpPr>
-            <a:spLocks xmlns:a="http://schemas.openxmlformats.org/drawingml/2006/main" noGrp="1"/>
-          </p:cNvSpPr>
-          <p:nvPr/>
-        </p:nvSpPr>
-        <p:spPr>
-          <a:xfrm xmlns:a="http://schemas.openxmlformats.org/drawingml/2006/main">
-            <a:off x="609600" y="5838825"/>
-            <a:ext cx="10858500" cy="381000"/>
+              <a:defRPr sz="3300" b="0">
+                <a:solidFill>
+                  <a:srgbClr val="FAFBF6"/>
+                </a:solidFill>
+                <a:latin typeface="Arial"/>
+                <a:ea typeface="Arial"/>
+                <a:cs typeface="Arial"/>
+              </a:defRPr>
+            </a:pPr>
+            <a:r>
+              <a:rPr sz="3300" b="0">
+                <a:solidFill>
+                  <a:srgbClr val="FAFBF6"/>
+                </a:solidFill>
+                <a:latin typeface="Arial"/>
+                <a:ea typeface="Arial"/>
+                <a:cs typeface="Arial"/>
+              </a:rPr>
+              <a:t>Which client? Which team?</a:t>
+            </a:r>
+          </a:p>
+          <a:p xmlns:a="http://schemas.openxmlformats.org/drawingml/2006/main">
+            <a:pPr>
+              <a:defRPr sz="3300" b="0">
+                <a:solidFill>
+                  <a:srgbClr val="FAFBF6"/>
+                </a:solidFill>
+                <a:latin typeface="Arial"/>
+                <a:ea typeface="Arial"/>
+                <a:cs typeface="Arial"/>
+              </a:defRPr>
+            </a:pPr>
+            <a:r>
+              <a:rPr sz="3300" b="0">
+                <a:solidFill>
+                  <a:srgbClr val="FAFBF6"/>
+                </a:solidFill>
+                <a:latin typeface="Arial"/>
+                <a:ea typeface="Arial"/>
+                <a:cs typeface="Arial"/>
+              </a:rPr>
+              <a:t>Which control is missing?</a:t>
+            </a:r>
+          </a:p>
+          <a:p xmlns:a="http://schemas.openxmlformats.org/drawingml/2006/main">
+            <a:pPr>
+              <a:defRPr sz="3300" b="0">
+                <a:solidFill>
+                  <a:srgbClr val="FAFBF6"/>
+                </a:solidFill>
+                <a:latin typeface="Arial"/>
+                <a:ea typeface="Arial"/>
+                <a:cs typeface="Arial"/>
+              </a:defRPr>
+            </a:pPr>
+            <a:r>
+              <a:rPr sz="3300" b="0">
+                <a:solidFill>
+                  <a:srgbClr val="FAFBF6"/>
+                </a:solidFill>
+                <a:latin typeface="Arial"/>
+                <a:ea typeface="Arial"/>
+                <a:cs typeface="Arial"/>
+              </a:rPr>
+              <a:t>Who operates the route?</a:t>
+            </a:r>
+          </a:p>
+        </p:txBody>
+      </p:sp>
+      <p:sp>
+        <p:nvSpPr>
+          <p:cNvPr id="10" name="contact">
+            <a:extLst xmlns:a="http://schemas.openxmlformats.org/drawingml/2006/main">
+              <a:ext uri="{FF2B5EF4-FFF2-40B4-BE49-F238E27FC236}">
+                <a16:creationId xmlns:a16="http://schemas.microsoft.com/office/drawing/2014/main" id="{C47A4B12-591F-4DDA-9272-214E7A25335E}"/>
+              </a:ext>
+            </a:extLst>
+          </p:cNvPr>
+          <p:cNvSpPr>
+            <a:spLocks xmlns:a="http://schemas.openxmlformats.org/drawingml/2006/main" noGrp="1"/>
+          </p:cNvSpPr>
+          <p:nvPr/>
+        </p:nvSpPr>
+        <p:spPr>
+          <a:xfrm xmlns:a="http://schemas.openxmlformats.org/drawingml/2006/main">
+            <a:off x="609600" y="4857750"/>
+            <a:ext cx="10858500" cy="819150"/>
           </a:xfrm>
           <a:prstGeom xmlns:a="http://schemas.openxmlformats.org/drawingml/2006/main" prst="rect">
             <a:avLst/>
@@ -6660,6 +6985,87 @@
           <a:lstStyle xmlns:a="http://schemas.openxmlformats.org/drawingml/2006/main"/>
           <a:p xmlns:a="http://schemas.openxmlformats.org/drawingml/2006/main">
             <a:pPr>
+              <a:defRPr sz="2325" b="1">
+                <a:solidFill>
+                  <a:srgbClr val="DCEDA6"/>
+                </a:solidFill>
+                <a:latin typeface="Arial"/>
+                <a:ea typeface="Arial"/>
+                <a:cs typeface="Arial"/>
+              </a:defRPr>
+            </a:pPr>
+            <a:r>
+              <a:rPr sz="2325" b="1">
+                <a:solidFill>
+                  <a:srgbClr val="DCEDA6"/>
+                </a:solidFill>
+                <a:latin typeface="Arial"/>
+                <a:ea typeface="Arial"/>
+                <a:cs typeface="Arial"/>
+              </a:rPr>
+              <a:t>Mehrdad Zaker</a:t>
+            </a:r>
+          </a:p>
+          <a:p xmlns:a="http://schemas.openxmlformats.org/drawingml/2006/main">
+            <a:pPr>
+              <a:defRPr sz="2325" b="1">
+                <a:solidFill>
+                  <a:srgbClr val="DCEDA6"/>
+                </a:solidFill>
+                <a:latin typeface="Arial"/>
+                <a:ea typeface="Arial"/>
+                <a:cs typeface="Arial"/>
+              </a:defRPr>
+            </a:pPr>
+            <a:r>
+              <a:rPr sz="2325" b="1">
+                <a:solidFill>
+                  <a:srgbClr val="DCEDA6"/>
+                </a:solidFill>
+                <a:latin typeface="Arial"/>
+                <a:ea typeface="Arial"/>
+                <a:cs typeface="Arial"/>
+              </a:rPr>
+              <a:t>mehrdadz@neuralint.io</a:t>
+            </a:r>
+          </a:p>
+        </p:txBody>
+      </p:sp>
+      <p:sp>
+        <p:nvSpPr>
+          <p:cNvPr id="11" name="website">
+            <a:extLst xmlns:a="http://schemas.openxmlformats.org/drawingml/2006/main">
+              <a:ext uri="{FF2B5EF4-FFF2-40B4-BE49-F238E27FC236}">
+                <a16:creationId xmlns:a16="http://schemas.microsoft.com/office/drawing/2014/main" id="{82219D55-44ED-4DC5-8BD8-2EFFA6F8CF2F}"/>
+              </a:ext>
+            </a:extLst>
+          </p:cNvPr>
+          <p:cNvSpPr>
+            <a:spLocks xmlns:a="http://schemas.openxmlformats.org/drawingml/2006/main" noGrp="1"/>
+          </p:cNvSpPr>
+          <p:nvPr/>
+        </p:nvSpPr>
+        <p:spPr>
+          <a:xfrm xmlns:a="http://schemas.openxmlformats.org/drawingml/2006/main">
+            <a:off x="609600" y="5838825"/>
+            <a:ext cx="10858500" cy="381000"/>
+          </a:xfrm>
+          <a:prstGeom xmlns:a="http://schemas.openxmlformats.org/drawingml/2006/main" prst="rect">
+            <a:avLst/>
+          </a:prstGeom>
+          <a:noFill xmlns:a="http://schemas.openxmlformats.org/drawingml/2006/main"/>
+          <a:ln xmlns:a="http://schemas.openxmlformats.org/drawingml/2006/main" w="0">
+            <a:noFill/>
+            <a:prstDash val="solid"/>
+          </a:ln>
+        </p:spPr>
+        <p:txBody>
+          <a:bodyPr xmlns:a="http://schemas.openxmlformats.org/drawingml/2006/main" wrap="square" lIns="0" tIns="0" rIns="0" bIns="0">
+            <a:noAutofit/>
+          </a:bodyPr>
+          <a:lstStyle xmlns:a="http://schemas.openxmlformats.org/drawingml/2006/main"/>
+          <a:p xmlns:a="http://schemas.openxmlformats.org/drawingml/2006/main">
+            <a:pPr>
               <a:defRPr sz="1875" b="0">
                 <a:solidFill>
                   <a:srgbClr val="D9E1DF"/>
@@ -6686,7 +7092,7 @@
     </p:spTree>
     <p:extLst>
       <p:ext uri="{BB962C8B-B14F-4D97-AF65-F5344CB8AC3E}">
-        <p14:creationId xmlns:p14="http://schemas.microsoft.com/office/powerpoint/2010/main" val="1628276503"/>
+        <p14:creationId xmlns:p14="http://schemas.microsoft.com/office/powerpoint/2010/main" val="1779482876"/>
       </p:ext>
     </p:extLst>
   </p:cSld>

</xml_diff>

<commit_message>
Adopt the approved passage H across Hormuz brand assets
</commit_message>
<xml_diff>
--- a/website/public/downloads/hormuz-buyer-briefing.pptx
+++ b/website/public/downloads/hormuz-buyer-briefing.pptx
@@ -2,19 +2,19 @@
 <file path=ppt/presentation.xml><?xml version="1.0" encoding="utf-8"?>
 <p:presentation xmlns:p="http://schemas.openxmlformats.org/presentationml/2006/main">
   <p:sldMasterIdLst>
-    <p:sldMasterId xmlns:r="http://schemas.openxmlformats.org/officeDocument/2006/relationships" id="2147483648" r:id="Rcd0c7e07e38e41b3"/>
+    <p:sldMasterId xmlns:r="http://schemas.openxmlformats.org/officeDocument/2006/relationships" id="2147483648" r:id="Ra3aace7adbed4046"/>
   </p:sldMasterIdLst>
   <p:notesMasterIdLst>
-    <p:notesMasterId xmlns:r="http://schemas.openxmlformats.org/officeDocument/2006/relationships" r:id="Rbcf5be65bfd24bbd"/>
+    <p:notesMasterId xmlns:r="http://schemas.openxmlformats.org/officeDocument/2006/relationships" r:id="Rf340521d323d453e"/>
   </p:notesMasterIdLst>
   <p:sldIdLst>
-    <p:sldId xmlns:r="http://schemas.openxmlformats.org/officeDocument/2006/relationships" id="256" r:id="R7a8054394795479f"/>
-    <p:sldId xmlns:r="http://schemas.openxmlformats.org/officeDocument/2006/relationships" id="257" r:id="R20531e4fea7646a6"/>
-    <p:sldId xmlns:r="http://schemas.openxmlformats.org/officeDocument/2006/relationships" id="258" r:id="Rd520fa6987eb4d73"/>
-    <p:sldId xmlns:r="http://schemas.openxmlformats.org/officeDocument/2006/relationships" id="259" r:id="R76120a6307804c4c"/>
-    <p:sldId xmlns:r="http://schemas.openxmlformats.org/officeDocument/2006/relationships" id="260" r:id="Re8a19d8fcfd14355"/>
-    <p:sldId xmlns:r="http://schemas.openxmlformats.org/officeDocument/2006/relationships" id="261" r:id="Rc1aa2f99143447ed"/>
-    <p:sldId xmlns:r="http://schemas.openxmlformats.org/officeDocument/2006/relationships" id="262" r:id="R4eaff636ae2e4d3f"/>
+    <p:sldId xmlns:r="http://schemas.openxmlformats.org/officeDocument/2006/relationships" id="256" r:id="R2af7859b638f4a90"/>
+    <p:sldId xmlns:r="http://schemas.openxmlformats.org/officeDocument/2006/relationships" id="257" r:id="R3012093706e24e2e"/>
+    <p:sldId xmlns:r="http://schemas.openxmlformats.org/officeDocument/2006/relationships" id="258" r:id="Rf985a675096e4343"/>
+    <p:sldId xmlns:r="http://schemas.openxmlformats.org/officeDocument/2006/relationships" id="259" r:id="R11a8213a72b9418d"/>
+    <p:sldId xmlns:r="http://schemas.openxmlformats.org/officeDocument/2006/relationships" id="260" r:id="R7378b605b8ed4834"/>
+    <p:sldId xmlns:r="http://schemas.openxmlformats.org/officeDocument/2006/relationships" id="261" r:id="Rd9a738c819b843b5"/>
+    <p:sldId xmlns:r="http://schemas.openxmlformats.org/officeDocument/2006/relationships" id="262" r:id="R2f31c2cb7e494864"/>
   </p:sldIdLst>
   <p:sldSz cx="12192000" cy="6858000"/>
   <p:notesSz cx="6858000" cy="9144000"/>
@@ -1116,7 +1116,7 @@
   </p:cSld>
   <p:clrMap bg1="lt1" tx1="dk1" bg2="lt2" tx2="dk2" accent1="accent1" accent2="accent2" accent3="accent3" accent4="accent4" accent5="accent5" accent6="accent6" hlink="hlink" folHlink="folHlink"/>
   <p:sldLayoutIdLst>
-    <p:sldLayoutId xmlns:r="http://schemas.openxmlformats.org/officeDocument/2006/relationships" id="2147483649" r:id="R8e0878a4228741fb"/>
+    <p:sldLayoutId xmlns:r="http://schemas.openxmlformats.org/officeDocument/2006/relationships" id="2147483649" r:id="Rfdf999c7227c4eee"/>
   </p:sldLayoutIdLst>
   <p:txStyles>
     <p:titleStyle>
@@ -1662,139 +1662,40 @@
       <p:grpSpPr>
         <a:xfrm xmlns:a="http://schemas.openxmlformats.org/drawingml/2006/main"/>
       </p:grpSpPr>
-      <p:sp>
-        <p:nvSpPr>
-          <p:cNvPr id="11" name="Hormuz mark boundary">
-            <a:extLst xmlns:a="http://schemas.openxmlformats.org/drawingml/2006/main">
-              <a:ext uri="{FF2B5EF4-FFF2-40B4-BE49-F238E27FC236}">
-                <a16:creationId xmlns:a16="http://schemas.microsoft.com/office/drawing/2014/main" id="{B0BF9A4E-E4B8-4521-8622-39C249134BEF}"/>
-              </a:ext>
-            </a:extLst>
-          </p:cNvPr>
-          <p:cNvSpPr>
-            <a:spLocks xmlns:a="http://schemas.openxmlformats.org/drawingml/2006/main" noGrp="1"/>
-          </p:cNvSpPr>
-          <p:nvPr/>
-        </p:nvSpPr>
+      <p:pic>
+        <p:nvPicPr>
+          <p:cNvPr id="8" name=""/>
+          <p:cNvPicPr>
+            <a:picLocks xmlns:a="http://schemas.openxmlformats.org/drawingml/2006/main" noChangeAspect="1"/>
+          </p:cNvPicPr>
+          <p:nvPr/>
+        </p:nvPicPr>
+        <p:blipFill>
+          <a:blip xmlns:r="http://schemas.openxmlformats.org/officeDocument/2006/relationships" xmlns:a="http://schemas.openxmlformats.org/drawingml/2006/main" r:embed="Rfe905ca50ebf469e">
+            <a:extLst>
+              <a:ext uri="{96DAC541-7B7A-43D3-8B79-37D633B846F1}">
+                <asvg:svgBlip xmlns:asvg="http://schemas.microsoft.com/office/drawing/2016/SVG/main" r:embed="Rade40133d7454587"/>
+              </a:ext>
+            </a:extLst>
+          </a:blip>
+          <a:stretch xmlns:a="http://schemas.openxmlformats.org/drawingml/2006/main"/>
+        </p:blipFill>
         <p:spPr>
           <a:xfrm xmlns:a="http://schemas.openxmlformats.org/drawingml/2006/main">
             <a:off x="11201400" y="333375"/>
             <a:ext cx="381000" cy="381000"/>
           </a:xfrm>
-          <a:prstGeom xmlns:a="http://schemas.openxmlformats.org/drawingml/2006/main" prst="ellipse">
-            <a:avLst/>
-          </a:prstGeom>
-          <a:noFill xmlns:a="http://schemas.openxmlformats.org/drawingml/2006/main"/>
-          <a:ln xmlns:a="http://schemas.openxmlformats.org/drawingml/2006/main" w="9525">
-            <a:solidFill>
-              <a:srgbClr val="DCEDA6"/>
-            </a:solidFill>
-            <a:prstDash val="solid"/>
-          </a:ln>
-        </p:spPr>
-      </p:sp>
-      <p:sp>
-        <p:nvSpPr>
-          <p:cNvPr id="2" name="Hormuz mark bar 1">
-            <a:extLst xmlns:a="http://schemas.openxmlformats.org/drawingml/2006/main">
-              <a:ext uri="{FF2B5EF4-FFF2-40B4-BE49-F238E27FC236}">
-                <a16:creationId xmlns:a16="http://schemas.microsoft.com/office/drawing/2014/main" id="{EF0088F8-7E6E-402B-AD04-7606A2BD4261}"/>
-              </a:ext>
-            </a:extLst>
-          </p:cNvPr>
-          <p:cNvSpPr>
-            <a:spLocks xmlns:a="http://schemas.openxmlformats.org/drawingml/2006/main" noGrp="1"/>
-          </p:cNvSpPr>
-          <p:nvPr/>
-        </p:nvSpPr>
-        <p:spPr>
-          <a:xfrm xmlns:a="http://schemas.openxmlformats.org/drawingml/2006/main">
-            <a:off x="11287125" y="476250"/>
-            <a:ext cx="47625" cy="95250"/>
-          </a:xfrm>
-          <a:prstGeom xmlns:a="http://schemas.openxmlformats.org/drawingml/2006/main" prst="roundRect">
-            <a:avLst>
-              <a:gd name="adj" fmla="val 50000"/>
-            </a:avLst>
-          </a:prstGeom>
-          <a:solidFill xmlns:a="http://schemas.openxmlformats.org/drawingml/2006/main">
-            <a:srgbClr val="DCEDA6"/>
-          </a:solidFill>
-          <a:ln xmlns:a="http://schemas.openxmlformats.org/drawingml/2006/main" w="0">
-            <a:noFill/>
-          </a:ln>
-        </p:spPr>
-      </p:sp>
-      <p:sp>
-        <p:nvSpPr>
-          <p:cNvPr id="3" name="Hormuz mark bar 2">
-            <a:extLst xmlns:a="http://schemas.openxmlformats.org/drawingml/2006/main">
-              <a:ext uri="{FF2B5EF4-FFF2-40B4-BE49-F238E27FC236}">
-                <a16:creationId xmlns:a16="http://schemas.microsoft.com/office/drawing/2014/main" id="{54380220-0332-4DC2-98B2-95143AD7C399}"/>
-              </a:ext>
-            </a:extLst>
-          </p:cNvPr>
-          <p:cNvSpPr>
-            <a:spLocks xmlns:a="http://schemas.openxmlformats.org/drawingml/2006/main" noGrp="1"/>
-          </p:cNvSpPr>
-          <p:nvPr/>
-        </p:nvSpPr>
-        <p:spPr>
-          <a:xfrm xmlns:a="http://schemas.openxmlformats.org/drawingml/2006/main">
-            <a:off x="11363325" y="428625"/>
-            <a:ext cx="47625" cy="190500"/>
-          </a:xfrm>
-          <a:prstGeom xmlns:a="http://schemas.openxmlformats.org/drawingml/2006/main" prst="roundRect">
-            <a:avLst>
-              <a:gd name="adj" fmla="val 50000"/>
-            </a:avLst>
-          </a:prstGeom>
-          <a:solidFill xmlns:a="http://schemas.openxmlformats.org/drawingml/2006/main">
-            <a:srgbClr val="DCEDA6"/>
-          </a:solidFill>
-          <a:ln xmlns:a="http://schemas.openxmlformats.org/drawingml/2006/main" w="0">
-            <a:noFill/>
-          </a:ln>
-        </p:spPr>
-      </p:sp>
-      <p:sp>
-        <p:nvSpPr>
-          <p:cNvPr id="4" name="Hormuz mark bar 3">
-            <a:extLst xmlns:a="http://schemas.openxmlformats.org/drawingml/2006/main">
-              <a:ext uri="{FF2B5EF4-FFF2-40B4-BE49-F238E27FC236}">
-                <a16:creationId xmlns:a16="http://schemas.microsoft.com/office/drawing/2014/main" id="{7258B745-79AC-462C-A959-91AB67CCEDEB}"/>
-              </a:ext>
-            </a:extLst>
-          </p:cNvPr>
-          <p:cNvSpPr>
-            <a:spLocks xmlns:a="http://schemas.openxmlformats.org/drawingml/2006/main" noGrp="1"/>
-          </p:cNvSpPr>
-          <p:nvPr/>
-        </p:nvSpPr>
-        <p:spPr>
-          <a:xfrm xmlns:a="http://schemas.openxmlformats.org/drawingml/2006/main">
-            <a:off x="11439525" y="457200"/>
-            <a:ext cx="47625" cy="133350"/>
-          </a:xfrm>
-          <a:prstGeom xmlns:a="http://schemas.openxmlformats.org/drawingml/2006/main" prst="roundRect">
-            <a:avLst>
-              <a:gd name="adj" fmla="val 50000"/>
-            </a:avLst>
-          </a:prstGeom>
-          <a:solidFill xmlns:a="http://schemas.openxmlformats.org/drawingml/2006/main">
-            <a:srgbClr val="DCEDA6"/>
-          </a:solidFill>
-          <a:ln xmlns:a="http://schemas.openxmlformats.org/drawingml/2006/main" w="0">
-            <a:noFill/>
-          </a:ln>
-        </p:spPr>
-      </p:sp>
-      <p:sp>
-        <p:nvSpPr>
-          <p:cNvPr id="5" name="section">
-            <a:extLst xmlns:a="http://schemas.openxmlformats.org/drawingml/2006/main">
-              <a:ext uri="{FF2B5EF4-FFF2-40B4-BE49-F238E27FC236}">
-                <a16:creationId xmlns:a16="http://schemas.microsoft.com/office/drawing/2014/main" id="{572C6C87-0550-4928-9512-30BFE602C035}"/>
+          <a:prstGeom xmlns:a="http://schemas.openxmlformats.org/drawingml/2006/main" prst="rect">
+            <a:avLst/>
+          </a:prstGeom>
+        </p:spPr>
+      </p:pic>
+      <p:sp>
+        <p:nvSpPr>
+          <p:cNvPr id="2" name="section">
+            <a:extLst xmlns:a="http://schemas.openxmlformats.org/drawingml/2006/main">
+              <a:ext uri="{FF2B5EF4-FFF2-40B4-BE49-F238E27FC236}">
+                <a16:creationId xmlns:a16="http://schemas.microsoft.com/office/drawing/2014/main" id="{EEB06EC4-01F6-4F00-8F04-66689B69D49A}"/>
               </a:ext>
             </a:extLst>
           </p:cNvPr>
@@ -1849,10 +1750,10 @@
       </p:sp>
       <p:sp>
         <p:nvSpPr>
-          <p:cNvPr id="6" name="footer">
-            <a:extLst xmlns:a="http://schemas.openxmlformats.org/drawingml/2006/main">
-              <a:ext uri="{FF2B5EF4-FFF2-40B4-BE49-F238E27FC236}">
-                <a16:creationId xmlns:a16="http://schemas.microsoft.com/office/drawing/2014/main" id="{4D898725-1652-4974-827E-B54240544021}"/>
+          <p:cNvPr id="3" name="footer">
+            <a:extLst xmlns:a="http://schemas.openxmlformats.org/drawingml/2006/main">
+              <a:ext uri="{FF2B5EF4-FFF2-40B4-BE49-F238E27FC236}">
+                <a16:creationId xmlns:a16="http://schemas.microsoft.com/office/drawing/2014/main" id="{27967F12-2463-4349-BD50-CCAD0B1F1F54}"/>
               </a:ext>
             </a:extLst>
           </p:cNvPr>
@@ -1907,10 +1808,10 @@
       </p:sp>
       <p:sp>
         <p:nvSpPr>
-          <p:cNvPr id="7" name="page-number">
-            <a:extLst xmlns:a="http://schemas.openxmlformats.org/drawingml/2006/main">
-              <a:ext uri="{FF2B5EF4-FFF2-40B4-BE49-F238E27FC236}">
-                <a16:creationId xmlns:a16="http://schemas.microsoft.com/office/drawing/2014/main" id="{84637D8D-E2A7-40F2-9D48-C9064B11C6C9}"/>
+          <p:cNvPr id="4" name="page-number">
+            <a:extLst xmlns:a="http://schemas.openxmlformats.org/drawingml/2006/main">
+              <a:ext uri="{FF2B5EF4-FFF2-40B4-BE49-F238E27FC236}">
+                <a16:creationId xmlns:a16="http://schemas.microsoft.com/office/drawing/2014/main" id="{520CCF5B-00AC-47CF-A216-F1998A8AD14B}"/>
               </a:ext>
             </a:extLst>
           </p:cNvPr>
@@ -1965,10 +1866,10 @@
       </p:sp>
       <p:sp>
         <p:nvSpPr>
-          <p:cNvPr id="8" name="cover-title">
-            <a:extLst xmlns:a="http://schemas.openxmlformats.org/drawingml/2006/main">
-              <a:ext uri="{FF2B5EF4-FFF2-40B4-BE49-F238E27FC236}">
-                <a16:creationId xmlns:a16="http://schemas.microsoft.com/office/drawing/2014/main" id="{EA793445-A2FD-48AF-88D2-FED2573CCC6C}"/>
+          <p:cNvPr id="5" name="cover-title">
+            <a:extLst xmlns:a="http://schemas.openxmlformats.org/drawingml/2006/main">
+              <a:ext uri="{FF2B5EF4-FFF2-40B4-BE49-F238E27FC236}">
+                <a16:creationId xmlns:a16="http://schemas.microsoft.com/office/drawing/2014/main" id="{D7353088-14C0-45BF-9E23-ECD7F6042B7A}"/>
               </a:ext>
             </a:extLst>
           </p:cNvPr>
@@ -2046,10 +1947,10 @@
       </p:sp>
       <p:sp>
         <p:nvSpPr>
-          <p:cNvPr id="9" name="cover-summary">
-            <a:extLst xmlns:a="http://schemas.openxmlformats.org/drawingml/2006/main">
-              <a:ext uri="{FF2B5EF4-FFF2-40B4-BE49-F238E27FC236}">
-                <a16:creationId xmlns:a16="http://schemas.microsoft.com/office/drawing/2014/main" id="{1A22AF0D-1E44-434B-B1ED-2ED8695F9C89}"/>
+          <p:cNvPr id="6" name="cover-summary">
+            <a:extLst xmlns:a="http://schemas.openxmlformats.org/drawingml/2006/main">
+              <a:ext uri="{FF2B5EF4-FFF2-40B4-BE49-F238E27FC236}">
+                <a16:creationId xmlns:a16="http://schemas.microsoft.com/office/drawing/2014/main" id="{BD907CB8-7FCF-4B6F-992C-7FAB8A08AE47}"/>
               </a:ext>
             </a:extLst>
           </p:cNvPr>
@@ -2127,10 +2028,10 @@
       </p:sp>
       <p:sp>
         <p:nvSpPr>
-          <p:cNvPr id="10" name="cover-boundary">
-            <a:extLst xmlns:a="http://schemas.openxmlformats.org/drawingml/2006/main">
-              <a:ext uri="{FF2B5EF4-FFF2-40B4-BE49-F238E27FC236}">
-                <a16:creationId xmlns:a16="http://schemas.microsoft.com/office/drawing/2014/main" id="{13E2D2F9-7272-4063-8C42-BF8EF3C897CA}"/>
+          <p:cNvPr id="7" name="cover-boundary">
+            <a:extLst xmlns:a="http://schemas.openxmlformats.org/drawingml/2006/main">
+              <a:ext uri="{FF2B5EF4-FFF2-40B4-BE49-F238E27FC236}">
+                <a16:creationId xmlns:a16="http://schemas.microsoft.com/office/drawing/2014/main" id="{1805D97F-95CA-41D4-B5A4-7CF1279A9E00}"/>
               </a:ext>
             </a:extLst>
           </p:cNvPr>
@@ -2186,7 +2087,7 @@
     </p:spTree>
     <p:extLst>
       <p:ext uri="{BB962C8B-B14F-4D97-AF65-F5344CB8AC3E}">
-        <p14:creationId xmlns:p14="http://schemas.microsoft.com/office/powerpoint/2010/main" val="257141337"/>
+        <p14:creationId xmlns:p14="http://schemas.microsoft.com/office/powerpoint/2010/main" val="1502598606"/>
       </p:ext>
     </p:extLst>
   </p:cSld>
@@ -2212,139 +2113,40 @@
       <p:grpSpPr>
         <a:xfrm xmlns:a="http://schemas.openxmlformats.org/drawingml/2006/main"/>
       </p:grpSpPr>
-      <p:sp>
-        <p:nvSpPr>
-          <p:cNvPr id="22" name="Hormuz mark boundary">
-            <a:extLst xmlns:a="http://schemas.openxmlformats.org/drawingml/2006/main">
-              <a:ext uri="{FF2B5EF4-FFF2-40B4-BE49-F238E27FC236}">
-                <a16:creationId xmlns:a16="http://schemas.microsoft.com/office/drawing/2014/main" id="{C616B305-D674-47A7-843B-73F2782E2D30}"/>
-              </a:ext>
-            </a:extLst>
-          </p:cNvPr>
-          <p:cNvSpPr>
-            <a:spLocks xmlns:a="http://schemas.openxmlformats.org/drawingml/2006/main" noGrp="1"/>
-          </p:cNvSpPr>
-          <p:nvPr/>
-        </p:nvSpPr>
+      <p:pic>
+        <p:nvPicPr>
+          <p:cNvPr id="19" name=""/>
+          <p:cNvPicPr>
+            <a:picLocks xmlns:a="http://schemas.openxmlformats.org/drawingml/2006/main" noChangeAspect="1"/>
+          </p:cNvPicPr>
+          <p:nvPr/>
+        </p:nvPicPr>
+        <p:blipFill>
+          <a:blip xmlns:r="http://schemas.openxmlformats.org/officeDocument/2006/relationships" xmlns:a="http://schemas.openxmlformats.org/drawingml/2006/main" r:embed="Rda2df477324c4688">
+            <a:extLst>
+              <a:ext uri="{96DAC541-7B7A-43D3-8B79-37D633B846F1}">
+                <asvg:svgBlip xmlns:asvg="http://schemas.microsoft.com/office/drawing/2016/SVG/main" r:embed="R8ae4e69bb7ae4a0a"/>
+              </a:ext>
+            </a:extLst>
+          </a:blip>
+          <a:stretch xmlns:a="http://schemas.openxmlformats.org/drawingml/2006/main"/>
+        </p:blipFill>
         <p:spPr>
           <a:xfrm xmlns:a="http://schemas.openxmlformats.org/drawingml/2006/main">
             <a:off x="11201400" y="333375"/>
             <a:ext cx="381000" cy="381000"/>
           </a:xfrm>
-          <a:prstGeom xmlns:a="http://schemas.openxmlformats.org/drawingml/2006/main" prst="ellipse">
-            <a:avLst/>
-          </a:prstGeom>
-          <a:noFill xmlns:a="http://schemas.openxmlformats.org/drawingml/2006/main"/>
-          <a:ln xmlns:a="http://schemas.openxmlformats.org/drawingml/2006/main" w="9525">
-            <a:solidFill>
-              <a:srgbClr val="31684B"/>
-            </a:solidFill>
-            <a:prstDash val="solid"/>
-          </a:ln>
-        </p:spPr>
-      </p:sp>
-      <p:sp>
-        <p:nvSpPr>
-          <p:cNvPr id="2" name="Hormuz mark bar 1">
-            <a:extLst xmlns:a="http://schemas.openxmlformats.org/drawingml/2006/main">
-              <a:ext uri="{FF2B5EF4-FFF2-40B4-BE49-F238E27FC236}">
-                <a16:creationId xmlns:a16="http://schemas.microsoft.com/office/drawing/2014/main" id="{F2620ED3-5197-48AD-857A-E734EB7C97FE}"/>
-              </a:ext>
-            </a:extLst>
-          </p:cNvPr>
-          <p:cNvSpPr>
-            <a:spLocks xmlns:a="http://schemas.openxmlformats.org/drawingml/2006/main" noGrp="1"/>
-          </p:cNvSpPr>
-          <p:nvPr/>
-        </p:nvSpPr>
-        <p:spPr>
-          <a:xfrm xmlns:a="http://schemas.openxmlformats.org/drawingml/2006/main">
-            <a:off x="11287125" y="476250"/>
-            <a:ext cx="47625" cy="95250"/>
-          </a:xfrm>
-          <a:prstGeom xmlns:a="http://schemas.openxmlformats.org/drawingml/2006/main" prst="roundRect">
-            <a:avLst>
-              <a:gd name="adj" fmla="val 50000"/>
-            </a:avLst>
-          </a:prstGeom>
-          <a:solidFill xmlns:a="http://schemas.openxmlformats.org/drawingml/2006/main">
-            <a:srgbClr val="31684B"/>
-          </a:solidFill>
-          <a:ln xmlns:a="http://schemas.openxmlformats.org/drawingml/2006/main" w="0">
-            <a:noFill/>
-          </a:ln>
-        </p:spPr>
-      </p:sp>
-      <p:sp>
-        <p:nvSpPr>
-          <p:cNvPr id="3" name="Hormuz mark bar 2">
-            <a:extLst xmlns:a="http://schemas.openxmlformats.org/drawingml/2006/main">
-              <a:ext uri="{FF2B5EF4-FFF2-40B4-BE49-F238E27FC236}">
-                <a16:creationId xmlns:a16="http://schemas.microsoft.com/office/drawing/2014/main" id="{A1F88F53-8E71-4813-9EA8-ACB15D614416}"/>
-              </a:ext>
-            </a:extLst>
-          </p:cNvPr>
-          <p:cNvSpPr>
-            <a:spLocks xmlns:a="http://schemas.openxmlformats.org/drawingml/2006/main" noGrp="1"/>
-          </p:cNvSpPr>
-          <p:nvPr/>
-        </p:nvSpPr>
-        <p:spPr>
-          <a:xfrm xmlns:a="http://schemas.openxmlformats.org/drawingml/2006/main">
-            <a:off x="11363325" y="428625"/>
-            <a:ext cx="47625" cy="190500"/>
-          </a:xfrm>
-          <a:prstGeom xmlns:a="http://schemas.openxmlformats.org/drawingml/2006/main" prst="roundRect">
-            <a:avLst>
-              <a:gd name="adj" fmla="val 50000"/>
-            </a:avLst>
-          </a:prstGeom>
-          <a:solidFill xmlns:a="http://schemas.openxmlformats.org/drawingml/2006/main">
-            <a:srgbClr val="31684B"/>
-          </a:solidFill>
-          <a:ln xmlns:a="http://schemas.openxmlformats.org/drawingml/2006/main" w="0">
-            <a:noFill/>
-          </a:ln>
-        </p:spPr>
-      </p:sp>
-      <p:sp>
-        <p:nvSpPr>
-          <p:cNvPr id="4" name="Hormuz mark bar 3">
-            <a:extLst xmlns:a="http://schemas.openxmlformats.org/drawingml/2006/main">
-              <a:ext uri="{FF2B5EF4-FFF2-40B4-BE49-F238E27FC236}">
-                <a16:creationId xmlns:a16="http://schemas.microsoft.com/office/drawing/2014/main" id="{6D49C5F2-DDE0-4C3D-A31C-50C1167174D6}"/>
-              </a:ext>
-            </a:extLst>
-          </p:cNvPr>
-          <p:cNvSpPr>
-            <a:spLocks xmlns:a="http://schemas.openxmlformats.org/drawingml/2006/main" noGrp="1"/>
-          </p:cNvSpPr>
-          <p:nvPr/>
-        </p:nvSpPr>
-        <p:spPr>
-          <a:xfrm xmlns:a="http://schemas.openxmlformats.org/drawingml/2006/main">
-            <a:off x="11439525" y="457200"/>
-            <a:ext cx="47625" cy="133350"/>
-          </a:xfrm>
-          <a:prstGeom xmlns:a="http://schemas.openxmlformats.org/drawingml/2006/main" prst="roundRect">
-            <a:avLst>
-              <a:gd name="adj" fmla="val 50000"/>
-            </a:avLst>
-          </a:prstGeom>
-          <a:solidFill xmlns:a="http://schemas.openxmlformats.org/drawingml/2006/main">
-            <a:srgbClr val="31684B"/>
-          </a:solidFill>
-          <a:ln xmlns:a="http://schemas.openxmlformats.org/drawingml/2006/main" w="0">
-            <a:noFill/>
-          </a:ln>
-        </p:spPr>
-      </p:sp>
-      <p:sp>
-        <p:nvSpPr>
-          <p:cNvPr id="5" name="section">
-            <a:extLst xmlns:a="http://schemas.openxmlformats.org/drawingml/2006/main">
-              <a:ext uri="{FF2B5EF4-FFF2-40B4-BE49-F238E27FC236}">
-                <a16:creationId xmlns:a16="http://schemas.microsoft.com/office/drawing/2014/main" id="{5F583A0B-7F92-408F-B34A-13E9CCB8EE23}"/>
+          <a:prstGeom xmlns:a="http://schemas.openxmlformats.org/drawingml/2006/main" prst="rect">
+            <a:avLst/>
+          </a:prstGeom>
+        </p:spPr>
+      </p:pic>
+      <p:sp>
+        <p:nvSpPr>
+          <p:cNvPr id="2" name="section">
+            <a:extLst xmlns:a="http://schemas.openxmlformats.org/drawingml/2006/main">
+              <a:ext uri="{FF2B5EF4-FFF2-40B4-BE49-F238E27FC236}">
+                <a16:creationId xmlns:a16="http://schemas.microsoft.com/office/drawing/2014/main" id="{45EC06CD-DEA5-4038-A835-20FDD7071EBF}"/>
               </a:ext>
             </a:extLst>
           </p:cNvPr>
@@ -2399,10 +2201,10 @@
       </p:sp>
       <p:sp>
         <p:nvSpPr>
-          <p:cNvPr id="6" name="takeaway">
-            <a:extLst xmlns:a="http://schemas.openxmlformats.org/drawingml/2006/main">
-              <a:ext uri="{FF2B5EF4-FFF2-40B4-BE49-F238E27FC236}">
-                <a16:creationId xmlns:a16="http://schemas.microsoft.com/office/drawing/2014/main" id="{89294B07-40D8-4888-B1B7-8DAD5BCCD9EE}"/>
+          <p:cNvPr id="3" name="takeaway">
+            <a:extLst xmlns:a="http://schemas.openxmlformats.org/drawingml/2006/main">
+              <a:ext uri="{FF2B5EF4-FFF2-40B4-BE49-F238E27FC236}">
+                <a16:creationId xmlns:a16="http://schemas.microsoft.com/office/drawing/2014/main" id="{B932E55F-D62C-4C64-91C7-1067C5891C0C}"/>
               </a:ext>
             </a:extLst>
           </p:cNvPr>
@@ -2457,10 +2259,10 @@
       </p:sp>
       <p:sp>
         <p:nvSpPr>
-          <p:cNvPr id="7" name="footer">
-            <a:extLst xmlns:a="http://schemas.openxmlformats.org/drawingml/2006/main">
-              <a:ext uri="{FF2B5EF4-FFF2-40B4-BE49-F238E27FC236}">
-                <a16:creationId xmlns:a16="http://schemas.microsoft.com/office/drawing/2014/main" id="{63E1982C-E102-4D86-B9EB-7BB490E5EFF0}"/>
+          <p:cNvPr id="4" name="footer">
+            <a:extLst xmlns:a="http://schemas.openxmlformats.org/drawingml/2006/main">
+              <a:ext uri="{FF2B5EF4-FFF2-40B4-BE49-F238E27FC236}">
+                <a16:creationId xmlns:a16="http://schemas.microsoft.com/office/drawing/2014/main" id="{9BDEBCF3-FA80-4395-B8A3-DAF3FCE32A20}"/>
               </a:ext>
             </a:extLst>
           </p:cNvPr>
@@ -2515,10 +2317,10 @@
       </p:sp>
       <p:sp>
         <p:nvSpPr>
-          <p:cNvPr id="8" name="page-number">
-            <a:extLst xmlns:a="http://schemas.openxmlformats.org/drawingml/2006/main">
-              <a:ext uri="{FF2B5EF4-FFF2-40B4-BE49-F238E27FC236}">
-                <a16:creationId xmlns:a16="http://schemas.microsoft.com/office/drawing/2014/main" id="{20E6A3A5-0105-4711-A6F9-55750AF8F5E0}"/>
+          <p:cNvPr id="5" name="page-number">
+            <a:extLst xmlns:a="http://schemas.openxmlformats.org/drawingml/2006/main">
+              <a:ext uri="{FF2B5EF4-FFF2-40B4-BE49-F238E27FC236}">
+                <a16:creationId xmlns:a16="http://schemas.microsoft.com/office/drawing/2014/main" id="{9A01BDBB-007D-4258-BBD5-9B4C96E10DC9}"/>
               </a:ext>
             </a:extLst>
           </p:cNvPr>
@@ -2573,10 +2375,10 @@
       </p:sp>
       <p:sp>
         <p:nvSpPr>
-          <p:cNvPr id="9" name="arrow-one">
-            <a:extLst xmlns:a="http://schemas.openxmlformats.org/drawingml/2006/main">
-              <a:ext uri="{FF2B5EF4-FFF2-40B4-BE49-F238E27FC236}">
-                <a16:creationId xmlns:a16="http://schemas.microsoft.com/office/drawing/2014/main" id="{7B53CAF2-30C5-488F-8E30-959273B21063}"/>
+          <p:cNvPr id="6" name="arrow-one">
+            <a:extLst xmlns:a="http://schemas.openxmlformats.org/drawingml/2006/main">
+              <a:ext uri="{FF2B5EF4-FFF2-40B4-BE49-F238E27FC236}">
+                <a16:creationId xmlns:a16="http://schemas.microsoft.com/office/drawing/2014/main" id="{1F164A8F-7AD4-4E62-A381-C06A09C5E424}"/>
               </a:ext>
             </a:extLst>
           </p:cNvPr>
@@ -2631,10 +2433,10 @@
       </p:sp>
       <p:sp>
         <p:nvSpPr>
-          <p:cNvPr id="10" name="arrow-two">
-            <a:extLst xmlns:a="http://schemas.openxmlformats.org/drawingml/2006/main">
-              <a:ext uri="{FF2B5EF4-FFF2-40B4-BE49-F238E27FC236}">
-                <a16:creationId xmlns:a16="http://schemas.microsoft.com/office/drawing/2014/main" id="{C245EF8B-E895-421E-A83F-ADB4768634F9}"/>
+          <p:cNvPr id="7" name="arrow-two">
+            <a:extLst xmlns:a="http://schemas.openxmlformats.org/drawingml/2006/main">
+              <a:ext uri="{FF2B5EF4-FFF2-40B4-BE49-F238E27FC236}">
+                <a16:creationId xmlns:a16="http://schemas.microsoft.com/office/drawing/2014/main" id="{82D31BB1-46C7-40E1-B7E6-EB7CA77B69C8}"/>
               </a:ext>
             </a:extLst>
           </p:cNvPr>
@@ -2689,10 +2491,10 @@
       </p:sp>
       <p:sp>
         <p:nvSpPr>
-          <p:cNvPr id="11" name="EMPLOYEE CLIENT">
-            <a:extLst xmlns:a="http://schemas.openxmlformats.org/drawingml/2006/main">
-              <a:ext uri="{FF2B5EF4-FFF2-40B4-BE49-F238E27FC236}">
-                <a16:creationId xmlns:a16="http://schemas.microsoft.com/office/drawing/2014/main" id="{EBA64CCD-4C42-47AB-A18A-3AF042D2F6A1}"/>
+          <p:cNvPr id="8" name="EMPLOYEE CLIENT">
+            <a:extLst xmlns:a="http://schemas.openxmlformats.org/drawingml/2006/main">
+              <a:ext uri="{FF2B5EF4-FFF2-40B4-BE49-F238E27FC236}">
+                <a16:creationId xmlns:a16="http://schemas.microsoft.com/office/drawing/2014/main" id="{26F4CEF6-B0C2-4EB0-8354-3EF359F77E51}"/>
               </a:ext>
             </a:extLst>
           </p:cNvPr>
@@ -2722,10 +2524,10 @@
       </p:sp>
       <p:sp>
         <p:nvSpPr>
-          <p:cNvPr id="12" name="EMPLOYEE CLIENT-title">
-            <a:extLst xmlns:a="http://schemas.openxmlformats.org/drawingml/2006/main">
-              <a:ext uri="{FF2B5EF4-FFF2-40B4-BE49-F238E27FC236}">
-                <a16:creationId xmlns:a16="http://schemas.microsoft.com/office/drawing/2014/main" id="{1C5E2250-BD72-4A8A-AFE2-F1B22E6027CC}"/>
+          <p:cNvPr id="9" name="EMPLOYEE CLIENT-title">
+            <a:extLst xmlns:a="http://schemas.openxmlformats.org/drawingml/2006/main">
+              <a:ext uri="{FF2B5EF4-FFF2-40B4-BE49-F238E27FC236}">
+                <a16:creationId xmlns:a16="http://schemas.microsoft.com/office/drawing/2014/main" id="{24C5FE9A-D7A6-4418-90A4-3FE92E3DC8D8}"/>
               </a:ext>
             </a:extLst>
           </p:cNvPr>
@@ -2780,10 +2582,10 @@
       </p:sp>
       <p:sp>
         <p:nvSpPr>
-          <p:cNvPr id="13" name="EMPLOYEE CLIENT-body">
-            <a:extLst xmlns:a="http://schemas.openxmlformats.org/drawingml/2006/main">
-              <a:ext uri="{FF2B5EF4-FFF2-40B4-BE49-F238E27FC236}">
-                <a16:creationId xmlns:a16="http://schemas.microsoft.com/office/drawing/2014/main" id="{FABEBE93-2670-4B15-93C8-B6FB4D04620C}"/>
+          <p:cNvPr id="10" name="EMPLOYEE CLIENT-body">
+            <a:extLst xmlns:a="http://schemas.openxmlformats.org/drawingml/2006/main">
+              <a:ext uri="{FF2B5EF4-FFF2-40B4-BE49-F238E27FC236}">
+                <a16:creationId xmlns:a16="http://schemas.microsoft.com/office/drawing/2014/main" id="{58CAB90E-461A-4036-9E9D-48C5A0CCB6E9}"/>
               </a:ext>
             </a:extLst>
           </p:cNvPr>
@@ -2861,10 +2663,10 @@
       </p:sp>
       <p:sp>
         <p:nvSpPr>
-          <p:cNvPr id="14" name="HORMUZ">
-            <a:extLst xmlns:a="http://schemas.openxmlformats.org/drawingml/2006/main">
-              <a:ext uri="{FF2B5EF4-FFF2-40B4-BE49-F238E27FC236}">
-                <a16:creationId xmlns:a16="http://schemas.microsoft.com/office/drawing/2014/main" id="{8CB34AFD-36A7-4997-9CA3-A4BC4527E7A9}"/>
+          <p:cNvPr id="11" name="HORMUZ">
+            <a:extLst xmlns:a="http://schemas.openxmlformats.org/drawingml/2006/main">
+              <a:ext uri="{FF2B5EF4-FFF2-40B4-BE49-F238E27FC236}">
+                <a16:creationId xmlns:a16="http://schemas.microsoft.com/office/drawing/2014/main" id="{828DBEAD-6D72-464C-B749-6E7DDB574384}"/>
               </a:ext>
             </a:extLst>
           </p:cNvPr>
@@ -2894,10 +2696,10 @@
       </p:sp>
       <p:sp>
         <p:nvSpPr>
-          <p:cNvPr id="15" name="HORMUZ-title">
-            <a:extLst xmlns:a="http://schemas.openxmlformats.org/drawingml/2006/main">
-              <a:ext uri="{FF2B5EF4-FFF2-40B4-BE49-F238E27FC236}">
-                <a16:creationId xmlns:a16="http://schemas.microsoft.com/office/drawing/2014/main" id="{7849F456-3F2F-4FC6-A3AB-4129EC5030F6}"/>
+          <p:cNvPr id="12" name="HORMUZ-title">
+            <a:extLst xmlns:a="http://schemas.openxmlformats.org/drawingml/2006/main">
+              <a:ext uri="{FF2B5EF4-FFF2-40B4-BE49-F238E27FC236}">
+                <a16:creationId xmlns:a16="http://schemas.microsoft.com/office/drawing/2014/main" id="{D752113F-1B7D-4AAE-8471-6A53AC0DE04A}"/>
               </a:ext>
             </a:extLst>
           </p:cNvPr>
@@ -2952,10 +2754,10 @@
       </p:sp>
       <p:sp>
         <p:nvSpPr>
-          <p:cNvPr id="16" name="HORMUZ-body">
-            <a:extLst xmlns:a="http://schemas.openxmlformats.org/drawingml/2006/main">
-              <a:ext uri="{FF2B5EF4-FFF2-40B4-BE49-F238E27FC236}">
-                <a16:creationId xmlns:a16="http://schemas.microsoft.com/office/drawing/2014/main" id="{68B17EBC-7A76-4FB3-A33B-DE1B515967D2}"/>
+          <p:cNvPr id="13" name="HORMUZ-body">
+            <a:extLst xmlns:a="http://schemas.openxmlformats.org/drawingml/2006/main">
+              <a:ext uri="{FF2B5EF4-FFF2-40B4-BE49-F238E27FC236}">
+                <a16:creationId xmlns:a16="http://schemas.microsoft.com/office/drawing/2014/main" id="{C7AB1D7F-DF30-409B-AA78-09085E918F5D}"/>
               </a:ext>
             </a:extLst>
           </p:cNvPr>
@@ -3033,10 +2835,10 @@
       </p:sp>
       <p:sp>
         <p:nvSpPr>
-          <p:cNvPr id="17" name="MODEL PROVIDER">
-            <a:extLst xmlns:a="http://schemas.openxmlformats.org/drawingml/2006/main">
-              <a:ext uri="{FF2B5EF4-FFF2-40B4-BE49-F238E27FC236}">
-                <a16:creationId xmlns:a16="http://schemas.microsoft.com/office/drawing/2014/main" id="{0A344401-14F5-45F2-B130-9A4B15F44DD3}"/>
+          <p:cNvPr id="14" name="MODEL PROVIDER">
+            <a:extLst xmlns:a="http://schemas.openxmlformats.org/drawingml/2006/main">
+              <a:ext uri="{FF2B5EF4-FFF2-40B4-BE49-F238E27FC236}">
+                <a16:creationId xmlns:a16="http://schemas.microsoft.com/office/drawing/2014/main" id="{89EDE08D-1394-4A29-B4CD-3C4721DDAA83}"/>
               </a:ext>
             </a:extLst>
           </p:cNvPr>
@@ -3066,10 +2868,10 @@
       </p:sp>
       <p:sp>
         <p:nvSpPr>
-          <p:cNvPr id="18" name="MODEL PROVIDER-title">
-            <a:extLst xmlns:a="http://schemas.openxmlformats.org/drawingml/2006/main">
-              <a:ext uri="{FF2B5EF4-FFF2-40B4-BE49-F238E27FC236}">
-                <a16:creationId xmlns:a16="http://schemas.microsoft.com/office/drawing/2014/main" id="{5B9EA19E-1824-4CDA-A304-F944375144C6}"/>
+          <p:cNvPr id="15" name="MODEL PROVIDER-title">
+            <a:extLst xmlns:a="http://schemas.openxmlformats.org/drawingml/2006/main">
+              <a:ext uri="{FF2B5EF4-FFF2-40B4-BE49-F238E27FC236}">
+                <a16:creationId xmlns:a16="http://schemas.microsoft.com/office/drawing/2014/main" id="{AE9710AE-AF92-4523-A8C1-19236DB58D52}"/>
               </a:ext>
             </a:extLst>
           </p:cNvPr>
@@ -3124,10 +2926,10 @@
       </p:sp>
       <p:sp>
         <p:nvSpPr>
-          <p:cNvPr id="19" name="MODEL PROVIDER-body">
-            <a:extLst xmlns:a="http://schemas.openxmlformats.org/drawingml/2006/main">
-              <a:ext uri="{FF2B5EF4-FFF2-40B4-BE49-F238E27FC236}">
-                <a16:creationId xmlns:a16="http://schemas.microsoft.com/office/drawing/2014/main" id="{B9F38047-5181-4262-8CF6-AF5F58EB1DA2}"/>
+          <p:cNvPr id="16" name="MODEL PROVIDER-body">
+            <a:extLst xmlns:a="http://schemas.openxmlformats.org/drawingml/2006/main">
+              <a:ext uri="{FF2B5EF4-FFF2-40B4-BE49-F238E27FC236}">
+                <a16:creationId xmlns:a16="http://schemas.microsoft.com/office/drawing/2014/main" id="{53360DC0-153C-41ED-B8C4-B6651A5C9BDC}"/>
               </a:ext>
             </a:extLst>
           </p:cNvPr>
@@ -3205,10 +3007,10 @@
       </p:sp>
       <p:sp>
         <p:nvSpPr>
-          <p:cNvPr id="20" name="metadata">
-            <a:extLst xmlns:a="http://schemas.openxmlformats.org/drawingml/2006/main">
-              <a:ext uri="{FF2B5EF4-FFF2-40B4-BE49-F238E27FC236}">
-                <a16:creationId xmlns:a16="http://schemas.microsoft.com/office/drawing/2014/main" id="{DD3377E4-448F-41CC-B9C1-A1AB8D1ADFFD}"/>
+          <p:cNvPr id="17" name="metadata">
+            <a:extLst xmlns:a="http://schemas.openxmlformats.org/drawingml/2006/main">
+              <a:ext uri="{FF2B5EF4-FFF2-40B4-BE49-F238E27FC236}">
+                <a16:creationId xmlns:a16="http://schemas.microsoft.com/office/drawing/2014/main" id="{2F0B9E83-1F0C-4FD9-BCFE-F6B12C9FD1A7}"/>
               </a:ext>
             </a:extLst>
           </p:cNvPr>
@@ -3263,10 +3065,10 @@
       </p:sp>
       <p:sp>
         <p:nvSpPr>
-          <p:cNvPr id="21" name="boundary">
-            <a:extLst xmlns:a="http://schemas.openxmlformats.org/drawingml/2006/main">
-              <a:ext uri="{FF2B5EF4-FFF2-40B4-BE49-F238E27FC236}">
-                <a16:creationId xmlns:a16="http://schemas.microsoft.com/office/drawing/2014/main" id="{1FA0D41D-CAB6-4F35-B856-21E57CF9D2E2}"/>
+          <p:cNvPr id="18" name="boundary">
+            <a:extLst xmlns:a="http://schemas.openxmlformats.org/drawingml/2006/main">
+              <a:ext uri="{FF2B5EF4-FFF2-40B4-BE49-F238E27FC236}">
+                <a16:creationId xmlns:a16="http://schemas.microsoft.com/office/drawing/2014/main" id="{35616240-55FA-4CCA-85F3-3D57B2734F28}"/>
               </a:ext>
             </a:extLst>
           </p:cNvPr>
@@ -3322,7 +3124,7 @@
     </p:spTree>
     <p:extLst>
       <p:ext uri="{BB962C8B-B14F-4D97-AF65-F5344CB8AC3E}">
-        <p14:creationId xmlns:p14="http://schemas.microsoft.com/office/powerpoint/2010/main" val="2093276171"/>
+        <p14:creationId xmlns:p14="http://schemas.microsoft.com/office/powerpoint/2010/main" val="941358670"/>
       </p:ext>
     </p:extLst>
   </p:cSld>
@@ -3348,139 +3150,40 @@
       <p:grpSpPr>
         <a:xfrm xmlns:a="http://schemas.openxmlformats.org/drawingml/2006/main"/>
       </p:grpSpPr>
-      <p:sp>
-        <p:nvSpPr>
-          <p:cNvPr id="13" name="Hormuz mark boundary">
-            <a:extLst xmlns:a="http://schemas.openxmlformats.org/drawingml/2006/main">
-              <a:ext uri="{FF2B5EF4-FFF2-40B4-BE49-F238E27FC236}">
-                <a16:creationId xmlns:a16="http://schemas.microsoft.com/office/drawing/2014/main" id="{279A3BFD-BF0E-42C1-B1B1-0983E9ACE8BC}"/>
-              </a:ext>
-            </a:extLst>
-          </p:cNvPr>
-          <p:cNvSpPr>
-            <a:spLocks xmlns:a="http://schemas.openxmlformats.org/drawingml/2006/main" noGrp="1"/>
-          </p:cNvSpPr>
-          <p:nvPr/>
-        </p:nvSpPr>
+      <p:pic>
+        <p:nvPicPr>
+          <p:cNvPr id="10" name=""/>
+          <p:cNvPicPr>
+            <a:picLocks xmlns:a="http://schemas.openxmlformats.org/drawingml/2006/main" noChangeAspect="1"/>
+          </p:cNvPicPr>
+          <p:nvPr/>
+        </p:nvPicPr>
+        <p:blipFill>
+          <a:blip xmlns:r="http://schemas.openxmlformats.org/officeDocument/2006/relationships" xmlns:a="http://schemas.openxmlformats.org/drawingml/2006/main" r:embed="Rb54a670779b64bc0">
+            <a:extLst>
+              <a:ext uri="{96DAC541-7B7A-43D3-8B79-37D633B846F1}">
+                <asvg:svgBlip xmlns:asvg="http://schemas.microsoft.com/office/drawing/2016/SVG/main" r:embed="Re88ab682a9414947"/>
+              </a:ext>
+            </a:extLst>
+          </a:blip>
+          <a:stretch xmlns:a="http://schemas.openxmlformats.org/drawingml/2006/main"/>
+        </p:blipFill>
         <p:spPr>
           <a:xfrm xmlns:a="http://schemas.openxmlformats.org/drawingml/2006/main">
             <a:off x="11201400" y="333375"/>
             <a:ext cx="381000" cy="381000"/>
           </a:xfrm>
-          <a:prstGeom xmlns:a="http://schemas.openxmlformats.org/drawingml/2006/main" prst="ellipse">
-            <a:avLst/>
-          </a:prstGeom>
-          <a:noFill xmlns:a="http://schemas.openxmlformats.org/drawingml/2006/main"/>
-          <a:ln xmlns:a="http://schemas.openxmlformats.org/drawingml/2006/main" w="9525">
-            <a:solidFill>
-              <a:srgbClr val="DCEDA6"/>
-            </a:solidFill>
-            <a:prstDash val="solid"/>
-          </a:ln>
-        </p:spPr>
-      </p:sp>
-      <p:sp>
-        <p:nvSpPr>
-          <p:cNvPr id="2" name="Hormuz mark bar 1">
-            <a:extLst xmlns:a="http://schemas.openxmlformats.org/drawingml/2006/main">
-              <a:ext uri="{FF2B5EF4-FFF2-40B4-BE49-F238E27FC236}">
-                <a16:creationId xmlns:a16="http://schemas.microsoft.com/office/drawing/2014/main" id="{242500A5-A78C-4276-BE7A-F142904061B9}"/>
-              </a:ext>
-            </a:extLst>
-          </p:cNvPr>
-          <p:cNvSpPr>
-            <a:spLocks xmlns:a="http://schemas.openxmlformats.org/drawingml/2006/main" noGrp="1"/>
-          </p:cNvSpPr>
-          <p:nvPr/>
-        </p:nvSpPr>
-        <p:spPr>
-          <a:xfrm xmlns:a="http://schemas.openxmlformats.org/drawingml/2006/main">
-            <a:off x="11287125" y="476250"/>
-            <a:ext cx="47625" cy="95250"/>
-          </a:xfrm>
-          <a:prstGeom xmlns:a="http://schemas.openxmlformats.org/drawingml/2006/main" prst="roundRect">
-            <a:avLst>
-              <a:gd name="adj" fmla="val 50000"/>
-            </a:avLst>
-          </a:prstGeom>
-          <a:solidFill xmlns:a="http://schemas.openxmlformats.org/drawingml/2006/main">
-            <a:srgbClr val="DCEDA6"/>
-          </a:solidFill>
-          <a:ln xmlns:a="http://schemas.openxmlformats.org/drawingml/2006/main" w="0">
-            <a:noFill/>
-          </a:ln>
-        </p:spPr>
-      </p:sp>
-      <p:sp>
-        <p:nvSpPr>
-          <p:cNvPr id="3" name="Hormuz mark bar 2">
-            <a:extLst xmlns:a="http://schemas.openxmlformats.org/drawingml/2006/main">
-              <a:ext uri="{FF2B5EF4-FFF2-40B4-BE49-F238E27FC236}">
-                <a16:creationId xmlns:a16="http://schemas.microsoft.com/office/drawing/2014/main" id="{B3AC06E0-0B74-4BCC-8C92-319A03C6BEED}"/>
-              </a:ext>
-            </a:extLst>
-          </p:cNvPr>
-          <p:cNvSpPr>
-            <a:spLocks xmlns:a="http://schemas.openxmlformats.org/drawingml/2006/main" noGrp="1"/>
-          </p:cNvSpPr>
-          <p:nvPr/>
-        </p:nvSpPr>
-        <p:spPr>
-          <a:xfrm xmlns:a="http://schemas.openxmlformats.org/drawingml/2006/main">
-            <a:off x="11363325" y="428625"/>
-            <a:ext cx="47625" cy="190500"/>
-          </a:xfrm>
-          <a:prstGeom xmlns:a="http://schemas.openxmlformats.org/drawingml/2006/main" prst="roundRect">
-            <a:avLst>
-              <a:gd name="adj" fmla="val 50000"/>
-            </a:avLst>
-          </a:prstGeom>
-          <a:solidFill xmlns:a="http://schemas.openxmlformats.org/drawingml/2006/main">
-            <a:srgbClr val="DCEDA6"/>
-          </a:solidFill>
-          <a:ln xmlns:a="http://schemas.openxmlformats.org/drawingml/2006/main" w="0">
-            <a:noFill/>
-          </a:ln>
-        </p:spPr>
-      </p:sp>
-      <p:sp>
-        <p:nvSpPr>
-          <p:cNvPr id="4" name="Hormuz mark bar 3">
-            <a:extLst xmlns:a="http://schemas.openxmlformats.org/drawingml/2006/main">
-              <a:ext uri="{FF2B5EF4-FFF2-40B4-BE49-F238E27FC236}">
-                <a16:creationId xmlns:a16="http://schemas.microsoft.com/office/drawing/2014/main" id="{78790558-2A3B-4A11-B07C-4AD2F0003DC3}"/>
-              </a:ext>
-            </a:extLst>
-          </p:cNvPr>
-          <p:cNvSpPr>
-            <a:spLocks xmlns:a="http://schemas.openxmlformats.org/drawingml/2006/main" noGrp="1"/>
-          </p:cNvSpPr>
-          <p:nvPr/>
-        </p:nvSpPr>
-        <p:spPr>
-          <a:xfrm xmlns:a="http://schemas.openxmlformats.org/drawingml/2006/main">
-            <a:off x="11439525" y="457200"/>
-            <a:ext cx="47625" cy="133350"/>
-          </a:xfrm>
-          <a:prstGeom xmlns:a="http://schemas.openxmlformats.org/drawingml/2006/main" prst="roundRect">
-            <a:avLst>
-              <a:gd name="adj" fmla="val 50000"/>
-            </a:avLst>
-          </a:prstGeom>
-          <a:solidFill xmlns:a="http://schemas.openxmlformats.org/drawingml/2006/main">
-            <a:srgbClr val="DCEDA6"/>
-          </a:solidFill>
-          <a:ln xmlns:a="http://schemas.openxmlformats.org/drawingml/2006/main" w="0">
-            <a:noFill/>
-          </a:ln>
-        </p:spPr>
-      </p:sp>
-      <p:sp>
-        <p:nvSpPr>
-          <p:cNvPr id="5" name="section">
-            <a:extLst xmlns:a="http://schemas.openxmlformats.org/drawingml/2006/main">
-              <a:ext uri="{FF2B5EF4-FFF2-40B4-BE49-F238E27FC236}">
-                <a16:creationId xmlns:a16="http://schemas.microsoft.com/office/drawing/2014/main" id="{C1ECAE55-81F7-4950-8F59-362475F72073}"/>
+          <a:prstGeom xmlns:a="http://schemas.openxmlformats.org/drawingml/2006/main" prst="rect">
+            <a:avLst/>
+          </a:prstGeom>
+        </p:spPr>
+      </p:pic>
+      <p:sp>
+        <p:nvSpPr>
+          <p:cNvPr id="2" name="section">
+            <a:extLst xmlns:a="http://schemas.openxmlformats.org/drawingml/2006/main">
+              <a:ext uri="{FF2B5EF4-FFF2-40B4-BE49-F238E27FC236}">
+                <a16:creationId xmlns:a16="http://schemas.microsoft.com/office/drawing/2014/main" id="{F8677E93-11AF-42C4-90D1-971C39B2FD55}"/>
               </a:ext>
             </a:extLst>
           </p:cNvPr>
@@ -3535,10 +3238,10 @@
       </p:sp>
       <p:sp>
         <p:nvSpPr>
-          <p:cNvPr id="6" name="takeaway">
-            <a:extLst xmlns:a="http://schemas.openxmlformats.org/drawingml/2006/main">
-              <a:ext uri="{FF2B5EF4-FFF2-40B4-BE49-F238E27FC236}">
-                <a16:creationId xmlns:a16="http://schemas.microsoft.com/office/drawing/2014/main" id="{BDD23D6F-7B13-4717-967F-6D7E81311E02}"/>
+          <p:cNvPr id="3" name="takeaway">
+            <a:extLst xmlns:a="http://schemas.openxmlformats.org/drawingml/2006/main">
+              <a:ext uri="{FF2B5EF4-FFF2-40B4-BE49-F238E27FC236}">
+                <a16:creationId xmlns:a16="http://schemas.microsoft.com/office/drawing/2014/main" id="{F81E9F06-59DB-4BEF-B113-2931BA5CA770}"/>
               </a:ext>
             </a:extLst>
           </p:cNvPr>
@@ -3593,10 +3296,10 @@
       </p:sp>
       <p:sp>
         <p:nvSpPr>
-          <p:cNvPr id="7" name="footer">
-            <a:extLst xmlns:a="http://schemas.openxmlformats.org/drawingml/2006/main">
-              <a:ext uri="{FF2B5EF4-FFF2-40B4-BE49-F238E27FC236}">
-                <a16:creationId xmlns:a16="http://schemas.microsoft.com/office/drawing/2014/main" id="{D86C3A45-C9E4-4329-ADFB-2F06E4364766}"/>
+          <p:cNvPr id="4" name="footer">
+            <a:extLst xmlns:a="http://schemas.openxmlformats.org/drawingml/2006/main">
+              <a:ext uri="{FF2B5EF4-FFF2-40B4-BE49-F238E27FC236}">
+                <a16:creationId xmlns:a16="http://schemas.microsoft.com/office/drawing/2014/main" id="{E532B85B-2D71-4A92-99FB-30BEB78B8F7D}"/>
               </a:ext>
             </a:extLst>
           </p:cNvPr>
@@ -3651,10 +3354,10 @@
       </p:sp>
       <p:sp>
         <p:nvSpPr>
-          <p:cNvPr id="8" name="page-number">
-            <a:extLst xmlns:a="http://schemas.openxmlformats.org/drawingml/2006/main">
-              <a:ext uri="{FF2B5EF4-FFF2-40B4-BE49-F238E27FC236}">
-                <a16:creationId xmlns:a16="http://schemas.microsoft.com/office/drawing/2014/main" id="{5E738AA0-F411-4D81-926F-B60EEBFC2BFE}"/>
+          <p:cNvPr id="5" name="page-number">
+            <a:extLst xmlns:a="http://schemas.openxmlformats.org/drawingml/2006/main">
+              <a:ext uri="{FF2B5EF4-FFF2-40B4-BE49-F238E27FC236}">
+                <a16:creationId xmlns:a16="http://schemas.microsoft.com/office/drawing/2014/main" id="{A7BD08B3-8BB0-424C-BAA6-D813C7ED8B58}"/>
               </a:ext>
             </a:extLst>
           </p:cNvPr>
@@ -3709,10 +3412,10 @@
       </p:sp>
       <p:sp>
         <p:nvSpPr>
-          <p:cNvPr id="9" name="zero">
-            <a:extLst xmlns:a="http://schemas.openxmlformats.org/drawingml/2006/main">
-              <a:ext uri="{FF2B5EF4-FFF2-40B4-BE49-F238E27FC236}">
-                <a16:creationId xmlns:a16="http://schemas.microsoft.com/office/drawing/2014/main" id="{C84849C1-7A7D-462D-8DA5-76DDBF7ED86C}"/>
+          <p:cNvPr id="6" name="zero">
+            <a:extLst xmlns:a="http://schemas.openxmlformats.org/drawingml/2006/main">
+              <a:ext uri="{FF2B5EF4-FFF2-40B4-BE49-F238E27FC236}">
+                <a16:creationId xmlns:a16="http://schemas.microsoft.com/office/drawing/2014/main" id="{F0B8DDD3-6EB3-4280-AC64-C3DA35A7A728}"/>
               </a:ext>
             </a:extLst>
           </p:cNvPr>
@@ -3767,10 +3470,10 @@
       </p:sp>
       <p:sp>
         <p:nvSpPr>
-          <p:cNvPr id="10" name="zero-label">
-            <a:extLst xmlns:a="http://schemas.openxmlformats.org/drawingml/2006/main">
-              <a:ext uri="{FF2B5EF4-FFF2-40B4-BE49-F238E27FC236}">
-                <a16:creationId xmlns:a16="http://schemas.microsoft.com/office/drawing/2014/main" id="{0EA22C6B-5151-426B-8934-4A4D4C35C222}"/>
+          <p:cNvPr id="7" name="zero-label">
+            <a:extLst xmlns:a="http://schemas.openxmlformats.org/drawingml/2006/main">
+              <a:ext uri="{FF2B5EF4-FFF2-40B4-BE49-F238E27FC236}">
+                <a16:creationId xmlns:a16="http://schemas.microsoft.com/office/drawing/2014/main" id="{E70CA0E1-E38A-4397-88C3-507DF01FCD28}"/>
               </a:ext>
             </a:extLst>
           </p:cNvPr>
@@ -3825,10 +3528,10 @@
       </p:sp>
       <p:sp>
         <p:nvSpPr>
-          <p:cNvPr id="11" name="checks">
-            <a:extLst xmlns:a="http://schemas.openxmlformats.org/drawingml/2006/main">
-              <a:ext uri="{FF2B5EF4-FFF2-40B4-BE49-F238E27FC236}">
-                <a16:creationId xmlns:a16="http://schemas.microsoft.com/office/drawing/2014/main" id="{5004E058-0859-48BA-869B-93098F96915C}"/>
+          <p:cNvPr id="8" name="checks">
+            <a:extLst xmlns:a="http://schemas.openxmlformats.org/drawingml/2006/main">
+              <a:ext uri="{FF2B5EF4-FFF2-40B4-BE49-F238E27FC236}">
+                <a16:creationId xmlns:a16="http://schemas.microsoft.com/office/drawing/2014/main" id="{0F7F5B02-6D21-4937-91B7-8D67061EEBED}"/>
               </a:ext>
             </a:extLst>
           </p:cNvPr>
@@ -3952,10 +3655,10 @@
       </p:sp>
       <p:sp>
         <p:nvSpPr>
-          <p:cNvPr id="12" name="proof-boundary">
-            <a:extLst xmlns:a="http://schemas.openxmlformats.org/drawingml/2006/main">
-              <a:ext uri="{FF2B5EF4-FFF2-40B4-BE49-F238E27FC236}">
-                <a16:creationId xmlns:a16="http://schemas.microsoft.com/office/drawing/2014/main" id="{0FAACA9B-D1CD-44F6-92A8-4BCEFDDB46B4}"/>
+          <p:cNvPr id="9" name="proof-boundary">
+            <a:extLst xmlns:a="http://schemas.openxmlformats.org/drawingml/2006/main">
+              <a:ext uri="{FF2B5EF4-FFF2-40B4-BE49-F238E27FC236}">
+                <a16:creationId xmlns:a16="http://schemas.microsoft.com/office/drawing/2014/main" id="{FA06732F-1C0D-4DF4-B92E-CA60D4B14FB1}"/>
               </a:ext>
             </a:extLst>
           </p:cNvPr>
@@ -4011,7 +3714,7 @@
     </p:spTree>
     <p:extLst>
       <p:ext uri="{BB962C8B-B14F-4D97-AF65-F5344CB8AC3E}">
-        <p14:creationId xmlns:p14="http://schemas.microsoft.com/office/powerpoint/2010/main" val="1057595032"/>
+        <p14:creationId xmlns:p14="http://schemas.microsoft.com/office/powerpoint/2010/main" val="988433846"/>
       </p:ext>
     </p:extLst>
   </p:cSld>
@@ -4037,139 +3740,40 @@
       <p:grpSpPr>
         <a:xfrm xmlns:a="http://schemas.openxmlformats.org/drawingml/2006/main"/>
       </p:grpSpPr>
-      <p:sp>
-        <p:nvSpPr>
-          <p:cNvPr id="14" name="Hormuz mark boundary">
-            <a:extLst xmlns:a="http://schemas.openxmlformats.org/drawingml/2006/main">
-              <a:ext uri="{FF2B5EF4-FFF2-40B4-BE49-F238E27FC236}">
-                <a16:creationId xmlns:a16="http://schemas.microsoft.com/office/drawing/2014/main" id="{D002D86A-4D7D-4013-9413-4BC45C5C9EC4}"/>
-              </a:ext>
-            </a:extLst>
-          </p:cNvPr>
-          <p:cNvSpPr>
-            <a:spLocks xmlns:a="http://schemas.openxmlformats.org/drawingml/2006/main" noGrp="1"/>
-          </p:cNvSpPr>
-          <p:nvPr/>
-        </p:nvSpPr>
+      <p:pic>
+        <p:nvPicPr>
+          <p:cNvPr id="11" name=""/>
+          <p:cNvPicPr>
+            <a:picLocks xmlns:a="http://schemas.openxmlformats.org/drawingml/2006/main" noChangeAspect="1"/>
+          </p:cNvPicPr>
+          <p:nvPr/>
+        </p:nvPicPr>
+        <p:blipFill>
+          <a:blip xmlns:r="http://schemas.openxmlformats.org/officeDocument/2006/relationships" xmlns:a="http://schemas.openxmlformats.org/drawingml/2006/main" r:embed="R89f7239f82ca4ad4">
+            <a:extLst>
+              <a:ext uri="{96DAC541-7B7A-43D3-8B79-37D633B846F1}">
+                <asvg:svgBlip xmlns:asvg="http://schemas.microsoft.com/office/drawing/2016/SVG/main" r:embed="Ra562799fe926472e"/>
+              </a:ext>
+            </a:extLst>
+          </a:blip>
+          <a:stretch xmlns:a="http://schemas.openxmlformats.org/drawingml/2006/main"/>
+        </p:blipFill>
         <p:spPr>
           <a:xfrm xmlns:a="http://schemas.openxmlformats.org/drawingml/2006/main">
             <a:off x="11201400" y="333375"/>
             <a:ext cx="381000" cy="381000"/>
           </a:xfrm>
-          <a:prstGeom xmlns:a="http://schemas.openxmlformats.org/drawingml/2006/main" prst="ellipse">
-            <a:avLst/>
-          </a:prstGeom>
-          <a:noFill xmlns:a="http://schemas.openxmlformats.org/drawingml/2006/main"/>
-          <a:ln xmlns:a="http://schemas.openxmlformats.org/drawingml/2006/main" w="9525">
-            <a:solidFill>
-              <a:srgbClr val="31684B"/>
-            </a:solidFill>
-            <a:prstDash val="solid"/>
-          </a:ln>
-        </p:spPr>
-      </p:sp>
-      <p:sp>
-        <p:nvSpPr>
-          <p:cNvPr id="2" name="Hormuz mark bar 1">
-            <a:extLst xmlns:a="http://schemas.openxmlformats.org/drawingml/2006/main">
-              <a:ext uri="{FF2B5EF4-FFF2-40B4-BE49-F238E27FC236}">
-                <a16:creationId xmlns:a16="http://schemas.microsoft.com/office/drawing/2014/main" id="{8DF9FF7F-CF66-467A-AF40-DAEA03F3290D}"/>
-              </a:ext>
-            </a:extLst>
-          </p:cNvPr>
-          <p:cNvSpPr>
-            <a:spLocks xmlns:a="http://schemas.openxmlformats.org/drawingml/2006/main" noGrp="1"/>
-          </p:cNvSpPr>
-          <p:nvPr/>
-        </p:nvSpPr>
-        <p:spPr>
-          <a:xfrm xmlns:a="http://schemas.openxmlformats.org/drawingml/2006/main">
-            <a:off x="11287125" y="476250"/>
-            <a:ext cx="47625" cy="95250"/>
-          </a:xfrm>
-          <a:prstGeom xmlns:a="http://schemas.openxmlformats.org/drawingml/2006/main" prst="roundRect">
-            <a:avLst>
-              <a:gd name="adj" fmla="val 50000"/>
-            </a:avLst>
-          </a:prstGeom>
-          <a:solidFill xmlns:a="http://schemas.openxmlformats.org/drawingml/2006/main">
-            <a:srgbClr val="31684B"/>
-          </a:solidFill>
-          <a:ln xmlns:a="http://schemas.openxmlformats.org/drawingml/2006/main" w="0">
-            <a:noFill/>
-          </a:ln>
-        </p:spPr>
-      </p:sp>
-      <p:sp>
-        <p:nvSpPr>
-          <p:cNvPr id="3" name="Hormuz mark bar 2">
-            <a:extLst xmlns:a="http://schemas.openxmlformats.org/drawingml/2006/main">
-              <a:ext uri="{FF2B5EF4-FFF2-40B4-BE49-F238E27FC236}">
-                <a16:creationId xmlns:a16="http://schemas.microsoft.com/office/drawing/2014/main" id="{DABAFD9D-1C7B-4ADB-9B31-C6F6F9EBB8F7}"/>
-              </a:ext>
-            </a:extLst>
-          </p:cNvPr>
-          <p:cNvSpPr>
-            <a:spLocks xmlns:a="http://schemas.openxmlformats.org/drawingml/2006/main" noGrp="1"/>
-          </p:cNvSpPr>
-          <p:nvPr/>
-        </p:nvSpPr>
-        <p:spPr>
-          <a:xfrm xmlns:a="http://schemas.openxmlformats.org/drawingml/2006/main">
-            <a:off x="11363325" y="428625"/>
-            <a:ext cx="47625" cy="190500"/>
-          </a:xfrm>
-          <a:prstGeom xmlns:a="http://schemas.openxmlformats.org/drawingml/2006/main" prst="roundRect">
-            <a:avLst>
-              <a:gd name="adj" fmla="val 50000"/>
-            </a:avLst>
-          </a:prstGeom>
-          <a:solidFill xmlns:a="http://schemas.openxmlformats.org/drawingml/2006/main">
-            <a:srgbClr val="31684B"/>
-          </a:solidFill>
-          <a:ln xmlns:a="http://schemas.openxmlformats.org/drawingml/2006/main" w="0">
-            <a:noFill/>
-          </a:ln>
-        </p:spPr>
-      </p:sp>
-      <p:sp>
-        <p:nvSpPr>
-          <p:cNvPr id="4" name="Hormuz mark bar 3">
-            <a:extLst xmlns:a="http://schemas.openxmlformats.org/drawingml/2006/main">
-              <a:ext uri="{FF2B5EF4-FFF2-40B4-BE49-F238E27FC236}">
-                <a16:creationId xmlns:a16="http://schemas.microsoft.com/office/drawing/2014/main" id="{96F04905-E795-4140-9483-AE835B8998DD}"/>
-              </a:ext>
-            </a:extLst>
-          </p:cNvPr>
-          <p:cNvSpPr>
-            <a:spLocks xmlns:a="http://schemas.openxmlformats.org/drawingml/2006/main" noGrp="1"/>
-          </p:cNvSpPr>
-          <p:nvPr/>
-        </p:nvSpPr>
-        <p:spPr>
-          <a:xfrm xmlns:a="http://schemas.openxmlformats.org/drawingml/2006/main">
-            <a:off x="11439525" y="457200"/>
-            <a:ext cx="47625" cy="133350"/>
-          </a:xfrm>
-          <a:prstGeom xmlns:a="http://schemas.openxmlformats.org/drawingml/2006/main" prst="roundRect">
-            <a:avLst>
-              <a:gd name="adj" fmla="val 50000"/>
-            </a:avLst>
-          </a:prstGeom>
-          <a:solidFill xmlns:a="http://schemas.openxmlformats.org/drawingml/2006/main">
-            <a:srgbClr val="31684B"/>
-          </a:solidFill>
-          <a:ln xmlns:a="http://schemas.openxmlformats.org/drawingml/2006/main" w="0">
-            <a:noFill/>
-          </a:ln>
-        </p:spPr>
-      </p:sp>
-      <p:sp>
-        <p:nvSpPr>
-          <p:cNvPr id="5" name="section">
-            <a:extLst xmlns:a="http://schemas.openxmlformats.org/drawingml/2006/main">
-              <a:ext uri="{FF2B5EF4-FFF2-40B4-BE49-F238E27FC236}">
-                <a16:creationId xmlns:a16="http://schemas.microsoft.com/office/drawing/2014/main" id="{A6DEB700-49C4-49A4-AF2F-C220173C0989}"/>
+          <a:prstGeom xmlns:a="http://schemas.openxmlformats.org/drawingml/2006/main" prst="rect">
+            <a:avLst/>
+          </a:prstGeom>
+        </p:spPr>
+      </p:pic>
+      <p:sp>
+        <p:nvSpPr>
+          <p:cNvPr id="2" name="section">
+            <a:extLst xmlns:a="http://schemas.openxmlformats.org/drawingml/2006/main">
+              <a:ext uri="{FF2B5EF4-FFF2-40B4-BE49-F238E27FC236}">
+                <a16:creationId xmlns:a16="http://schemas.microsoft.com/office/drawing/2014/main" id="{28A3C433-A600-462C-9516-54E883ACF25E}"/>
               </a:ext>
             </a:extLst>
           </p:cNvPr>
@@ -4224,10 +3828,10 @@
       </p:sp>
       <p:sp>
         <p:nvSpPr>
-          <p:cNvPr id="6" name="takeaway">
-            <a:extLst xmlns:a="http://schemas.openxmlformats.org/drawingml/2006/main">
-              <a:ext uri="{FF2B5EF4-FFF2-40B4-BE49-F238E27FC236}">
-                <a16:creationId xmlns:a16="http://schemas.microsoft.com/office/drawing/2014/main" id="{C4DBF591-92E5-4CD4-8FA8-1BFE844AAC54}"/>
+          <p:cNvPr id="3" name="takeaway">
+            <a:extLst xmlns:a="http://schemas.openxmlformats.org/drawingml/2006/main">
+              <a:ext uri="{FF2B5EF4-FFF2-40B4-BE49-F238E27FC236}">
+                <a16:creationId xmlns:a16="http://schemas.microsoft.com/office/drawing/2014/main" id="{0332C878-26E5-4503-BDF9-60DBC0F2460B}"/>
               </a:ext>
             </a:extLst>
           </p:cNvPr>
@@ -4282,10 +3886,10 @@
       </p:sp>
       <p:sp>
         <p:nvSpPr>
-          <p:cNvPr id="7" name="footer">
-            <a:extLst xmlns:a="http://schemas.openxmlformats.org/drawingml/2006/main">
-              <a:ext uri="{FF2B5EF4-FFF2-40B4-BE49-F238E27FC236}">
-                <a16:creationId xmlns:a16="http://schemas.microsoft.com/office/drawing/2014/main" id="{FB81E9A3-EB12-41CA-99DE-7AA52300399F}"/>
+          <p:cNvPr id="4" name="footer">
+            <a:extLst xmlns:a="http://schemas.openxmlformats.org/drawingml/2006/main">
+              <a:ext uri="{FF2B5EF4-FFF2-40B4-BE49-F238E27FC236}">
+                <a16:creationId xmlns:a16="http://schemas.microsoft.com/office/drawing/2014/main" id="{34A6678F-E2EA-4D6A-AA80-D46BE7DE3026}"/>
               </a:ext>
             </a:extLst>
           </p:cNvPr>
@@ -4340,10 +3944,10 @@
       </p:sp>
       <p:sp>
         <p:nvSpPr>
-          <p:cNvPr id="8" name="page-number">
-            <a:extLst xmlns:a="http://schemas.openxmlformats.org/drawingml/2006/main">
-              <a:ext uri="{FF2B5EF4-FFF2-40B4-BE49-F238E27FC236}">
-                <a16:creationId xmlns:a16="http://schemas.microsoft.com/office/drawing/2014/main" id="{91057037-058E-47AD-A9D0-0BCD9D03E15B}"/>
+          <p:cNvPr id="5" name="page-number">
+            <a:extLst xmlns:a="http://schemas.openxmlformats.org/drawingml/2006/main">
+              <a:ext uri="{FF2B5EF4-FFF2-40B4-BE49-F238E27FC236}">
+                <a16:creationId xmlns:a16="http://schemas.microsoft.com/office/drawing/2014/main" id="{8C64FE29-EA6C-47A8-A19E-BE4D7ED73E20}"/>
               </a:ext>
             </a:extLst>
           </p:cNvPr>
@@ -4398,10 +4002,10 @@
       </p:sp>
       <p:sp>
         <p:nvSpPr>
-          <p:cNvPr id="9" name="oss-title">
-            <a:extLst xmlns:a="http://schemas.openxmlformats.org/drawingml/2006/main">
-              <a:ext uri="{FF2B5EF4-FFF2-40B4-BE49-F238E27FC236}">
-                <a16:creationId xmlns:a16="http://schemas.microsoft.com/office/drawing/2014/main" id="{2BE7EA69-4982-44A9-AF60-0B214D4824C5}"/>
+          <p:cNvPr id="6" name="oss-title">
+            <a:extLst xmlns:a="http://schemas.openxmlformats.org/drawingml/2006/main">
+              <a:ext uri="{FF2B5EF4-FFF2-40B4-BE49-F238E27FC236}">
+                <a16:creationId xmlns:a16="http://schemas.microsoft.com/office/drawing/2014/main" id="{DEBC22E6-9FD1-4EA9-9324-4C19CDAB8C20}"/>
               </a:ext>
             </a:extLst>
           </p:cNvPr>
@@ -4456,10 +4060,10 @@
       </p:sp>
       <p:sp>
         <p:nvSpPr>
-          <p:cNvPr id="10" name="oss-body">
-            <a:extLst xmlns:a="http://schemas.openxmlformats.org/drawingml/2006/main">
-              <a:ext uri="{FF2B5EF4-FFF2-40B4-BE49-F238E27FC236}">
-                <a16:creationId xmlns:a16="http://schemas.microsoft.com/office/drawing/2014/main" id="{48B82B0E-A82C-4C5B-8A5E-3452E70C3C9A}"/>
+          <p:cNvPr id="7" name="oss-body">
+            <a:extLst xmlns:a="http://schemas.openxmlformats.org/drawingml/2006/main">
+              <a:ext uri="{FF2B5EF4-FFF2-40B4-BE49-F238E27FC236}">
+                <a16:creationId xmlns:a16="http://schemas.microsoft.com/office/drawing/2014/main" id="{73380E0E-10C0-4E4D-B9E4-07EA2FC858F9}"/>
               </a:ext>
             </a:extLst>
           </p:cNvPr>
@@ -4606,10 +4210,10 @@
       </p:sp>
       <p:sp>
         <p:nvSpPr>
-          <p:cNvPr id="11" name="paid-title">
-            <a:extLst xmlns:a="http://schemas.openxmlformats.org/drawingml/2006/main">
-              <a:ext uri="{FF2B5EF4-FFF2-40B4-BE49-F238E27FC236}">
-                <a16:creationId xmlns:a16="http://schemas.microsoft.com/office/drawing/2014/main" id="{25145E82-B9E9-493A-8AE9-5D9CE411CC63}"/>
+          <p:cNvPr id="8" name="paid-title">
+            <a:extLst xmlns:a="http://schemas.openxmlformats.org/drawingml/2006/main">
+              <a:ext uri="{FF2B5EF4-FFF2-40B4-BE49-F238E27FC236}">
+                <a16:creationId xmlns:a16="http://schemas.microsoft.com/office/drawing/2014/main" id="{5A7C70DB-B076-4687-93A0-2C2654232177}"/>
               </a:ext>
             </a:extLst>
           </p:cNvPr>
@@ -4664,10 +4268,10 @@
       </p:sp>
       <p:sp>
         <p:nvSpPr>
-          <p:cNvPr id="12" name="paid-body">
-            <a:extLst xmlns:a="http://schemas.openxmlformats.org/drawingml/2006/main">
-              <a:ext uri="{FF2B5EF4-FFF2-40B4-BE49-F238E27FC236}">
-                <a16:creationId xmlns:a16="http://schemas.microsoft.com/office/drawing/2014/main" id="{E64D9F00-E499-4918-B60C-C0B6C81C8388}"/>
+          <p:cNvPr id="9" name="paid-body">
+            <a:extLst xmlns:a="http://schemas.openxmlformats.org/drawingml/2006/main">
+              <a:ext uri="{FF2B5EF4-FFF2-40B4-BE49-F238E27FC236}">
+                <a16:creationId xmlns:a16="http://schemas.microsoft.com/office/drawing/2014/main" id="{46D5E578-194E-4779-AD67-B50F571815CD}"/>
               </a:ext>
             </a:extLst>
           </p:cNvPr>
@@ -4814,10 +4418,10 @@
       </p:sp>
       <p:sp>
         <p:nvSpPr>
-          <p:cNvPr id="13" name="same-core">
-            <a:extLst xmlns:a="http://schemas.openxmlformats.org/drawingml/2006/main">
-              <a:ext uri="{FF2B5EF4-FFF2-40B4-BE49-F238E27FC236}">
-                <a16:creationId xmlns:a16="http://schemas.microsoft.com/office/drawing/2014/main" id="{AB4CC30F-EACE-4E3C-A585-BDBB418B56C9}"/>
+          <p:cNvPr id="10" name="same-core">
+            <a:extLst xmlns:a="http://schemas.openxmlformats.org/drawingml/2006/main">
+              <a:ext uri="{FF2B5EF4-FFF2-40B4-BE49-F238E27FC236}">
+                <a16:creationId xmlns:a16="http://schemas.microsoft.com/office/drawing/2014/main" id="{0C699C64-37CF-407F-895E-160B284F7DB2}"/>
               </a:ext>
             </a:extLst>
           </p:cNvPr>
@@ -4873,7 +4477,7 @@
     </p:spTree>
     <p:extLst>
       <p:ext uri="{BB962C8B-B14F-4D97-AF65-F5344CB8AC3E}">
-        <p14:creationId xmlns:p14="http://schemas.microsoft.com/office/powerpoint/2010/main" val="1027642876"/>
+        <p14:creationId xmlns:p14="http://schemas.microsoft.com/office/powerpoint/2010/main" val="765567838"/>
       </p:ext>
     </p:extLst>
   </p:cSld>
@@ -4899,139 +4503,40 @@
       <p:grpSpPr>
         <a:xfrm xmlns:a="http://schemas.openxmlformats.org/drawingml/2006/main"/>
       </p:grpSpPr>
-      <p:sp>
-        <p:nvSpPr>
-          <p:cNvPr id="13" name="Hormuz mark boundary">
-            <a:extLst xmlns:a="http://schemas.openxmlformats.org/drawingml/2006/main">
-              <a:ext uri="{FF2B5EF4-FFF2-40B4-BE49-F238E27FC236}">
-                <a16:creationId xmlns:a16="http://schemas.microsoft.com/office/drawing/2014/main" id="{38529B8C-6DD1-48AB-A155-EC9C83666202}"/>
-              </a:ext>
-            </a:extLst>
-          </p:cNvPr>
-          <p:cNvSpPr>
-            <a:spLocks xmlns:a="http://schemas.openxmlformats.org/drawingml/2006/main" noGrp="1"/>
-          </p:cNvSpPr>
-          <p:nvPr/>
-        </p:nvSpPr>
+      <p:pic>
+        <p:nvPicPr>
+          <p:cNvPr id="10" name=""/>
+          <p:cNvPicPr>
+            <a:picLocks xmlns:a="http://schemas.openxmlformats.org/drawingml/2006/main" noChangeAspect="1"/>
+          </p:cNvPicPr>
+          <p:nvPr/>
+        </p:nvPicPr>
+        <p:blipFill>
+          <a:blip xmlns:r="http://schemas.openxmlformats.org/officeDocument/2006/relationships" xmlns:a="http://schemas.openxmlformats.org/drawingml/2006/main" r:embed="Re3cd6281265a4a59">
+            <a:extLst>
+              <a:ext uri="{96DAC541-7B7A-43D3-8B79-37D633B846F1}">
+                <asvg:svgBlip xmlns:asvg="http://schemas.microsoft.com/office/drawing/2016/SVG/main" r:embed="R5c20ed34cbbc4d09"/>
+              </a:ext>
+            </a:extLst>
+          </a:blip>
+          <a:stretch xmlns:a="http://schemas.openxmlformats.org/drawingml/2006/main"/>
+        </p:blipFill>
         <p:spPr>
           <a:xfrm xmlns:a="http://schemas.openxmlformats.org/drawingml/2006/main">
             <a:off x="11201400" y="333375"/>
             <a:ext cx="381000" cy="381000"/>
           </a:xfrm>
-          <a:prstGeom xmlns:a="http://schemas.openxmlformats.org/drawingml/2006/main" prst="ellipse">
-            <a:avLst/>
-          </a:prstGeom>
-          <a:noFill xmlns:a="http://schemas.openxmlformats.org/drawingml/2006/main"/>
-          <a:ln xmlns:a="http://schemas.openxmlformats.org/drawingml/2006/main" w="9525">
-            <a:solidFill>
-              <a:srgbClr val="31684B"/>
-            </a:solidFill>
-            <a:prstDash val="solid"/>
-          </a:ln>
-        </p:spPr>
-      </p:sp>
-      <p:sp>
-        <p:nvSpPr>
-          <p:cNvPr id="2" name="Hormuz mark bar 1">
-            <a:extLst xmlns:a="http://schemas.openxmlformats.org/drawingml/2006/main">
-              <a:ext uri="{FF2B5EF4-FFF2-40B4-BE49-F238E27FC236}">
-                <a16:creationId xmlns:a16="http://schemas.microsoft.com/office/drawing/2014/main" id="{FC629D12-FF25-4EE5-8FCC-FD71EAD84FB0}"/>
-              </a:ext>
-            </a:extLst>
-          </p:cNvPr>
-          <p:cNvSpPr>
-            <a:spLocks xmlns:a="http://schemas.openxmlformats.org/drawingml/2006/main" noGrp="1"/>
-          </p:cNvSpPr>
-          <p:nvPr/>
-        </p:nvSpPr>
-        <p:spPr>
-          <a:xfrm xmlns:a="http://schemas.openxmlformats.org/drawingml/2006/main">
-            <a:off x="11287125" y="476250"/>
-            <a:ext cx="47625" cy="95250"/>
-          </a:xfrm>
-          <a:prstGeom xmlns:a="http://schemas.openxmlformats.org/drawingml/2006/main" prst="roundRect">
-            <a:avLst>
-              <a:gd name="adj" fmla="val 50000"/>
-            </a:avLst>
-          </a:prstGeom>
-          <a:solidFill xmlns:a="http://schemas.openxmlformats.org/drawingml/2006/main">
-            <a:srgbClr val="31684B"/>
-          </a:solidFill>
-          <a:ln xmlns:a="http://schemas.openxmlformats.org/drawingml/2006/main" w="0">
-            <a:noFill/>
-          </a:ln>
-        </p:spPr>
-      </p:sp>
-      <p:sp>
-        <p:nvSpPr>
-          <p:cNvPr id="3" name="Hormuz mark bar 2">
-            <a:extLst xmlns:a="http://schemas.openxmlformats.org/drawingml/2006/main">
-              <a:ext uri="{FF2B5EF4-FFF2-40B4-BE49-F238E27FC236}">
-                <a16:creationId xmlns:a16="http://schemas.microsoft.com/office/drawing/2014/main" id="{03522793-D55F-4DE7-8410-35596C92BDCE}"/>
-              </a:ext>
-            </a:extLst>
-          </p:cNvPr>
-          <p:cNvSpPr>
-            <a:spLocks xmlns:a="http://schemas.openxmlformats.org/drawingml/2006/main" noGrp="1"/>
-          </p:cNvSpPr>
-          <p:nvPr/>
-        </p:nvSpPr>
-        <p:spPr>
-          <a:xfrm xmlns:a="http://schemas.openxmlformats.org/drawingml/2006/main">
-            <a:off x="11363325" y="428625"/>
-            <a:ext cx="47625" cy="190500"/>
-          </a:xfrm>
-          <a:prstGeom xmlns:a="http://schemas.openxmlformats.org/drawingml/2006/main" prst="roundRect">
-            <a:avLst>
-              <a:gd name="adj" fmla="val 50000"/>
-            </a:avLst>
-          </a:prstGeom>
-          <a:solidFill xmlns:a="http://schemas.openxmlformats.org/drawingml/2006/main">
-            <a:srgbClr val="31684B"/>
-          </a:solidFill>
-          <a:ln xmlns:a="http://schemas.openxmlformats.org/drawingml/2006/main" w="0">
-            <a:noFill/>
-          </a:ln>
-        </p:spPr>
-      </p:sp>
-      <p:sp>
-        <p:nvSpPr>
-          <p:cNvPr id="4" name="Hormuz mark bar 3">
-            <a:extLst xmlns:a="http://schemas.openxmlformats.org/drawingml/2006/main">
-              <a:ext uri="{FF2B5EF4-FFF2-40B4-BE49-F238E27FC236}">
-                <a16:creationId xmlns:a16="http://schemas.microsoft.com/office/drawing/2014/main" id="{CEAB5B2D-50DC-46B3-80EC-E977FB5DBB32}"/>
-              </a:ext>
-            </a:extLst>
-          </p:cNvPr>
-          <p:cNvSpPr>
-            <a:spLocks xmlns:a="http://schemas.openxmlformats.org/drawingml/2006/main" noGrp="1"/>
-          </p:cNvSpPr>
-          <p:nvPr/>
-        </p:nvSpPr>
-        <p:spPr>
-          <a:xfrm xmlns:a="http://schemas.openxmlformats.org/drawingml/2006/main">
-            <a:off x="11439525" y="457200"/>
-            <a:ext cx="47625" cy="133350"/>
-          </a:xfrm>
-          <a:prstGeom xmlns:a="http://schemas.openxmlformats.org/drawingml/2006/main" prst="roundRect">
-            <a:avLst>
-              <a:gd name="adj" fmla="val 50000"/>
-            </a:avLst>
-          </a:prstGeom>
-          <a:solidFill xmlns:a="http://schemas.openxmlformats.org/drawingml/2006/main">
-            <a:srgbClr val="31684B"/>
-          </a:solidFill>
-          <a:ln xmlns:a="http://schemas.openxmlformats.org/drawingml/2006/main" w="0">
-            <a:noFill/>
-          </a:ln>
-        </p:spPr>
-      </p:sp>
-      <p:sp>
-        <p:nvSpPr>
-          <p:cNvPr id="5" name="section">
-            <a:extLst xmlns:a="http://schemas.openxmlformats.org/drawingml/2006/main">
-              <a:ext uri="{FF2B5EF4-FFF2-40B4-BE49-F238E27FC236}">
-                <a16:creationId xmlns:a16="http://schemas.microsoft.com/office/drawing/2014/main" id="{57E2B7DB-A528-4B5D-A7AD-9F44198835C4}"/>
+          <a:prstGeom xmlns:a="http://schemas.openxmlformats.org/drawingml/2006/main" prst="rect">
+            <a:avLst/>
+          </a:prstGeom>
+        </p:spPr>
+      </p:pic>
+      <p:sp>
+        <p:nvSpPr>
+          <p:cNvPr id="2" name="section">
+            <a:extLst xmlns:a="http://schemas.openxmlformats.org/drawingml/2006/main">
+              <a:ext uri="{FF2B5EF4-FFF2-40B4-BE49-F238E27FC236}">
+                <a16:creationId xmlns:a16="http://schemas.microsoft.com/office/drawing/2014/main" id="{DDB3BF24-1935-4E13-BBD0-374D852A62A0}"/>
               </a:ext>
             </a:extLst>
           </p:cNvPr>
@@ -5086,10 +4591,10 @@
       </p:sp>
       <p:sp>
         <p:nvSpPr>
-          <p:cNvPr id="6" name="takeaway">
-            <a:extLst xmlns:a="http://schemas.openxmlformats.org/drawingml/2006/main">
-              <a:ext uri="{FF2B5EF4-FFF2-40B4-BE49-F238E27FC236}">
-                <a16:creationId xmlns:a16="http://schemas.microsoft.com/office/drawing/2014/main" id="{4C59ABBD-6CA8-4C06-B334-DDC180591784}"/>
+          <p:cNvPr id="3" name="takeaway">
+            <a:extLst xmlns:a="http://schemas.openxmlformats.org/drawingml/2006/main">
+              <a:ext uri="{FF2B5EF4-FFF2-40B4-BE49-F238E27FC236}">
+                <a16:creationId xmlns:a16="http://schemas.microsoft.com/office/drawing/2014/main" id="{8FA73E07-AE73-4FE8-B314-04CBBEBB8ED6}"/>
               </a:ext>
             </a:extLst>
           </p:cNvPr>
@@ -5144,10 +4649,10 @@
       </p:sp>
       <p:sp>
         <p:nvSpPr>
-          <p:cNvPr id="7" name="footer">
-            <a:extLst xmlns:a="http://schemas.openxmlformats.org/drawingml/2006/main">
-              <a:ext uri="{FF2B5EF4-FFF2-40B4-BE49-F238E27FC236}">
-                <a16:creationId xmlns:a16="http://schemas.microsoft.com/office/drawing/2014/main" id="{13970EDB-2AFC-4B9B-8D86-1F55CF47B049}"/>
+          <p:cNvPr id="4" name="footer">
+            <a:extLst xmlns:a="http://schemas.openxmlformats.org/drawingml/2006/main">
+              <a:ext uri="{FF2B5EF4-FFF2-40B4-BE49-F238E27FC236}">
+                <a16:creationId xmlns:a16="http://schemas.microsoft.com/office/drawing/2014/main" id="{809CAB2F-47B7-463E-AAC3-A9BA2A0C52D6}"/>
               </a:ext>
             </a:extLst>
           </p:cNvPr>
@@ -5202,10 +4707,10 @@
       </p:sp>
       <p:sp>
         <p:nvSpPr>
-          <p:cNvPr id="8" name="page-number">
-            <a:extLst xmlns:a="http://schemas.openxmlformats.org/drawingml/2006/main">
-              <a:ext uri="{FF2B5EF4-FFF2-40B4-BE49-F238E27FC236}">
-                <a16:creationId xmlns:a16="http://schemas.microsoft.com/office/drawing/2014/main" id="{789160AD-0629-490C-9B1B-F9E898C302DA}"/>
+          <p:cNvPr id="5" name="page-number">
+            <a:extLst xmlns:a="http://schemas.openxmlformats.org/drawingml/2006/main">
+              <a:ext uri="{FF2B5EF4-FFF2-40B4-BE49-F238E27FC236}">
+                <a16:creationId xmlns:a16="http://schemas.microsoft.com/office/drawing/2014/main" id="{593F1CF3-AA26-419D-B613-11F80EF80E2A}"/>
               </a:ext>
             </a:extLst>
           </p:cNvPr>
@@ -5260,10 +4765,10 @@
       </p:sp>
       <p:sp>
         <p:nvSpPr>
-          <p:cNvPr id="9" name="release">
-            <a:extLst xmlns:a="http://schemas.openxmlformats.org/drawingml/2006/main">
-              <a:ext uri="{FF2B5EF4-FFF2-40B4-BE49-F238E27FC236}">
-                <a16:creationId xmlns:a16="http://schemas.microsoft.com/office/drawing/2014/main" id="{04995EB8-AF83-4A42-95F4-E09ADA394300}"/>
+          <p:cNvPr id="6" name="release">
+            <a:extLst xmlns:a="http://schemas.openxmlformats.org/drawingml/2006/main">
+              <a:ext uri="{FF2B5EF4-FFF2-40B4-BE49-F238E27FC236}">
+                <a16:creationId xmlns:a16="http://schemas.microsoft.com/office/drawing/2014/main" id="{D63E1231-E3F4-4FB5-8965-F987095A3FA8}"/>
               </a:ext>
             </a:extLst>
           </p:cNvPr>
@@ -5318,10 +4823,10 @@
       </p:sp>
       <p:sp>
         <p:nvSpPr>
-          <p:cNvPr id="10" name="oci">
-            <a:extLst xmlns:a="http://schemas.openxmlformats.org/drawingml/2006/main">
-              <a:ext uri="{FF2B5EF4-FFF2-40B4-BE49-F238E27FC236}">
-                <a16:creationId xmlns:a16="http://schemas.microsoft.com/office/drawing/2014/main" id="{446426B3-E045-4995-87E3-34E43FA824F9}"/>
+          <p:cNvPr id="7" name="oci">
+            <a:extLst xmlns:a="http://schemas.openxmlformats.org/drawingml/2006/main">
+              <a:ext uri="{FF2B5EF4-FFF2-40B4-BE49-F238E27FC236}">
+                <a16:creationId xmlns:a16="http://schemas.microsoft.com/office/drawing/2014/main" id="{9D7DF6A6-F27C-4E3D-9871-5D4937456172}"/>
               </a:ext>
             </a:extLst>
           </p:cNvPr>
@@ -5376,10 +4881,10 @@
       </p:sp>
       <p:sp>
         <p:nvSpPr>
-          <p:cNvPr id="11" name="operators">
-            <a:extLst xmlns:a="http://schemas.openxmlformats.org/drawingml/2006/main">
-              <a:ext uri="{FF2B5EF4-FFF2-40B4-BE49-F238E27FC236}">
-                <a16:creationId xmlns:a16="http://schemas.microsoft.com/office/drawing/2014/main" id="{5E0B17BE-F452-4E0B-9523-EDCBD118E36F}"/>
+          <p:cNvPr id="8" name="operators">
+            <a:extLst xmlns:a="http://schemas.openxmlformats.org/drawingml/2006/main">
+              <a:ext uri="{FF2B5EF4-FFF2-40B4-BE49-F238E27FC236}">
+                <a16:creationId xmlns:a16="http://schemas.microsoft.com/office/drawing/2014/main" id="{3C789051-5BF2-404E-A3A9-2C3521F83682}"/>
               </a:ext>
             </a:extLst>
           </p:cNvPr>
@@ -5434,10 +4939,10 @@
       </p:sp>
       <p:sp>
         <p:nvSpPr>
-          <p:cNvPr id="12" name="nonclaims">
-            <a:extLst xmlns:a="http://schemas.openxmlformats.org/drawingml/2006/main">
-              <a:ext uri="{FF2B5EF4-FFF2-40B4-BE49-F238E27FC236}">
-                <a16:creationId xmlns:a16="http://schemas.microsoft.com/office/drawing/2014/main" id="{55714865-0A4D-4D4D-92CF-4C8C0A90CCD0}"/>
+          <p:cNvPr id="9" name="nonclaims">
+            <a:extLst xmlns:a="http://schemas.openxmlformats.org/drawingml/2006/main">
+              <a:ext uri="{FF2B5EF4-FFF2-40B4-BE49-F238E27FC236}">
+                <a16:creationId xmlns:a16="http://schemas.microsoft.com/office/drawing/2014/main" id="{5A28C66B-751A-4F47-BDBF-C55CDD6B15B0}"/>
               </a:ext>
             </a:extLst>
           </p:cNvPr>
@@ -5493,7 +4998,7 @@
     </p:spTree>
     <p:extLst>
       <p:ext uri="{BB962C8B-B14F-4D97-AF65-F5344CB8AC3E}">
-        <p14:creationId xmlns:p14="http://schemas.microsoft.com/office/powerpoint/2010/main" val="1223543956"/>
+        <p14:creationId xmlns:p14="http://schemas.microsoft.com/office/powerpoint/2010/main" val="1221232574"/>
       </p:ext>
     </p:extLst>
   </p:cSld>
@@ -5519,139 +5024,40 @@
       <p:grpSpPr>
         <a:xfrm xmlns:a="http://schemas.openxmlformats.org/drawingml/2006/main"/>
       </p:grpSpPr>
-      <p:sp>
-        <p:nvSpPr>
-          <p:cNvPr id="19" name="Hormuz mark boundary">
-            <a:extLst xmlns:a="http://schemas.openxmlformats.org/drawingml/2006/main">
-              <a:ext uri="{FF2B5EF4-FFF2-40B4-BE49-F238E27FC236}">
-                <a16:creationId xmlns:a16="http://schemas.microsoft.com/office/drawing/2014/main" id="{E8000EB6-088A-4268-84B4-9DC862C3752B}"/>
-              </a:ext>
-            </a:extLst>
-          </p:cNvPr>
-          <p:cNvSpPr>
-            <a:spLocks xmlns:a="http://schemas.openxmlformats.org/drawingml/2006/main" noGrp="1"/>
-          </p:cNvSpPr>
-          <p:nvPr/>
-        </p:nvSpPr>
+      <p:pic>
+        <p:nvPicPr>
+          <p:cNvPr id="16" name=""/>
+          <p:cNvPicPr>
+            <a:picLocks xmlns:a="http://schemas.openxmlformats.org/drawingml/2006/main" noChangeAspect="1"/>
+          </p:cNvPicPr>
+          <p:nvPr/>
+        </p:nvPicPr>
+        <p:blipFill>
+          <a:blip xmlns:r="http://schemas.openxmlformats.org/officeDocument/2006/relationships" xmlns:a="http://schemas.openxmlformats.org/drawingml/2006/main" r:embed="R1bfd5982f2ef4904">
+            <a:extLst>
+              <a:ext uri="{96DAC541-7B7A-43D3-8B79-37D633B846F1}">
+                <asvg:svgBlip xmlns:asvg="http://schemas.microsoft.com/office/drawing/2016/SVG/main" r:embed="R6417a8acd26143ea"/>
+              </a:ext>
+            </a:extLst>
+          </a:blip>
+          <a:stretch xmlns:a="http://schemas.openxmlformats.org/drawingml/2006/main"/>
+        </p:blipFill>
         <p:spPr>
           <a:xfrm xmlns:a="http://schemas.openxmlformats.org/drawingml/2006/main">
             <a:off x="11201400" y="333375"/>
             <a:ext cx="381000" cy="381000"/>
           </a:xfrm>
-          <a:prstGeom xmlns:a="http://schemas.openxmlformats.org/drawingml/2006/main" prst="ellipse">
-            <a:avLst/>
-          </a:prstGeom>
-          <a:noFill xmlns:a="http://schemas.openxmlformats.org/drawingml/2006/main"/>
-          <a:ln xmlns:a="http://schemas.openxmlformats.org/drawingml/2006/main" w="9525">
-            <a:solidFill>
-              <a:srgbClr val="31684B"/>
-            </a:solidFill>
-            <a:prstDash val="solid"/>
-          </a:ln>
-        </p:spPr>
-      </p:sp>
-      <p:sp>
-        <p:nvSpPr>
-          <p:cNvPr id="2" name="Hormuz mark bar 1">
-            <a:extLst xmlns:a="http://schemas.openxmlformats.org/drawingml/2006/main">
-              <a:ext uri="{FF2B5EF4-FFF2-40B4-BE49-F238E27FC236}">
-                <a16:creationId xmlns:a16="http://schemas.microsoft.com/office/drawing/2014/main" id="{52EBD7E2-070D-47B7-AD51-DD36EB7A3FC1}"/>
-              </a:ext>
-            </a:extLst>
-          </p:cNvPr>
-          <p:cNvSpPr>
-            <a:spLocks xmlns:a="http://schemas.openxmlformats.org/drawingml/2006/main" noGrp="1"/>
-          </p:cNvSpPr>
-          <p:nvPr/>
-        </p:nvSpPr>
-        <p:spPr>
-          <a:xfrm xmlns:a="http://schemas.openxmlformats.org/drawingml/2006/main">
-            <a:off x="11287125" y="476250"/>
-            <a:ext cx="47625" cy="95250"/>
-          </a:xfrm>
-          <a:prstGeom xmlns:a="http://schemas.openxmlformats.org/drawingml/2006/main" prst="roundRect">
-            <a:avLst>
-              <a:gd name="adj" fmla="val 50000"/>
-            </a:avLst>
-          </a:prstGeom>
-          <a:solidFill xmlns:a="http://schemas.openxmlformats.org/drawingml/2006/main">
-            <a:srgbClr val="31684B"/>
-          </a:solidFill>
-          <a:ln xmlns:a="http://schemas.openxmlformats.org/drawingml/2006/main" w="0">
-            <a:noFill/>
-          </a:ln>
-        </p:spPr>
-      </p:sp>
-      <p:sp>
-        <p:nvSpPr>
-          <p:cNvPr id="3" name="Hormuz mark bar 2">
-            <a:extLst xmlns:a="http://schemas.openxmlformats.org/drawingml/2006/main">
-              <a:ext uri="{FF2B5EF4-FFF2-40B4-BE49-F238E27FC236}">
-                <a16:creationId xmlns:a16="http://schemas.microsoft.com/office/drawing/2014/main" id="{06F3567A-B671-4C99-BD52-FF1E7F53ED43}"/>
-              </a:ext>
-            </a:extLst>
-          </p:cNvPr>
-          <p:cNvSpPr>
-            <a:spLocks xmlns:a="http://schemas.openxmlformats.org/drawingml/2006/main" noGrp="1"/>
-          </p:cNvSpPr>
-          <p:nvPr/>
-        </p:nvSpPr>
-        <p:spPr>
-          <a:xfrm xmlns:a="http://schemas.openxmlformats.org/drawingml/2006/main">
-            <a:off x="11363325" y="428625"/>
-            <a:ext cx="47625" cy="190500"/>
-          </a:xfrm>
-          <a:prstGeom xmlns:a="http://schemas.openxmlformats.org/drawingml/2006/main" prst="roundRect">
-            <a:avLst>
-              <a:gd name="adj" fmla="val 50000"/>
-            </a:avLst>
-          </a:prstGeom>
-          <a:solidFill xmlns:a="http://schemas.openxmlformats.org/drawingml/2006/main">
-            <a:srgbClr val="31684B"/>
-          </a:solidFill>
-          <a:ln xmlns:a="http://schemas.openxmlformats.org/drawingml/2006/main" w="0">
-            <a:noFill/>
-          </a:ln>
-        </p:spPr>
-      </p:sp>
-      <p:sp>
-        <p:nvSpPr>
-          <p:cNvPr id="4" name="Hormuz mark bar 3">
-            <a:extLst xmlns:a="http://schemas.openxmlformats.org/drawingml/2006/main">
-              <a:ext uri="{FF2B5EF4-FFF2-40B4-BE49-F238E27FC236}">
-                <a16:creationId xmlns:a16="http://schemas.microsoft.com/office/drawing/2014/main" id="{2226E4F3-627D-4A7B-9DB3-D8391D5125C5}"/>
-              </a:ext>
-            </a:extLst>
-          </p:cNvPr>
-          <p:cNvSpPr>
-            <a:spLocks xmlns:a="http://schemas.openxmlformats.org/drawingml/2006/main" noGrp="1"/>
-          </p:cNvSpPr>
-          <p:nvPr/>
-        </p:nvSpPr>
-        <p:spPr>
-          <a:xfrm xmlns:a="http://schemas.openxmlformats.org/drawingml/2006/main">
-            <a:off x="11439525" y="457200"/>
-            <a:ext cx="47625" cy="133350"/>
-          </a:xfrm>
-          <a:prstGeom xmlns:a="http://schemas.openxmlformats.org/drawingml/2006/main" prst="roundRect">
-            <a:avLst>
-              <a:gd name="adj" fmla="val 50000"/>
-            </a:avLst>
-          </a:prstGeom>
-          <a:solidFill xmlns:a="http://schemas.openxmlformats.org/drawingml/2006/main">
-            <a:srgbClr val="31684B"/>
-          </a:solidFill>
-          <a:ln xmlns:a="http://schemas.openxmlformats.org/drawingml/2006/main" w="0">
-            <a:noFill/>
-          </a:ln>
-        </p:spPr>
-      </p:sp>
-      <p:sp>
-        <p:nvSpPr>
-          <p:cNvPr id="5" name="section">
-            <a:extLst xmlns:a="http://schemas.openxmlformats.org/drawingml/2006/main">
-              <a:ext uri="{FF2B5EF4-FFF2-40B4-BE49-F238E27FC236}">
-                <a16:creationId xmlns:a16="http://schemas.microsoft.com/office/drawing/2014/main" id="{443588CD-FF48-44F7-8A1A-436B829D0CB7}"/>
+          <a:prstGeom xmlns:a="http://schemas.openxmlformats.org/drawingml/2006/main" prst="rect">
+            <a:avLst/>
+          </a:prstGeom>
+        </p:spPr>
+      </p:pic>
+      <p:sp>
+        <p:nvSpPr>
+          <p:cNvPr id="2" name="section">
+            <a:extLst xmlns:a="http://schemas.openxmlformats.org/drawingml/2006/main">
+              <a:ext uri="{FF2B5EF4-FFF2-40B4-BE49-F238E27FC236}">
+                <a16:creationId xmlns:a16="http://schemas.microsoft.com/office/drawing/2014/main" id="{CA25D972-AAB3-4FF1-82CE-C04E2EF6FBCA}"/>
               </a:ext>
             </a:extLst>
           </p:cNvPr>
@@ -5706,10 +5112,10 @@
       </p:sp>
       <p:sp>
         <p:nvSpPr>
-          <p:cNvPr id="6" name="takeaway">
-            <a:extLst xmlns:a="http://schemas.openxmlformats.org/drawingml/2006/main">
-              <a:ext uri="{FF2B5EF4-FFF2-40B4-BE49-F238E27FC236}">
-                <a16:creationId xmlns:a16="http://schemas.microsoft.com/office/drawing/2014/main" id="{4AAD8345-0483-49CA-A1DB-538123B26F01}"/>
+          <p:cNvPr id="3" name="takeaway">
+            <a:extLst xmlns:a="http://schemas.openxmlformats.org/drawingml/2006/main">
+              <a:ext uri="{FF2B5EF4-FFF2-40B4-BE49-F238E27FC236}">
+                <a16:creationId xmlns:a16="http://schemas.microsoft.com/office/drawing/2014/main" id="{E2E80C74-735F-4254-9CFA-0D26FC9802BF}"/>
               </a:ext>
             </a:extLst>
           </p:cNvPr>
@@ -5764,10 +5170,10 @@
       </p:sp>
       <p:sp>
         <p:nvSpPr>
-          <p:cNvPr id="7" name="footer">
-            <a:extLst xmlns:a="http://schemas.openxmlformats.org/drawingml/2006/main">
-              <a:ext uri="{FF2B5EF4-FFF2-40B4-BE49-F238E27FC236}">
-                <a16:creationId xmlns:a16="http://schemas.microsoft.com/office/drawing/2014/main" id="{5253A6CD-434B-4A81-B858-1C3E1C022C5D}"/>
+          <p:cNvPr id="4" name="footer">
+            <a:extLst xmlns:a="http://schemas.openxmlformats.org/drawingml/2006/main">
+              <a:ext uri="{FF2B5EF4-FFF2-40B4-BE49-F238E27FC236}">
+                <a16:creationId xmlns:a16="http://schemas.microsoft.com/office/drawing/2014/main" id="{B17A0690-9760-465A-8070-CB47CE4ECEE7}"/>
               </a:ext>
             </a:extLst>
           </p:cNvPr>
@@ -5822,10 +5228,10 @@
       </p:sp>
       <p:sp>
         <p:nvSpPr>
-          <p:cNvPr id="8" name="page-number">
-            <a:extLst xmlns:a="http://schemas.openxmlformats.org/drawingml/2006/main">
-              <a:ext uri="{FF2B5EF4-FFF2-40B4-BE49-F238E27FC236}">
-                <a16:creationId xmlns:a16="http://schemas.microsoft.com/office/drawing/2014/main" id="{31F78D1C-806A-434F-BE45-C624446FA28E}"/>
+          <p:cNvPr id="5" name="page-number">
+            <a:extLst xmlns:a="http://schemas.openxmlformats.org/drawingml/2006/main">
+              <a:ext uri="{FF2B5EF4-FFF2-40B4-BE49-F238E27FC236}">
+                <a16:creationId xmlns:a16="http://schemas.microsoft.com/office/drawing/2014/main" id="{721A023B-3E44-4580-B64A-AAAAA33253E0}"/>
               </a:ext>
             </a:extLst>
           </p:cNvPr>
@@ -5880,10 +5286,10 @@
       </p:sp>
       <p:sp>
         <p:nvSpPr>
-          <p:cNvPr id="9" name="phase-01">
-            <a:extLst xmlns:a="http://schemas.openxmlformats.org/drawingml/2006/main">
-              <a:ext uri="{FF2B5EF4-FFF2-40B4-BE49-F238E27FC236}">
-                <a16:creationId xmlns:a16="http://schemas.microsoft.com/office/drawing/2014/main" id="{550DB0B3-C7D9-41C3-B443-08DD41398328}"/>
+          <p:cNvPr id="6" name="phase-01">
+            <a:extLst xmlns:a="http://schemas.openxmlformats.org/drawingml/2006/main">
+              <a:ext uri="{FF2B5EF4-FFF2-40B4-BE49-F238E27FC236}">
+                <a16:creationId xmlns:a16="http://schemas.microsoft.com/office/drawing/2014/main" id="{D79D1F30-E5EF-40B4-9E3C-8A0E0FB36D11}"/>
               </a:ext>
             </a:extLst>
           </p:cNvPr>
@@ -5938,10 +5344,10 @@
       </p:sp>
       <p:sp>
         <p:nvSpPr>
-          <p:cNvPr id="10" name="phase-title-01">
-            <a:extLst xmlns:a="http://schemas.openxmlformats.org/drawingml/2006/main">
-              <a:ext uri="{FF2B5EF4-FFF2-40B4-BE49-F238E27FC236}">
-                <a16:creationId xmlns:a16="http://schemas.microsoft.com/office/drawing/2014/main" id="{E7B8A1F9-4FDC-4FE1-83B8-2535C31832ED}"/>
+          <p:cNvPr id="7" name="phase-title-01">
+            <a:extLst xmlns:a="http://schemas.openxmlformats.org/drawingml/2006/main">
+              <a:ext uri="{FF2B5EF4-FFF2-40B4-BE49-F238E27FC236}">
+                <a16:creationId xmlns:a16="http://schemas.microsoft.com/office/drawing/2014/main" id="{B3B42111-1983-4069-911B-67558336871D}"/>
               </a:ext>
             </a:extLst>
           </p:cNvPr>
@@ -5996,10 +5402,10 @@
       </p:sp>
       <p:sp>
         <p:nvSpPr>
-          <p:cNvPr id="11" name="phase-body-01">
-            <a:extLst xmlns:a="http://schemas.openxmlformats.org/drawingml/2006/main">
-              <a:ext uri="{FF2B5EF4-FFF2-40B4-BE49-F238E27FC236}">
-                <a16:creationId xmlns:a16="http://schemas.microsoft.com/office/drawing/2014/main" id="{9BC4AD9D-D9C7-46F5-AA12-0F858053552C}"/>
+          <p:cNvPr id="8" name="phase-body-01">
+            <a:extLst xmlns:a="http://schemas.openxmlformats.org/drawingml/2006/main">
+              <a:ext uri="{FF2B5EF4-FFF2-40B4-BE49-F238E27FC236}">
+                <a16:creationId xmlns:a16="http://schemas.microsoft.com/office/drawing/2014/main" id="{A47D3804-4A1D-4F6A-B6E4-47D290120323}"/>
               </a:ext>
             </a:extLst>
           </p:cNvPr>
@@ -6054,10 +5460,10 @@
       </p:sp>
       <p:sp>
         <p:nvSpPr>
-          <p:cNvPr id="12" name="phase-02">
-            <a:extLst xmlns:a="http://schemas.openxmlformats.org/drawingml/2006/main">
-              <a:ext uri="{FF2B5EF4-FFF2-40B4-BE49-F238E27FC236}">
-                <a16:creationId xmlns:a16="http://schemas.microsoft.com/office/drawing/2014/main" id="{101BF7FB-437F-46BF-A691-817191BC4340}"/>
+          <p:cNvPr id="9" name="phase-02">
+            <a:extLst xmlns:a="http://schemas.openxmlformats.org/drawingml/2006/main">
+              <a:ext uri="{FF2B5EF4-FFF2-40B4-BE49-F238E27FC236}">
+                <a16:creationId xmlns:a16="http://schemas.microsoft.com/office/drawing/2014/main" id="{FB9A25B2-A18A-4F40-B7BF-1EDCC4158E21}"/>
               </a:ext>
             </a:extLst>
           </p:cNvPr>
@@ -6112,10 +5518,10 @@
       </p:sp>
       <p:sp>
         <p:nvSpPr>
-          <p:cNvPr id="13" name="phase-title-02">
-            <a:extLst xmlns:a="http://schemas.openxmlformats.org/drawingml/2006/main">
-              <a:ext uri="{FF2B5EF4-FFF2-40B4-BE49-F238E27FC236}">
-                <a16:creationId xmlns:a16="http://schemas.microsoft.com/office/drawing/2014/main" id="{3B199FC9-34F7-4CF8-A737-831D32B262E5}"/>
+          <p:cNvPr id="10" name="phase-title-02">
+            <a:extLst xmlns:a="http://schemas.openxmlformats.org/drawingml/2006/main">
+              <a:ext uri="{FF2B5EF4-FFF2-40B4-BE49-F238E27FC236}">
+                <a16:creationId xmlns:a16="http://schemas.microsoft.com/office/drawing/2014/main" id="{9AFC6487-F1DA-4507-A0EF-D17BD578250E}"/>
               </a:ext>
             </a:extLst>
           </p:cNvPr>
@@ -6170,10 +5576,10 @@
       </p:sp>
       <p:sp>
         <p:nvSpPr>
-          <p:cNvPr id="14" name="phase-body-02">
-            <a:extLst xmlns:a="http://schemas.openxmlformats.org/drawingml/2006/main">
-              <a:ext uri="{FF2B5EF4-FFF2-40B4-BE49-F238E27FC236}">
-                <a16:creationId xmlns:a16="http://schemas.microsoft.com/office/drawing/2014/main" id="{92DE5B6D-1764-4BBD-9D74-B92EE4AA21BC}"/>
+          <p:cNvPr id="11" name="phase-body-02">
+            <a:extLst xmlns:a="http://schemas.openxmlformats.org/drawingml/2006/main">
+              <a:ext uri="{FF2B5EF4-FFF2-40B4-BE49-F238E27FC236}">
+                <a16:creationId xmlns:a16="http://schemas.microsoft.com/office/drawing/2014/main" id="{0C658C4D-3197-42D5-9C99-C89866EF6FC0}"/>
               </a:ext>
             </a:extLst>
           </p:cNvPr>
@@ -6228,10 +5634,10 @@
       </p:sp>
       <p:sp>
         <p:nvSpPr>
-          <p:cNvPr id="15" name="phase-03">
-            <a:extLst xmlns:a="http://schemas.openxmlformats.org/drawingml/2006/main">
-              <a:ext uri="{FF2B5EF4-FFF2-40B4-BE49-F238E27FC236}">
-                <a16:creationId xmlns:a16="http://schemas.microsoft.com/office/drawing/2014/main" id="{20CD735D-8E03-4493-8673-BD26920608B3}"/>
+          <p:cNvPr id="12" name="phase-03">
+            <a:extLst xmlns:a="http://schemas.openxmlformats.org/drawingml/2006/main">
+              <a:ext uri="{FF2B5EF4-FFF2-40B4-BE49-F238E27FC236}">
+                <a16:creationId xmlns:a16="http://schemas.microsoft.com/office/drawing/2014/main" id="{0062D162-C430-45F8-A72E-9B5A3F47011C}"/>
               </a:ext>
             </a:extLst>
           </p:cNvPr>
@@ -6286,10 +5692,10 @@
       </p:sp>
       <p:sp>
         <p:nvSpPr>
-          <p:cNvPr id="16" name="phase-title-03">
-            <a:extLst xmlns:a="http://schemas.openxmlformats.org/drawingml/2006/main">
-              <a:ext uri="{FF2B5EF4-FFF2-40B4-BE49-F238E27FC236}">
-                <a16:creationId xmlns:a16="http://schemas.microsoft.com/office/drawing/2014/main" id="{7440107E-FC99-4BFE-A6C7-176829F164D3}"/>
+          <p:cNvPr id="13" name="phase-title-03">
+            <a:extLst xmlns:a="http://schemas.openxmlformats.org/drawingml/2006/main">
+              <a:ext uri="{FF2B5EF4-FFF2-40B4-BE49-F238E27FC236}">
+                <a16:creationId xmlns:a16="http://schemas.microsoft.com/office/drawing/2014/main" id="{F2504E70-A106-4336-A677-EF1192427D8C}"/>
               </a:ext>
             </a:extLst>
           </p:cNvPr>
@@ -6344,10 +5750,10 @@
       </p:sp>
       <p:sp>
         <p:nvSpPr>
-          <p:cNvPr id="17" name="phase-body-03">
-            <a:extLst xmlns:a="http://schemas.openxmlformats.org/drawingml/2006/main">
-              <a:ext uri="{FF2B5EF4-FFF2-40B4-BE49-F238E27FC236}">
-                <a16:creationId xmlns:a16="http://schemas.microsoft.com/office/drawing/2014/main" id="{817F79B8-028B-4D34-B34D-6C27C8205ACF}"/>
+          <p:cNvPr id="14" name="phase-body-03">
+            <a:extLst xmlns:a="http://schemas.openxmlformats.org/drawingml/2006/main">
+              <a:ext uri="{FF2B5EF4-FFF2-40B4-BE49-F238E27FC236}">
+                <a16:creationId xmlns:a16="http://schemas.microsoft.com/office/drawing/2014/main" id="{1110FD3C-D302-418F-A254-62D8AE008531}"/>
               </a:ext>
             </a:extLst>
           </p:cNvPr>
@@ -6402,10 +5808,10 @@
       </p:sp>
       <p:sp>
         <p:nvSpPr>
-          <p:cNvPr id="18" name="pilot-boundary">
-            <a:extLst xmlns:a="http://schemas.openxmlformats.org/drawingml/2006/main">
-              <a:ext uri="{FF2B5EF4-FFF2-40B4-BE49-F238E27FC236}">
-                <a16:creationId xmlns:a16="http://schemas.microsoft.com/office/drawing/2014/main" id="{C764D2E0-5168-4BEF-A09C-96560F467494}"/>
+          <p:cNvPr id="15" name="pilot-boundary">
+            <a:extLst xmlns:a="http://schemas.openxmlformats.org/drawingml/2006/main">
+              <a:ext uri="{FF2B5EF4-FFF2-40B4-BE49-F238E27FC236}">
+                <a16:creationId xmlns:a16="http://schemas.microsoft.com/office/drawing/2014/main" id="{63356C82-E1D3-4A1F-B74A-F48438660FD2}"/>
               </a:ext>
             </a:extLst>
           </p:cNvPr>
@@ -6461,7 +5867,7 @@
     </p:spTree>
     <p:extLst>
       <p:ext uri="{BB962C8B-B14F-4D97-AF65-F5344CB8AC3E}">
-        <p14:creationId xmlns:p14="http://schemas.microsoft.com/office/powerpoint/2010/main" val="1544896850"/>
+        <p14:creationId xmlns:p14="http://schemas.microsoft.com/office/powerpoint/2010/main" val="1782424605"/>
       </p:ext>
     </p:extLst>
   </p:cSld>
@@ -6487,139 +5893,40 @@
       <p:grpSpPr>
         <a:xfrm xmlns:a="http://schemas.openxmlformats.org/drawingml/2006/main"/>
       </p:grpSpPr>
-      <p:sp>
-        <p:nvSpPr>
-          <p:cNvPr id="12" name="Hormuz mark boundary">
-            <a:extLst xmlns:a="http://schemas.openxmlformats.org/drawingml/2006/main">
-              <a:ext uri="{FF2B5EF4-FFF2-40B4-BE49-F238E27FC236}">
-                <a16:creationId xmlns:a16="http://schemas.microsoft.com/office/drawing/2014/main" id="{1866E042-7D9E-4508-B94C-C97686025ACB}"/>
-              </a:ext>
-            </a:extLst>
-          </p:cNvPr>
-          <p:cNvSpPr>
-            <a:spLocks xmlns:a="http://schemas.openxmlformats.org/drawingml/2006/main" noGrp="1"/>
-          </p:cNvSpPr>
-          <p:nvPr/>
-        </p:nvSpPr>
+      <p:pic>
+        <p:nvPicPr>
+          <p:cNvPr id="9" name=""/>
+          <p:cNvPicPr>
+            <a:picLocks xmlns:a="http://schemas.openxmlformats.org/drawingml/2006/main" noChangeAspect="1"/>
+          </p:cNvPicPr>
+          <p:nvPr/>
+        </p:nvPicPr>
+        <p:blipFill>
+          <a:blip xmlns:r="http://schemas.openxmlformats.org/officeDocument/2006/relationships" xmlns:a="http://schemas.openxmlformats.org/drawingml/2006/main" r:embed="Rd5f40a9b142f4b09">
+            <a:extLst>
+              <a:ext uri="{96DAC541-7B7A-43D3-8B79-37D633B846F1}">
+                <asvg:svgBlip xmlns:asvg="http://schemas.microsoft.com/office/drawing/2016/SVG/main" r:embed="R9a9fdb9879cf4c0e"/>
+              </a:ext>
+            </a:extLst>
+          </a:blip>
+          <a:stretch xmlns:a="http://schemas.openxmlformats.org/drawingml/2006/main"/>
+        </p:blipFill>
         <p:spPr>
           <a:xfrm xmlns:a="http://schemas.openxmlformats.org/drawingml/2006/main">
             <a:off x="11201400" y="333375"/>
             <a:ext cx="381000" cy="381000"/>
           </a:xfrm>
-          <a:prstGeom xmlns:a="http://schemas.openxmlformats.org/drawingml/2006/main" prst="ellipse">
-            <a:avLst/>
-          </a:prstGeom>
-          <a:noFill xmlns:a="http://schemas.openxmlformats.org/drawingml/2006/main"/>
-          <a:ln xmlns:a="http://schemas.openxmlformats.org/drawingml/2006/main" w="9525">
-            <a:solidFill>
-              <a:srgbClr val="DCEDA6"/>
-            </a:solidFill>
-            <a:prstDash val="solid"/>
-          </a:ln>
-        </p:spPr>
-      </p:sp>
-      <p:sp>
-        <p:nvSpPr>
-          <p:cNvPr id="2" name="Hormuz mark bar 1">
-            <a:extLst xmlns:a="http://schemas.openxmlformats.org/drawingml/2006/main">
-              <a:ext uri="{FF2B5EF4-FFF2-40B4-BE49-F238E27FC236}">
-                <a16:creationId xmlns:a16="http://schemas.microsoft.com/office/drawing/2014/main" id="{1A0EB7BF-3228-46EC-8247-FC4C9CAB6BE3}"/>
-              </a:ext>
-            </a:extLst>
-          </p:cNvPr>
-          <p:cNvSpPr>
-            <a:spLocks xmlns:a="http://schemas.openxmlformats.org/drawingml/2006/main" noGrp="1"/>
-          </p:cNvSpPr>
-          <p:nvPr/>
-        </p:nvSpPr>
-        <p:spPr>
-          <a:xfrm xmlns:a="http://schemas.openxmlformats.org/drawingml/2006/main">
-            <a:off x="11287125" y="476250"/>
-            <a:ext cx="47625" cy="95250"/>
-          </a:xfrm>
-          <a:prstGeom xmlns:a="http://schemas.openxmlformats.org/drawingml/2006/main" prst="roundRect">
-            <a:avLst>
-              <a:gd name="adj" fmla="val 50000"/>
-            </a:avLst>
-          </a:prstGeom>
-          <a:solidFill xmlns:a="http://schemas.openxmlformats.org/drawingml/2006/main">
-            <a:srgbClr val="DCEDA6"/>
-          </a:solidFill>
-          <a:ln xmlns:a="http://schemas.openxmlformats.org/drawingml/2006/main" w="0">
-            <a:noFill/>
-          </a:ln>
-        </p:spPr>
-      </p:sp>
-      <p:sp>
-        <p:nvSpPr>
-          <p:cNvPr id="3" name="Hormuz mark bar 2">
-            <a:extLst xmlns:a="http://schemas.openxmlformats.org/drawingml/2006/main">
-              <a:ext uri="{FF2B5EF4-FFF2-40B4-BE49-F238E27FC236}">
-                <a16:creationId xmlns:a16="http://schemas.microsoft.com/office/drawing/2014/main" id="{EE9D4311-9E6E-4A1C-91D9-66A35E74A2F4}"/>
-              </a:ext>
-            </a:extLst>
-          </p:cNvPr>
-          <p:cNvSpPr>
-            <a:spLocks xmlns:a="http://schemas.openxmlformats.org/drawingml/2006/main" noGrp="1"/>
-          </p:cNvSpPr>
-          <p:nvPr/>
-        </p:nvSpPr>
-        <p:spPr>
-          <a:xfrm xmlns:a="http://schemas.openxmlformats.org/drawingml/2006/main">
-            <a:off x="11363325" y="428625"/>
-            <a:ext cx="47625" cy="190500"/>
-          </a:xfrm>
-          <a:prstGeom xmlns:a="http://schemas.openxmlformats.org/drawingml/2006/main" prst="roundRect">
-            <a:avLst>
-              <a:gd name="adj" fmla="val 50000"/>
-            </a:avLst>
-          </a:prstGeom>
-          <a:solidFill xmlns:a="http://schemas.openxmlformats.org/drawingml/2006/main">
-            <a:srgbClr val="DCEDA6"/>
-          </a:solidFill>
-          <a:ln xmlns:a="http://schemas.openxmlformats.org/drawingml/2006/main" w="0">
-            <a:noFill/>
-          </a:ln>
-        </p:spPr>
-      </p:sp>
-      <p:sp>
-        <p:nvSpPr>
-          <p:cNvPr id="4" name="Hormuz mark bar 3">
-            <a:extLst xmlns:a="http://schemas.openxmlformats.org/drawingml/2006/main">
-              <a:ext uri="{FF2B5EF4-FFF2-40B4-BE49-F238E27FC236}">
-                <a16:creationId xmlns:a16="http://schemas.microsoft.com/office/drawing/2014/main" id="{35EB695D-A5F9-458B-A10E-FE8D9397DEF5}"/>
-              </a:ext>
-            </a:extLst>
-          </p:cNvPr>
-          <p:cNvSpPr>
-            <a:spLocks xmlns:a="http://schemas.openxmlformats.org/drawingml/2006/main" noGrp="1"/>
-          </p:cNvSpPr>
-          <p:nvPr/>
-        </p:nvSpPr>
-        <p:spPr>
-          <a:xfrm xmlns:a="http://schemas.openxmlformats.org/drawingml/2006/main">
-            <a:off x="11439525" y="457200"/>
-            <a:ext cx="47625" cy="133350"/>
-          </a:xfrm>
-          <a:prstGeom xmlns:a="http://schemas.openxmlformats.org/drawingml/2006/main" prst="roundRect">
-            <a:avLst>
-              <a:gd name="adj" fmla="val 50000"/>
-            </a:avLst>
-          </a:prstGeom>
-          <a:solidFill xmlns:a="http://schemas.openxmlformats.org/drawingml/2006/main">
-            <a:srgbClr val="DCEDA6"/>
-          </a:solidFill>
-          <a:ln xmlns:a="http://schemas.openxmlformats.org/drawingml/2006/main" w="0">
-            <a:noFill/>
-          </a:ln>
-        </p:spPr>
-      </p:sp>
-      <p:sp>
-        <p:nvSpPr>
-          <p:cNvPr id="5" name="section">
-            <a:extLst xmlns:a="http://schemas.openxmlformats.org/drawingml/2006/main">
-              <a:ext uri="{FF2B5EF4-FFF2-40B4-BE49-F238E27FC236}">
-                <a16:creationId xmlns:a16="http://schemas.microsoft.com/office/drawing/2014/main" id="{34A8E6D3-DBF9-4998-AC5C-772616443F57}"/>
+          <a:prstGeom xmlns:a="http://schemas.openxmlformats.org/drawingml/2006/main" prst="rect">
+            <a:avLst/>
+          </a:prstGeom>
+        </p:spPr>
+      </p:pic>
+      <p:sp>
+        <p:nvSpPr>
+          <p:cNvPr id="2" name="section">
+            <a:extLst xmlns:a="http://schemas.openxmlformats.org/drawingml/2006/main">
+              <a:ext uri="{FF2B5EF4-FFF2-40B4-BE49-F238E27FC236}">
+                <a16:creationId xmlns:a16="http://schemas.microsoft.com/office/drawing/2014/main" id="{0C6BDB77-89D7-4F8B-986D-6EA8D7C9A463}"/>
               </a:ext>
             </a:extLst>
           </p:cNvPr>
@@ -6674,10 +5981,10 @@
       </p:sp>
       <p:sp>
         <p:nvSpPr>
-          <p:cNvPr id="6" name="takeaway">
-            <a:extLst xmlns:a="http://schemas.openxmlformats.org/drawingml/2006/main">
-              <a:ext uri="{FF2B5EF4-FFF2-40B4-BE49-F238E27FC236}">
-                <a16:creationId xmlns:a16="http://schemas.microsoft.com/office/drawing/2014/main" id="{5F284DE5-2CBE-44BC-AF5D-7FCCFAB9DD18}"/>
+          <p:cNvPr id="3" name="takeaway">
+            <a:extLst xmlns:a="http://schemas.openxmlformats.org/drawingml/2006/main">
+              <a:ext uri="{FF2B5EF4-FFF2-40B4-BE49-F238E27FC236}">
+                <a16:creationId xmlns:a16="http://schemas.microsoft.com/office/drawing/2014/main" id="{0DE03F2D-D3C3-4F72-8B8E-1AFD840E1653}"/>
               </a:ext>
             </a:extLst>
           </p:cNvPr>
@@ -6732,10 +6039,10 @@
       </p:sp>
       <p:sp>
         <p:nvSpPr>
-          <p:cNvPr id="7" name="footer">
-            <a:extLst xmlns:a="http://schemas.openxmlformats.org/drawingml/2006/main">
-              <a:ext uri="{FF2B5EF4-FFF2-40B4-BE49-F238E27FC236}">
-                <a16:creationId xmlns:a16="http://schemas.microsoft.com/office/drawing/2014/main" id="{89E207F7-81C6-437A-B775-B727A211AAC2}"/>
+          <p:cNvPr id="4" name="footer">
+            <a:extLst xmlns:a="http://schemas.openxmlformats.org/drawingml/2006/main">
+              <a:ext uri="{FF2B5EF4-FFF2-40B4-BE49-F238E27FC236}">
+                <a16:creationId xmlns:a16="http://schemas.microsoft.com/office/drawing/2014/main" id="{26102BAB-CDA1-4407-91CC-62B4AB07C893}"/>
               </a:ext>
             </a:extLst>
           </p:cNvPr>
@@ -6790,10 +6097,10 @@
       </p:sp>
       <p:sp>
         <p:nvSpPr>
-          <p:cNvPr id="8" name="page-number">
-            <a:extLst xmlns:a="http://schemas.openxmlformats.org/drawingml/2006/main">
-              <a:ext uri="{FF2B5EF4-FFF2-40B4-BE49-F238E27FC236}">
-                <a16:creationId xmlns:a16="http://schemas.microsoft.com/office/drawing/2014/main" id="{774D8CBC-73B1-4CBE-99C5-891603F84959}"/>
+          <p:cNvPr id="5" name="page-number">
+            <a:extLst xmlns:a="http://schemas.openxmlformats.org/drawingml/2006/main">
+              <a:ext uri="{FF2B5EF4-FFF2-40B4-BE49-F238E27FC236}">
+                <a16:creationId xmlns:a16="http://schemas.microsoft.com/office/drawing/2014/main" id="{AC7FDC17-85BC-433E-BC74-C6766101BEC0}"/>
               </a:ext>
             </a:extLst>
           </p:cNvPr>
@@ -6848,10 +6155,10 @@
       </p:sp>
       <p:sp>
         <p:nvSpPr>
-          <p:cNvPr id="9" name="next-step">
-            <a:extLst xmlns:a="http://schemas.openxmlformats.org/drawingml/2006/main">
-              <a:ext uri="{FF2B5EF4-FFF2-40B4-BE49-F238E27FC236}">
-                <a16:creationId xmlns:a16="http://schemas.microsoft.com/office/drawing/2014/main" id="{89EE2300-DF5F-4A39-AD60-53C0BF2F4923}"/>
+          <p:cNvPr id="6" name="next-step">
+            <a:extLst xmlns:a="http://schemas.openxmlformats.org/drawingml/2006/main">
+              <a:ext uri="{FF2B5EF4-FFF2-40B4-BE49-F238E27FC236}">
+                <a16:creationId xmlns:a16="http://schemas.microsoft.com/office/drawing/2014/main" id="{10909061-CA1A-4F63-9A1E-84CDDFC1058C}"/>
               </a:ext>
             </a:extLst>
           </p:cNvPr>
@@ -6952,10 +6259,10 @@
       </p:sp>
       <p:sp>
         <p:nvSpPr>
-          <p:cNvPr id="10" name="contact">
-            <a:extLst xmlns:a="http://schemas.openxmlformats.org/drawingml/2006/main">
-              <a:ext uri="{FF2B5EF4-FFF2-40B4-BE49-F238E27FC236}">
-                <a16:creationId xmlns:a16="http://schemas.microsoft.com/office/drawing/2014/main" id="{C47A4B12-591F-4DDA-9272-214E7A25335E}"/>
+          <p:cNvPr id="7" name="contact">
+            <a:extLst xmlns:a="http://schemas.openxmlformats.org/drawingml/2006/main">
+              <a:ext uri="{FF2B5EF4-FFF2-40B4-BE49-F238E27FC236}">
+                <a16:creationId xmlns:a16="http://schemas.microsoft.com/office/drawing/2014/main" id="{384C3FA3-FA33-45C3-BF06-A135FF12737E}"/>
               </a:ext>
             </a:extLst>
           </p:cNvPr>
@@ -7033,10 +6340,10 @@
       </p:sp>
       <p:sp>
         <p:nvSpPr>
-          <p:cNvPr id="11" name="website">
-            <a:extLst xmlns:a="http://schemas.openxmlformats.org/drawingml/2006/main">
-              <a:ext uri="{FF2B5EF4-FFF2-40B4-BE49-F238E27FC236}">
-                <a16:creationId xmlns:a16="http://schemas.microsoft.com/office/drawing/2014/main" id="{82219D55-44ED-4DC5-8BD8-2EFFA6F8CF2F}"/>
+          <p:cNvPr id="8" name="website">
+            <a:extLst xmlns:a="http://schemas.openxmlformats.org/drawingml/2006/main">
+              <a:ext uri="{FF2B5EF4-FFF2-40B4-BE49-F238E27FC236}">
+                <a16:creationId xmlns:a16="http://schemas.microsoft.com/office/drawing/2014/main" id="{750F37F2-B9B4-44E6-A5F9-A2DE77888327}"/>
               </a:ext>
             </a:extLst>
           </p:cNvPr>
@@ -7092,7 +6399,7 @@
     </p:spTree>
     <p:extLst>
       <p:ext uri="{BB962C8B-B14F-4D97-AF65-F5344CB8AC3E}">
-        <p14:creationId xmlns:p14="http://schemas.microsoft.com/office/powerpoint/2010/main" val="1779482876"/>
+        <p14:creationId xmlns:p14="http://schemas.microsoft.com/office/powerpoint/2010/main" val="1154311883"/>
       </p:ext>
     </p:extLst>
   </p:cSld>

</xml_diff>

<commit_message>
Publish v1.2.0 downloads and evidence
</commit_message>
<xml_diff>
--- a/website/public/downloads/hormuz-buyer-briefing.pptx
+++ b/website/public/downloads/hormuz-buyer-briefing.pptx
@@ -2,19 +2,19 @@
 <file path=ppt/presentation.xml><?xml version="1.0" encoding="utf-8"?>
 <p:presentation xmlns:p="http://schemas.openxmlformats.org/presentationml/2006/main">
   <p:sldMasterIdLst>
-    <p:sldMasterId xmlns:r="http://schemas.openxmlformats.org/officeDocument/2006/relationships" id="2147483648" r:id="Ra3aace7adbed4046"/>
+    <p:sldMasterId xmlns:r="http://schemas.openxmlformats.org/officeDocument/2006/relationships" id="2147483648" r:id="Ref6005e08f954fdd"/>
   </p:sldMasterIdLst>
   <p:notesMasterIdLst>
-    <p:notesMasterId xmlns:r="http://schemas.openxmlformats.org/officeDocument/2006/relationships" r:id="Rf340521d323d453e"/>
+    <p:notesMasterId xmlns:r="http://schemas.openxmlformats.org/officeDocument/2006/relationships" r:id="R4c21589d282a4a7f"/>
   </p:notesMasterIdLst>
   <p:sldIdLst>
-    <p:sldId xmlns:r="http://schemas.openxmlformats.org/officeDocument/2006/relationships" id="256" r:id="R2af7859b638f4a90"/>
-    <p:sldId xmlns:r="http://schemas.openxmlformats.org/officeDocument/2006/relationships" id="257" r:id="R3012093706e24e2e"/>
-    <p:sldId xmlns:r="http://schemas.openxmlformats.org/officeDocument/2006/relationships" id="258" r:id="Rf985a675096e4343"/>
-    <p:sldId xmlns:r="http://schemas.openxmlformats.org/officeDocument/2006/relationships" id="259" r:id="R11a8213a72b9418d"/>
-    <p:sldId xmlns:r="http://schemas.openxmlformats.org/officeDocument/2006/relationships" id="260" r:id="R7378b605b8ed4834"/>
-    <p:sldId xmlns:r="http://schemas.openxmlformats.org/officeDocument/2006/relationships" id="261" r:id="Rd9a738c819b843b5"/>
-    <p:sldId xmlns:r="http://schemas.openxmlformats.org/officeDocument/2006/relationships" id="262" r:id="R2f31c2cb7e494864"/>
+    <p:sldId xmlns:r="http://schemas.openxmlformats.org/officeDocument/2006/relationships" id="256" r:id="R9ea205da86e34341"/>
+    <p:sldId xmlns:r="http://schemas.openxmlformats.org/officeDocument/2006/relationships" id="257" r:id="Re130d9e3926441b8"/>
+    <p:sldId xmlns:r="http://schemas.openxmlformats.org/officeDocument/2006/relationships" id="258" r:id="R6bf087821f11416f"/>
+    <p:sldId xmlns:r="http://schemas.openxmlformats.org/officeDocument/2006/relationships" id="259" r:id="Ra745340050d84e75"/>
+    <p:sldId xmlns:r="http://schemas.openxmlformats.org/officeDocument/2006/relationships" id="260" r:id="R4ff689c1404d4d0a"/>
+    <p:sldId xmlns:r="http://schemas.openxmlformats.org/officeDocument/2006/relationships" id="261" r:id="R553eef0cb4004a08"/>
+    <p:sldId xmlns:r="http://schemas.openxmlformats.org/officeDocument/2006/relationships" id="262" r:id="R3d584900ef184b52"/>
   </p:sldIdLst>
   <p:sldSz cx="12192000" cy="6858000"/>
   <p:notesSz cx="6858000" cy="9144000"/>
@@ -1116,7 +1116,7 @@
   </p:cSld>
   <p:clrMap bg1="lt1" tx1="dk1" bg2="lt2" tx2="dk2" accent1="accent1" accent2="accent2" accent3="accent3" accent4="accent4" accent5="accent5" accent6="accent6" hlink="hlink" folHlink="folHlink"/>
   <p:sldLayoutIdLst>
-    <p:sldLayoutId xmlns:r="http://schemas.openxmlformats.org/officeDocument/2006/relationships" id="2147483649" r:id="Rfdf999c7227c4eee"/>
+    <p:sldLayoutId xmlns:r="http://schemas.openxmlformats.org/officeDocument/2006/relationships" id="2147483649" r:id="R03d5c8606ee84609"/>
   </p:sldLayoutIdLst>
   <p:txStyles>
     <p:titleStyle>
@@ -1671,10 +1671,10 @@
           <p:nvPr/>
         </p:nvPicPr>
         <p:blipFill>
-          <a:blip xmlns:r="http://schemas.openxmlformats.org/officeDocument/2006/relationships" xmlns:a="http://schemas.openxmlformats.org/drawingml/2006/main" r:embed="Rfe905ca50ebf469e">
+          <a:blip xmlns:r="http://schemas.openxmlformats.org/officeDocument/2006/relationships" xmlns:a="http://schemas.openxmlformats.org/drawingml/2006/main" r:embed="Rc17a4ad40bc641d0">
             <a:extLst>
               <a:ext uri="{96DAC541-7B7A-43D3-8B79-37D633B846F1}">
-                <asvg:svgBlip xmlns:asvg="http://schemas.microsoft.com/office/drawing/2016/SVG/main" r:embed="Rade40133d7454587"/>
+                <asvg:svgBlip xmlns:asvg="http://schemas.microsoft.com/office/drawing/2016/SVG/main" r:embed="R2653d04ca08f4d76"/>
               </a:ext>
             </a:extLst>
           </a:blip>
@@ -1695,7 +1695,7 @@
           <p:cNvPr id="2" name="section">
             <a:extLst xmlns:a="http://schemas.openxmlformats.org/drawingml/2006/main">
               <a:ext uri="{FF2B5EF4-FFF2-40B4-BE49-F238E27FC236}">
-                <a16:creationId xmlns:a16="http://schemas.microsoft.com/office/drawing/2014/main" id="{EEB06EC4-01F6-4F00-8F04-66689B69D49A}"/>
+                <a16:creationId xmlns:a16="http://schemas.microsoft.com/office/drawing/2014/main" id="{92497F51-B23F-4255-9D1B-D9FC43C5DDC3}"/>
               </a:ext>
             </a:extLst>
           </p:cNvPr>
@@ -1753,7 +1753,7 @@
           <p:cNvPr id="3" name="footer">
             <a:extLst xmlns:a="http://schemas.openxmlformats.org/drawingml/2006/main">
               <a:ext uri="{FF2B5EF4-FFF2-40B4-BE49-F238E27FC236}">
-                <a16:creationId xmlns:a16="http://schemas.microsoft.com/office/drawing/2014/main" id="{27967F12-2463-4349-BD50-CCAD0B1F1F54}"/>
+                <a16:creationId xmlns:a16="http://schemas.microsoft.com/office/drawing/2014/main" id="{CE9B3292-B54B-4269-885F-535FCF2110A0}"/>
               </a:ext>
             </a:extLst>
           </p:cNvPr>
@@ -1811,7 +1811,7 @@
           <p:cNvPr id="4" name="page-number">
             <a:extLst xmlns:a="http://schemas.openxmlformats.org/drawingml/2006/main">
               <a:ext uri="{FF2B5EF4-FFF2-40B4-BE49-F238E27FC236}">
-                <a16:creationId xmlns:a16="http://schemas.microsoft.com/office/drawing/2014/main" id="{520CCF5B-00AC-47CF-A216-F1998A8AD14B}"/>
+                <a16:creationId xmlns:a16="http://schemas.microsoft.com/office/drawing/2014/main" id="{B3B51764-DA82-4DA5-AEC8-F284D7595CEC}"/>
               </a:ext>
             </a:extLst>
           </p:cNvPr>
@@ -1869,7 +1869,7 @@
           <p:cNvPr id="5" name="cover-title">
             <a:extLst xmlns:a="http://schemas.openxmlformats.org/drawingml/2006/main">
               <a:ext uri="{FF2B5EF4-FFF2-40B4-BE49-F238E27FC236}">
-                <a16:creationId xmlns:a16="http://schemas.microsoft.com/office/drawing/2014/main" id="{D7353088-14C0-45BF-9E23-ECD7F6042B7A}"/>
+                <a16:creationId xmlns:a16="http://schemas.microsoft.com/office/drawing/2014/main" id="{BE7CD798-8734-4629-A8B2-058C689E20D3}"/>
               </a:ext>
             </a:extLst>
           </p:cNvPr>
@@ -1950,7 +1950,7 @@
           <p:cNvPr id="6" name="cover-summary">
             <a:extLst xmlns:a="http://schemas.openxmlformats.org/drawingml/2006/main">
               <a:ext uri="{FF2B5EF4-FFF2-40B4-BE49-F238E27FC236}">
-                <a16:creationId xmlns:a16="http://schemas.microsoft.com/office/drawing/2014/main" id="{BD907CB8-7FCF-4B6F-992C-7FAB8A08AE47}"/>
+                <a16:creationId xmlns:a16="http://schemas.microsoft.com/office/drawing/2014/main" id="{6F221611-0436-47FE-8284-160E9247C6EE}"/>
               </a:ext>
             </a:extLst>
           </p:cNvPr>
@@ -2031,7 +2031,7 @@
           <p:cNvPr id="7" name="cover-boundary">
             <a:extLst xmlns:a="http://schemas.openxmlformats.org/drawingml/2006/main">
               <a:ext uri="{FF2B5EF4-FFF2-40B4-BE49-F238E27FC236}">
-                <a16:creationId xmlns:a16="http://schemas.microsoft.com/office/drawing/2014/main" id="{1805D97F-95CA-41D4-B5A4-7CF1279A9E00}"/>
+                <a16:creationId xmlns:a16="http://schemas.microsoft.com/office/drawing/2014/main" id="{75908FF6-23D3-4CB6-B844-22531D4FC13B}"/>
               </a:ext>
             </a:extLst>
           </p:cNvPr>
@@ -2079,7 +2079,7 @@
                 <a:ea typeface="Arial"/>
                 <a:cs typeface="Arial"/>
               </a:rPr>
-              <a:t>Apache-2.0 core  •  v1.0.0 source contracts</a:t>
+              <a:t>Apache-2.0 core  •  v1.2.0 source release</a:t>
             </a:r>
           </a:p>
         </p:txBody>
@@ -2087,7 +2087,7 @@
     </p:spTree>
     <p:extLst>
       <p:ext uri="{BB962C8B-B14F-4D97-AF65-F5344CB8AC3E}">
-        <p14:creationId xmlns:p14="http://schemas.microsoft.com/office/powerpoint/2010/main" val="1502598606"/>
+        <p14:creationId xmlns:p14="http://schemas.microsoft.com/office/powerpoint/2010/main" val="994147057"/>
       </p:ext>
     </p:extLst>
   </p:cSld>
@@ -2122,10 +2122,10 @@
           <p:nvPr/>
         </p:nvPicPr>
         <p:blipFill>
-          <a:blip xmlns:r="http://schemas.openxmlformats.org/officeDocument/2006/relationships" xmlns:a="http://schemas.openxmlformats.org/drawingml/2006/main" r:embed="Rda2df477324c4688">
+          <a:blip xmlns:r="http://schemas.openxmlformats.org/officeDocument/2006/relationships" xmlns:a="http://schemas.openxmlformats.org/drawingml/2006/main" r:embed="Rb449f3dd146d4de7">
             <a:extLst>
               <a:ext uri="{96DAC541-7B7A-43D3-8B79-37D633B846F1}">
-                <asvg:svgBlip xmlns:asvg="http://schemas.microsoft.com/office/drawing/2016/SVG/main" r:embed="R8ae4e69bb7ae4a0a"/>
+                <asvg:svgBlip xmlns:asvg="http://schemas.microsoft.com/office/drawing/2016/SVG/main" r:embed="Rd48b1636bd4f471b"/>
               </a:ext>
             </a:extLst>
           </a:blip>
@@ -2146,7 +2146,7 @@
           <p:cNvPr id="2" name="section">
             <a:extLst xmlns:a="http://schemas.openxmlformats.org/drawingml/2006/main">
               <a:ext uri="{FF2B5EF4-FFF2-40B4-BE49-F238E27FC236}">
-                <a16:creationId xmlns:a16="http://schemas.microsoft.com/office/drawing/2014/main" id="{45EC06CD-DEA5-4038-A835-20FDD7071EBF}"/>
+                <a16:creationId xmlns:a16="http://schemas.microsoft.com/office/drawing/2014/main" id="{25B878BD-F515-4A02-8FAA-4A6F14741031}"/>
               </a:ext>
             </a:extLst>
           </p:cNvPr>
@@ -2204,7 +2204,7 @@
           <p:cNvPr id="3" name="takeaway">
             <a:extLst xmlns:a="http://schemas.openxmlformats.org/drawingml/2006/main">
               <a:ext uri="{FF2B5EF4-FFF2-40B4-BE49-F238E27FC236}">
-                <a16:creationId xmlns:a16="http://schemas.microsoft.com/office/drawing/2014/main" id="{B932E55F-D62C-4C64-91C7-1067C5891C0C}"/>
+                <a16:creationId xmlns:a16="http://schemas.microsoft.com/office/drawing/2014/main" id="{A2988A2B-4B03-4D49-906A-BC082481CE9B}"/>
               </a:ext>
             </a:extLst>
           </p:cNvPr>
@@ -2262,7 +2262,7 @@
           <p:cNvPr id="4" name="footer">
             <a:extLst xmlns:a="http://schemas.openxmlformats.org/drawingml/2006/main">
               <a:ext uri="{FF2B5EF4-FFF2-40B4-BE49-F238E27FC236}">
-                <a16:creationId xmlns:a16="http://schemas.microsoft.com/office/drawing/2014/main" id="{9BDEBCF3-FA80-4395-B8A3-DAF3FCE32A20}"/>
+                <a16:creationId xmlns:a16="http://schemas.microsoft.com/office/drawing/2014/main" id="{831E13C8-BF83-4CFC-A082-8E28C802DD39}"/>
               </a:ext>
             </a:extLst>
           </p:cNvPr>
@@ -2320,7 +2320,7 @@
           <p:cNvPr id="5" name="page-number">
             <a:extLst xmlns:a="http://schemas.openxmlformats.org/drawingml/2006/main">
               <a:ext uri="{FF2B5EF4-FFF2-40B4-BE49-F238E27FC236}">
-                <a16:creationId xmlns:a16="http://schemas.microsoft.com/office/drawing/2014/main" id="{9A01BDBB-007D-4258-BBD5-9B4C96E10DC9}"/>
+                <a16:creationId xmlns:a16="http://schemas.microsoft.com/office/drawing/2014/main" id="{4D02E5EE-4D1F-40CF-B5B1-56EA7780DA89}"/>
               </a:ext>
             </a:extLst>
           </p:cNvPr>
@@ -2378,7 +2378,7 @@
           <p:cNvPr id="6" name="arrow-one">
             <a:extLst xmlns:a="http://schemas.openxmlformats.org/drawingml/2006/main">
               <a:ext uri="{FF2B5EF4-FFF2-40B4-BE49-F238E27FC236}">
-                <a16:creationId xmlns:a16="http://schemas.microsoft.com/office/drawing/2014/main" id="{1F164A8F-7AD4-4E62-A381-C06A09C5E424}"/>
+                <a16:creationId xmlns:a16="http://schemas.microsoft.com/office/drawing/2014/main" id="{1063903D-AC72-4799-9C3D-3B4A346B428F}"/>
               </a:ext>
             </a:extLst>
           </p:cNvPr>
@@ -2436,7 +2436,7 @@
           <p:cNvPr id="7" name="arrow-two">
             <a:extLst xmlns:a="http://schemas.openxmlformats.org/drawingml/2006/main">
               <a:ext uri="{FF2B5EF4-FFF2-40B4-BE49-F238E27FC236}">
-                <a16:creationId xmlns:a16="http://schemas.microsoft.com/office/drawing/2014/main" id="{82D31BB1-46C7-40E1-B7E6-EB7CA77B69C8}"/>
+                <a16:creationId xmlns:a16="http://schemas.microsoft.com/office/drawing/2014/main" id="{D0BE4B4E-0A02-4860-8198-6156071136BD}"/>
               </a:ext>
             </a:extLst>
           </p:cNvPr>
@@ -2494,7 +2494,7 @@
           <p:cNvPr id="8" name="EMPLOYEE CLIENT">
             <a:extLst xmlns:a="http://schemas.openxmlformats.org/drawingml/2006/main">
               <a:ext uri="{FF2B5EF4-FFF2-40B4-BE49-F238E27FC236}">
-                <a16:creationId xmlns:a16="http://schemas.microsoft.com/office/drawing/2014/main" id="{26F4CEF6-B0C2-4EB0-8354-3EF359F77E51}"/>
+                <a16:creationId xmlns:a16="http://schemas.microsoft.com/office/drawing/2014/main" id="{34CA1DC1-FACD-4DC4-8F9A-46A08BBB071C}"/>
               </a:ext>
             </a:extLst>
           </p:cNvPr>
@@ -2527,7 +2527,7 @@
           <p:cNvPr id="9" name="EMPLOYEE CLIENT-title">
             <a:extLst xmlns:a="http://schemas.openxmlformats.org/drawingml/2006/main">
               <a:ext uri="{FF2B5EF4-FFF2-40B4-BE49-F238E27FC236}">
-                <a16:creationId xmlns:a16="http://schemas.microsoft.com/office/drawing/2014/main" id="{24C5FE9A-D7A6-4418-90A4-3FE92E3DC8D8}"/>
+                <a16:creationId xmlns:a16="http://schemas.microsoft.com/office/drawing/2014/main" id="{44C76B1B-FA6F-4AE5-9446-BE432494780D}"/>
               </a:ext>
             </a:extLst>
           </p:cNvPr>
@@ -2585,7 +2585,7 @@
           <p:cNvPr id="10" name="EMPLOYEE CLIENT-body">
             <a:extLst xmlns:a="http://schemas.openxmlformats.org/drawingml/2006/main">
               <a:ext uri="{FF2B5EF4-FFF2-40B4-BE49-F238E27FC236}">
-                <a16:creationId xmlns:a16="http://schemas.microsoft.com/office/drawing/2014/main" id="{58CAB90E-461A-4036-9E9D-48C5A0CCB6E9}"/>
+                <a16:creationId xmlns:a16="http://schemas.microsoft.com/office/drawing/2014/main" id="{2727CC07-F766-41AE-9AB6-620700AC61F4}"/>
               </a:ext>
             </a:extLst>
           </p:cNvPr>
@@ -2666,7 +2666,7 @@
           <p:cNvPr id="11" name="HORMUZ">
             <a:extLst xmlns:a="http://schemas.openxmlformats.org/drawingml/2006/main">
               <a:ext uri="{FF2B5EF4-FFF2-40B4-BE49-F238E27FC236}">
-                <a16:creationId xmlns:a16="http://schemas.microsoft.com/office/drawing/2014/main" id="{828DBEAD-6D72-464C-B749-6E7DDB574384}"/>
+                <a16:creationId xmlns:a16="http://schemas.microsoft.com/office/drawing/2014/main" id="{06284F97-4DA5-4D94-BC9F-149FD5FF14A2}"/>
               </a:ext>
             </a:extLst>
           </p:cNvPr>
@@ -2699,7 +2699,7 @@
           <p:cNvPr id="12" name="HORMUZ-title">
             <a:extLst xmlns:a="http://schemas.openxmlformats.org/drawingml/2006/main">
               <a:ext uri="{FF2B5EF4-FFF2-40B4-BE49-F238E27FC236}">
-                <a16:creationId xmlns:a16="http://schemas.microsoft.com/office/drawing/2014/main" id="{D752113F-1B7D-4AAE-8471-6A53AC0DE04A}"/>
+                <a16:creationId xmlns:a16="http://schemas.microsoft.com/office/drawing/2014/main" id="{745FA606-28D3-4744-A0BC-D5278035ED08}"/>
               </a:ext>
             </a:extLst>
           </p:cNvPr>
@@ -2757,7 +2757,7 @@
           <p:cNvPr id="13" name="HORMUZ-body">
             <a:extLst xmlns:a="http://schemas.openxmlformats.org/drawingml/2006/main">
               <a:ext uri="{FF2B5EF4-FFF2-40B4-BE49-F238E27FC236}">
-                <a16:creationId xmlns:a16="http://schemas.microsoft.com/office/drawing/2014/main" id="{C7AB1D7F-DF30-409B-AA78-09085E918F5D}"/>
+                <a16:creationId xmlns:a16="http://schemas.microsoft.com/office/drawing/2014/main" id="{61AB946A-4064-4AAC-A883-712D8231BB4F}"/>
               </a:ext>
             </a:extLst>
           </p:cNvPr>
@@ -2838,7 +2838,7 @@
           <p:cNvPr id="14" name="MODEL PROVIDER">
             <a:extLst xmlns:a="http://schemas.openxmlformats.org/drawingml/2006/main">
               <a:ext uri="{FF2B5EF4-FFF2-40B4-BE49-F238E27FC236}">
-                <a16:creationId xmlns:a16="http://schemas.microsoft.com/office/drawing/2014/main" id="{89EDE08D-1394-4A29-B4CD-3C4721DDAA83}"/>
+                <a16:creationId xmlns:a16="http://schemas.microsoft.com/office/drawing/2014/main" id="{04EB5027-89FF-47A0-95AC-D56D12CF68DE}"/>
               </a:ext>
             </a:extLst>
           </p:cNvPr>
@@ -2871,7 +2871,7 @@
           <p:cNvPr id="15" name="MODEL PROVIDER-title">
             <a:extLst xmlns:a="http://schemas.openxmlformats.org/drawingml/2006/main">
               <a:ext uri="{FF2B5EF4-FFF2-40B4-BE49-F238E27FC236}">
-                <a16:creationId xmlns:a16="http://schemas.microsoft.com/office/drawing/2014/main" id="{AE9710AE-AF92-4523-A8C1-19236DB58D52}"/>
+                <a16:creationId xmlns:a16="http://schemas.microsoft.com/office/drawing/2014/main" id="{4267EB83-491A-4BD1-93F5-9D7E506DA9C8}"/>
               </a:ext>
             </a:extLst>
           </p:cNvPr>
@@ -2929,7 +2929,7 @@
           <p:cNvPr id="16" name="MODEL PROVIDER-body">
             <a:extLst xmlns:a="http://schemas.openxmlformats.org/drawingml/2006/main">
               <a:ext uri="{FF2B5EF4-FFF2-40B4-BE49-F238E27FC236}">
-                <a16:creationId xmlns:a16="http://schemas.microsoft.com/office/drawing/2014/main" id="{53360DC0-153C-41ED-B8C4-B6651A5C9BDC}"/>
+                <a16:creationId xmlns:a16="http://schemas.microsoft.com/office/drawing/2014/main" id="{7BFE4860-19A3-4870-80BA-F4AE2A7CAA08}"/>
               </a:ext>
             </a:extLst>
           </p:cNvPr>
@@ -3010,7 +3010,7 @@
           <p:cNvPr id="17" name="metadata">
             <a:extLst xmlns:a="http://schemas.openxmlformats.org/drawingml/2006/main">
               <a:ext uri="{FF2B5EF4-FFF2-40B4-BE49-F238E27FC236}">
-                <a16:creationId xmlns:a16="http://schemas.microsoft.com/office/drawing/2014/main" id="{2F0B9E83-1F0C-4FD9-BCFE-F6B12C9FD1A7}"/>
+                <a16:creationId xmlns:a16="http://schemas.microsoft.com/office/drawing/2014/main" id="{1FEF1AA9-4733-40EB-B5C0-B04FC2209AA0}"/>
               </a:ext>
             </a:extLst>
           </p:cNvPr>
@@ -3068,7 +3068,7 @@
           <p:cNvPr id="18" name="boundary">
             <a:extLst xmlns:a="http://schemas.openxmlformats.org/drawingml/2006/main">
               <a:ext uri="{FF2B5EF4-FFF2-40B4-BE49-F238E27FC236}">
-                <a16:creationId xmlns:a16="http://schemas.microsoft.com/office/drawing/2014/main" id="{35616240-55FA-4CCA-85F3-3D57B2734F28}"/>
+                <a16:creationId xmlns:a16="http://schemas.microsoft.com/office/drawing/2014/main" id="{DDFEC4BD-903B-439F-B336-4A3ECC1BB104}"/>
               </a:ext>
             </a:extLst>
           </p:cNvPr>
@@ -3124,7 +3124,7 @@
     </p:spTree>
     <p:extLst>
       <p:ext uri="{BB962C8B-B14F-4D97-AF65-F5344CB8AC3E}">
-        <p14:creationId xmlns:p14="http://schemas.microsoft.com/office/powerpoint/2010/main" val="941358670"/>
+        <p14:creationId xmlns:p14="http://schemas.microsoft.com/office/powerpoint/2010/main" val="1407605191"/>
       </p:ext>
     </p:extLst>
   </p:cSld>
@@ -3159,10 +3159,10 @@
           <p:nvPr/>
         </p:nvPicPr>
         <p:blipFill>
-          <a:blip xmlns:r="http://schemas.openxmlformats.org/officeDocument/2006/relationships" xmlns:a="http://schemas.openxmlformats.org/drawingml/2006/main" r:embed="Rb54a670779b64bc0">
+          <a:blip xmlns:r="http://schemas.openxmlformats.org/officeDocument/2006/relationships" xmlns:a="http://schemas.openxmlformats.org/drawingml/2006/main" r:embed="R1b8d69dd191f4867">
             <a:extLst>
               <a:ext uri="{96DAC541-7B7A-43D3-8B79-37D633B846F1}">
-                <asvg:svgBlip xmlns:asvg="http://schemas.microsoft.com/office/drawing/2016/SVG/main" r:embed="Re88ab682a9414947"/>
+                <asvg:svgBlip xmlns:asvg="http://schemas.microsoft.com/office/drawing/2016/SVG/main" r:embed="R55d3781b8f234c1c"/>
               </a:ext>
             </a:extLst>
           </a:blip>
@@ -3183,7 +3183,7 @@
           <p:cNvPr id="2" name="section">
             <a:extLst xmlns:a="http://schemas.openxmlformats.org/drawingml/2006/main">
               <a:ext uri="{FF2B5EF4-FFF2-40B4-BE49-F238E27FC236}">
-                <a16:creationId xmlns:a16="http://schemas.microsoft.com/office/drawing/2014/main" id="{F8677E93-11AF-42C4-90D1-971C39B2FD55}"/>
+                <a16:creationId xmlns:a16="http://schemas.microsoft.com/office/drawing/2014/main" id="{2E1BA9A2-5EDD-4F1F-B3D6-23BA39245D85}"/>
               </a:ext>
             </a:extLst>
           </p:cNvPr>
@@ -3241,7 +3241,7 @@
           <p:cNvPr id="3" name="takeaway">
             <a:extLst xmlns:a="http://schemas.openxmlformats.org/drawingml/2006/main">
               <a:ext uri="{FF2B5EF4-FFF2-40B4-BE49-F238E27FC236}">
-                <a16:creationId xmlns:a16="http://schemas.microsoft.com/office/drawing/2014/main" id="{F81E9F06-59DB-4BEF-B113-2931BA5CA770}"/>
+                <a16:creationId xmlns:a16="http://schemas.microsoft.com/office/drawing/2014/main" id="{B132B2D7-78D8-4C4A-86A3-43B31D7212D6}"/>
               </a:ext>
             </a:extLst>
           </p:cNvPr>
@@ -3299,7 +3299,7 @@
           <p:cNvPr id="4" name="footer">
             <a:extLst xmlns:a="http://schemas.openxmlformats.org/drawingml/2006/main">
               <a:ext uri="{FF2B5EF4-FFF2-40B4-BE49-F238E27FC236}">
-                <a16:creationId xmlns:a16="http://schemas.microsoft.com/office/drawing/2014/main" id="{E532B85B-2D71-4A92-99FB-30BEB78B8F7D}"/>
+                <a16:creationId xmlns:a16="http://schemas.microsoft.com/office/drawing/2014/main" id="{A1B085A1-3A00-49B8-A802-1AF67C8C0D6C}"/>
               </a:ext>
             </a:extLst>
           </p:cNvPr>
@@ -3357,7 +3357,7 @@
           <p:cNvPr id="5" name="page-number">
             <a:extLst xmlns:a="http://schemas.openxmlformats.org/drawingml/2006/main">
               <a:ext uri="{FF2B5EF4-FFF2-40B4-BE49-F238E27FC236}">
-                <a16:creationId xmlns:a16="http://schemas.microsoft.com/office/drawing/2014/main" id="{A7BD08B3-8BB0-424C-BAA6-D813C7ED8B58}"/>
+                <a16:creationId xmlns:a16="http://schemas.microsoft.com/office/drawing/2014/main" id="{2EC3DB84-6FAE-4675-8BE9-C6B593E0F7E4}"/>
               </a:ext>
             </a:extLst>
           </p:cNvPr>
@@ -3415,7 +3415,7 @@
           <p:cNvPr id="6" name="zero">
             <a:extLst xmlns:a="http://schemas.openxmlformats.org/drawingml/2006/main">
               <a:ext uri="{FF2B5EF4-FFF2-40B4-BE49-F238E27FC236}">
-                <a16:creationId xmlns:a16="http://schemas.microsoft.com/office/drawing/2014/main" id="{F0B8DDD3-6EB3-4280-AC64-C3DA35A7A728}"/>
+                <a16:creationId xmlns:a16="http://schemas.microsoft.com/office/drawing/2014/main" id="{3273CDCC-2B9E-482D-8646-F6182986031E}"/>
               </a:ext>
             </a:extLst>
           </p:cNvPr>
@@ -3473,7 +3473,7 @@
           <p:cNvPr id="7" name="zero-label">
             <a:extLst xmlns:a="http://schemas.openxmlformats.org/drawingml/2006/main">
               <a:ext uri="{FF2B5EF4-FFF2-40B4-BE49-F238E27FC236}">
-                <a16:creationId xmlns:a16="http://schemas.microsoft.com/office/drawing/2014/main" id="{E70CA0E1-E38A-4397-88C3-507DF01FCD28}"/>
+                <a16:creationId xmlns:a16="http://schemas.microsoft.com/office/drawing/2014/main" id="{9C1CFB09-C5E3-49B2-B304-479B364567C7}"/>
               </a:ext>
             </a:extLst>
           </p:cNvPr>
@@ -3531,7 +3531,7 @@
           <p:cNvPr id="8" name="checks">
             <a:extLst xmlns:a="http://schemas.openxmlformats.org/drawingml/2006/main">
               <a:ext uri="{FF2B5EF4-FFF2-40B4-BE49-F238E27FC236}">
-                <a16:creationId xmlns:a16="http://schemas.microsoft.com/office/drawing/2014/main" id="{0F7F5B02-6D21-4937-91B7-8D67061EEBED}"/>
+                <a16:creationId xmlns:a16="http://schemas.microsoft.com/office/drawing/2014/main" id="{BD7FF8FE-2EDE-414D-A3A6-60996B115209}"/>
               </a:ext>
             </a:extLst>
           </p:cNvPr>
@@ -3658,7 +3658,7 @@
           <p:cNvPr id="9" name="proof-boundary">
             <a:extLst xmlns:a="http://schemas.openxmlformats.org/drawingml/2006/main">
               <a:ext uri="{FF2B5EF4-FFF2-40B4-BE49-F238E27FC236}">
-                <a16:creationId xmlns:a16="http://schemas.microsoft.com/office/drawing/2014/main" id="{FA06732F-1C0D-4DF4-B92E-CA60D4B14FB1}"/>
+                <a16:creationId xmlns:a16="http://schemas.microsoft.com/office/drawing/2014/main" id="{3567B68E-0F35-4F9B-847E-60712930235F}"/>
               </a:ext>
             </a:extLst>
           </p:cNvPr>
@@ -3714,7 +3714,7 @@
     </p:spTree>
     <p:extLst>
       <p:ext uri="{BB962C8B-B14F-4D97-AF65-F5344CB8AC3E}">
-        <p14:creationId xmlns:p14="http://schemas.microsoft.com/office/powerpoint/2010/main" val="988433846"/>
+        <p14:creationId xmlns:p14="http://schemas.microsoft.com/office/powerpoint/2010/main" val="447901411"/>
       </p:ext>
     </p:extLst>
   </p:cSld>
@@ -3749,10 +3749,10 @@
           <p:nvPr/>
         </p:nvPicPr>
         <p:blipFill>
-          <a:blip xmlns:r="http://schemas.openxmlformats.org/officeDocument/2006/relationships" xmlns:a="http://schemas.openxmlformats.org/drawingml/2006/main" r:embed="R89f7239f82ca4ad4">
+          <a:blip xmlns:r="http://schemas.openxmlformats.org/officeDocument/2006/relationships" xmlns:a="http://schemas.openxmlformats.org/drawingml/2006/main" r:embed="R09c79ad1460d4631">
             <a:extLst>
               <a:ext uri="{96DAC541-7B7A-43D3-8B79-37D633B846F1}">
-                <asvg:svgBlip xmlns:asvg="http://schemas.microsoft.com/office/drawing/2016/SVG/main" r:embed="Ra562799fe926472e"/>
+                <asvg:svgBlip xmlns:asvg="http://schemas.microsoft.com/office/drawing/2016/SVG/main" r:embed="R41d023aa434e49d0"/>
               </a:ext>
             </a:extLst>
           </a:blip>
@@ -3773,7 +3773,7 @@
           <p:cNvPr id="2" name="section">
             <a:extLst xmlns:a="http://schemas.openxmlformats.org/drawingml/2006/main">
               <a:ext uri="{FF2B5EF4-FFF2-40B4-BE49-F238E27FC236}">
-                <a16:creationId xmlns:a16="http://schemas.microsoft.com/office/drawing/2014/main" id="{28A3C433-A600-462C-9516-54E883ACF25E}"/>
+                <a16:creationId xmlns:a16="http://schemas.microsoft.com/office/drawing/2014/main" id="{060ECEC6-ECFC-4BBB-AAC9-76B1286CE2CC}"/>
               </a:ext>
             </a:extLst>
           </p:cNvPr>
@@ -3831,7 +3831,7 @@
           <p:cNvPr id="3" name="takeaway">
             <a:extLst xmlns:a="http://schemas.openxmlformats.org/drawingml/2006/main">
               <a:ext uri="{FF2B5EF4-FFF2-40B4-BE49-F238E27FC236}">
-                <a16:creationId xmlns:a16="http://schemas.microsoft.com/office/drawing/2014/main" id="{0332C878-26E5-4503-BDF9-60DBC0F2460B}"/>
+                <a16:creationId xmlns:a16="http://schemas.microsoft.com/office/drawing/2014/main" id="{8BC254C1-F073-4204-9235-AB49CA13A65D}"/>
               </a:ext>
             </a:extLst>
           </p:cNvPr>
@@ -3889,7 +3889,7 @@
           <p:cNvPr id="4" name="footer">
             <a:extLst xmlns:a="http://schemas.openxmlformats.org/drawingml/2006/main">
               <a:ext uri="{FF2B5EF4-FFF2-40B4-BE49-F238E27FC236}">
-                <a16:creationId xmlns:a16="http://schemas.microsoft.com/office/drawing/2014/main" id="{34A6678F-E2EA-4D6A-AA80-D46BE7DE3026}"/>
+                <a16:creationId xmlns:a16="http://schemas.microsoft.com/office/drawing/2014/main" id="{9C40A736-90A4-4E72-90D2-CEF2940F3A68}"/>
               </a:ext>
             </a:extLst>
           </p:cNvPr>
@@ -3947,7 +3947,7 @@
           <p:cNvPr id="5" name="page-number">
             <a:extLst xmlns:a="http://schemas.openxmlformats.org/drawingml/2006/main">
               <a:ext uri="{FF2B5EF4-FFF2-40B4-BE49-F238E27FC236}">
-                <a16:creationId xmlns:a16="http://schemas.microsoft.com/office/drawing/2014/main" id="{8C64FE29-EA6C-47A8-A19E-BE4D7ED73E20}"/>
+                <a16:creationId xmlns:a16="http://schemas.microsoft.com/office/drawing/2014/main" id="{246DD9CD-96E2-4432-BE7F-31B3B0DC6AF5}"/>
               </a:ext>
             </a:extLst>
           </p:cNvPr>
@@ -4005,7 +4005,7 @@
           <p:cNvPr id="6" name="oss-title">
             <a:extLst xmlns:a="http://schemas.openxmlformats.org/drawingml/2006/main">
               <a:ext uri="{FF2B5EF4-FFF2-40B4-BE49-F238E27FC236}">
-                <a16:creationId xmlns:a16="http://schemas.microsoft.com/office/drawing/2014/main" id="{DEBC22E6-9FD1-4EA9-9324-4C19CDAB8C20}"/>
+                <a16:creationId xmlns:a16="http://schemas.microsoft.com/office/drawing/2014/main" id="{A8DE57E0-F0DE-47C7-AADC-484A192B1FFF}"/>
               </a:ext>
             </a:extLst>
           </p:cNvPr>
@@ -4063,7 +4063,7 @@
           <p:cNvPr id="7" name="oss-body">
             <a:extLst xmlns:a="http://schemas.openxmlformats.org/drawingml/2006/main">
               <a:ext uri="{FF2B5EF4-FFF2-40B4-BE49-F238E27FC236}">
-                <a16:creationId xmlns:a16="http://schemas.microsoft.com/office/drawing/2014/main" id="{73380E0E-10C0-4E4D-B9E4-07EA2FC858F9}"/>
+                <a16:creationId xmlns:a16="http://schemas.microsoft.com/office/drawing/2014/main" id="{11DF5268-794C-47FF-9934-B6AE627091B6}"/>
               </a:ext>
             </a:extLst>
           </p:cNvPr>
@@ -4213,7 +4213,7 @@
           <p:cNvPr id="8" name="paid-title">
             <a:extLst xmlns:a="http://schemas.openxmlformats.org/drawingml/2006/main">
               <a:ext uri="{FF2B5EF4-FFF2-40B4-BE49-F238E27FC236}">
-                <a16:creationId xmlns:a16="http://schemas.microsoft.com/office/drawing/2014/main" id="{5A7C70DB-B076-4687-93A0-2C2654232177}"/>
+                <a16:creationId xmlns:a16="http://schemas.microsoft.com/office/drawing/2014/main" id="{66E14868-C408-4D4D-83CD-1DB0A2AA0C39}"/>
               </a:ext>
             </a:extLst>
           </p:cNvPr>
@@ -4271,7 +4271,7 @@
           <p:cNvPr id="9" name="paid-body">
             <a:extLst xmlns:a="http://schemas.openxmlformats.org/drawingml/2006/main">
               <a:ext uri="{FF2B5EF4-FFF2-40B4-BE49-F238E27FC236}">
-                <a16:creationId xmlns:a16="http://schemas.microsoft.com/office/drawing/2014/main" id="{46D5E578-194E-4779-AD67-B50F571815CD}"/>
+                <a16:creationId xmlns:a16="http://schemas.microsoft.com/office/drawing/2014/main" id="{F2EA2F00-1432-4577-9C12-DD0D14FD46C5}"/>
               </a:ext>
             </a:extLst>
           </p:cNvPr>
@@ -4421,7 +4421,7 @@
           <p:cNvPr id="10" name="same-core">
             <a:extLst xmlns:a="http://schemas.openxmlformats.org/drawingml/2006/main">
               <a:ext uri="{FF2B5EF4-FFF2-40B4-BE49-F238E27FC236}">
-                <a16:creationId xmlns:a16="http://schemas.microsoft.com/office/drawing/2014/main" id="{0C699C64-37CF-407F-895E-160B284F7DB2}"/>
+                <a16:creationId xmlns:a16="http://schemas.microsoft.com/office/drawing/2014/main" id="{77F42F39-D834-44D3-B507-9E94D657768C}"/>
               </a:ext>
             </a:extLst>
           </p:cNvPr>
@@ -4477,7 +4477,7 @@
     </p:spTree>
     <p:extLst>
       <p:ext uri="{BB962C8B-B14F-4D97-AF65-F5344CB8AC3E}">
-        <p14:creationId xmlns:p14="http://schemas.microsoft.com/office/powerpoint/2010/main" val="765567838"/>
+        <p14:creationId xmlns:p14="http://schemas.microsoft.com/office/powerpoint/2010/main" val="433633184"/>
       </p:ext>
     </p:extLst>
   </p:cSld>
@@ -4512,10 +4512,10 @@
           <p:nvPr/>
         </p:nvPicPr>
         <p:blipFill>
-          <a:blip xmlns:r="http://schemas.openxmlformats.org/officeDocument/2006/relationships" xmlns:a="http://schemas.openxmlformats.org/drawingml/2006/main" r:embed="Re3cd6281265a4a59">
+          <a:blip xmlns:r="http://schemas.openxmlformats.org/officeDocument/2006/relationships" xmlns:a="http://schemas.openxmlformats.org/drawingml/2006/main" r:embed="R5410740079f04bbb">
             <a:extLst>
               <a:ext uri="{96DAC541-7B7A-43D3-8B79-37D633B846F1}">
-                <asvg:svgBlip xmlns:asvg="http://schemas.microsoft.com/office/drawing/2016/SVG/main" r:embed="R5c20ed34cbbc4d09"/>
+                <asvg:svgBlip xmlns:asvg="http://schemas.microsoft.com/office/drawing/2016/SVG/main" r:embed="R2e776c7a25ae4ce0"/>
               </a:ext>
             </a:extLst>
           </a:blip>
@@ -4536,7 +4536,7 @@
           <p:cNvPr id="2" name="section">
             <a:extLst xmlns:a="http://schemas.openxmlformats.org/drawingml/2006/main">
               <a:ext uri="{FF2B5EF4-FFF2-40B4-BE49-F238E27FC236}">
-                <a16:creationId xmlns:a16="http://schemas.microsoft.com/office/drawing/2014/main" id="{DDB3BF24-1935-4E13-BBD0-374D852A62A0}"/>
+                <a16:creationId xmlns:a16="http://schemas.microsoft.com/office/drawing/2014/main" id="{67759EB5-A8AE-49AF-9B3F-826DEFAA525C}"/>
               </a:ext>
             </a:extLst>
           </p:cNvPr>
@@ -4594,7 +4594,7 @@
           <p:cNvPr id="3" name="takeaway">
             <a:extLst xmlns:a="http://schemas.openxmlformats.org/drawingml/2006/main">
               <a:ext uri="{FF2B5EF4-FFF2-40B4-BE49-F238E27FC236}">
-                <a16:creationId xmlns:a16="http://schemas.microsoft.com/office/drawing/2014/main" id="{8FA73E07-AE73-4FE8-B314-04CBBEBB8ED6}"/>
+                <a16:creationId xmlns:a16="http://schemas.microsoft.com/office/drawing/2014/main" id="{CFE197D5-B1DE-4F67-B653-2A8B07DF612E}"/>
               </a:ext>
             </a:extLst>
           </p:cNvPr>
@@ -4652,7 +4652,7 @@
           <p:cNvPr id="4" name="footer">
             <a:extLst xmlns:a="http://schemas.openxmlformats.org/drawingml/2006/main">
               <a:ext uri="{FF2B5EF4-FFF2-40B4-BE49-F238E27FC236}">
-                <a16:creationId xmlns:a16="http://schemas.microsoft.com/office/drawing/2014/main" id="{809CAB2F-47B7-463E-AAC3-A9BA2A0C52D6}"/>
+                <a16:creationId xmlns:a16="http://schemas.microsoft.com/office/drawing/2014/main" id="{8DAA3946-86B2-4AF7-A204-920F146D8446}"/>
               </a:ext>
             </a:extLst>
           </p:cNvPr>
@@ -4710,7 +4710,7 @@
           <p:cNvPr id="5" name="page-number">
             <a:extLst xmlns:a="http://schemas.openxmlformats.org/drawingml/2006/main">
               <a:ext uri="{FF2B5EF4-FFF2-40B4-BE49-F238E27FC236}">
-                <a16:creationId xmlns:a16="http://schemas.microsoft.com/office/drawing/2014/main" id="{593F1CF3-AA26-419D-B613-11F80EF80E2A}"/>
+                <a16:creationId xmlns:a16="http://schemas.microsoft.com/office/drawing/2014/main" id="{2F677BB0-E4BC-461C-B991-7A7215506A14}"/>
               </a:ext>
             </a:extLst>
           </p:cNvPr>
@@ -4768,7 +4768,7 @@
           <p:cNvPr id="6" name="release">
             <a:extLst xmlns:a="http://schemas.openxmlformats.org/drawingml/2006/main">
               <a:ext uri="{FF2B5EF4-FFF2-40B4-BE49-F238E27FC236}">
-                <a16:creationId xmlns:a16="http://schemas.microsoft.com/office/drawing/2014/main" id="{D63E1231-E3F4-4FB5-8965-F987095A3FA8}"/>
+                <a16:creationId xmlns:a16="http://schemas.microsoft.com/office/drawing/2014/main" id="{31924C3F-FA3F-4786-BCED-E3A2568C5B8F}"/>
               </a:ext>
             </a:extLst>
           </p:cNvPr>
@@ -4816,7 +4816,7 @@
                 <a:ea typeface="Arial"/>
                 <a:cs typeface="Arial"/>
               </a:rPr>
-              <a:t>v1.0.0 source contracts</a:t>
+              <a:t>v1.2.0 source + Apple Silicon app</a:t>
             </a:r>
           </a:p>
         </p:txBody>
@@ -4826,7 +4826,7 @@
           <p:cNvPr id="7" name="oci">
             <a:extLst xmlns:a="http://schemas.openxmlformats.org/drawingml/2006/main">
               <a:ext uri="{FF2B5EF4-FFF2-40B4-BE49-F238E27FC236}">
-                <a16:creationId xmlns:a16="http://schemas.microsoft.com/office/drawing/2014/main" id="{9D7DF6A6-F27C-4E3D-9871-5D4937456172}"/>
+                <a16:creationId xmlns:a16="http://schemas.microsoft.com/office/drawing/2014/main" id="{236C26CA-11CB-4B41-964D-95704A1AF0C5}"/>
               </a:ext>
             </a:extLst>
           </p:cNvPr>
@@ -4874,7 +4874,7 @@
                 <a:ea typeface="Arial"/>
                 <a:cs typeface="Arial"/>
               </a:rPr>
-              <a:t>Signed OCI v0.1.3 linux/amd64 is a separate reference stream.</a:t>
+              <a:t>Signed OCI v1.2.0 linux/amd64 is the matching reference image.</a:t>
             </a:r>
           </a:p>
         </p:txBody>
@@ -4884,7 +4884,7 @@
           <p:cNvPr id="8" name="operators">
             <a:extLst xmlns:a="http://schemas.openxmlformats.org/drawingml/2006/main">
               <a:ext uri="{FF2B5EF4-FFF2-40B4-BE49-F238E27FC236}">
-                <a16:creationId xmlns:a16="http://schemas.microsoft.com/office/drawing/2014/main" id="{3C789051-5BF2-404E-A3A9-2C3521F83682}"/>
+                <a16:creationId xmlns:a16="http://schemas.microsoft.com/office/drawing/2014/main" id="{4609D079-40D4-43E0-AB32-0E78592AF642}"/>
               </a:ext>
             </a:extLst>
           </p:cNvPr>
@@ -4942,7 +4942,7 @@
           <p:cNvPr id="9" name="nonclaims">
             <a:extLst xmlns:a="http://schemas.openxmlformats.org/drawingml/2006/main">
               <a:ext uri="{FF2B5EF4-FFF2-40B4-BE49-F238E27FC236}">
-                <a16:creationId xmlns:a16="http://schemas.microsoft.com/office/drawing/2014/main" id="{5A28C66B-751A-4F47-BDBF-C55CDD6B15B0}"/>
+                <a16:creationId xmlns:a16="http://schemas.microsoft.com/office/drawing/2014/main" id="{05C8BE94-FD1B-4C72-A105-1C7296C06336}"/>
               </a:ext>
             </a:extLst>
           </p:cNvPr>
@@ -4990,7 +4990,7 @@
                 <a:ea typeface="Arial"/>
                 <a:cs typeface="Arial"/>
               </a:rPr>
-              <a:t>Not claimed: native Hormuz login/refresh sessions, complete semantic DLP, per-inference human approval, reconciled provider invoices, managed SaaS, or a 24/7 SLA.</a:t>
+              <a:t>Not claimed: complete semantic DLP, per-inference human approval, reconciled provider invoices, generally available managed SaaS, or a 24/7 SLA.</a:t>
             </a:r>
           </a:p>
         </p:txBody>
@@ -4998,7 +4998,7 @@
     </p:spTree>
     <p:extLst>
       <p:ext uri="{BB962C8B-B14F-4D97-AF65-F5344CB8AC3E}">
-        <p14:creationId xmlns:p14="http://schemas.microsoft.com/office/powerpoint/2010/main" val="1221232574"/>
+        <p14:creationId xmlns:p14="http://schemas.microsoft.com/office/powerpoint/2010/main" val="456994352"/>
       </p:ext>
     </p:extLst>
   </p:cSld>
@@ -5033,10 +5033,10 @@
           <p:nvPr/>
         </p:nvPicPr>
         <p:blipFill>
-          <a:blip xmlns:r="http://schemas.openxmlformats.org/officeDocument/2006/relationships" xmlns:a="http://schemas.openxmlformats.org/drawingml/2006/main" r:embed="R1bfd5982f2ef4904">
+          <a:blip xmlns:r="http://schemas.openxmlformats.org/officeDocument/2006/relationships" xmlns:a="http://schemas.openxmlformats.org/drawingml/2006/main" r:embed="R4b35893b1ab846f3">
             <a:extLst>
               <a:ext uri="{96DAC541-7B7A-43D3-8B79-37D633B846F1}">
-                <asvg:svgBlip xmlns:asvg="http://schemas.microsoft.com/office/drawing/2016/SVG/main" r:embed="R6417a8acd26143ea"/>
+                <asvg:svgBlip xmlns:asvg="http://schemas.microsoft.com/office/drawing/2016/SVG/main" r:embed="R27c0754e1e434790"/>
               </a:ext>
             </a:extLst>
           </a:blip>
@@ -5057,7 +5057,7 @@
           <p:cNvPr id="2" name="section">
             <a:extLst xmlns:a="http://schemas.openxmlformats.org/drawingml/2006/main">
               <a:ext uri="{FF2B5EF4-FFF2-40B4-BE49-F238E27FC236}">
-                <a16:creationId xmlns:a16="http://schemas.microsoft.com/office/drawing/2014/main" id="{CA25D972-AAB3-4FF1-82CE-C04E2EF6FBCA}"/>
+                <a16:creationId xmlns:a16="http://schemas.microsoft.com/office/drawing/2014/main" id="{95640054-6E28-4DBC-9A0D-BF77E75E7167}"/>
               </a:ext>
             </a:extLst>
           </p:cNvPr>
@@ -5115,7 +5115,7 @@
           <p:cNvPr id="3" name="takeaway">
             <a:extLst xmlns:a="http://schemas.openxmlformats.org/drawingml/2006/main">
               <a:ext uri="{FF2B5EF4-FFF2-40B4-BE49-F238E27FC236}">
-                <a16:creationId xmlns:a16="http://schemas.microsoft.com/office/drawing/2014/main" id="{E2E80C74-735F-4254-9CFA-0D26FC9802BF}"/>
+                <a16:creationId xmlns:a16="http://schemas.microsoft.com/office/drawing/2014/main" id="{2A9AF63B-D7A8-4DAB-A812-2FE20D92D2CC}"/>
               </a:ext>
             </a:extLst>
           </p:cNvPr>
@@ -5173,7 +5173,7 @@
           <p:cNvPr id="4" name="footer">
             <a:extLst xmlns:a="http://schemas.openxmlformats.org/drawingml/2006/main">
               <a:ext uri="{FF2B5EF4-FFF2-40B4-BE49-F238E27FC236}">
-                <a16:creationId xmlns:a16="http://schemas.microsoft.com/office/drawing/2014/main" id="{B17A0690-9760-465A-8070-CB47CE4ECEE7}"/>
+                <a16:creationId xmlns:a16="http://schemas.microsoft.com/office/drawing/2014/main" id="{DFD61CAB-9B6F-4446-9EE3-171AD3F6F17B}"/>
               </a:ext>
             </a:extLst>
           </p:cNvPr>
@@ -5231,7 +5231,7 @@
           <p:cNvPr id="5" name="page-number">
             <a:extLst xmlns:a="http://schemas.openxmlformats.org/drawingml/2006/main">
               <a:ext uri="{FF2B5EF4-FFF2-40B4-BE49-F238E27FC236}">
-                <a16:creationId xmlns:a16="http://schemas.microsoft.com/office/drawing/2014/main" id="{721A023B-3E44-4580-B64A-AAAAA33253E0}"/>
+                <a16:creationId xmlns:a16="http://schemas.microsoft.com/office/drawing/2014/main" id="{2D1E0E57-746B-40E1-B3CD-CF20535EF5F5}"/>
               </a:ext>
             </a:extLst>
           </p:cNvPr>
@@ -5289,7 +5289,7 @@
           <p:cNvPr id="6" name="phase-01">
             <a:extLst xmlns:a="http://schemas.openxmlformats.org/drawingml/2006/main">
               <a:ext uri="{FF2B5EF4-FFF2-40B4-BE49-F238E27FC236}">
-                <a16:creationId xmlns:a16="http://schemas.microsoft.com/office/drawing/2014/main" id="{D79D1F30-E5EF-40B4-9E3C-8A0E0FB36D11}"/>
+                <a16:creationId xmlns:a16="http://schemas.microsoft.com/office/drawing/2014/main" id="{A4D4BAA0-A79C-479A-BD84-8570BD1DB5C1}"/>
               </a:ext>
             </a:extLst>
           </p:cNvPr>
@@ -5347,7 +5347,7 @@
           <p:cNvPr id="7" name="phase-title-01">
             <a:extLst xmlns:a="http://schemas.openxmlformats.org/drawingml/2006/main">
               <a:ext uri="{FF2B5EF4-FFF2-40B4-BE49-F238E27FC236}">
-                <a16:creationId xmlns:a16="http://schemas.microsoft.com/office/drawing/2014/main" id="{B3B42111-1983-4069-911B-67558336871D}"/>
+                <a16:creationId xmlns:a16="http://schemas.microsoft.com/office/drawing/2014/main" id="{09BBCE4A-5A43-4CB3-BBA0-CD96633F0C2F}"/>
               </a:ext>
             </a:extLst>
           </p:cNvPr>
@@ -5405,7 +5405,7 @@
           <p:cNvPr id="8" name="phase-body-01">
             <a:extLst xmlns:a="http://schemas.openxmlformats.org/drawingml/2006/main">
               <a:ext uri="{FF2B5EF4-FFF2-40B4-BE49-F238E27FC236}">
-                <a16:creationId xmlns:a16="http://schemas.microsoft.com/office/drawing/2014/main" id="{A47D3804-4A1D-4F6A-B6E4-47D290120323}"/>
+                <a16:creationId xmlns:a16="http://schemas.microsoft.com/office/drawing/2014/main" id="{007B8B3F-6431-4EBF-8E5F-F146EA8B4579}"/>
               </a:ext>
             </a:extLst>
           </p:cNvPr>
@@ -5463,7 +5463,7 @@
           <p:cNvPr id="9" name="phase-02">
             <a:extLst xmlns:a="http://schemas.openxmlformats.org/drawingml/2006/main">
               <a:ext uri="{FF2B5EF4-FFF2-40B4-BE49-F238E27FC236}">
-                <a16:creationId xmlns:a16="http://schemas.microsoft.com/office/drawing/2014/main" id="{FB9A25B2-A18A-4F40-B7BF-1EDCC4158E21}"/>
+                <a16:creationId xmlns:a16="http://schemas.microsoft.com/office/drawing/2014/main" id="{443BF0FB-474C-4DC1-8196-FDBD86B66619}"/>
               </a:ext>
             </a:extLst>
           </p:cNvPr>
@@ -5521,7 +5521,7 @@
           <p:cNvPr id="10" name="phase-title-02">
             <a:extLst xmlns:a="http://schemas.openxmlformats.org/drawingml/2006/main">
               <a:ext uri="{FF2B5EF4-FFF2-40B4-BE49-F238E27FC236}">
-                <a16:creationId xmlns:a16="http://schemas.microsoft.com/office/drawing/2014/main" id="{9AFC6487-F1DA-4507-A0EF-D17BD578250E}"/>
+                <a16:creationId xmlns:a16="http://schemas.microsoft.com/office/drawing/2014/main" id="{304B67F3-C5EF-41F7-8755-3E3D45C7D6F0}"/>
               </a:ext>
             </a:extLst>
           </p:cNvPr>
@@ -5579,7 +5579,7 @@
           <p:cNvPr id="11" name="phase-body-02">
             <a:extLst xmlns:a="http://schemas.openxmlformats.org/drawingml/2006/main">
               <a:ext uri="{FF2B5EF4-FFF2-40B4-BE49-F238E27FC236}">
-                <a16:creationId xmlns:a16="http://schemas.microsoft.com/office/drawing/2014/main" id="{0C658C4D-3197-42D5-9C99-C89866EF6FC0}"/>
+                <a16:creationId xmlns:a16="http://schemas.microsoft.com/office/drawing/2014/main" id="{CBFBCAB5-8921-4D64-9FC1-6670DA000DAA}"/>
               </a:ext>
             </a:extLst>
           </p:cNvPr>
@@ -5637,7 +5637,7 @@
           <p:cNvPr id="12" name="phase-03">
             <a:extLst xmlns:a="http://schemas.openxmlformats.org/drawingml/2006/main">
               <a:ext uri="{FF2B5EF4-FFF2-40B4-BE49-F238E27FC236}">
-                <a16:creationId xmlns:a16="http://schemas.microsoft.com/office/drawing/2014/main" id="{0062D162-C430-45F8-A72E-9B5A3F47011C}"/>
+                <a16:creationId xmlns:a16="http://schemas.microsoft.com/office/drawing/2014/main" id="{34541B2E-88E6-4B09-8870-7DBCA80D48DC}"/>
               </a:ext>
             </a:extLst>
           </p:cNvPr>
@@ -5695,7 +5695,7 @@
           <p:cNvPr id="13" name="phase-title-03">
             <a:extLst xmlns:a="http://schemas.openxmlformats.org/drawingml/2006/main">
               <a:ext uri="{FF2B5EF4-FFF2-40B4-BE49-F238E27FC236}">
-                <a16:creationId xmlns:a16="http://schemas.microsoft.com/office/drawing/2014/main" id="{F2504E70-A106-4336-A677-EF1192427D8C}"/>
+                <a16:creationId xmlns:a16="http://schemas.microsoft.com/office/drawing/2014/main" id="{CA8F7D53-4F01-4E25-8053-2A6086C45C90}"/>
               </a:ext>
             </a:extLst>
           </p:cNvPr>
@@ -5753,7 +5753,7 @@
           <p:cNvPr id="14" name="phase-body-03">
             <a:extLst xmlns:a="http://schemas.openxmlformats.org/drawingml/2006/main">
               <a:ext uri="{FF2B5EF4-FFF2-40B4-BE49-F238E27FC236}">
-                <a16:creationId xmlns:a16="http://schemas.microsoft.com/office/drawing/2014/main" id="{1110FD3C-D302-418F-A254-62D8AE008531}"/>
+                <a16:creationId xmlns:a16="http://schemas.microsoft.com/office/drawing/2014/main" id="{6CF362C9-423B-4307-A6EE-34617D4B7E95}"/>
               </a:ext>
             </a:extLst>
           </p:cNvPr>
@@ -5811,7 +5811,7 @@
           <p:cNvPr id="15" name="pilot-boundary">
             <a:extLst xmlns:a="http://schemas.openxmlformats.org/drawingml/2006/main">
               <a:ext uri="{FF2B5EF4-FFF2-40B4-BE49-F238E27FC236}">
-                <a16:creationId xmlns:a16="http://schemas.microsoft.com/office/drawing/2014/main" id="{63356C82-E1D3-4A1F-B74A-F48438660FD2}"/>
+                <a16:creationId xmlns:a16="http://schemas.microsoft.com/office/drawing/2014/main" id="{ECD0DF03-7EC4-4D10-989C-8D0B36AC3951}"/>
               </a:ext>
             </a:extLst>
           </p:cNvPr>
@@ -5867,7 +5867,7 @@
     </p:spTree>
     <p:extLst>
       <p:ext uri="{BB962C8B-B14F-4D97-AF65-F5344CB8AC3E}">
-        <p14:creationId xmlns:p14="http://schemas.microsoft.com/office/powerpoint/2010/main" val="1782424605"/>
+        <p14:creationId xmlns:p14="http://schemas.microsoft.com/office/powerpoint/2010/main" val="1445271208"/>
       </p:ext>
     </p:extLst>
   </p:cSld>
@@ -5902,10 +5902,10 @@
           <p:nvPr/>
         </p:nvPicPr>
         <p:blipFill>
-          <a:blip xmlns:r="http://schemas.openxmlformats.org/officeDocument/2006/relationships" xmlns:a="http://schemas.openxmlformats.org/drawingml/2006/main" r:embed="Rd5f40a9b142f4b09">
+          <a:blip xmlns:r="http://schemas.openxmlformats.org/officeDocument/2006/relationships" xmlns:a="http://schemas.openxmlformats.org/drawingml/2006/main" r:embed="R58dd97a0352d45de">
             <a:extLst>
               <a:ext uri="{96DAC541-7B7A-43D3-8B79-37D633B846F1}">
-                <asvg:svgBlip xmlns:asvg="http://schemas.microsoft.com/office/drawing/2016/SVG/main" r:embed="R9a9fdb9879cf4c0e"/>
+                <asvg:svgBlip xmlns:asvg="http://schemas.microsoft.com/office/drawing/2016/SVG/main" r:embed="Rc0c5a4f75bed4854"/>
               </a:ext>
             </a:extLst>
           </a:blip>
@@ -5926,7 +5926,7 @@
           <p:cNvPr id="2" name="section">
             <a:extLst xmlns:a="http://schemas.openxmlformats.org/drawingml/2006/main">
               <a:ext uri="{FF2B5EF4-FFF2-40B4-BE49-F238E27FC236}">
-                <a16:creationId xmlns:a16="http://schemas.microsoft.com/office/drawing/2014/main" id="{0C6BDB77-89D7-4F8B-986D-6EA8D7C9A463}"/>
+                <a16:creationId xmlns:a16="http://schemas.microsoft.com/office/drawing/2014/main" id="{935B2D0D-1324-4A9D-966D-25636F9C8D9F}"/>
               </a:ext>
             </a:extLst>
           </p:cNvPr>
@@ -5984,7 +5984,7 @@
           <p:cNvPr id="3" name="takeaway">
             <a:extLst xmlns:a="http://schemas.openxmlformats.org/drawingml/2006/main">
               <a:ext uri="{FF2B5EF4-FFF2-40B4-BE49-F238E27FC236}">
-                <a16:creationId xmlns:a16="http://schemas.microsoft.com/office/drawing/2014/main" id="{0DE03F2D-D3C3-4F72-8B8E-1AFD840E1653}"/>
+                <a16:creationId xmlns:a16="http://schemas.microsoft.com/office/drawing/2014/main" id="{690296EC-E36C-40E1-AB4D-031E3A3E0E30}"/>
               </a:ext>
             </a:extLst>
           </p:cNvPr>
@@ -6042,7 +6042,7 @@
           <p:cNvPr id="4" name="footer">
             <a:extLst xmlns:a="http://schemas.openxmlformats.org/drawingml/2006/main">
               <a:ext uri="{FF2B5EF4-FFF2-40B4-BE49-F238E27FC236}">
-                <a16:creationId xmlns:a16="http://schemas.microsoft.com/office/drawing/2014/main" id="{26102BAB-CDA1-4407-91CC-62B4AB07C893}"/>
+                <a16:creationId xmlns:a16="http://schemas.microsoft.com/office/drawing/2014/main" id="{E7101BD9-D8A9-4867-AD46-EAE98482FEBD}"/>
               </a:ext>
             </a:extLst>
           </p:cNvPr>
@@ -6100,7 +6100,7 @@
           <p:cNvPr id="5" name="page-number">
             <a:extLst xmlns:a="http://schemas.openxmlformats.org/drawingml/2006/main">
               <a:ext uri="{FF2B5EF4-FFF2-40B4-BE49-F238E27FC236}">
-                <a16:creationId xmlns:a16="http://schemas.microsoft.com/office/drawing/2014/main" id="{AC7FDC17-85BC-433E-BC74-C6766101BEC0}"/>
+                <a16:creationId xmlns:a16="http://schemas.microsoft.com/office/drawing/2014/main" id="{E45229F4-2CFD-451C-8EF4-B338DE012BBA}"/>
               </a:ext>
             </a:extLst>
           </p:cNvPr>
@@ -6158,7 +6158,7 @@
           <p:cNvPr id="6" name="next-step">
             <a:extLst xmlns:a="http://schemas.openxmlformats.org/drawingml/2006/main">
               <a:ext uri="{FF2B5EF4-FFF2-40B4-BE49-F238E27FC236}">
-                <a16:creationId xmlns:a16="http://schemas.microsoft.com/office/drawing/2014/main" id="{10909061-CA1A-4F63-9A1E-84CDDFC1058C}"/>
+                <a16:creationId xmlns:a16="http://schemas.microsoft.com/office/drawing/2014/main" id="{F05CD2F4-1F43-4AB2-AD32-C2169024A3A0}"/>
               </a:ext>
             </a:extLst>
           </p:cNvPr>
@@ -6262,7 +6262,7 @@
           <p:cNvPr id="7" name="contact">
             <a:extLst xmlns:a="http://schemas.openxmlformats.org/drawingml/2006/main">
               <a:ext uri="{FF2B5EF4-FFF2-40B4-BE49-F238E27FC236}">
-                <a16:creationId xmlns:a16="http://schemas.microsoft.com/office/drawing/2014/main" id="{384C3FA3-FA33-45C3-BF06-A135FF12737E}"/>
+                <a16:creationId xmlns:a16="http://schemas.microsoft.com/office/drawing/2014/main" id="{020FCB58-F0E3-4EB8-8CA0-B45356B36FC9}"/>
               </a:ext>
             </a:extLst>
           </p:cNvPr>
@@ -6343,7 +6343,7 @@
           <p:cNvPr id="8" name="website">
             <a:extLst xmlns:a="http://schemas.openxmlformats.org/drawingml/2006/main">
               <a:ext uri="{FF2B5EF4-FFF2-40B4-BE49-F238E27FC236}">
-                <a16:creationId xmlns:a16="http://schemas.microsoft.com/office/drawing/2014/main" id="{750F37F2-B9B4-44E6-A5F9-A2DE77888327}"/>
+                <a16:creationId xmlns:a16="http://schemas.microsoft.com/office/drawing/2014/main" id="{81AB35D1-58B0-43DC-A237-7376AB2401F2}"/>
               </a:ext>
             </a:extLst>
           </p:cNvPr>
@@ -6399,7 +6399,7 @@
     </p:spTree>
     <p:extLst>
       <p:ext uri="{BB962C8B-B14F-4D97-AF65-F5344CB8AC3E}">
-        <p14:creationId xmlns:p14="http://schemas.microsoft.com/office/powerpoint/2010/main" val="1154311883"/>
+        <p14:creationId xmlns:p14="http://schemas.microsoft.com/office/powerpoint/2010/main" val="2006680692"/>
       </p:ext>
     </p:extLst>
   </p:cSld>

</xml_diff>